<commit_message>
Improve architecture slide readability
</commit_message>
<xml_diff>
--- a/presentation/cloud-native-vbng-edge.pptx
+++ b/presentation/cloud-native-vbng-edge.pptx
@@ -2,18 +2,18 @@
 <file path=ppt/presentation.xml><?xml version="1.0" encoding="utf-8"?>
 <p:presentation xmlns:p="http://schemas.openxmlformats.org/presentationml/2006/main">
   <p:sldMasterIdLst>
-    <p:sldMasterId xmlns:r="http://schemas.openxmlformats.org/officeDocument/2006/relationships" id="2147483648" r:id="R118f40249afc4a63"/>
+    <p:sldMasterId xmlns:r="http://schemas.openxmlformats.org/officeDocument/2006/relationships" id="2147483648" r:id="R099c34bc31154fd9"/>
   </p:sldMasterIdLst>
   <p:notesMasterIdLst>
-    <p:notesMasterId xmlns:r="http://schemas.openxmlformats.org/officeDocument/2006/relationships" r:id="Rb7042a7c47434907"/>
+    <p:notesMasterId xmlns:r="http://schemas.openxmlformats.org/officeDocument/2006/relationships" r:id="R04bb106fbf3c4227"/>
   </p:notesMasterIdLst>
   <p:sldIdLst>
-    <p:sldId xmlns:r="http://schemas.openxmlformats.org/officeDocument/2006/relationships" id="256" r:id="R1bc9eff3a3d64af8"/>
-    <p:sldId xmlns:r="http://schemas.openxmlformats.org/officeDocument/2006/relationships" id="257" r:id="R11c43ccb22264b20"/>
-    <p:sldId xmlns:r="http://schemas.openxmlformats.org/officeDocument/2006/relationships" id="258" r:id="R9a5518f9ead74d69"/>
-    <p:sldId xmlns:r="http://schemas.openxmlformats.org/officeDocument/2006/relationships" id="259" r:id="R7b5763d82a1d43c6"/>
-    <p:sldId xmlns:r="http://schemas.openxmlformats.org/officeDocument/2006/relationships" id="260" r:id="R6c5c7f244dcf4e55"/>
-    <p:sldId xmlns:r="http://schemas.openxmlformats.org/officeDocument/2006/relationships" id="261" r:id="Rb02e0b3dd2d243fe"/>
+    <p:sldId xmlns:r="http://schemas.openxmlformats.org/officeDocument/2006/relationships" id="256" r:id="R5cbbeded363948e9"/>
+    <p:sldId xmlns:r="http://schemas.openxmlformats.org/officeDocument/2006/relationships" id="257" r:id="Ra2e436cc60294aac"/>
+    <p:sldId xmlns:r="http://schemas.openxmlformats.org/officeDocument/2006/relationships" id="258" r:id="R75e2665446744670"/>
+    <p:sldId xmlns:r="http://schemas.openxmlformats.org/officeDocument/2006/relationships" id="259" r:id="R7b5365a960c74c67"/>
+    <p:sldId xmlns:r="http://schemas.openxmlformats.org/officeDocument/2006/relationships" id="260" r:id="Re656d220b822466e"/>
+    <p:sldId xmlns:r="http://schemas.openxmlformats.org/officeDocument/2006/relationships" id="261" r:id="R6ef66d0fff164e37"/>
   </p:sldIdLst>
   <p:sldSz cx="12192000" cy="6858000"/>
   <p:notesSz cx="6858000" cy="9144000"/>
@@ -844,7 +844,7 @@
           <p:cNvPr id="3" name="Title">
             <a:extLst xmlns:a="http://schemas.openxmlformats.org/drawingml/2006/main">
               <a:ext uri="{FF2B5EF4-FFF2-40B4-BE49-F238E27FC236}">
-                <a16:creationId xmlns:a16="http://schemas.microsoft.com/office/drawing/2014/main" id="{212C4320-55F4-451A-9F93-15B6C040DA27}"/>
+                <a16:creationId xmlns:a16="http://schemas.microsoft.com/office/drawing/2014/main" id="{EB306CAD-AA95-4032-BDAD-5DA339FCDD16}"/>
               </a:ext>
             </a:extLst>
           </p:cNvPr>
@@ -1001,7 +1001,7 @@
           <p:cNvPr id="2" name="Subtitle">
             <a:extLst xmlns:a="http://schemas.openxmlformats.org/drawingml/2006/main">
               <a:ext uri="{FF2B5EF4-FFF2-40B4-BE49-F238E27FC236}">
-                <a16:creationId xmlns:a16="http://schemas.microsoft.com/office/drawing/2014/main" id="{004550C4-D16A-4DAD-BBE6-DFBC4CF667F1}"/>
+                <a16:creationId xmlns:a16="http://schemas.microsoft.com/office/drawing/2014/main" id="{7843DC9D-2BDB-453B-9DB5-9747AEF040F2}"/>
               </a:ext>
             </a:extLst>
           </p:cNvPr>
@@ -1175,7 +1175,7 @@
           <p:cNvPr id="2" name="Section title">
             <a:extLst xmlns:a="http://schemas.openxmlformats.org/drawingml/2006/main">
               <a:ext uri="{FF2B5EF4-FFF2-40B4-BE49-F238E27FC236}">
-                <a16:creationId xmlns:a16="http://schemas.microsoft.com/office/drawing/2014/main" id="{E9F5D719-9CEC-4864-9B01-04522898CECD}"/>
+                <a16:creationId xmlns:a16="http://schemas.microsoft.com/office/drawing/2014/main" id="{F642F8EA-32B7-445F-9971-4A4199DD276D}"/>
               </a:ext>
             </a:extLst>
           </p:cNvPr>
@@ -1349,7 +1349,7 @@
           <p:cNvPr id="3" name="Title">
             <a:extLst xmlns:a="http://schemas.openxmlformats.org/drawingml/2006/main">
               <a:ext uri="{FF2B5EF4-FFF2-40B4-BE49-F238E27FC236}">
-                <a16:creationId xmlns:a16="http://schemas.microsoft.com/office/drawing/2014/main" id="{DA87170E-32E8-48B5-9CCB-159C432CBB46}"/>
+                <a16:creationId xmlns:a16="http://schemas.microsoft.com/office/drawing/2014/main" id="{205EBA84-8FA7-4282-B3E3-F12AF33B2C33}"/>
               </a:ext>
             </a:extLst>
           </p:cNvPr>
@@ -1506,7 +1506,7 @@
           <p:cNvPr id="2" name="Body">
             <a:extLst xmlns:a="http://schemas.openxmlformats.org/drawingml/2006/main">
               <a:ext uri="{FF2B5EF4-FFF2-40B4-BE49-F238E27FC236}">
-                <a16:creationId xmlns:a16="http://schemas.microsoft.com/office/drawing/2014/main" id="{85D56F0C-29B1-45F8-B1C6-118944F42490}"/>
+                <a16:creationId xmlns:a16="http://schemas.microsoft.com/office/drawing/2014/main" id="{BA670E81-912D-4476-A39F-3886667C4CA9}"/>
               </a:ext>
             </a:extLst>
           </p:cNvPr>
@@ -1680,7 +1680,7 @@
           <p:cNvPr id="4" name="Title">
             <a:extLst xmlns:a="http://schemas.openxmlformats.org/drawingml/2006/main">
               <a:ext uri="{FF2B5EF4-FFF2-40B4-BE49-F238E27FC236}">
-                <a16:creationId xmlns:a16="http://schemas.microsoft.com/office/drawing/2014/main" id="{57F990DB-54DF-4620-9B16-96AE406C0C45}"/>
+                <a16:creationId xmlns:a16="http://schemas.microsoft.com/office/drawing/2014/main" id="{AE430557-56B6-46A5-8F69-E3B5123F96DA}"/>
               </a:ext>
             </a:extLst>
           </p:cNvPr>
@@ -1837,7 +1837,7 @@
           <p:cNvPr id="2" name="Left column">
             <a:extLst xmlns:a="http://schemas.openxmlformats.org/drawingml/2006/main">
               <a:ext uri="{FF2B5EF4-FFF2-40B4-BE49-F238E27FC236}">
-                <a16:creationId xmlns:a16="http://schemas.microsoft.com/office/drawing/2014/main" id="{EF5674FD-08EC-43D2-942E-A01336C741CA}"/>
+                <a16:creationId xmlns:a16="http://schemas.microsoft.com/office/drawing/2014/main" id="{28D073BA-E89F-40AA-A524-93D0164A59E9}"/>
               </a:ext>
             </a:extLst>
           </p:cNvPr>
@@ -1994,7 +1994,7 @@
           <p:cNvPr id="3" name="Right column">
             <a:extLst xmlns:a="http://schemas.openxmlformats.org/drawingml/2006/main">
               <a:ext uri="{FF2B5EF4-FFF2-40B4-BE49-F238E27FC236}">
-                <a16:creationId xmlns:a16="http://schemas.microsoft.com/office/drawing/2014/main" id="{7A31F389-341D-4774-8037-4E6467EA2A30}"/>
+                <a16:creationId xmlns:a16="http://schemas.microsoft.com/office/drawing/2014/main" id="{12524E09-0BE1-4DA8-8449-375BDFA1926C}"/>
               </a:ext>
             </a:extLst>
           </p:cNvPr>
@@ -2168,7 +2168,7 @@
           <p:cNvPr id="3" name="Title">
             <a:extLst xmlns:a="http://schemas.openxmlformats.org/drawingml/2006/main">
               <a:ext uri="{FF2B5EF4-FFF2-40B4-BE49-F238E27FC236}">
-                <a16:creationId xmlns:a16="http://schemas.microsoft.com/office/drawing/2014/main" id="{100995E1-A0F0-4273-902D-990EEC9EE772}"/>
+                <a16:creationId xmlns:a16="http://schemas.microsoft.com/office/drawing/2014/main" id="{08F63CD9-08A9-49AC-A626-6ABBA8B1987A}"/>
               </a:ext>
             </a:extLst>
           </p:cNvPr>
@@ -2325,7 +2325,7 @@
           <p:cNvPr id="2" name="Left column">
             <a:extLst xmlns:a="http://schemas.openxmlformats.org/drawingml/2006/main">
               <a:ext uri="{FF2B5EF4-FFF2-40B4-BE49-F238E27FC236}">
-                <a16:creationId xmlns:a16="http://schemas.microsoft.com/office/drawing/2014/main" id="{A2F2EB13-46A4-4DF7-AAD0-2115663F8779}"/>
+                <a16:creationId xmlns:a16="http://schemas.microsoft.com/office/drawing/2014/main" id="{D35B4B70-C830-47A6-87D8-BA925085C6C2}"/>
               </a:ext>
             </a:extLst>
           </p:cNvPr>
@@ -2520,12 +2520,12 @@
   </p:cSld>
   <p:clrMap bg1="lt1" tx1="dk1" bg2="lt2" tx2="dk2" accent1="accent1" accent2="accent2" accent3="accent3" accent4="accent4" accent5="accent5" accent6="accent6" hlink="hlink" folHlink="folHlink"/>
   <p:sldLayoutIdLst>
-    <p:sldLayoutId xmlns:r="http://schemas.openxmlformats.org/officeDocument/2006/relationships" id="2147483649" r:id="R456c212460b54b86"/>
-    <p:sldLayoutId xmlns:r="http://schemas.openxmlformats.org/officeDocument/2006/relationships" id="2147483650" r:id="R0eea063b70714d96"/>
-    <p:sldLayoutId xmlns:r="http://schemas.openxmlformats.org/officeDocument/2006/relationships" id="2147483651" r:id="R41b3f6c529f44fac"/>
-    <p:sldLayoutId xmlns:r="http://schemas.openxmlformats.org/officeDocument/2006/relationships" id="2147483652" r:id="R86371bf272b14c10"/>
-    <p:sldLayoutId xmlns:r="http://schemas.openxmlformats.org/officeDocument/2006/relationships" id="2147483653" r:id="R1436cbb8e9aa4e49"/>
-    <p:sldLayoutId xmlns:r="http://schemas.openxmlformats.org/officeDocument/2006/relationships" id="2147483654" r:id="R63a464b8bc354373"/>
+    <p:sldLayoutId xmlns:r="http://schemas.openxmlformats.org/officeDocument/2006/relationships" id="2147483649" r:id="R97496ab6f5a248dc"/>
+    <p:sldLayoutId xmlns:r="http://schemas.openxmlformats.org/officeDocument/2006/relationships" id="2147483650" r:id="R886745a8f2b84dde"/>
+    <p:sldLayoutId xmlns:r="http://schemas.openxmlformats.org/officeDocument/2006/relationships" id="2147483651" r:id="R2f21591489d348c1"/>
+    <p:sldLayoutId xmlns:r="http://schemas.openxmlformats.org/officeDocument/2006/relationships" id="2147483652" r:id="R0b096217ade64c23"/>
+    <p:sldLayoutId xmlns:r="http://schemas.openxmlformats.org/officeDocument/2006/relationships" id="2147483653" r:id="R39a1383072214ebf"/>
+    <p:sldLayoutId xmlns:r="http://schemas.openxmlformats.org/officeDocument/2006/relationships" id="2147483654" r:id="R0b3e213e5fc249f3"/>
   </p:sldLayoutIdLst>
   <p:txStyles>
     <p:titleStyle>
@@ -3076,7 +3076,7 @@
           <p:cNvPr id="27" name="">
             <a:extLst xmlns:a="http://schemas.openxmlformats.org/drawingml/2006/main">
               <a:ext uri="{FF2B5EF4-FFF2-40B4-BE49-F238E27FC236}">
-                <a16:creationId xmlns:a16="http://schemas.microsoft.com/office/drawing/2014/main" id="{8E446897-6FD4-411B-88A1-8A9E4EABBC6C}"/>
+                <a16:creationId xmlns:a16="http://schemas.microsoft.com/office/drawing/2014/main" id="{7F781E14-4A37-4EC8-98F0-13ACC998BB6D}"/>
               </a:ext>
             </a:extLst>
           </p:cNvPr>
@@ -3109,7 +3109,7 @@
           <p:cNvPr id="2" name="">
             <a:extLst xmlns:a="http://schemas.openxmlformats.org/drawingml/2006/main">
               <a:ext uri="{FF2B5EF4-FFF2-40B4-BE49-F238E27FC236}">
-                <a16:creationId xmlns:a16="http://schemas.microsoft.com/office/drawing/2014/main" id="{ADAF6E83-0EF0-40E1-B8D9-D1D265AE76D6}"/>
+                <a16:creationId xmlns:a16="http://schemas.microsoft.com/office/drawing/2014/main" id="{39C845ED-5434-4ED5-A4BA-20BF36BC7BC7}"/>
               </a:ext>
             </a:extLst>
           </p:cNvPr>
@@ -3144,7 +3144,7 @@
           <p:cNvPr id="3" name="">
             <a:extLst xmlns:a="http://schemas.openxmlformats.org/drawingml/2006/main">
               <a:ext uri="{FF2B5EF4-FFF2-40B4-BE49-F238E27FC236}">
-                <a16:creationId xmlns:a16="http://schemas.microsoft.com/office/drawing/2014/main" id="{0739EF4D-DB37-4F6E-B668-7D89FB343C20}"/>
+                <a16:creationId xmlns:a16="http://schemas.microsoft.com/office/drawing/2014/main" id="{896CE5C2-F7DD-491E-9C00-C3099D808D90}"/>
               </a:ext>
             </a:extLst>
           </p:cNvPr>
@@ -3177,7 +3177,7 @@
           <p:cNvPr id="4" name="">
             <a:extLst xmlns:a="http://schemas.openxmlformats.org/drawingml/2006/main">
               <a:ext uri="{FF2B5EF4-FFF2-40B4-BE49-F238E27FC236}">
-                <a16:creationId xmlns:a16="http://schemas.microsoft.com/office/drawing/2014/main" id="{4DECEA71-64B6-45E7-A52E-A40BD8E1DEF6}"/>
+                <a16:creationId xmlns:a16="http://schemas.microsoft.com/office/drawing/2014/main" id="{A982FE7A-EFA3-42C0-8A48-2E378AF13EC6}"/>
               </a:ext>
             </a:extLst>
           </p:cNvPr>
@@ -3235,7 +3235,7 @@
           <p:cNvPr id="5" name="">
             <a:extLst xmlns:a="http://schemas.openxmlformats.org/drawingml/2006/main">
               <a:ext uri="{FF2B5EF4-FFF2-40B4-BE49-F238E27FC236}">
-                <a16:creationId xmlns:a16="http://schemas.microsoft.com/office/drawing/2014/main" id="{347A6C8B-AEDC-4F11-8D08-B4DFBD6716B9}"/>
+                <a16:creationId xmlns:a16="http://schemas.microsoft.com/office/drawing/2014/main" id="{ACF98C53-B97C-41A2-A491-CF87225D2610}"/>
               </a:ext>
             </a:extLst>
           </p:cNvPr>
@@ -3268,7 +3268,7 @@
           <p:cNvPr id="6" name="">
             <a:extLst xmlns:a="http://schemas.openxmlformats.org/drawingml/2006/main">
               <a:ext uri="{FF2B5EF4-FFF2-40B4-BE49-F238E27FC236}">
-                <a16:creationId xmlns:a16="http://schemas.microsoft.com/office/drawing/2014/main" id="{BEB202C4-153F-4606-8143-195D48634F33}"/>
+                <a16:creationId xmlns:a16="http://schemas.microsoft.com/office/drawing/2014/main" id="{7CBA46AC-BBE4-4B86-B4AB-AB12BD6A8652}"/>
               </a:ext>
             </a:extLst>
           </p:cNvPr>
@@ -3301,7 +3301,7 @@
           <p:cNvPr id="7" name="">
             <a:extLst xmlns:a="http://schemas.openxmlformats.org/drawingml/2006/main">
               <a:ext uri="{FF2B5EF4-FFF2-40B4-BE49-F238E27FC236}">
-                <a16:creationId xmlns:a16="http://schemas.microsoft.com/office/drawing/2014/main" id="{AC60E135-A747-49BC-9258-B4D67E9CE7EC}"/>
+                <a16:creationId xmlns:a16="http://schemas.microsoft.com/office/drawing/2014/main" id="{F205AA90-F6CB-47E2-80F0-5739A870BCC3}"/>
               </a:ext>
             </a:extLst>
           </p:cNvPr>
@@ -3359,7 +3359,7 @@
           <p:cNvPr id="8" name="">
             <a:extLst xmlns:a="http://schemas.openxmlformats.org/drawingml/2006/main">
               <a:ext uri="{FF2B5EF4-FFF2-40B4-BE49-F238E27FC236}">
-                <a16:creationId xmlns:a16="http://schemas.microsoft.com/office/drawing/2014/main" id="{468065DC-2BBA-48CA-A024-5BAE603D87CE}"/>
+                <a16:creationId xmlns:a16="http://schemas.microsoft.com/office/drawing/2014/main" id="{B89F9FE8-5CF3-451E-94B4-2F29ACAC2A59}"/>
               </a:ext>
             </a:extLst>
           </p:cNvPr>
@@ -3392,7 +3392,7 @@
           <p:cNvPr id="9" name="">
             <a:extLst xmlns:a="http://schemas.openxmlformats.org/drawingml/2006/main">
               <a:ext uri="{FF2B5EF4-FFF2-40B4-BE49-F238E27FC236}">
-                <a16:creationId xmlns:a16="http://schemas.microsoft.com/office/drawing/2014/main" id="{3BE3FAF1-1685-4A90-930D-EFD06F345BC9}"/>
+                <a16:creationId xmlns:a16="http://schemas.microsoft.com/office/drawing/2014/main" id="{70AD722C-3CC6-4CB1-93FA-1BC2CEBA68C3}"/>
               </a:ext>
             </a:extLst>
           </p:cNvPr>
@@ -3425,7 +3425,7 @@
           <p:cNvPr id="10" name="">
             <a:extLst xmlns:a="http://schemas.openxmlformats.org/drawingml/2006/main">
               <a:ext uri="{FF2B5EF4-FFF2-40B4-BE49-F238E27FC236}">
-                <a16:creationId xmlns:a16="http://schemas.microsoft.com/office/drawing/2014/main" id="{E5E6D2B4-D679-4F64-9B01-44B099D0B5D3}"/>
+                <a16:creationId xmlns:a16="http://schemas.microsoft.com/office/drawing/2014/main" id="{3B16B055-C46D-4E02-9ADC-31F6088544B7}"/>
               </a:ext>
             </a:extLst>
           </p:cNvPr>
@@ -3483,7 +3483,7 @@
           <p:cNvPr id="11" name="">
             <a:extLst xmlns:a="http://schemas.openxmlformats.org/drawingml/2006/main">
               <a:ext uri="{FF2B5EF4-FFF2-40B4-BE49-F238E27FC236}">
-                <a16:creationId xmlns:a16="http://schemas.microsoft.com/office/drawing/2014/main" id="{A2026BB4-95EF-4DFE-B51D-B6C56B7B2307}"/>
+                <a16:creationId xmlns:a16="http://schemas.microsoft.com/office/drawing/2014/main" id="{F39E45DF-AA2E-4862-8C71-232AC9AE4968}"/>
               </a:ext>
             </a:extLst>
           </p:cNvPr>
@@ -3516,7 +3516,7 @@
           <p:cNvPr id="12" name="">
             <a:extLst xmlns:a="http://schemas.openxmlformats.org/drawingml/2006/main">
               <a:ext uri="{FF2B5EF4-FFF2-40B4-BE49-F238E27FC236}">
-                <a16:creationId xmlns:a16="http://schemas.microsoft.com/office/drawing/2014/main" id="{F2EB5D66-6C6A-40D0-A2FA-DC9D85E6515D}"/>
+                <a16:creationId xmlns:a16="http://schemas.microsoft.com/office/drawing/2014/main" id="{9C46FF8B-E913-4EA3-9A78-DD60EEC49A92}"/>
               </a:ext>
             </a:extLst>
           </p:cNvPr>
@@ -3549,7 +3549,7 @@
           <p:cNvPr id="13" name="">
             <a:extLst xmlns:a="http://schemas.openxmlformats.org/drawingml/2006/main">
               <a:ext uri="{FF2B5EF4-FFF2-40B4-BE49-F238E27FC236}">
-                <a16:creationId xmlns:a16="http://schemas.microsoft.com/office/drawing/2014/main" id="{F281A855-86DB-4DB7-B844-7C4137F1B4FA}"/>
+                <a16:creationId xmlns:a16="http://schemas.microsoft.com/office/drawing/2014/main" id="{1CDEA71D-34DB-4B2E-830F-BF2DDDF810E3}"/>
               </a:ext>
             </a:extLst>
           </p:cNvPr>
@@ -3607,7 +3607,7 @@
           <p:cNvPr id="14" name="">
             <a:extLst xmlns:a="http://schemas.openxmlformats.org/drawingml/2006/main">
               <a:ext uri="{FF2B5EF4-FFF2-40B4-BE49-F238E27FC236}">
-                <a16:creationId xmlns:a16="http://schemas.microsoft.com/office/drawing/2014/main" id="{F3CEDDB9-49CF-4970-A503-B4406A3F2069}"/>
+                <a16:creationId xmlns:a16="http://schemas.microsoft.com/office/drawing/2014/main" id="{F49CF0B3-798F-4D03-8854-ABE54742D27D}"/>
               </a:ext>
             </a:extLst>
           </p:cNvPr>
@@ -3682,7 +3682,7 @@
           <p:cNvPr id="15" name="">
             <a:extLst xmlns:a="http://schemas.openxmlformats.org/drawingml/2006/main">
               <a:ext uri="{FF2B5EF4-FFF2-40B4-BE49-F238E27FC236}">
-                <a16:creationId xmlns:a16="http://schemas.microsoft.com/office/drawing/2014/main" id="{C331DBA0-537A-40A8-84D2-B48B003153B9}"/>
+                <a16:creationId xmlns:a16="http://schemas.microsoft.com/office/drawing/2014/main" id="{62D2C13B-CD79-495F-A3FA-3FA1228824FF}"/>
               </a:ext>
             </a:extLst>
           </p:cNvPr>
@@ -3740,7 +3740,7 @@
           <p:cNvPr id="16" name="">
             <a:extLst xmlns:a="http://schemas.openxmlformats.org/drawingml/2006/main">
               <a:ext uri="{FF2B5EF4-FFF2-40B4-BE49-F238E27FC236}">
-                <a16:creationId xmlns:a16="http://schemas.microsoft.com/office/drawing/2014/main" id="{5294C9D3-D099-4A32-9DF1-F24AA4610D0C}"/>
+                <a16:creationId xmlns:a16="http://schemas.microsoft.com/office/drawing/2014/main" id="{FE97397D-42F8-4E64-A08F-7C2607189DA7}"/>
               </a:ext>
             </a:extLst>
           </p:cNvPr>
@@ -3788,7 +3788,7 @@
                   <a:srgbClr val="A9C1D2"/>
                 </a:solidFill>
               </a:rPr>
-              <a:t>A practical 10-minute lab story: DPDK data plane, BGP routing, CGNAT, and repeatable Helm operations.</a:t>
+              <a:t>A practical 10-minute deployment story: DPDK data plane, BGP routing, CGNAT, and repeatable Helm operations.</a:t>
             </a:r>
           </a:p>
         </p:txBody>
@@ -3798,7 +3798,7 @@
           <p:cNvPr id="17" name="">
             <a:extLst xmlns:a="http://schemas.openxmlformats.org/drawingml/2006/main">
               <a:ext uri="{FF2B5EF4-FFF2-40B4-BE49-F238E27FC236}">
-                <a16:creationId xmlns:a16="http://schemas.microsoft.com/office/drawing/2014/main" id="{88CDA69F-1763-4409-8C21-0C2D498C1679}"/>
+                <a16:creationId xmlns:a16="http://schemas.microsoft.com/office/drawing/2014/main" id="{1E0B2C45-CFAB-4ACD-8733-488AD8D53A44}"/>
               </a:ext>
             </a:extLst>
           </p:cNvPr>
@@ -3831,7 +3831,7 @@
           <p:cNvPr id="18" name="">
             <a:extLst xmlns:a="http://schemas.openxmlformats.org/drawingml/2006/main">
               <a:ext uri="{FF2B5EF4-FFF2-40B4-BE49-F238E27FC236}">
-                <a16:creationId xmlns:a16="http://schemas.microsoft.com/office/drawing/2014/main" id="{9E31D3F2-D9D2-4547-A481-70C58D337467}"/>
+                <a16:creationId xmlns:a16="http://schemas.microsoft.com/office/drawing/2014/main" id="{CB54DF6B-0163-47CF-BC51-E9B57F25FA3C}"/>
               </a:ext>
             </a:extLst>
           </p:cNvPr>
@@ -3889,7 +3889,7 @@
           <p:cNvPr id="19" name="">
             <a:extLst xmlns:a="http://schemas.openxmlformats.org/drawingml/2006/main">
               <a:ext uri="{FF2B5EF4-FFF2-40B4-BE49-F238E27FC236}">
-                <a16:creationId xmlns:a16="http://schemas.microsoft.com/office/drawing/2014/main" id="{7DEDA17B-06C0-432A-B2AB-E0C70367EC87}"/>
+                <a16:creationId xmlns:a16="http://schemas.microsoft.com/office/drawing/2014/main" id="{1F693526-2EAE-49EE-9DC4-C2A8D0861DFC}"/>
               </a:ext>
             </a:extLst>
           </p:cNvPr>
@@ -3922,7 +3922,7 @@
           <p:cNvPr id="20" name="">
             <a:extLst xmlns:a="http://schemas.openxmlformats.org/drawingml/2006/main">
               <a:ext uri="{FF2B5EF4-FFF2-40B4-BE49-F238E27FC236}">
-                <a16:creationId xmlns:a16="http://schemas.microsoft.com/office/drawing/2014/main" id="{62BFD3D7-9CE3-40D9-8983-849E8A844858}"/>
+                <a16:creationId xmlns:a16="http://schemas.microsoft.com/office/drawing/2014/main" id="{BFECE7AF-8ADE-4998-B9FE-168B329E19C9}"/>
               </a:ext>
             </a:extLst>
           </p:cNvPr>
@@ -3980,7 +3980,7 @@
           <p:cNvPr id="21" name="">
             <a:extLst xmlns:a="http://schemas.openxmlformats.org/drawingml/2006/main">
               <a:ext uri="{FF2B5EF4-FFF2-40B4-BE49-F238E27FC236}">
-                <a16:creationId xmlns:a16="http://schemas.microsoft.com/office/drawing/2014/main" id="{CD72BBD8-8C8C-4129-BB92-738031BED81C}"/>
+                <a16:creationId xmlns:a16="http://schemas.microsoft.com/office/drawing/2014/main" id="{D658371D-16FD-406A-A22C-4B4E9F76310B}"/>
               </a:ext>
             </a:extLst>
           </p:cNvPr>
@@ -4013,7 +4013,7 @@
           <p:cNvPr id="22" name="">
             <a:extLst xmlns:a="http://schemas.openxmlformats.org/drawingml/2006/main">
               <a:ext uri="{FF2B5EF4-FFF2-40B4-BE49-F238E27FC236}">
-                <a16:creationId xmlns:a16="http://schemas.microsoft.com/office/drawing/2014/main" id="{F38543B8-0851-4206-AFDA-584A189CE5A6}"/>
+                <a16:creationId xmlns:a16="http://schemas.microsoft.com/office/drawing/2014/main" id="{178D2B73-CDC6-45C7-A39E-B2E0520BF469}"/>
               </a:ext>
             </a:extLst>
           </p:cNvPr>
@@ -4071,7 +4071,7 @@
           <p:cNvPr id="23" name="">
             <a:extLst xmlns:a="http://schemas.openxmlformats.org/drawingml/2006/main">
               <a:ext uri="{FF2B5EF4-FFF2-40B4-BE49-F238E27FC236}">
-                <a16:creationId xmlns:a16="http://schemas.microsoft.com/office/drawing/2014/main" id="{15DD6787-6BE2-4F4B-821C-65A76318413C}"/>
+                <a16:creationId xmlns:a16="http://schemas.microsoft.com/office/drawing/2014/main" id="{F1F69E3B-E306-4B0C-B3BF-7A6C931E3702}"/>
               </a:ext>
             </a:extLst>
           </p:cNvPr>
@@ -4083,7 +4083,7 @@
         <p:spPr>
           <a:xfrm xmlns:a="http://schemas.openxmlformats.org/drawingml/2006/main">
             <a:off x="685800" y="5905500"/>
-            <a:ext cx="4286250" cy="228600"/>
+            <a:ext cx="4953000" cy="228600"/>
           </a:xfrm>
           <a:prstGeom xmlns:a="http://schemas.openxmlformats.org/drawingml/2006/main" prst="rect">
             <a:avLst/>
@@ -4119,7 +4119,7 @@
                   <a:srgbClr val="A9C1D2"/>
                 </a:solidFill>
               </a:rPr>
-              <a:t>Infinitydon lab • October 2026</a:t>
+              <a:t>Presented by Christopher Adigun • October 2026</a:t>
             </a:r>
           </a:p>
         </p:txBody>
@@ -4129,7 +4129,7 @@
           <p:cNvPr id="24" name="">
             <a:extLst xmlns:a="http://schemas.openxmlformats.org/drawingml/2006/main">
               <a:ext uri="{FF2B5EF4-FFF2-40B4-BE49-F238E27FC236}">
-                <a16:creationId xmlns:a16="http://schemas.microsoft.com/office/drawing/2014/main" id="{C6690AB0-E904-4526-9353-13C991CC8490}"/>
+                <a16:creationId xmlns:a16="http://schemas.microsoft.com/office/drawing/2014/main" id="{D366E2E0-9D72-4FDF-85C5-55B53ECFAB3F}"/>
               </a:ext>
             </a:extLst>
           </p:cNvPr>
@@ -4162,7 +4162,7 @@
           <p:cNvPr id="25" name="">
             <a:extLst xmlns:a="http://schemas.openxmlformats.org/drawingml/2006/main">
               <a:ext uri="{FF2B5EF4-FFF2-40B4-BE49-F238E27FC236}">
-                <a16:creationId xmlns:a16="http://schemas.microsoft.com/office/drawing/2014/main" id="{18F01F30-ADD2-49D6-8227-F37EEFB50644}"/>
+                <a16:creationId xmlns:a16="http://schemas.microsoft.com/office/drawing/2014/main" id="{59A66930-BC11-426E-ABCC-4D67B88E7C75}"/>
               </a:ext>
             </a:extLst>
           </p:cNvPr>
@@ -4208,7 +4208,7 @@
           <p:cNvPr id="26" name="">
             <a:extLst xmlns:a="http://schemas.openxmlformats.org/drawingml/2006/main">
               <a:ext uri="{FF2B5EF4-FFF2-40B4-BE49-F238E27FC236}">
-                <a16:creationId xmlns:a16="http://schemas.microsoft.com/office/drawing/2014/main" id="{11069C07-1061-4C58-91A2-58041E095ED6}"/>
+                <a16:creationId xmlns:a16="http://schemas.microsoft.com/office/drawing/2014/main" id="{45D90558-7BCB-4D92-BB9B-D0BB903F3C60}"/>
               </a:ext>
             </a:extLst>
           </p:cNvPr>
@@ -4264,7 +4264,7 @@
     </p:spTree>
     <p:extLst>
       <p:ext uri="{BB962C8B-B14F-4D97-AF65-F5344CB8AC3E}">
-        <p14:creationId xmlns:p14="http://schemas.microsoft.com/office/powerpoint/2010/main" val="1380044567"/>
+        <p14:creationId xmlns:p14="http://schemas.microsoft.com/office/powerpoint/2010/main" val="710938844"/>
       </p:ext>
     </p:extLst>
   </p:cSld>
@@ -4295,7 +4295,7 @@
           <p:cNvPr id="30" name="">
             <a:extLst xmlns:a="http://schemas.openxmlformats.org/drawingml/2006/main">
               <a:ext uri="{FF2B5EF4-FFF2-40B4-BE49-F238E27FC236}">
-                <a16:creationId xmlns:a16="http://schemas.microsoft.com/office/drawing/2014/main" id="{2126DCD6-0155-4748-A27A-E299EF9BC15E}"/>
+                <a16:creationId xmlns:a16="http://schemas.microsoft.com/office/drawing/2014/main" id="{FE91AA9D-4130-4113-8D70-7C5BEF0FFB9D}"/>
               </a:ext>
             </a:extLst>
           </p:cNvPr>
@@ -4353,7 +4353,7 @@
           <p:cNvPr id="2" name="">
             <a:extLst xmlns:a="http://schemas.openxmlformats.org/drawingml/2006/main">
               <a:ext uri="{FF2B5EF4-FFF2-40B4-BE49-F238E27FC236}">
-                <a16:creationId xmlns:a16="http://schemas.microsoft.com/office/drawing/2014/main" id="{651921BA-86BA-4B24-B1C4-746752A31600}"/>
+                <a16:creationId xmlns:a16="http://schemas.microsoft.com/office/drawing/2014/main" id="{4A9369A0-BA94-40BF-ABFF-B7F64EEB96ED}"/>
               </a:ext>
             </a:extLst>
           </p:cNvPr>
@@ -4411,7 +4411,7 @@
           <p:cNvPr id="3" name="">
             <a:extLst xmlns:a="http://schemas.openxmlformats.org/drawingml/2006/main">
               <a:ext uri="{FF2B5EF4-FFF2-40B4-BE49-F238E27FC236}">
-                <a16:creationId xmlns:a16="http://schemas.microsoft.com/office/drawing/2014/main" id="{820A5228-815B-4EEC-9DEB-BAC69BC45345}"/>
+                <a16:creationId xmlns:a16="http://schemas.microsoft.com/office/drawing/2014/main" id="{4FAC5BAE-616B-4B1F-B9D2-72FEEAE57A7A}"/>
               </a:ext>
             </a:extLst>
           </p:cNvPr>
@@ -4469,7 +4469,7 @@
           <p:cNvPr id="4" name="">
             <a:extLst xmlns:a="http://schemas.openxmlformats.org/drawingml/2006/main">
               <a:ext uri="{FF2B5EF4-FFF2-40B4-BE49-F238E27FC236}">
-                <a16:creationId xmlns:a16="http://schemas.microsoft.com/office/drawing/2014/main" id="{BBFC3CF7-EFCA-41F2-9C28-825A16480F39}"/>
+                <a16:creationId xmlns:a16="http://schemas.microsoft.com/office/drawing/2014/main" id="{55BD8822-1651-46B6-BC01-F2466B48CCE5}"/>
               </a:ext>
             </a:extLst>
           </p:cNvPr>
@@ -4504,7 +4504,7 @@
           <p:cNvPr id="5" name="">
             <a:extLst xmlns:a="http://schemas.openxmlformats.org/drawingml/2006/main">
               <a:ext uri="{FF2B5EF4-FFF2-40B4-BE49-F238E27FC236}">
-                <a16:creationId xmlns:a16="http://schemas.microsoft.com/office/drawing/2014/main" id="{DCD54543-B3E7-4648-B917-A862958F7D6B}"/>
+                <a16:creationId xmlns:a16="http://schemas.microsoft.com/office/drawing/2014/main" id="{BDE39197-32D1-4FF5-9BBF-DC7D43FFA181}"/>
               </a:ext>
             </a:extLst>
           </p:cNvPr>
@@ -4537,7 +4537,7 @@
           <p:cNvPr id="6" name="">
             <a:extLst xmlns:a="http://schemas.openxmlformats.org/drawingml/2006/main">
               <a:ext uri="{FF2B5EF4-FFF2-40B4-BE49-F238E27FC236}">
-                <a16:creationId xmlns:a16="http://schemas.microsoft.com/office/drawing/2014/main" id="{8C5D51EE-80CF-4D58-82B2-E19A674FE57A}"/>
+                <a16:creationId xmlns:a16="http://schemas.microsoft.com/office/drawing/2014/main" id="{A667A50D-F8BD-4E1B-86F9-F9692F72DEEB}"/>
               </a:ext>
             </a:extLst>
           </p:cNvPr>
@@ -4595,7 +4595,7 @@
           <p:cNvPr id="7" name="">
             <a:extLst xmlns:a="http://schemas.openxmlformats.org/drawingml/2006/main">
               <a:ext uri="{FF2B5EF4-FFF2-40B4-BE49-F238E27FC236}">
-                <a16:creationId xmlns:a16="http://schemas.microsoft.com/office/drawing/2014/main" id="{936AE44E-DE12-4013-886A-F09784919A71}"/>
+                <a16:creationId xmlns:a16="http://schemas.microsoft.com/office/drawing/2014/main" id="{F7A11C97-E787-4AD7-A142-6CC00A4E2C36}"/>
               </a:ext>
             </a:extLst>
           </p:cNvPr>
@@ -4653,7 +4653,7 @@
           <p:cNvPr id="8" name="">
             <a:extLst xmlns:a="http://schemas.openxmlformats.org/drawingml/2006/main">
               <a:ext uri="{FF2B5EF4-FFF2-40B4-BE49-F238E27FC236}">
-                <a16:creationId xmlns:a16="http://schemas.microsoft.com/office/drawing/2014/main" id="{3798CBA2-1319-43C7-8DBA-93D8FD565475}"/>
+                <a16:creationId xmlns:a16="http://schemas.microsoft.com/office/drawing/2014/main" id="{E209B841-C2BE-4119-9819-ABD056691AB9}"/>
               </a:ext>
             </a:extLst>
           </p:cNvPr>
@@ -4728,7 +4728,7 @@
           <p:cNvPr id="9" name="">
             <a:extLst xmlns:a="http://schemas.openxmlformats.org/drawingml/2006/main">
               <a:ext uri="{FF2B5EF4-FFF2-40B4-BE49-F238E27FC236}">
-                <a16:creationId xmlns:a16="http://schemas.microsoft.com/office/drawing/2014/main" id="{761AD713-A9CD-451E-8CD4-105A8E2071E8}"/>
+                <a16:creationId xmlns:a16="http://schemas.microsoft.com/office/drawing/2014/main" id="{45A567EA-14C9-4831-8F70-12A20A3A8771}"/>
               </a:ext>
             </a:extLst>
           </p:cNvPr>
@@ -4763,7 +4763,7 @@
           <p:cNvPr id="10" name="">
             <a:extLst xmlns:a="http://schemas.openxmlformats.org/drawingml/2006/main">
               <a:ext uri="{FF2B5EF4-FFF2-40B4-BE49-F238E27FC236}">
-                <a16:creationId xmlns:a16="http://schemas.microsoft.com/office/drawing/2014/main" id="{AE582499-D179-4D4A-8EC0-16834E9403C3}"/>
+                <a16:creationId xmlns:a16="http://schemas.microsoft.com/office/drawing/2014/main" id="{F8BDFB5A-027A-4A27-AB0C-99C7C735DA7E}"/>
               </a:ext>
             </a:extLst>
           </p:cNvPr>
@@ -4796,7 +4796,7 @@
           <p:cNvPr id="11" name="">
             <a:extLst xmlns:a="http://schemas.openxmlformats.org/drawingml/2006/main">
               <a:ext uri="{FF2B5EF4-FFF2-40B4-BE49-F238E27FC236}">
-                <a16:creationId xmlns:a16="http://schemas.microsoft.com/office/drawing/2014/main" id="{DF472120-AAEA-4485-BAC7-F5534871DC57}"/>
+                <a16:creationId xmlns:a16="http://schemas.microsoft.com/office/drawing/2014/main" id="{DDA3932D-CC48-4AEF-BCB2-94405A204467}"/>
               </a:ext>
             </a:extLst>
           </p:cNvPr>
@@ -4854,7 +4854,7 @@
           <p:cNvPr id="12" name="">
             <a:extLst xmlns:a="http://schemas.openxmlformats.org/drawingml/2006/main">
               <a:ext uri="{FF2B5EF4-FFF2-40B4-BE49-F238E27FC236}">
-                <a16:creationId xmlns:a16="http://schemas.microsoft.com/office/drawing/2014/main" id="{22873846-FF16-4CED-A6C5-5AFA9CF0B290}"/>
+                <a16:creationId xmlns:a16="http://schemas.microsoft.com/office/drawing/2014/main" id="{D1D2F086-1AEC-46EF-AE96-81C9DE465095}"/>
               </a:ext>
             </a:extLst>
           </p:cNvPr>
@@ -4912,7 +4912,7 @@
           <p:cNvPr id="13" name="">
             <a:extLst xmlns:a="http://schemas.openxmlformats.org/drawingml/2006/main">
               <a:ext uri="{FF2B5EF4-FFF2-40B4-BE49-F238E27FC236}">
-                <a16:creationId xmlns:a16="http://schemas.microsoft.com/office/drawing/2014/main" id="{759C4125-1CDC-452D-BFE9-F32AF7B82957}"/>
+                <a16:creationId xmlns:a16="http://schemas.microsoft.com/office/drawing/2014/main" id="{6DC25665-8A46-4B46-8A5A-29155EBA918E}"/>
               </a:ext>
             </a:extLst>
           </p:cNvPr>
@@ -4987,7 +4987,7 @@
           <p:cNvPr id="14" name="">
             <a:extLst xmlns:a="http://schemas.openxmlformats.org/drawingml/2006/main">
               <a:ext uri="{FF2B5EF4-FFF2-40B4-BE49-F238E27FC236}">
-                <a16:creationId xmlns:a16="http://schemas.microsoft.com/office/drawing/2014/main" id="{A05BF809-8ACC-43F8-8254-6260EFD0F0BE}"/>
+                <a16:creationId xmlns:a16="http://schemas.microsoft.com/office/drawing/2014/main" id="{D9F6E633-C6C8-4CBE-B1FF-167519C061D7}"/>
               </a:ext>
             </a:extLst>
           </p:cNvPr>
@@ -5022,7 +5022,7 @@
           <p:cNvPr id="15" name="">
             <a:extLst xmlns:a="http://schemas.openxmlformats.org/drawingml/2006/main">
               <a:ext uri="{FF2B5EF4-FFF2-40B4-BE49-F238E27FC236}">
-                <a16:creationId xmlns:a16="http://schemas.microsoft.com/office/drawing/2014/main" id="{7510DF26-8F18-4C42-9737-FE35921EA97E}"/>
+                <a16:creationId xmlns:a16="http://schemas.microsoft.com/office/drawing/2014/main" id="{71A9B322-D589-4FFB-9B53-B3ABABF34E88}"/>
               </a:ext>
             </a:extLst>
           </p:cNvPr>
@@ -5055,7 +5055,7 @@
           <p:cNvPr id="16" name="">
             <a:extLst xmlns:a="http://schemas.openxmlformats.org/drawingml/2006/main">
               <a:ext uri="{FF2B5EF4-FFF2-40B4-BE49-F238E27FC236}">
-                <a16:creationId xmlns:a16="http://schemas.microsoft.com/office/drawing/2014/main" id="{465ECFF0-51F0-4C61-93A1-A7845F9DC995}"/>
+                <a16:creationId xmlns:a16="http://schemas.microsoft.com/office/drawing/2014/main" id="{E57F0030-4891-430C-803E-E4722F79DA2B}"/>
               </a:ext>
             </a:extLst>
           </p:cNvPr>
@@ -5113,7 +5113,7 @@
           <p:cNvPr id="17" name="">
             <a:extLst xmlns:a="http://schemas.openxmlformats.org/drawingml/2006/main">
               <a:ext uri="{FF2B5EF4-FFF2-40B4-BE49-F238E27FC236}">
-                <a16:creationId xmlns:a16="http://schemas.microsoft.com/office/drawing/2014/main" id="{E966CAB4-83FC-42DD-B53F-7FFAE634A422}"/>
+                <a16:creationId xmlns:a16="http://schemas.microsoft.com/office/drawing/2014/main" id="{8D966A12-FD00-42FF-B34D-6C09DA55F22E}"/>
               </a:ext>
             </a:extLst>
           </p:cNvPr>
@@ -5171,7 +5171,7 @@
           <p:cNvPr id="18" name="">
             <a:extLst xmlns:a="http://schemas.openxmlformats.org/drawingml/2006/main">
               <a:ext uri="{FF2B5EF4-FFF2-40B4-BE49-F238E27FC236}">
-                <a16:creationId xmlns:a16="http://schemas.microsoft.com/office/drawing/2014/main" id="{BB7A353C-1CBF-4F1B-B5CD-F8D07CBA3A8A}"/>
+                <a16:creationId xmlns:a16="http://schemas.microsoft.com/office/drawing/2014/main" id="{DEA4E9A2-68F1-4184-A651-B10B9EFAAD1A}"/>
               </a:ext>
             </a:extLst>
           </p:cNvPr>
@@ -5246,7 +5246,7 @@
           <p:cNvPr id="19" name="">
             <a:extLst xmlns:a="http://schemas.openxmlformats.org/drawingml/2006/main">
               <a:ext uri="{FF2B5EF4-FFF2-40B4-BE49-F238E27FC236}">
-                <a16:creationId xmlns:a16="http://schemas.microsoft.com/office/drawing/2014/main" id="{9E22E6DE-53F4-463B-A49E-0B7B19EB6CC6}"/>
+                <a16:creationId xmlns:a16="http://schemas.microsoft.com/office/drawing/2014/main" id="{30A296FF-A30F-4FFC-ACC5-DAB211145A8D}"/>
               </a:ext>
             </a:extLst>
           </p:cNvPr>
@@ -5281,7 +5281,7 @@
           <p:cNvPr id="20" name="">
             <a:extLst xmlns:a="http://schemas.openxmlformats.org/drawingml/2006/main">
               <a:ext uri="{FF2B5EF4-FFF2-40B4-BE49-F238E27FC236}">
-                <a16:creationId xmlns:a16="http://schemas.microsoft.com/office/drawing/2014/main" id="{98368287-F3E7-4DD2-9F28-5FA2EF212144}"/>
+                <a16:creationId xmlns:a16="http://schemas.microsoft.com/office/drawing/2014/main" id="{66EBAB1C-A3B1-4A4D-8F3B-38A5C51AD314}"/>
               </a:ext>
             </a:extLst>
           </p:cNvPr>
@@ -5314,7 +5314,7 @@
           <p:cNvPr id="21" name="">
             <a:extLst xmlns:a="http://schemas.openxmlformats.org/drawingml/2006/main">
               <a:ext uri="{FF2B5EF4-FFF2-40B4-BE49-F238E27FC236}">
-                <a16:creationId xmlns:a16="http://schemas.microsoft.com/office/drawing/2014/main" id="{34573981-2E66-44A8-ACE4-26AA9067B1CE}"/>
+                <a16:creationId xmlns:a16="http://schemas.microsoft.com/office/drawing/2014/main" id="{2710F067-BFC9-4B5C-B50C-121349DAA5EE}"/>
               </a:ext>
             </a:extLst>
           </p:cNvPr>
@@ -5372,7 +5372,7 @@
           <p:cNvPr id="22" name="">
             <a:extLst xmlns:a="http://schemas.openxmlformats.org/drawingml/2006/main">
               <a:ext uri="{FF2B5EF4-FFF2-40B4-BE49-F238E27FC236}">
-                <a16:creationId xmlns:a16="http://schemas.microsoft.com/office/drawing/2014/main" id="{5FED8DAA-D59C-4C29-BFF9-3178D42C1324}"/>
+                <a16:creationId xmlns:a16="http://schemas.microsoft.com/office/drawing/2014/main" id="{A9D1D1B7-C166-497C-8138-40D98C004BED}"/>
               </a:ext>
             </a:extLst>
           </p:cNvPr>
@@ -5430,7 +5430,7 @@
           <p:cNvPr id="23" name="">
             <a:extLst xmlns:a="http://schemas.openxmlformats.org/drawingml/2006/main">
               <a:ext uri="{FF2B5EF4-FFF2-40B4-BE49-F238E27FC236}">
-                <a16:creationId xmlns:a16="http://schemas.microsoft.com/office/drawing/2014/main" id="{3DFD5D52-49D8-441F-B4F6-3F16CBDD4045}"/>
+                <a16:creationId xmlns:a16="http://schemas.microsoft.com/office/drawing/2014/main" id="{883CB6F3-F4AC-4B7B-9AAA-78BC468FA204}"/>
               </a:ext>
             </a:extLst>
           </p:cNvPr>
@@ -5505,7 +5505,7 @@
           <p:cNvPr id="24" name="">
             <a:extLst xmlns:a="http://schemas.openxmlformats.org/drawingml/2006/main">
               <a:ext uri="{FF2B5EF4-FFF2-40B4-BE49-F238E27FC236}">
-                <a16:creationId xmlns:a16="http://schemas.microsoft.com/office/drawing/2014/main" id="{228090F4-D53B-41FB-9BB8-6DE43403C420}"/>
+                <a16:creationId xmlns:a16="http://schemas.microsoft.com/office/drawing/2014/main" id="{E8B48078-8964-455F-9669-8FD98D5091DC}"/>
               </a:ext>
             </a:extLst>
           </p:cNvPr>
@@ -5538,7 +5538,7 @@
           <p:cNvPr id="25" name="">
             <a:extLst xmlns:a="http://schemas.openxmlformats.org/drawingml/2006/main">
               <a:ext uri="{FF2B5EF4-FFF2-40B4-BE49-F238E27FC236}">
-                <a16:creationId xmlns:a16="http://schemas.microsoft.com/office/drawing/2014/main" id="{49712DA3-81B5-4E1F-9405-77B86E401CEB}"/>
+                <a16:creationId xmlns:a16="http://schemas.microsoft.com/office/drawing/2014/main" id="{F8CBA29F-C370-405A-A700-96C57DA160A0}"/>
               </a:ext>
             </a:extLst>
           </p:cNvPr>
@@ -5596,7 +5596,7 @@
           <p:cNvPr id="26" name="">
             <a:extLst xmlns:a="http://schemas.openxmlformats.org/drawingml/2006/main">
               <a:ext uri="{FF2B5EF4-FFF2-40B4-BE49-F238E27FC236}">
-                <a16:creationId xmlns:a16="http://schemas.microsoft.com/office/drawing/2014/main" id="{CBB6930E-8145-4188-BCC9-DFDFF2E329BD}"/>
+                <a16:creationId xmlns:a16="http://schemas.microsoft.com/office/drawing/2014/main" id="{5B5D4849-2590-416D-8552-EB5B78A315E0}"/>
               </a:ext>
             </a:extLst>
           </p:cNvPr>
@@ -5654,7 +5654,7 @@
           <p:cNvPr id="27" name="">
             <a:extLst xmlns:a="http://schemas.openxmlformats.org/drawingml/2006/main">
               <a:ext uri="{FF2B5EF4-FFF2-40B4-BE49-F238E27FC236}">
-                <a16:creationId xmlns:a16="http://schemas.microsoft.com/office/drawing/2014/main" id="{C7975652-C7A5-4488-B26B-9A8AE6BA1B4E}"/>
+                <a16:creationId xmlns:a16="http://schemas.microsoft.com/office/drawing/2014/main" id="{BF6D0F10-E9F5-4BFE-83EE-14D9D151E2A5}"/>
               </a:ext>
             </a:extLst>
           </p:cNvPr>
@@ -5687,7 +5687,7 @@
           <p:cNvPr id="28" name="">
             <a:extLst xmlns:a="http://schemas.openxmlformats.org/drawingml/2006/main">
               <a:ext uri="{FF2B5EF4-FFF2-40B4-BE49-F238E27FC236}">
-                <a16:creationId xmlns:a16="http://schemas.microsoft.com/office/drawing/2014/main" id="{8E35F5E3-F7EE-4807-AAED-8E23EF895850}"/>
+                <a16:creationId xmlns:a16="http://schemas.microsoft.com/office/drawing/2014/main" id="{CD3163A2-F69D-4BCD-828A-2D136A1D9907}"/>
               </a:ext>
             </a:extLst>
           </p:cNvPr>
@@ -5745,7 +5745,7 @@
           <p:cNvPr id="29" name="">
             <a:extLst xmlns:a="http://schemas.openxmlformats.org/drawingml/2006/main">
               <a:ext uri="{FF2B5EF4-FFF2-40B4-BE49-F238E27FC236}">
-                <a16:creationId xmlns:a16="http://schemas.microsoft.com/office/drawing/2014/main" id="{2A76D887-863F-4289-AAA5-CE017ECDC7A5}"/>
+                <a16:creationId xmlns:a16="http://schemas.microsoft.com/office/drawing/2014/main" id="{0B893596-026F-4394-9F04-329F64867477}"/>
               </a:ext>
             </a:extLst>
           </p:cNvPr>
@@ -5801,7 +5801,7 @@
     </p:spTree>
     <p:extLst>
       <p:ext uri="{BB962C8B-B14F-4D97-AF65-F5344CB8AC3E}">
-        <p14:creationId xmlns:p14="http://schemas.microsoft.com/office/powerpoint/2010/main" val="290931762"/>
+        <p14:creationId xmlns:p14="http://schemas.microsoft.com/office/powerpoint/2010/main" val="297304293"/>
       </p:ext>
     </p:extLst>
   </p:cSld>
@@ -5832,7 +5832,7 @@
           <p:cNvPr id="36" name="">
             <a:extLst xmlns:a="http://schemas.openxmlformats.org/drawingml/2006/main">
               <a:ext uri="{FF2B5EF4-FFF2-40B4-BE49-F238E27FC236}">
-                <a16:creationId xmlns:a16="http://schemas.microsoft.com/office/drawing/2014/main" id="{0E00412F-5B21-4B1D-A471-C9A8E8286F78}"/>
+                <a16:creationId xmlns:a16="http://schemas.microsoft.com/office/drawing/2014/main" id="{8652CE66-E678-4D7D-A971-CCED4DB9D7AD}"/>
               </a:ext>
             </a:extLst>
           </p:cNvPr>
@@ -5890,7 +5890,7 @@
           <p:cNvPr id="2" name="">
             <a:extLst xmlns:a="http://schemas.openxmlformats.org/drawingml/2006/main">
               <a:ext uri="{FF2B5EF4-FFF2-40B4-BE49-F238E27FC236}">
-                <a16:creationId xmlns:a16="http://schemas.microsoft.com/office/drawing/2014/main" id="{73C5C261-4024-4C9A-AA13-7F7C4FB097CA}"/>
+                <a16:creationId xmlns:a16="http://schemas.microsoft.com/office/drawing/2014/main" id="{FFDF0F51-AB84-4B0F-829E-CD30EFDE2F47}"/>
               </a:ext>
             </a:extLst>
           </p:cNvPr>
@@ -5948,7 +5948,7 @@
           <p:cNvPr id="3" name="">
             <a:extLst xmlns:a="http://schemas.openxmlformats.org/drawingml/2006/main">
               <a:ext uri="{FF2B5EF4-FFF2-40B4-BE49-F238E27FC236}">
-                <a16:creationId xmlns:a16="http://schemas.microsoft.com/office/drawing/2014/main" id="{4949C0B8-D530-4BC5-97F0-51B69A0CF0D6}"/>
+                <a16:creationId xmlns:a16="http://schemas.microsoft.com/office/drawing/2014/main" id="{E8E74B43-25F6-41CE-8D21-8C6854195A6B}"/>
               </a:ext>
             </a:extLst>
           </p:cNvPr>
@@ -6006,23 +6006,23 @@
           <p:cNvPr id="4" name="">
             <a:extLst xmlns:a="http://schemas.openxmlformats.org/drawingml/2006/main">
               <a:ext uri="{FF2B5EF4-FFF2-40B4-BE49-F238E27FC236}">
-                <a16:creationId xmlns:a16="http://schemas.microsoft.com/office/drawing/2014/main" id="{A5B7CBF2-A04F-42F7-9562-6173E3DD7C03}"/>
-              </a:ext>
-            </a:extLst>
-          </p:cNvPr>
-          <p:cNvSpPr>
-            <a:spLocks xmlns:a="http://schemas.openxmlformats.org/drawingml/2006/main" noGrp="1"/>
-          </p:cNvSpPr>
-          <p:nvPr/>
-        </p:nvSpPr>
-        <p:spPr>
-          <a:xfrm xmlns:a="http://schemas.openxmlformats.org/drawingml/2006/main">
-            <a:off x="552450" y="2667000"/>
-            <a:ext cx="2095500" cy="1143000"/>
+                <a16:creationId xmlns:a16="http://schemas.microsoft.com/office/drawing/2014/main" id="{075270A3-8346-4581-BC09-5BC51EA01851}"/>
+              </a:ext>
+            </a:extLst>
+          </p:cNvPr>
+          <p:cNvSpPr>
+            <a:spLocks xmlns:a="http://schemas.openxmlformats.org/drawingml/2006/main" noGrp="1"/>
+          </p:cNvSpPr>
+          <p:nvPr/>
+        </p:nvSpPr>
+        <p:spPr>
+          <a:xfrm xmlns:a="http://schemas.openxmlformats.org/drawingml/2006/main">
+            <a:off x="552450" y="2343150"/>
+            <a:ext cx="2095500" cy="1381125"/>
           </a:xfrm>
           <a:prstGeom xmlns:a="http://schemas.openxmlformats.org/drawingml/2006/main" prst="roundRect">
             <a:avLst>
-              <a:gd name="adj" fmla="val 10000"/>
+              <a:gd name="adj" fmla="val 8276"/>
             </a:avLst>
           </a:prstGeom>
           <a:solidFill xmlns:a="http://schemas.openxmlformats.org/drawingml/2006/main">
@@ -6041,19 +6041,19 @@
           <p:cNvPr id="5" name="">
             <a:extLst xmlns:a="http://schemas.openxmlformats.org/drawingml/2006/main">
               <a:ext uri="{FF2B5EF4-FFF2-40B4-BE49-F238E27FC236}">
-                <a16:creationId xmlns:a16="http://schemas.microsoft.com/office/drawing/2014/main" id="{5F65358F-9817-43CC-ABFD-CACF35BE4DBC}"/>
-              </a:ext>
-            </a:extLst>
-          </p:cNvPr>
-          <p:cNvSpPr>
-            <a:spLocks xmlns:a="http://schemas.openxmlformats.org/drawingml/2006/main" noGrp="1"/>
-          </p:cNvSpPr>
-          <p:nvPr/>
-        </p:nvSpPr>
-        <p:spPr>
-          <a:xfrm xmlns:a="http://schemas.openxmlformats.org/drawingml/2006/main">
-            <a:off x="552450" y="2667000"/>
-            <a:ext cx="57150" cy="1143000"/>
+                <a16:creationId xmlns:a16="http://schemas.microsoft.com/office/drawing/2014/main" id="{7A1FD101-96CD-4636-B7D4-8CEF244F5E3A}"/>
+              </a:ext>
+            </a:extLst>
+          </p:cNvPr>
+          <p:cNvSpPr>
+            <a:spLocks xmlns:a="http://schemas.openxmlformats.org/drawingml/2006/main" noGrp="1"/>
+          </p:cNvSpPr>
+          <p:nvPr/>
+        </p:nvSpPr>
+        <p:spPr>
+          <a:xfrm xmlns:a="http://schemas.openxmlformats.org/drawingml/2006/main">
+            <a:off x="552450" y="2343150"/>
+            <a:ext cx="57150" cy="1381125"/>
           </a:xfrm>
           <a:prstGeom xmlns:a="http://schemas.openxmlformats.org/drawingml/2006/main" prst="rect">
             <a:avLst/>
@@ -6074,19 +6074,19 @@
           <p:cNvPr id="6" name="">
             <a:extLst xmlns:a="http://schemas.openxmlformats.org/drawingml/2006/main">
               <a:ext uri="{FF2B5EF4-FFF2-40B4-BE49-F238E27FC236}">
-                <a16:creationId xmlns:a16="http://schemas.microsoft.com/office/drawing/2014/main" id="{2E3ECC3C-FFE3-426D-8619-776BE70677B1}"/>
-              </a:ext>
-            </a:extLst>
-          </p:cNvPr>
-          <p:cNvSpPr>
-            <a:spLocks xmlns:a="http://schemas.openxmlformats.org/drawingml/2006/main" noGrp="1"/>
-          </p:cNvSpPr>
-          <p:nvPr/>
-        </p:nvSpPr>
-        <p:spPr>
-          <a:xfrm xmlns:a="http://schemas.openxmlformats.org/drawingml/2006/main">
-            <a:off x="742950" y="2819400"/>
-            <a:ext cx="1790700" cy="285750"/>
+                <a16:creationId xmlns:a16="http://schemas.microsoft.com/office/drawing/2014/main" id="{40CFF99C-13E9-4282-9CA3-8F54ED9DB09C}"/>
+              </a:ext>
+            </a:extLst>
+          </p:cNvPr>
+          <p:cNvSpPr>
+            <a:spLocks xmlns:a="http://schemas.openxmlformats.org/drawingml/2006/main" noGrp="1"/>
+          </p:cNvSpPr>
+          <p:nvPr/>
+        </p:nvSpPr>
+        <p:spPr>
+          <a:xfrm xmlns:a="http://schemas.openxmlformats.org/drawingml/2006/main">
+            <a:off x="742950" y="2476500"/>
+            <a:ext cx="1790700" cy="495300"/>
           </a:xfrm>
           <a:prstGeom xmlns:a="http://schemas.openxmlformats.org/drawingml/2006/main" prst="rect">
             <a:avLst/>
@@ -6122,7 +6122,7 @@
                   <a:srgbClr val="F7FBFF"/>
                 </a:solidFill>
               </a:rPr>
-              <a:t>BNG Blaster / UE pods</a:t>
+              <a:t>UE generator</a:t>
             </a:r>
           </a:p>
         </p:txBody>
@@ -6132,19 +6132,19 @@
           <p:cNvPr id="7" name="">
             <a:extLst xmlns:a="http://schemas.openxmlformats.org/drawingml/2006/main">
               <a:ext uri="{FF2B5EF4-FFF2-40B4-BE49-F238E27FC236}">
-                <a16:creationId xmlns:a16="http://schemas.microsoft.com/office/drawing/2014/main" id="{052B86F2-91A4-413D-9935-BB4906529F56}"/>
-              </a:ext>
-            </a:extLst>
-          </p:cNvPr>
-          <p:cNvSpPr>
-            <a:spLocks xmlns:a="http://schemas.openxmlformats.org/drawingml/2006/main" noGrp="1"/>
-          </p:cNvSpPr>
-          <p:nvPr/>
-        </p:nvSpPr>
-        <p:spPr>
-          <a:xfrm xmlns:a="http://schemas.openxmlformats.org/drawingml/2006/main">
-            <a:off x="742950" y="3143250"/>
-            <a:ext cx="1790700" cy="571500"/>
+                <a16:creationId xmlns:a16="http://schemas.microsoft.com/office/drawing/2014/main" id="{B1B2D643-C05D-48F0-A93C-75B2744A69A2}"/>
+              </a:ext>
+            </a:extLst>
+          </p:cNvPr>
+          <p:cNvSpPr>
+            <a:spLocks xmlns:a="http://schemas.openxmlformats.org/drawingml/2006/main" noGrp="1"/>
+          </p:cNvSpPr>
+          <p:nvPr/>
+        </p:nvSpPr>
+        <p:spPr>
+          <a:xfrm xmlns:a="http://schemas.openxmlformats.org/drawingml/2006/main">
+            <a:off x="742950" y="3028950"/>
+            <a:ext cx="1790700" cy="600075"/>
           </a:xfrm>
           <a:prstGeom xmlns:a="http://schemas.openxmlformats.org/drawingml/2006/main" prst="rect">
             <a:avLst/>
@@ -6180,7 +6180,7 @@
                   <a:srgbClr val="A9C1D2"/>
                 </a:solidFill>
               </a:rPr>
-              <a:t>VLAN-tagged sessions</a:t>
+              <a:t>BNG Blaster</a:t>
             </a:r>
           </a:p>
           <a:p xmlns:a="http://schemas.openxmlformats.org/drawingml/2006/main">
@@ -6197,7 +6197,7 @@
                   <a:srgbClr val="A9C1D2"/>
                 </a:solidFill>
               </a:rPr>
-              <a:t>and traffic probes</a:t>
+              <a:t>VLAN sessions and tests</a:t>
             </a:r>
           </a:p>
         </p:txBody>
@@ -6207,23 +6207,23 @@
           <p:cNvPr id="8" name="">
             <a:extLst xmlns:a="http://schemas.openxmlformats.org/drawingml/2006/main">
               <a:ext uri="{FF2B5EF4-FFF2-40B4-BE49-F238E27FC236}">
-                <a16:creationId xmlns:a16="http://schemas.microsoft.com/office/drawing/2014/main" id="{5A115BFC-831E-4841-8345-E0B44550B85C}"/>
-              </a:ext>
-            </a:extLst>
-          </p:cNvPr>
-          <p:cNvSpPr>
-            <a:spLocks xmlns:a="http://schemas.openxmlformats.org/drawingml/2006/main" noGrp="1"/>
-          </p:cNvSpPr>
-          <p:nvPr/>
-        </p:nvSpPr>
-        <p:spPr>
-          <a:xfrm xmlns:a="http://schemas.openxmlformats.org/drawingml/2006/main">
-            <a:off x="3333750" y="2238375"/>
-            <a:ext cx="2381250" cy="1143000"/>
+                <a16:creationId xmlns:a16="http://schemas.microsoft.com/office/drawing/2014/main" id="{BD965246-3AF0-4A44-ABF5-4CE8CB699145}"/>
+              </a:ext>
+            </a:extLst>
+          </p:cNvPr>
+          <p:cNvSpPr>
+            <a:spLocks xmlns:a="http://schemas.openxmlformats.org/drawingml/2006/main" noGrp="1"/>
+          </p:cNvSpPr>
+          <p:nvPr/>
+        </p:nvSpPr>
+        <p:spPr>
+          <a:xfrm xmlns:a="http://schemas.openxmlformats.org/drawingml/2006/main">
+            <a:off x="3333750" y="2343150"/>
+            <a:ext cx="2381250" cy="1381125"/>
           </a:xfrm>
           <a:prstGeom xmlns:a="http://schemas.openxmlformats.org/drawingml/2006/main" prst="roundRect">
             <a:avLst>
-              <a:gd name="adj" fmla="val 10000"/>
+              <a:gd name="adj" fmla="val 8276"/>
             </a:avLst>
           </a:prstGeom>
           <a:solidFill xmlns:a="http://schemas.openxmlformats.org/drawingml/2006/main">
@@ -6242,19 +6242,19 @@
           <p:cNvPr id="9" name="">
             <a:extLst xmlns:a="http://schemas.openxmlformats.org/drawingml/2006/main">
               <a:ext uri="{FF2B5EF4-FFF2-40B4-BE49-F238E27FC236}">
-                <a16:creationId xmlns:a16="http://schemas.microsoft.com/office/drawing/2014/main" id="{F6034E99-BC15-40CA-ABB9-78F51F1F6327}"/>
-              </a:ext>
-            </a:extLst>
-          </p:cNvPr>
-          <p:cNvSpPr>
-            <a:spLocks xmlns:a="http://schemas.openxmlformats.org/drawingml/2006/main" noGrp="1"/>
-          </p:cNvSpPr>
-          <p:nvPr/>
-        </p:nvSpPr>
-        <p:spPr>
-          <a:xfrm xmlns:a="http://schemas.openxmlformats.org/drawingml/2006/main">
-            <a:off x="3333750" y="2238375"/>
-            <a:ext cx="57150" cy="1143000"/>
+                <a16:creationId xmlns:a16="http://schemas.microsoft.com/office/drawing/2014/main" id="{6A3C7D75-A062-4C2A-B111-14DF59727098}"/>
+              </a:ext>
+            </a:extLst>
+          </p:cNvPr>
+          <p:cNvSpPr>
+            <a:spLocks xmlns:a="http://schemas.openxmlformats.org/drawingml/2006/main" noGrp="1"/>
+          </p:cNvSpPr>
+          <p:nvPr/>
+        </p:nvSpPr>
+        <p:spPr>
+          <a:xfrm xmlns:a="http://schemas.openxmlformats.org/drawingml/2006/main">
+            <a:off x="3333750" y="2343150"/>
+            <a:ext cx="57150" cy="1381125"/>
           </a:xfrm>
           <a:prstGeom xmlns:a="http://schemas.openxmlformats.org/drawingml/2006/main" prst="rect">
             <a:avLst/>
@@ -6275,19 +6275,19 @@
           <p:cNvPr id="10" name="">
             <a:extLst xmlns:a="http://schemas.openxmlformats.org/drawingml/2006/main">
               <a:ext uri="{FF2B5EF4-FFF2-40B4-BE49-F238E27FC236}">
-                <a16:creationId xmlns:a16="http://schemas.microsoft.com/office/drawing/2014/main" id="{FA98A234-D562-42C8-B5ED-22C075129741}"/>
-              </a:ext>
-            </a:extLst>
-          </p:cNvPr>
-          <p:cNvSpPr>
-            <a:spLocks xmlns:a="http://schemas.openxmlformats.org/drawingml/2006/main" noGrp="1"/>
-          </p:cNvSpPr>
-          <p:nvPr/>
-        </p:nvSpPr>
-        <p:spPr>
-          <a:xfrm xmlns:a="http://schemas.openxmlformats.org/drawingml/2006/main">
-            <a:off x="3524250" y="2390775"/>
-            <a:ext cx="2076450" cy="285750"/>
+                <a16:creationId xmlns:a16="http://schemas.microsoft.com/office/drawing/2014/main" id="{94872E2B-8107-409A-AD56-2A81027E168F}"/>
+              </a:ext>
+            </a:extLst>
+          </p:cNvPr>
+          <p:cNvSpPr>
+            <a:spLocks xmlns:a="http://schemas.openxmlformats.org/drawingml/2006/main" noGrp="1"/>
+          </p:cNvSpPr>
+          <p:nvPr/>
+        </p:nvSpPr>
+        <p:spPr>
+          <a:xfrm xmlns:a="http://schemas.openxmlformats.org/drawingml/2006/main">
+            <a:off x="3524250" y="2476500"/>
+            <a:ext cx="2076450" cy="495300"/>
           </a:xfrm>
           <a:prstGeom xmlns:a="http://schemas.openxmlformats.org/drawingml/2006/main" prst="rect">
             <a:avLst/>
@@ -6333,19 +6333,19 @@
           <p:cNvPr id="11" name="">
             <a:extLst xmlns:a="http://schemas.openxmlformats.org/drawingml/2006/main">
               <a:ext uri="{FF2B5EF4-FFF2-40B4-BE49-F238E27FC236}">
-                <a16:creationId xmlns:a16="http://schemas.microsoft.com/office/drawing/2014/main" id="{C80205B3-E632-4793-B38F-EE73C4A436E8}"/>
-              </a:ext>
-            </a:extLst>
-          </p:cNvPr>
-          <p:cNvSpPr>
-            <a:spLocks xmlns:a="http://schemas.openxmlformats.org/drawingml/2006/main" noGrp="1"/>
-          </p:cNvSpPr>
-          <p:nvPr/>
-        </p:nvSpPr>
-        <p:spPr>
-          <a:xfrm xmlns:a="http://schemas.openxmlformats.org/drawingml/2006/main">
-            <a:off x="3524250" y="2714625"/>
-            <a:ext cx="2076450" cy="571500"/>
+                <a16:creationId xmlns:a16="http://schemas.microsoft.com/office/drawing/2014/main" id="{5A5E0875-66A4-4B69-A0A6-2AFAF6EDB4CC}"/>
+              </a:ext>
+            </a:extLst>
+          </p:cNvPr>
+          <p:cNvSpPr>
+            <a:spLocks xmlns:a="http://schemas.openxmlformats.org/drawingml/2006/main" noGrp="1"/>
+          </p:cNvSpPr>
+          <p:nvPr/>
+        </p:nvSpPr>
+        <p:spPr>
+          <a:xfrm xmlns:a="http://schemas.openxmlformats.org/drawingml/2006/main">
+            <a:off x="3524250" y="3028950"/>
+            <a:ext cx="2076450" cy="600075"/>
           </a:xfrm>
           <a:prstGeom xmlns:a="http://schemas.openxmlformats.org/drawingml/2006/main" prst="rect">
             <a:avLst/>
@@ -6398,7 +6398,7 @@
                   <a:srgbClr val="A9C1D2"/>
                 </a:solidFill>
               </a:rPr>
-              <a:t>subscriber state</a:t>
+              <a:t>subscriber forwarding</a:t>
             </a:r>
           </a:p>
         </p:txBody>
@@ -6408,23 +6408,23 @@
           <p:cNvPr id="12" name="">
             <a:extLst xmlns:a="http://schemas.openxmlformats.org/drawingml/2006/main">
               <a:ext uri="{FF2B5EF4-FFF2-40B4-BE49-F238E27FC236}">
-                <a16:creationId xmlns:a16="http://schemas.microsoft.com/office/drawing/2014/main" id="{2003B9D0-067C-48AC-BD9C-54E3673110EC}"/>
-              </a:ext>
-            </a:extLst>
-          </p:cNvPr>
-          <p:cNvSpPr>
-            <a:spLocks xmlns:a="http://schemas.openxmlformats.org/drawingml/2006/main" noGrp="1"/>
-          </p:cNvSpPr>
-          <p:nvPr/>
-        </p:nvSpPr>
-        <p:spPr>
-          <a:xfrm xmlns:a="http://schemas.openxmlformats.org/drawingml/2006/main">
-            <a:off x="6572250" y="2238375"/>
-            <a:ext cx="2190750" cy="1143000"/>
+                <a16:creationId xmlns:a16="http://schemas.microsoft.com/office/drawing/2014/main" id="{069F2107-B8E5-4D1D-9987-3206B80C77F9}"/>
+              </a:ext>
+            </a:extLst>
+          </p:cNvPr>
+          <p:cNvSpPr>
+            <a:spLocks xmlns:a="http://schemas.openxmlformats.org/drawingml/2006/main" noGrp="1"/>
+          </p:cNvSpPr>
+          <p:nvPr/>
+        </p:nvSpPr>
+        <p:spPr>
+          <a:xfrm xmlns:a="http://schemas.openxmlformats.org/drawingml/2006/main">
+            <a:off x="6572250" y="2343150"/>
+            <a:ext cx="2190750" cy="1381125"/>
           </a:xfrm>
           <a:prstGeom xmlns:a="http://schemas.openxmlformats.org/drawingml/2006/main" prst="roundRect">
             <a:avLst>
-              <a:gd name="adj" fmla="val 10000"/>
+              <a:gd name="adj" fmla="val 8276"/>
             </a:avLst>
           </a:prstGeom>
           <a:solidFill xmlns:a="http://schemas.openxmlformats.org/drawingml/2006/main">
@@ -6443,19 +6443,19 @@
           <p:cNvPr id="13" name="">
             <a:extLst xmlns:a="http://schemas.openxmlformats.org/drawingml/2006/main">
               <a:ext uri="{FF2B5EF4-FFF2-40B4-BE49-F238E27FC236}">
-                <a16:creationId xmlns:a16="http://schemas.microsoft.com/office/drawing/2014/main" id="{D61520DD-61AA-4300-B035-D8D1AEB6F5F6}"/>
-              </a:ext>
-            </a:extLst>
-          </p:cNvPr>
-          <p:cNvSpPr>
-            <a:spLocks xmlns:a="http://schemas.openxmlformats.org/drawingml/2006/main" noGrp="1"/>
-          </p:cNvSpPr>
-          <p:nvPr/>
-        </p:nvSpPr>
-        <p:spPr>
-          <a:xfrm xmlns:a="http://schemas.openxmlformats.org/drawingml/2006/main">
-            <a:off x="6572250" y="2238375"/>
-            <a:ext cx="57150" cy="1143000"/>
+                <a16:creationId xmlns:a16="http://schemas.microsoft.com/office/drawing/2014/main" id="{0E9F7D07-4D67-4784-AAC9-A6E615D76E3A}"/>
+              </a:ext>
+            </a:extLst>
+          </p:cNvPr>
+          <p:cNvSpPr>
+            <a:spLocks xmlns:a="http://schemas.openxmlformats.org/drawingml/2006/main" noGrp="1"/>
+          </p:cNvSpPr>
+          <p:nvPr/>
+        </p:nvSpPr>
+        <p:spPr>
+          <a:xfrm xmlns:a="http://schemas.openxmlformats.org/drawingml/2006/main">
+            <a:off x="6572250" y="2343150"/>
+            <a:ext cx="57150" cy="1381125"/>
           </a:xfrm>
           <a:prstGeom xmlns:a="http://schemas.openxmlformats.org/drawingml/2006/main" prst="rect">
             <a:avLst/>
@@ -6476,19 +6476,19 @@
           <p:cNvPr id="14" name="">
             <a:extLst xmlns:a="http://schemas.openxmlformats.org/drawingml/2006/main">
               <a:ext uri="{FF2B5EF4-FFF2-40B4-BE49-F238E27FC236}">
-                <a16:creationId xmlns:a16="http://schemas.microsoft.com/office/drawing/2014/main" id="{A444B216-D1C6-47AF-BD86-4F6B2115CE20}"/>
-              </a:ext>
-            </a:extLst>
-          </p:cNvPr>
-          <p:cNvSpPr>
-            <a:spLocks xmlns:a="http://schemas.openxmlformats.org/drawingml/2006/main" noGrp="1"/>
-          </p:cNvSpPr>
-          <p:nvPr/>
-        </p:nvSpPr>
-        <p:spPr>
-          <a:xfrm xmlns:a="http://schemas.openxmlformats.org/drawingml/2006/main">
-            <a:off x="6762750" y="2390775"/>
-            <a:ext cx="1885950" cy="285750"/>
+                <a16:creationId xmlns:a16="http://schemas.microsoft.com/office/drawing/2014/main" id="{C6819007-FB89-43D9-ABBA-7D0501046671}"/>
+              </a:ext>
+            </a:extLst>
+          </p:cNvPr>
+          <p:cNvSpPr>
+            <a:spLocks xmlns:a="http://schemas.openxmlformats.org/drawingml/2006/main" noGrp="1"/>
+          </p:cNvSpPr>
+          <p:nvPr/>
+        </p:nvSpPr>
+        <p:spPr>
+          <a:xfrm xmlns:a="http://schemas.openxmlformats.org/drawingml/2006/main">
+            <a:off x="6762750" y="2476500"/>
+            <a:ext cx="1885950" cy="495300"/>
           </a:xfrm>
           <a:prstGeom xmlns:a="http://schemas.openxmlformats.org/drawingml/2006/main" prst="rect">
             <a:avLst/>
@@ -6534,19 +6534,19 @@
           <p:cNvPr id="15" name="">
             <a:extLst xmlns:a="http://schemas.openxmlformats.org/drawingml/2006/main">
               <a:ext uri="{FF2B5EF4-FFF2-40B4-BE49-F238E27FC236}">
-                <a16:creationId xmlns:a16="http://schemas.microsoft.com/office/drawing/2014/main" id="{13E602AA-8312-4F0C-B3E4-A85DA6F4CACA}"/>
-              </a:ext>
-            </a:extLst>
-          </p:cNvPr>
-          <p:cNvSpPr>
-            <a:spLocks xmlns:a="http://schemas.openxmlformats.org/drawingml/2006/main" noGrp="1"/>
-          </p:cNvSpPr>
-          <p:nvPr/>
-        </p:nvSpPr>
-        <p:spPr>
-          <a:xfrm xmlns:a="http://schemas.openxmlformats.org/drawingml/2006/main">
-            <a:off x="6762750" y="2714625"/>
-            <a:ext cx="1885950" cy="571500"/>
+                <a16:creationId xmlns:a16="http://schemas.microsoft.com/office/drawing/2014/main" id="{8746A92C-04EB-407C-A73E-B054C4AF5A03}"/>
+              </a:ext>
+            </a:extLst>
+          </p:cNvPr>
+          <p:cNvSpPr>
+            <a:spLocks xmlns:a="http://schemas.openxmlformats.org/drawingml/2006/main" noGrp="1"/>
+          </p:cNvSpPr>
+          <p:nvPr/>
+        </p:nvSpPr>
+        <p:spPr>
+          <a:xfrm xmlns:a="http://schemas.openxmlformats.org/drawingml/2006/main">
+            <a:off x="6762750" y="3028950"/>
+            <a:ext cx="1885950" cy="600075"/>
           </a:xfrm>
           <a:prstGeom xmlns:a="http://schemas.openxmlformats.org/drawingml/2006/main" prst="rect">
             <a:avLst/>
@@ -6582,7 +6582,7 @@
                   <a:srgbClr val="A9C1D2"/>
                 </a:solidFill>
               </a:rPr>
-              <a:t>eBGP toward BNG</a:t>
+              <a:t>BGP toward the BNG</a:t>
             </a:r>
           </a:p>
           <a:p xmlns:a="http://schemas.openxmlformats.org/drawingml/2006/main">
@@ -6609,23 +6609,23 @@
           <p:cNvPr id="16" name="">
             <a:extLst xmlns:a="http://schemas.openxmlformats.org/drawingml/2006/main">
               <a:ext uri="{FF2B5EF4-FFF2-40B4-BE49-F238E27FC236}">
-                <a16:creationId xmlns:a16="http://schemas.microsoft.com/office/drawing/2014/main" id="{60181BEE-BAF8-4A5F-99D6-338FA423ABD3}"/>
-              </a:ext>
-            </a:extLst>
-          </p:cNvPr>
-          <p:cNvSpPr>
-            <a:spLocks xmlns:a="http://schemas.openxmlformats.org/drawingml/2006/main" noGrp="1"/>
-          </p:cNvSpPr>
-          <p:nvPr/>
-        </p:nvSpPr>
-        <p:spPr>
-          <a:xfrm xmlns:a="http://schemas.openxmlformats.org/drawingml/2006/main">
-            <a:off x="9525000" y="2667000"/>
-            <a:ext cx="2095500" cy="1143000"/>
+                <a16:creationId xmlns:a16="http://schemas.microsoft.com/office/drawing/2014/main" id="{DAB79A6D-0BA0-4EBE-91C5-35D9017C7230}"/>
+              </a:ext>
+            </a:extLst>
+          </p:cNvPr>
+          <p:cNvSpPr>
+            <a:spLocks xmlns:a="http://schemas.openxmlformats.org/drawingml/2006/main" noGrp="1"/>
+          </p:cNvSpPr>
+          <p:nvPr/>
+        </p:nvSpPr>
+        <p:spPr>
+          <a:xfrm xmlns:a="http://schemas.openxmlformats.org/drawingml/2006/main">
+            <a:off x="9525000" y="2343150"/>
+            <a:ext cx="2095500" cy="1381125"/>
           </a:xfrm>
           <a:prstGeom xmlns:a="http://schemas.openxmlformats.org/drawingml/2006/main" prst="roundRect">
             <a:avLst>
-              <a:gd name="adj" fmla="val 10000"/>
+              <a:gd name="adj" fmla="val 8276"/>
             </a:avLst>
           </a:prstGeom>
           <a:solidFill xmlns:a="http://schemas.openxmlformats.org/drawingml/2006/main">
@@ -6644,19 +6644,19 @@
           <p:cNvPr id="17" name="">
             <a:extLst xmlns:a="http://schemas.openxmlformats.org/drawingml/2006/main">
               <a:ext uri="{FF2B5EF4-FFF2-40B4-BE49-F238E27FC236}">
-                <a16:creationId xmlns:a16="http://schemas.microsoft.com/office/drawing/2014/main" id="{FF0E3460-0740-4FE6-A643-6B6B40419817}"/>
-              </a:ext>
-            </a:extLst>
-          </p:cNvPr>
-          <p:cNvSpPr>
-            <a:spLocks xmlns:a="http://schemas.openxmlformats.org/drawingml/2006/main" noGrp="1"/>
-          </p:cNvSpPr>
-          <p:nvPr/>
-        </p:nvSpPr>
-        <p:spPr>
-          <a:xfrm xmlns:a="http://schemas.openxmlformats.org/drawingml/2006/main">
-            <a:off x="9525000" y="2667000"/>
-            <a:ext cx="57150" cy="1143000"/>
+                <a16:creationId xmlns:a16="http://schemas.microsoft.com/office/drawing/2014/main" id="{D60B7567-AB26-44FF-B803-77F6ADB94848}"/>
+              </a:ext>
+            </a:extLst>
+          </p:cNvPr>
+          <p:cNvSpPr>
+            <a:spLocks xmlns:a="http://schemas.openxmlformats.org/drawingml/2006/main" noGrp="1"/>
+          </p:cNvSpPr>
+          <p:nvPr/>
+        </p:nvSpPr>
+        <p:spPr>
+          <a:xfrm xmlns:a="http://schemas.openxmlformats.org/drawingml/2006/main">
+            <a:off x="9525000" y="2343150"/>
+            <a:ext cx="57150" cy="1381125"/>
           </a:xfrm>
           <a:prstGeom xmlns:a="http://schemas.openxmlformats.org/drawingml/2006/main" prst="rect">
             <a:avLst/>
@@ -6677,19 +6677,19 @@
           <p:cNvPr id="18" name="">
             <a:extLst xmlns:a="http://schemas.openxmlformats.org/drawingml/2006/main">
               <a:ext uri="{FF2B5EF4-FFF2-40B4-BE49-F238E27FC236}">
-                <a16:creationId xmlns:a16="http://schemas.microsoft.com/office/drawing/2014/main" id="{0BA2C7C4-CBD9-4E31-9C73-07093338A3A7}"/>
-              </a:ext>
-            </a:extLst>
-          </p:cNvPr>
-          <p:cNvSpPr>
-            <a:spLocks xmlns:a="http://schemas.openxmlformats.org/drawingml/2006/main" noGrp="1"/>
-          </p:cNvSpPr>
-          <p:nvPr/>
-        </p:nvSpPr>
-        <p:spPr>
-          <a:xfrm xmlns:a="http://schemas.openxmlformats.org/drawingml/2006/main">
-            <a:off x="9715500" y="2819400"/>
-            <a:ext cx="1790700" cy="285750"/>
+                <a16:creationId xmlns:a16="http://schemas.microsoft.com/office/drawing/2014/main" id="{98B88BDE-C27D-42D1-A523-9EE81FC6B3AE}"/>
+              </a:ext>
+            </a:extLst>
+          </p:cNvPr>
+          <p:cNvSpPr>
+            <a:spLocks xmlns:a="http://schemas.openxmlformats.org/drawingml/2006/main" noGrp="1"/>
+          </p:cNvSpPr>
+          <p:nvPr/>
+        </p:nvSpPr>
+        <p:spPr>
+          <a:xfrm xmlns:a="http://schemas.openxmlformats.org/drawingml/2006/main">
+            <a:off x="9715500" y="2476500"/>
+            <a:ext cx="1790700" cy="495300"/>
           </a:xfrm>
           <a:prstGeom xmlns:a="http://schemas.openxmlformats.org/drawingml/2006/main" prst="rect">
             <a:avLst/>
@@ -6735,19 +6735,19 @@
           <p:cNvPr id="19" name="">
             <a:extLst xmlns:a="http://schemas.openxmlformats.org/drawingml/2006/main">
               <a:ext uri="{FF2B5EF4-FFF2-40B4-BE49-F238E27FC236}">
-                <a16:creationId xmlns:a16="http://schemas.microsoft.com/office/drawing/2014/main" id="{417C05FA-F139-476F-9B41-A7930071A9FA}"/>
-              </a:ext>
-            </a:extLst>
-          </p:cNvPr>
-          <p:cNvSpPr>
-            <a:spLocks xmlns:a="http://schemas.openxmlformats.org/drawingml/2006/main" noGrp="1"/>
-          </p:cNvSpPr>
-          <p:nvPr/>
-        </p:nvSpPr>
-        <p:spPr>
-          <a:xfrm xmlns:a="http://schemas.openxmlformats.org/drawingml/2006/main">
-            <a:off x="9715500" y="3143250"/>
-            <a:ext cx="1790700" cy="571500"/>
+                <a16:creationId xmlns:a16="http://schemas.microsoft.com/office/drawing/2014/main" id="{ED3FECBB-36DF-48EE-9C90-6DEB99924CB9}"/>
+              </a:ext>
+            </a:extLst>
+          </p:cNvPr>
+          <p:cNvSpPr>
+            <a:spLocks xmlns:a="http://schemas.openxmlformats.org/drawingml/2006/main" noGrp="1"/>
+          </p:cNvSpPr>
+          <p:nvPr/>
+        </p:nvSpPr>
+        <p:spPr>
+          <a:xfrm xmlns:a="http://schemas.openxmlformats.org/drawingml/2006/main">
+            <a:off x="9715500" y="3028950"/>
+            <a:ext cx="1790700" cy="600075"/>
           </a:xfrm>
           <a:prstGeom xmlns:a="http://schemas.openxmlformats.org/drawingml/2006/main" prst="rect">
             <a:avLst/>
@@ -6783,7 +6783,7 @@
                   <a:srgbClr val="A9C1D2"/>
                 </a:solidFill>
               </a:rPr>
-              <a:t>Upstream default route</a:t>
+              <a:t>Default route</a:t>
             </a:r>
           </a:p>
           <a:p xmlns:a="http://schemas.openxmlformats.org/drawingml/2006/main">
@@ -6810,18 +6810,18 @@
           <p:cNvPr id="20" name="">
             <a:extLst xmlns:a="http://schemas.openxmlformats.org/drawingml/2006/main">
               <a:ext uri="{FF2B5EF4-FFF2-40B4-BE49-F238E27FC236}">
-                <a16:creationId xmlns:a16="http://schemas.microsoft.com/office/drawing/2014/main" id="{ECFF059F-DA43-4943-AC16-F6727B64E136}"/>
-              </a:ext>
-            </a:extLst>
-          </p:cNvPr>
-          <p:cNvSpPr>
-            <a:spLocks xmlns:a="http://schemas.openxmlformats.org/drawingml/2006/main" noGrp="1"/>
-          </p:cNvSpPr>
-          <p:nvPr/>
-        </p:nvSpPr>
-        <p:spPr>
-          <a:xfrm xmlns:a="http://schemas.openxmlformats.org/drawingml/2006/main">
-            <a:off x="2647950" y="3200400"/>
+                <a16:creationId xmlns:a16="http://schemas.microsoft.com/office/drawing/2014/main" id="{C0C89BC1-83B6-483F-B2B8-72072209D1FD}"/>
+              </a:ext>
+            </a:extLst>
+          </p:cNvPr>
+          <p:cNvSpPr>
+            <a:spLocks xmlns:a="http://schemas.openxmlformats.org/drawingml/2006/main" noGrp="1"/>
+          </p:cNvSpPr>
+          <p:nvPr/>
+        </p:nvSpPr>
+        <p:spPr>
+          <a:xfrm xmlns:a="http://schemas.openxmlformats.org/drawingml/2006/main">
+            <a:off x="2647950" y="3009900"/>
             <a:ext cx="685800" cy="38100"/>
           </a:xfrm>
           <a:prstGeom xmlns:a="http://schemas.openxmlformats.org/drawingml/2006/main" prst="rect">
@@ -6843,18 +6843,18 @@
           <p:cNvPr id="21" name="">
             <a:extLst xmlns:a="http://schemas.openxmlformats.org/drawingml/2006/main">
               <a:ext uri="{FF2B5EF4-FFF2-40B4-BE49-F238E27FC236}">
-                <a16:creationId xmlns:a16="http://schemas.microsoft.com/office/drawing/2014/main" id="{291FAF15-5389-4F12-BF28-AB9B51FD38D3}"/>
-              </a:ext>
-            </a:extLst>
-          </p:cNvPr>
-          <p:cNvSpPr>
-            <a:spLocks xmlns:a="http://schemas.openxmlformats.org/drawingml/2006/main" noGrp="1"/>
-          </p:cNvSpPr>
-          <p:nvPr/>
-        </p:nvSpPr>
-        <p:spPr>
-          <a:xfrm xmlns:a="http://schemas.openxmlformats.org/drawingml/2006/main">
-            <a:off x="5715000" y="2800350"/>
+                <a16:creationId xmlns:a16="http://schemas.microsoft.com/office/drawing/2014/main" id="{744CD504-49CC-4990-819C-C56A9D90C8BF}"/>
+              </a:ext>
+            </a:extLst>
+          </p:cNvPr>
+          <p:cNvSpPr>
+            <a:spLocks xmlns:a="http://schemas.openxmlformats.org/drawingml/2006/main" noGrp="1"/>
+          </p:cNvSpPr>
+          <p:nvPr/>
+        </p:nvSpPr>
+        <p:spPr>
+          <a:xfrm xmlns:a="http://schemas.openxmlformats.org/drawingml/2006/main">
+            <a:off x="5715000" y="3009900"/>
             <a:ext cx="857250" cy="38100"/>
           </a:xfrm>
           <a:prstGeom xmlns:a="http://schemas.openxmlformats.org/drawingml/2006/main" prst="rect">
@@ -6876,18 +6876,18 @@
           <p:cNvPr id="22" name="">
             <a:extLst xmlns:a="http://schemas.openxmlformats.org/drawingml/2006/main">
               <a:ext uri="{FF2B5EF4-FFF2-40B4-BE49-F238E27FC236}">
-                <a16:creationId xmlns:a16="http://schemas.microsoft.com/office/drawing/2014/main" id="{B799D475-4263-4D3B-BF52-D21201F49444}"/>
-              </a:ext>
-            </a:extLst>
-          </p:cNvPr>
-          <p:cNvSpPr>
-            <a:spLocks xmlns:a="http://schemas.openxmlformats.org/drawingml/2006/main" noGrp="1"/>
-          </p:cNvSpPr>
-          <p:nvPr/>
-        </p:nvSpPr>
-        <p:spPr>
-          <a:xfrm xmlns:a="http://schemas.openxmlformats.org/drawingml/2006/main">
-            <a:off x="8763000" y="3200400"/>
+                <a16:creationId xmlns:a16="http://schemas.microsoft.com/office/drawing/2014/main" id="{3161673A-0C3F-4910-A0C4-0F851E2BDBBD}"/>
+              </a:ext>
+            </a:extLst>
+          </p:cNvPr>
+          <p:cNvSpPr>
+            <a:spLocks xmlns:a="http://schemas.openxmlformats.org/drawingml/2006/main" noGrp="1"/>
+          </p:cNvSpPr>
+          <p:nvPr/>
+        </p:nvSpPr>
+        <p:spPr>
+          <a:xfrm xmlns:a="http://schemas.openxmlformats.org/drawingml/2006/main">
+            <a:off x="8763000" y="3009900"/>
             <a:ext cx="762000" cy="38100"/>
           </a:xfrm>
           <a:prstGeom xmlns:a="http://schemas.openxmlformats.org/drawingml/2006/main" prst="rect">
@@ -6909,387 +6909,23 @@
           <p:cNvPr id="23" name="">
             <a:extLst xmlns:a="http://schemas.openxmlformats.org/drawingml/2006/main">
               <a:ext uri="{FF2B5EF4-FFF2-40B4-BE49-F238E27FC236}">
-                <a16:creationId xmlns:a16="http://schemas.microsoft.com/office/drawing/2014/main" id="{C0D48DE7-1C73-4E20-BBCB-D98B038DA07B}"/>
-              </a:ext>
-            </a:extLst>
-          </p:cNvPr>
-          <p:cNvSpPr>
-            <a:spLocks xmlns:a="http://schemas.openxmlformats.org/drawingml/2006/main" noGrp="1"/>
-          </p:cNvSpPr>
-          <p:nvPr/>
-        </p:nvSpPr>
-        <p:spPr>
-          <a:xfrm xmlns:a="http://schemas.openxmlformats.org/drawingml/2006/main">
-            <a:off x="971550" y="4038600"/>
-            <a:ext cx="1428750" cy="323850"/>
+                <a16:creationId xmlns:a16="http://schemas.microsoft.com/office/drawing/2014/main" id="{3637E4B5-35CF-48E1-9080-535D94BF0949}"/>
+              </a:ext>
+            </a:extLst>
+          </p:cNvPr>
+          <p:cNvSpPr>
+            <a:spLocks xmlns:a="http://schemas.openxmlformats.org/drawingml/2006/main" noGrp="1"/>
+          </p:cNvSpPr>
+          <p:nvPr/>
+        </p:nvSpPr>
+        <p:spPr>
+          <a:xfrm xmlns:a="http://schemas.openxmlformats.org/drawingml/2006/main">
+            <a:off x="552450" y="4048125"/>
+            <a:ext cx="2095500" cy="590550"/>
           </a:xfrm>
           <a:prstGeom xmlns:a="http://schemas.openxmlformats.org/drawingml/2006/main" prst="roundRect">
             <a:avLst>
-              <a:gd name="adj" fmla="val 50000"/>
-            </a:avLst>
-          </a:prstGeom>
-          <a:solidFill xmlns:a="http://schemas.openxmlformats.org/drawingml/2006/main">
-            <a:srgbClr val="0E2B42"/>
-          </a:solidFill>
-          <a:ln xmlns:a="http://schemas.openxmlformats.org/drawingml/2006/main" w="0">
-            <a:noFill/>
-            <a:prstDash val="solid"/>
-          </a:ln>
-        </p:spPr>
-      </p:sp>
-      <p:sp>
-        <p:nvSpPr>
-          <p:cNvPr id="24" name="">
-            <a:extLst xmlns:a="http://schemas.openxmlformats.org/drawingml/2006/main">
-              <a:ext uri="{FF2B5EF4-FFF2-40B4-BE49-F238E27FC236}">
-                <a16:creationId xmlns:a16="http://schemas.microsoft.com/office/drawing/2014/main" id="{975225D3-9CC7-444B-A216-2D60ED41DC53}"/>
-              </a:ext>
-            </a:extLst>
-          </p:cNvPr>
-          <p:cNvSpPr>
-            <a:spLocks xmlns:a="http://schemas.openxmlformats.org/drawingml/2006/main" noGrp="1"/>
-          </p:cNvSpPr>
-          <p:nvPr/>
-        </p:nvSpPr>
-        <p:spPr>
-          <a:xfrm xmlns:a="http://schemas.openxmlformats.org/drawingml/2006/main">
-            <a:off x="1085850" y="4105275"/>
-            <a:ext cx="1200150" cy="190500"/>
-          </a:xfrm>
-          <a:prstGeom xmlns:a="http://schemas.openxmlformats.org/drawingml/2006/main" prst="rect">
-            <a:avLst/>
-          </a:prstGeom>
-          <a:noFill xmlns:a="http://schemas.openxmlformats.org/drawingml/2006/main"/>
-          <a:ln xmlns:a="http://schemas.openxmlformats.org/drawingml/2006/main" w="0">
-            <a:noFill/>
-            <a:prstDash val="solid"/>
-          </a:ln>
-        </p:spPr>
-        <p:txBody>
-          <a:bodyPr xmlns:a="http://schemas.openxmlformats.org/drawingml/2006/main"/>
-          <a:lstStyle xmlns:a="http://schemas.openxmlformats.org/drawingml/2006/main">
-            <a:defPPr algn="ctr">
-              <a:defRPr sz="975" b="1">
-                <a:solidFill>
-                  <a:srgbClr val="F7FBFF"/>
-                </a:solidFill>
-              </a:defRPr>
-            </a:defPPr>
-          </a:lstStyle>
-          <a:p xmlns:a="http://schemas.openxmlformats.org/drawingml/2006/main">
-            <a:pPr algn="ctr">
-              <a:defRPr sz="975" b="1">
-                <a:solidFill>
-                  <a:srgbClr val="F7FBFF"/>
-                </a:solidFill>
-              </a:defRPr>
-            </a:pPr>
-            <a:r>
-              <a:rPr sz="975" b="1">
-                <a:solidFill>
-                  <a:srgbClr val="F7FBFF"/>
-                </a:solidFill>
-              </a:rPr>
-              <a:t>ACCESS VLANs</a:t>
-            </a:r>
-          </a:p>
-        </p:txBody>
-      </p:sp>
-      <p:sp>
-        <p:nvSpPr>
-          <p:cNvPr id="25" name="">
-            <a:extLst xmlns:a="http://schemas.openxmlformats.org/drawingml/2006/main">
-              <a:ext uri="{FF2B5EF4-FFF2-40B4-BE49-F238E27FC236}">
-                <a16:creationId xmlns:a16="http://schemas.microsoft.com/office/drawing/2014/main" id="{0937D910-7F09-46AF-B34B-45F905D80298}"/>
-              </a:ext>
-            </a:extLst>
-          </p:cNvPr>
-          <p:cNvSpPr>
-            <a:spLocks xmlns:a="http://schemas.openxmlformats.org/drawingml/2006/main" noGrp="1"/>
-          </p:cNvSpPr>
-          <p:nvPr/>
-        </p:nvSpPr>
-        <p:spPr>
-          <a:xfrm xmlns:a="http://schemas.openxmlformats.org/drawingml/2006/main">
-            <a:off x="3733800" y="4038600"/>
-            <a:ext cx="1638300" cy="323850"/>
-          </a:xfrm>
-          <a:prstGeom xmlns:a="http://schemas.openxmlformats.org/drawingml/2006/main" prst="roundRect">
-            <a:avLst>
-              <a:gd name="adj" fmla="val 50000"/>
-            </a:avLst>
-          </a:prstGeom>
-          <a:solidFill xmlns:a="http://schemas.openxmlformats.org/drawingml/2006/main">
-            <a:srgbClr val="0E2B42"/>
-          </a:solidFill>
-          <a:ln xmlns:a="http://schemas.openxmlformats.org/drawingml/2006/main" w="0">
-            <a:noFill/>
-            <a:prstDash val="solid"/>
-          </a:ln>
-        </p:spPr>
-      </p:sp>
-      <p:sp>
-        <p:nvSpPr>
-          <p:cNvPr id="26" name="">
-            <a:extLst xmlns:a="http://schemas.openxmlformats.org/drawingml/2006/main">
-              <a:ext uri="{FF2B5EF4-FFF2-40B4-BE49-F238E27FC236}">
-                <a16:creationId xmlns:a16="http://schemas.microsoft.com/office/drawing/2014/main" id="{28EAE7DA-6E1E-4B3D-B768-D1ABDECFAA80}"/>
-              </a:ext>
-            </a:extLst>
-          </p:cNvPr>
-          <p:cNvSpPr>
-            <a:spLocks xmlns:a="http://schemas.openxmlformats.org/drawingml/2006/main" noGrp="1"/>
-          </p:cNvSpPr>
-          <p:nvPr/>
-        </p:nvSpPr>
-        <p:spPr>
-          <a:xfrm xmlns:a="http://schemas.openxmlformats.org/drawingml/2006/main">
-            <a:off x="3848100" y="4105275"/>
-            <a:ext cx="1409700" cy="190500"/>
-          </a:xfrm>
-          <a:prstGeom xmlns:a="http://schemas.openxmlformats.org/drawingml/2006/main" prst="rect">
-            <a:avLst/>
-          </a:prstGeom>
-          <a:noFill xmlns:a="http://schemas.openxmlformats.org/drawingml/2006/main"/>
-          <a:ln xmlns:a="http://schemas.openxmlformats.org/drawingml/2006/main" w="0">
-            <a:noFill/>
-            <a:prstDash val="solid"/>
-          </a:ln>
-        </p:spPr>
-        <p:txBody>
-          <a:bodyPr xmlns:a="http://schemas.openxmlformats.org/drawingml/2006/main"/>
-          <a:lstStyle xmlns:a="http://schemas.openxmlformats.org/drawingml/2006/main">
-            <a:defPPr algn="ctr">
-              <a:defRPr sz="975" b="1">
-                <a:solidFill>
-                  <a:srgbClr val="F7FBFF"/>
-                </a:solidFill>
-              </a:defRPr>
-            </a:defPPr>
-          </a:lstStyle>
-          <a:p xmlns:a="http://schemas.openxmlformats.org/drawingml/2006/main">
-            <a:pPr algn="ctr">
-              <a:defRPr sz="975" b="1">
-                <a:solidFill>
-                  <a:srgbClr val="F7FBFF"/>
-                </a:solidFill>
-              </a:defRPr>
-            </a:pPr>
-            <a:r>
-              <a:rPr sz="975" b="1">
-                <a:solidFill>
-                  <a:srgbClr val="F7FBFF"/>
-                </a:solidFill>
-              </a:rPr>
-              <a:t>172.31.255.0/29</a:t>
-            </a:r>
-          </a:p>
-        </p:txBody>
-      </p:sp>
-      <p:sp>
-        <p:nvSpPr>
-          <p:cNvPr id="27" name="">
-            <a:extLst xmlns:a="http://schemas.openxmlformats.org/drawingml/2006/main">
-              <a:ext uri="{FF2B5EF4-FFF2-40B4-BE49-F238E27FC236}">
-                <a16:creationId xmlns:a16="http://schemas.microsoft.com/office/drawing/2014/main" id="{9733ED73-3AA0-4FBB-856A-E3C91CFE2138}"/>
-              </a:ext>
-            </a:extLst>
-          </p:cNvPr>
-          <p:cNvSpPr>
-            <a:spLocks xmlns:a="http://schemas.openxmlformats.org/drawingml/2006/main" noGrp="1"/>
-          </p:cNvSpPr>
-          <p:nvPr/>
-        </p:nvSpPr>
-        <p:spPr>
-          <a:xfrm xmlns:a="http://schemas.openxmlformats.org/drawingml/2006/main">
-            <a:off x="6762750" y="4038600"/>
-            <a:ext cx="1828800" cy="323850"/>
-          </a:xfrm>
-          <a:prstGeom xmlns:a="http://schemas.openxmlformats.org/drawingml/2006/main" prst="roundRect">
-            <a:avLst>
-              <a:gd name="adj" fmla="val 50000"/>
-            </a:avLst>
-          </a:prstGeom>
-          <a:solidFill xmlns:a="http://schemas.openxmlformats.org/drawingml/2006/main">
-            <a:srgbClr val="0E2B42"/>
-          </a:solidFill>
-          <a:ln xmlns:a="http://schemas.openxmlformats.org/drawingml/2006/main" w="0">
-            <a:noFill/>
-            <a:prstDash val="solid"/>
-          </a:ln>
-        </p:spPr>
-      </p:sp>
-      <p:sp>
-        <p:nvSpPr>
-          <p:cNvPr id="28" name="">
-            <a:extLst xmlns:a="http://schemas.openxmlformats.org/drawingml/2006/main">
-              <a:ext uri="{FF2B5EF4-FFF2-40B4-BE49-F238E27FC236}">
-                <a16:creationId xmlns:a16="http://schemas.microsoft.com/office/drawing/2014/main" id="{645F6693-1A8A-4D71-A898-76A10EF60EF9}"/>
-              </a:ext>
-            </a:extLst>
-          </p:cNvPr>
-          <p:cNvSpPr>
-            <a:spLocks xmlns:a="http://schemas.openxmlformats.org/drawingml/2006/main" noGrp="1"/>
-          </p:cNvSpPr>
-          <p:nvPr/>
-        </p:nvSpPr>
-        <p:spPr>
-          <a:xfrm xmlns:a="http://schemas.openxmlformats.org/drawingml/2006/main">
-            <a:off x="6877050" y="4105275"/>
-            <a:ext cx="1600200" cy="190500"/>
-          </a:xfrm>
-          <a:prstGeom xmlns:a="http://schemas.openxmlformats.org/drawingml/2006/main" prst="rect">
-            <a:avLst/>
-          </a:prstGeom>
-          <a:noFill xmlns:a="http://schemas.openxmlformats.org/drawingml/2006/main"/>
-          <a:ln xmlns:a="http://schemas.openxmlformats.org/drawingml/2006/main" w="0">
-            <a:noFill/>
-            <a:prstDash val="solid"/>
-          </a:ln>
-        </p:spPr>
-        <p:txBody>
-          <a:bodyPr xmlns:a="http://schemas.openxmlformats.org/drawingml/2006/main"/>
-          <a:lstStyle xmlns:a="http://schemas.openxmlformats.org/drawingml/2006/main">
-            <a:defPPr algn="ctr">
-              <a:defRPr sz="975" b="1">
-                <a:solidFill>
-                  <a:srgbClr val="F7FBFF"/>
-                </a:solidFill>
-              </a:defRPr>
-            </a:defPPr>
-          </a:lstStyle>
-          <a:p xmlns:a="http://schemas.openxmlformats.org/drawingml/2006/main">
-            <a:pPr algn="ctr">
-              <a:defRPr sz="975" b="1">
-                <a:solidFill>
-                  <a:srgbClr val="F7FBFF"/>
-                </a:solidFill>
-              </a:defRPr>
-            </a:pPr>
-            <a:r>
-              <a:rPr sz="975" b="1">
-                <a:solidFill>
-                  <a:srgbClr val="F7FBFF"/>
-                </a:solidFill>
-              </a:rPr>
-              <a:t>192.168.88.12 / .13</a:t>
-            </a:r>
-          </a:p>
-        </p:txBody>
-      </p:sp>
-      <p:sp>
-        <p:nvSpPr>
-          <p:cNvPr id="29" name="">
-            <a:extLst xmlns:a="http://schemas.openxmlformats.org/drawingml/2006/main">
-              <a:ext uri="{FF2B5EF4-FFF2-40B4-BE49-F238E27FC236}">
-                <a16:creationId xmlns:a16="http://schemas.microsoft.com/office/drawing/2014/main" id="{DE7A742F-340F-46AD-BD0F-BC909A0BBE00}"/>
-              </a:ext>
-            </a:extLst>
-          </p:cNvPr>
-          <p:cNvSpPr>
-            <a:spLocks xmlns:a="http://schemas.openxmlformats.org/drawingml/2006/main" noGrp="1"/>
-          </p:cNvSpPr>
-          <p:nvPr/>
-        </p:nvSpPr>
-        <p:spPr>
-          <a:xfrm xmlns:a="http://schemas.openxmlformats.org/drawingml/2006/main">
-            <a:off x="10020300" y="4038600"/>
-            <a:ext cx="857250" cy="323850"/>
-          </a:xfrm>
-          <a:prstGeom xmlns:a="http://schemas.openxmlformats.org/drawingml/2006/main" prst="roundRect">
-            <a:avLst>
-              <a:gd name="adj" fmla="val 50000"/>
-            </a:avLst>
-          </a:prstGeom>
-          <a:solidFill xmlns:a="http://schemas.openxmlformats.org/drawingml/2006/main">
-            <a:srgbClr val="FF9D42"/>
-          </a:solidFill>
-          <a:ln xmlns:a="http://schemas.openxmlformats.org/drawingml/2006/main" w="0">
-            <a:noFill/>
-            <a:prstDash val="solid"/>
-          </a:ln>
-        </p:spPr>
-      </p:sp>
-      <p:sp>
-        <p:nvSpPr>
-          <p:cNvPr id="30" name="">
-            <a:extLst xmlns:a="http://schemas.openxmlformats.org/drawingml/2006/main">
-              <a:ext uri="{FF2B5EF4-FFF2-40B4-BE49-F238E27FC236}">
-                <a16:creationId xmlns:a16="http://schemas.microsoft.com/office/drawing/2014/main" id="{9709E0FB-A0A1-4EE5-B692-79D7C0D5AFEE}"/>
-              </a:ext>
-            </a:extLst>
-          </p:cNvPr>
-          <p:cNvSpPr>
-            <a:spLocks xmlns:a="http://schemas.openxmlformats.org/drawingml/2006/main" noGrp="1"/>
-          </p:cNvSpPr>
-          <p:nvPr/>
-        </p:nvSpPr>
-        <p:spPr>
-          <a:xfrm xmlns:a="http://schemas.openxmlformats.org/drawingml/2006/main">
-            <a:off x="10134600" y="4105275"/>
-            <a:ext cx="628650" cy="190500"/>
-          </a:xfrm>
-          <a:prstGeom xmlns:a="http://schemas.openxmlformats.org/drawingml/2006/main" prst="rect">
-            <a:avLst/>
-          </a:prstGeom>
-          <a:noFill xmlns:a="http://schemas.openxmlformats.org/drawingml/2006/main"/>
-          <a:ln xmlns:a="http://schemas.openxmlformats.org/drawingml/2006/main" w="0">
-            <a:noFill/>
-            <a:prstDash val="solid"/>
-          </a:ln>
-        </p:spPr>
-        <p:txBody>
-          <a:bodyPr xmlns:a="http://schemas.openxmlformats.org/drawingml/2006/main"/>
-          <a:lstStyle xmlns:a="http://schemas.openxmlformats.org/drawingml/2006/main">
-            <a:defPPr algn="ctr">
-              <a:defRPr sz="975" b="1">
-                <a:solidFill>
-                  <a:srgbClr val="071A2B"/>
-                </a:solidFill>
-              </a:defRPr>
-            </a:defPPr>
-          </a:lstStyle>
-          <a:p xmlns:a="http://schemas.openxmlformats.org/drawingml/2006/main">
-            <a:pPr algn="ctr">
-              <a:defRPr sz="975" b="1">
-                <a:solidFill>
-                  <a:srgbClr val="071A2B"/>
-                </a:solidFill>
-              </a:defRPr>
-            </a:pPr>
-            <a:r>
-              <a:rPr sz="975" b="1">
-                <a:solidFill>
-                  <a:srgbClr val="071A2B"/>
-                </a:solidFill>
-              </a:rPr>
-              <a:t>BGP</a:t>
-            </a:r>
-          </a:p>
-        </p:txBody>
-      </p:sp>
-      <p:sp>
-        <p:nvSpPr>
-          <p:cNvPr id="31" name="">
-            <a:extLst xmlns:a="http://schemas.openxmlformats.org/drawingml/2006/main">
-              <a:ext uri="{FF2B5EF4-FFF2-40B4-BE49-F238E27FC236}">
-                <a16:creationId xmlns:a16="http://schemas.microsoft.com/office/drawing/2014/main" id="{5A11103E-1238-4F3A-88A9-C5B3D4845E26}"/>
-              </a:ext>
-            </a:extLst>
-          </p:cNvPr>
-          <p:cNvSpPr>
-            <a:spLocks xmlns:a="http://schemas.openxmlformats.org/drawingml/2006/main" noGrp="1"/>
-          </p:cNvSpPr>
-          <p:nvPr/>
-        </p:nvSpPr>
-        <p:spPr>
-          <a:xfrm xmlns:a="http://schemas.openxmlformats.org/drawingml/2006/main">
-            <a:off x="2714625" y="4857750"/>
-            <a:ext cx="6858000" cy="838200"/>
-          </a:xfrm>
-          <a:prstGeom xmlns:a="http://schemas.openxmlformats.org/drawingml/2006/main" prst="roundRect">
-            <a:avLst>
-              <a:gd name="adj" fmla="val 13636"/>
+              <a:gd name="adj" fmla="val 19355"/>
             </a:avLst>
           </a:prstGeom>
           <a:solidFill xmlns:a="http://schemas.openxmlformats.org/drawingml/2006/main">
@@ -7303,22 +6939,22 @@
       </p:sp>
       <p:sp>
         <p:nvSpPr>
-          <p:cNvPr id="32" name="">
-            <a:extLst xmlns:a="http://schemas.openxmlformats.org/drawingml/2006/main">
-              <a:ext uri="{FF2B5EF4-FFF2-40B4-BE49-F238E27FC236}">
-                <a16:creationId xmlns:a16="http://schemas.microsoft.com/office/drawing/2014/main" id="{A2334389-3913-4219-8CBB-546FF19F34ED}"/>
-              </a:ext>
-            </a:extLst>
-          </p:cNvPr>
-          <p:cNvSpPr>
-            <a:spLocks xmlns:a="http://schemas.openxmlformats.org/drawingml/2006/main" noGrp="1"/>
-          </p:cNvSpPr>
-          <p:nvPr/>
-        </p:nvSpPr>
-        <p:spPr>
-          <a:xfrm xmlns:a="http://schemas.openxmlformats.org/drawingml/2006/main">
-            <a:off x="3000375" y="5067300"/>
-            <a:ext cx="6286500" cy="457200"/>
+          <p:cNvPr id="24" name="">
+            <a:extLst xmlns:a="http://schemas.openxmlformats.org/drawingml/2006/main">
+              <a:ext uri="{FF2B5EF4-FFF2-40B4-BE49-F238E27FC236}">
+                <a16:creationId xmlns:a16="http://schemas.microsoft.com/office/drawing/2014/main" id="{C0C6AAA6-D8A3-442F-97A8-A5355560CDDC}"/>
+              </a:ext>
+            </a:extLst>
+          </p:cNvPr>
+          <p:cNvSpPr>
+            <a:spLocks xmlns:a="http://schemas.openxmlformats.org/drawingml/2006/main" noGrp="1"/>
+          </p:cNvSpPr>
+          <p:nvPr/>
+        </p:nvSpPr>
+        <p:spPr>
+          <a:xfrm xmlns:a="http://schemas.openxmlformats.org/drawingml/2006/main">
+            <a:off x="666750" y="4152900"/>
+            <a:ext cx="1866900" cy="400050"/>
           </a:xfrm>
           <a:prstGeom xmlns:a="http://schemas.openxmlformats.org/drawingml/2006/main" prst="rect">
             <a:avLst/>
@@ -7333,7 +6969,7 @@
           <a:bodyPr xmlns:a="http://schemas.openxmlformats.org/drawingml/2006/main"/>
           <a:lstStyle xmlns:a="http://schemas.openxmlformats.org/drawingml/2006/main">
             <a:defPPr algn="ctr">
-              <a:defRPr sz="1500" b="1">
+              <a:defRPr sz="1125" b="1">
                 <a:solidFill>
                   <a:srgbClr val="F7FBFF"/>
                 </a:solidFill>
@@ -7342,19 +6978,451 @@
           </a:lstStyle>
           <a:p xmlns:a="http://schemas.openxmlformats.org/drawingml/2006/main">
             <a:pPr algn="ctr">
-              <a:defRPr sz="1500" b="1">
-                <a:solidFill>
-                  <a:srgbClr val="F7FBFF"/>
-                </a:solidFill>
-              </a:defRPr>
-            </a:pPr>
-            <a:r>
-              <a:rPr sz="1500" b="1">
-                <a:solidFill>
-                  <a:srgbClr val="F7FBFF"/>
-                </a:solidFill>
-              </a:rPr>
-              <a:t>Kubernetes supplies placement, restart, configuration, secrets, and observability.</a:t>
+              <a:defRPr sz="1125" b="1">
+                <a:solidFill>
+                  <a:srgbClr val="F7FBFF"/>
+                </a:solidFill>
+              </a:defRPr>
+            </a:pPr>
+            <a:r>
+              <a:rPr sz="1125" b="1">
+                <a:solidFill>
+                  <a:srgbClr val="F7FBFF"/>
+                </a:solidFill>
+              </a:rPr>
+              <a:t>Subscriber access</a:t>
+            </a:r>
+          </a:p>
+          <a:p xmlns:a="http://schemas.openxmlformats.org/drawingml/2006/main">
+            <a:pPr algn="ctr">
+              <a:defRPr sz="1125" b="1">
+                <a:solidFill>
+                  <a:srgbClr val="F7FBFF"/>
+                </a:solidFill>
+              </a:defRPr>
+            </a:pPr>
+            <a:r>
+              <a:rPr sz="1125" b="1">
+                <a:solidFill>
+                  <a:srgbClr val="F7FBFF"/>
+                </a:solidFill>
+              </a:rPr>
+              <a:t>VLANs 100–119</a:t>
+            </a:r>
+          </a:p>
+        </p:txBody>
+      </p:sp>
+      <p:sp>
+        <p:nvSpPr>
+          <p:cNvPr id="25" name="">
+            <a:extLst xmlns:a="http://schemas.openxmlformats.org/drawingml/2006/main">
+              <a:ext uri="{FF2B5EF4-FFF2-40B4-BE49-F238E27FC236}">
+                <a16:creationId xmlns:a16="http://schemas.microsoft.com/office/drawing/2014/main" id="{1060F738-A97F-46FC-ADAB-72360583EA58}"/>
+              </a:ext>
+            </a:extLst>
+          </p:cNvPr>
+          <p:cNvSpPr>
+            <a:spLocks xmlns:a="http://schemas.openxmlformats.org/drawingml/2006/main" noGrp="1"/>
+          </p:cNvSpPr>
+          <p:nvPr/>
+        </p:nvSpPr>
+        <p:spPr>
+          <a:xfrm xmlns:a="http://schemas.openxmlformats.org/drawingml/2006/main">
+            <a:off x="3333750" y="4048125"/>
+            <a:ext cx="2381250" cy="590550"/>
+          </a:xfrm>
+          <a:prstGeom xmlns:a="http://schemas.openxmlformats.org/drawingml/2006/main" prst="roundRect">
+            <a:avLst>
+              <a:gd name="adj" fmla="val 19355"/>
+            </a:avLst>
+          </a:prstGeom>
+          <a:solidFill xmlns:a="http://schemas.openxmlformats.org/drawingml/2006/main">
+            <a:srgbClr val="102C41"/>
+          </a:solidFill>
+          <a:ln xmlns:a="http://schemas.openxmlformats.org/drawingml/2006/main" w="0">
+            <a:noFill/>
+            <a:prstDash val="solid"/>
+          </a:ln>
+        </p:spPr>
+      </p:sp>
+      <p:sp>
+        <p:nvSpPr>
+          <p:cNvPr id="26" name="">
+            <a:extLst xmlns:a="http://schemas.openxmlformats.org/drawingml/2006/main">
+              <a:ext uri="{FF2B5EF4-FFF2-40B4-BE49-F238E27FC236}">
+                <a16:creationId xmlns:a16="http://schemas.microsoft.com/office/drawing/2014/main" id="{C370C099-668A-40EC-BB01-BA7F0E5D6D8A}"/>
+              </a:ext>
+            </a:extLst>
+          </p:cNvPr>
+          <p:cNvSpPr>
+            <a:spLocks xmlns:a="http://schemas.openxmlformats.org/drawingml/2006/main" noGrp="1"/>
+          </p:cNvSpPr>
+          <p:nvPr/>
+        </p:nvSpPr>
+        <p:spPr>
+          <a:xfrm xmlns:a="http://schemas.openxmlformats.org/drawingml/2006/main">
+            <a:off x="3486150" y="4152900"/>
+            <a:ext cx="2076450" cy="400050"/>
+          </a:xfrm>
+          <a:prstGeom xmlns:a="http://schemas.openxmlformats.org/drawingml/2006/main" prst="rect">
+            <a:avLst/>
+          </a:prstGeom>
+          <a:noFill xmlns:a="http://schemas.openxmlformats.org/drawingml/2006/main"/>
+          <a:ln xmlns:a="http://schemas.openxmlformats.org/drawingml/2006/main" w="0">
+            <a:noFill/>
+            <a:prstDash val="solid"/>
+          </a:ln>
+        </p:spPr>
+        <p:txBody>
+          <a:bodyPr xmlns:a="http://schemas.openxmlformats.org/drawingml/2006/main"/>
+          <a:lstStyle xmlns:a="http://schemas.openxmlformats.org/drawingml/2006/main">
+            <a:defPPr algn="ctr">
+              <a:defRPr sz="1125" b="1">
+                <a:solidFill>
+                  <a:srgbClr val="F7FBFF"/>
+                </a:solidFill>
+              </a:defRPr>
+            </a:defPPr>
+          </a:lstStyle>
+          <a:p xmlns:a="http://schemas.openxmlformats.org/drawingml/2006/main">
+            <a:pPr algn="ctr">
+              <a:defRPr sz="1125" b="1">
+                <a:solidFill>
+                  <a:srgbClr val="F7FBFF"/>
+                </a:solidFill>
+              </a:defRPr>
+            </a:pPr>
+            <a:r>
+              <a:rPr sz="1125" b="1">
+                <a:solidFill>
+                  <a:srgbClr val="F7FBFF"/>
+                </a:solidFill>
+              </a:rPr>
+              <a:t>BNG–FRR transit</a:t>
+            </a:r>
+          </a:p>
+          <a:p xmlns:a="http://schemas.openxmlformats.org/drawingml/2006/main">
+            <a:pPr algn="ctr">
+              <a:defRPr sz="1125" b="1">
+                <a:solidFill>
+                  <a:srgbClr val="F7FBFF"/>
+                </a:solidFill>
+              </a:defRPr>
+            </a:pPr>
+            <a:r>
+              <a:rPr sz="1125" b="1">
+                <a:solidFill>
+                  <a:srgbClr val="F7FBFF"/>
+                </a:solidFill>
+              </a:rPr>
+              <a:t>172.31.255.0/29</a:t>
+            </a:r>
+          </a:p>
+        </p:txBody>
+      </p:sp>
+      <p:sp>
+        <p:nvSpPr>
+          <p:cNvPr id="27" name="">
+            <a:extLst xmlns:a="http://schemas.openxmlformats.org/drawingml/2006/main">
+              <a:ext uri="{FF2B5EF4-FFF2-40B4-BE49-F238E27FC236}">
+                <a16:creationId xmlns:a16="http://schemas.microsoft.com/office/drawing/2014/main" id="{8A0E09E8-8FDD-4B82-B651-46836E493B3D}"/>
+              </a:ext>
+            </a:extLst>
+          </p:cNvPr>
+          <p:cNvSpPr>
+            <a:spLocks xmlns:a="http://schemas.openxmlformats.org/drawingml/2006/main" noGrp="1"/>
+          </p:cNvSpPr>
+          <p:nvPr/>
+        </p:nvSpPr>
+        <p:spPr>
+          <a:xfrm xmlns:a="http://schemas.openxmlformats.org/drawingml/2006/main">
+            <a:off x="6572250" y="4048125"/>
+            <a:ext cx="2190750" cy="590550"/>
+          </a:xfrm>
+          <a:prstGeom xmlns:a="http://schemas.openxmlformats.org/drawingml/2006/main" prst="roundRect">
+            <a:avLst>
+              <a:gd name="adj" fmla="val 19355"/>
+            </a:avLst>
+          </a:prstGeom>
+          <a:solidFill xmlns:a="http://schemas.openxmlformats.org/drawingml/2006/main">
+            <a:srgbClr val="102C41"/>
+          </a:solidFill>
+          <a:ln xmlns:a="http://schemas.openxmlformats.org/drawingml/2006/main" w="0">
+            <a:noFill/>
+            <a:prstDash val="solid"/>
+          </a:ln>
+        </p:spPr>
+      </p:sp>
+      <p:sp>
+        <p:nvSpPr>
+          <p:cNvPr id="28" name="">
+            <a:extLst xmlns:a="http://schemas.openxmlformats.org/drawingml/2006/main">
+              <a:ext uri="{FF2B5EF4-FFF2-40B4-BE49-F238E27FC236}">
+                <a16:creationId xmlns:a16="http://schemas.microsoft.com/office/drawing/2014/main" id="{B92F3281-DD42-4569-A578-371B8D9B8CC5}"/>
+              </a:ext>
+            </a:extLst>
+          </p:cNvPr>
+          <p:cNvSpPr>
+            <a:spLocks xmlns:a="http://schemas.openxmlformats.org/drawingml/2006/main" noGrp="1"/>
+          </p:cNvSpPr>
+          <p:nvPr/>
+        </p:nvSpPr>
+        <p:spPr>
+          <a:xfrm xmlns:a="http://schemas.openxmlformats.org/drawingml/2006/main">
+            <a:off x="6705600" y="4152900"/>
+            <a:ext cx="1924050" cy="400050"/>
+          </a:xfrm>
+          <a:prstGeom xmlns:a="http://schemas.openxmlformats.org/drawingml/2006/main" prst="rect">
+            <a:avLst/>
+          </a:prstGeom>
+          <a:noFill xmlns:a="http://schemas.openxmlformats.org/drawingml/2006/main"/>
+          <a:ln xmlns:a="http://schemas.openxmlformats.org/drawingml/2006/main" w="0">
+            <a:noFill/>
+            <a:prstDash val="solid"/>
+          </a:ln>
+        </p:spPr>
+        <p:txBody>
+          <a:bodyPr xmlns:a="http://schemas.openxmlformats.org/drawingml/2006/main"/>
+          <a:lstStyle xmlns:a="http://schemas.openxmlformats.org/drawingml/2006/main">
+            <a:defPPr algn="ctr">
+              <a:defRPr sz="1125" b="1">
+                <a:solidFill>
+                  <a:srgbClr val="F7FBFF"/>
+                </a:solidFill>
+              </a:defRPr>
+            </a:defPPr>
+          </a:lstStyle>
+          <a:p xmlns:a="http://schemas.openxmlformats.org/drawingml/2006/main">
+            <a:pPr algn="ctr">
+              <a:defRPr sz="1125" b="1">
+                <a:solidFill>
+                  <a:srgbClr val="F7FBFF"/>
+                </a:solidFill>
+              </a:defRPr>
+            </a:pPr>
+            <a:r>
+              <a:rPr sz="1125" b="1">
+                <a:solidFill>
+                  <a:srgbClr val="F7FBFF"/>
+                </a:solidFill>
+              </a:rPr>
+              <a:t>FRR–MikroTik uplink</a:t>
+            </a:r>
+          </a:p>
+          <a:p xmlns:a="http://schemas.openxmlformats.org/drawingml/2006/main">
+            <a:pPr algn="ctr">
+              <a:defRPr sz="1125" b="1">
+                <a:solidFill>
+                  <a:srgbClr val="F7FBFF"/>
+                </a:solidFill>
+              </a:defRPr>
+            </a:pPr>
+            <a:r>
+              <a:rPr sz="1125" b="1">
+                <a:solidFill>
+                  <a:srgbClr val="F7FBFF"/>
+                </a:solidFill>
+              </a:rPr>
+              <a:t>192.168.88.12 / .13</a:t>
+            </a:r>
+          </a:p>
+        </p:txBody>
+      </p:sp>
+      <p:sp>
+        <p:nvSpPr>
+          <p:cNvPr id="29" name="">
+            <a:extLst xmlns:a="http://schemas.openxmlformats.org/drawingml/2006/main">
+              <a:ext uri="{FF2B5EF4-FFF2-40B4-BE49-F238E27FC236}">
+                <a16:creationId xmlns:a16="http://schemas.microsoft.com/office/drawing/2014/main" id="{15E49002-2E3C-4ED4-95ED-EA97ED85697A}"/>
+              </a:ext>
+            </a:extLst>
+          </p:cNvPr>
+          <p:cNvSpPr>
+            <a:spLocks xmlns:a="http://schemas.openxmlformats.org/drawingml/2006/main" noGrp="1"/>
+          </p:cNvSpPr>
+          <p:nvPr/>
+        </p:nvSpPr>
+        <p:spPr>
+          <a:xfrm xmlns:a="http://schemas.openxmlformats.org/drawingml/2006/main">
+            <a:off x="9525000" y="4048125"/>
+            <a:ext cx="2095500" cy="590550"/>
+          </a:xfrm>
+          <a:prstGeom xmlns:a="http://schemas.openxmlformats.org/drawingml/2006/main" prst="roundRect">
+            <a:avLst>
+              <a:gd name="adj" fmla="val 19355"/>
+            </a:avLst>
+          </a:prstGeom>
+          <a:solidFill xmlns:a="http://schemas.openxmlformats.org/drawingml/2006/main">
+            <a:srgbClr val="102C41"/>
+          </a:solidFill>
+          <a:ln xmlns:a="http://schemas.openxmlformats.org/drawingml/2006/main" w="0">
+            <a:noFill/>
+            <a:prstDash val="solid"/>
+          </a:ln>
+        </p:spPr>
+      </p:sp>
+      <p:sp>
+        <p:nvSpPr>
+          <p:cNvPr id="30" name="">
+            <a:extLst xmlns:a="http://schemas.openxmlformats.org/drawingml/2006/main">
+              <a:ext uri="{FF2B5EF4-FFF2-40B4-BE49-F238E27FC236}">
+                <a16:creationId xmlns:a16="http://schemas.microsoft.com/office/drawing/2014/main" id="{CD007679-2770-4788-B51E-1CB79C861A5C}"/>
+              </a:ext>
+            </a:extLst>
+          </p:cNvPr>
+          <p:cNvSpPr>
+            <a:spLocks xmlns:a="http://schemas.openxmlformats.org/drawingml/2006/main" noGrp="1"/>
+          </p:cNvSpPr>
+          <p:nvPr/>
+        </p:nvSpPr>
+        <p:spPr>
+          <a:xfrm xmlns:a="http://schemas.openxmlformats.org/drawingml/2006/main">
+            <a:off x="9639300" y="4152900"/>
+            <a:ext cx="1866900" cy="400050"/>
+          </a:xfrm>
+          <a:prstGeom xmlns:a="http://schemas.openxmlformats.org/drawingml/2006/main" prst="rect">
+            <a:avLst/>
+          </a:prstGeom>
+          <a:noFill xmlns:a="http://schemas.openxmlformats.org/drawingml/2006/main"/>
+          <a:ln xmlns:a="http://schemas.openxmlformats.org/drawingml/2006/main" w="0">
+            <a:noFill/>
+            <a:prstDash val="solid"/>
+          </a:ln>
+        </p:spPr>
+        <p:txBody>
+          <a:bodyPr xmlns:a="http://schemas.openxmlformats.org/drawingml/2006/main"/>
+          <a:lstStyle xmlns:a="http://schemas.openxmlformats.org/drawingml/2006/main">
+            <a:defPPr algn="ctr">
+              <a:defRPr sz="1125" b="1">
+                <a:solidFill>
+                  <a:srgbClr val="F7FBFF"/>
+                </a:solidFill>
+              </a:defRPr>
+            </a:defPPr>
+          </a:lstStyle>
+          <a:p xmlns:a="http://schemas.openxmlformats.org/drawingml/2006/main">
+            <a:pPr algn="ctr">
+              <a:defRPr sz="1125" b="1">
+                <a:solidFill>
+                  <a:srgbClr val="F7FBFF"/>
+                </a:solidFill>
+              </a:defRPr>
+            </a:pPr>
+            <a:r>
+              <a:rPr sz="1125" b="1">
+                <a:solidFill>
+                  <a:srgbClr val="F7FBFF"/>
+                </a:solidFill>
+              </a:rPr>
+              <a:t>Upstream LAN</a:t>
+            </a:r>
+          </a:p>
+          <a:p xmlns:a="http://schemas.openxmlformats.org/drawingml/2006/main">
+            <a:pPr algn="ctr">
+              <a:defRPr sz="1125" b="1">
+                <a:solidFill>
+                  <a:srgbClr val="F7FBFF"/>
+                </a:solidFill>
+              </a:defRPr>
+            </a:pPr>
+            <a:r>
+              <a:rPr sz="1125" b="1">
+                <a:solidFill>
+                  <a:srgbClr val="F7FBFF"/>
+                </a:solidFill>
+              </a:rPr>
+              <a:t>192.168.88.0/24</a:t>
+            </a:r>
+          </a:p>
+        </p:txBody>
+      </p:sp>
+      <p:sp>
+        <p:nvSpPr>
+          <p:cNvPr id="31" name="">
+            <a:extLst xmlns:a="http://schemas.openxmlformats.org/drawingml/2006/main">
+              <a:ext uri="{FF2B5EF4-FFF2-40B4-BE49-F238E27FC236}">
+                <a16:creationId xmlns:a16="http://schemas.microsoft.com/office/drawing/2014/main" id="{91132683-9797-4A4D-B318-8B39AE337F4F}"/>
+              </a:ext>
+            </a:extLst>
+          </p:cNvPr>
+          <p:cNvSpPr>
+            <a:spLocks xmlns:a="http://schemas.openxmlformats.org/drawingml/2006/main" noGrp="1"/>
+          </p:cNvSpPr>
+          <p:nvPr/>
+        </p:nvSpPr>
+        <p:spPr>
+          <a:xfrm xmlns:a="http://schemas.openxmlformats.org/drawingml/2006/main">
+            <a:off x="2714625" y="5010150"/>
+            <a:ext cx="6858000" cy="685800"/>
+          </a:xfrm>
+          <a:prstGeom xmlns:a="http://schemas.openxmlformats.org/drawingml/2006/main" prst="roundRect">
+            <a:avLst>
+              <a:gd name="adj" fmla="val 16667"/>
+            </a:avLst>
+          </a:prstGeom>
+          <a:solidFill xmlns:a="http://schemas.openxmlformats.org/drawingml/2006/main">
+            <a:srgbClr val="102C41"/>
+          </a:solidFill>
+          <a:ln xmlns:a="http://schemas.openxmlformats.org/drawingml/2006/main" w="0">
+            <a:noFill/>
+            <a:prstDash val="solid"/>
+          </a:ln>
+        </p:spPr>
+      </p:sp>
+      <p:sp>
+        <p:nvSpPr>
+          <p:cNvPr id="32" name="">
+            <a:extLst xmlns:a="http://schemas.openxmlformats.org/drawingml/2006/main">
+              <a:ext uri="{FF2B5EF4-FFF2-40B4-BE49-F238E27FC236}">
+                <a16:creationId xmlns:a16="http://schemas.microsoft.com/office/drawing/2014/main" id="{42D467BA-BF7B-4C49-BF8A-8B59C4584D4D}"/>
+              </a:ext>
+            </a:extLst>
+          </p:cNvPr>
+          <p:cNvSpPr>
+            <a:spLocks xmlns:a="http://schemas.openxmlformats.org/drawingml/2006/main" noGrp="1"/>
+          </p:cNvSpPr>
+          <p:nvPr/>
+        </p:nvSpPr>
+        <p:spPr>
+          <a:xfrm xmlns:a="http://schemas.openxmlformats.org/drawingml/2006/main">
+            <a:off x="3000375" y="5191125"/>
+            <a:ext cx="6286500" cy="381000"/>
+          </a:xfrm>
+          <a:prstGeom xmlns:a="http://schemas.openxmlformats.org/drawingml/2006/main" prst="rect">
+            <a:avLst/>
+          </a:prstGeom>
+          <a:noFill xmlns:a="http://schemas.openxmlformats.org/drawingml/2006/main"/>
+          <a:ln xmlns:a="http://schemas.openxmlformats.org/drawingml/2006/main" w="0">
+            <a:noFill/>
+            <a:prstDash val="solid"/>
+          </a:ln>
+        </p:spPr>
+        <p:txBody>
+          <a:bodyPr xmlns:a="http://schemas.openxmlformats.org/drawingml/2006/main"/>
+          <a:lstStyle xmlns:a="http://schemas.openxmlformats.org/drawingml/2006/main">
+            <a:defPPr algn="ctr">
+              <a:defRPr sz="1425" b="1">
+                <a:solidFill>
+                  <a:srgbClr val="F7FBFF"/>
+                </a:solidFill>
+              </a:defRPr>
+            </a:defPPr>
+          </a:lstStyle>
+          <a:p xmlns:a="http://schemas.openxmlformats.org/drawingml/2006/main">
+            <a:pPr algn="ctr">
+              <a:defRPr sz="1425" b="1">
+                <a:solidFill>
+                  <a:srgbClr val="F7FBFF"/>
+                </a:solidFill>
+              </a:defRPr>
+            </a:pPr>
+            <a:r>
+              <a:rPr sz="1425" b="1">
+                <a:solidFill>
+                  <a:srgbClr val="F7FBFF"/>
+                </a:solidFill>
+              </a:rPr>
+              <a:t>Kubernetes manages placement, restart, configuration, secrets, and observability.</a:t>
             </a:r>
           </a:p>
         </p:txBody>
@@ -7364,7 +7432,7 @@
           <p:cNvPr id="33" name="">
             <a:extLst xmlns:a="http://schemas.openxmlformats.org/drawingml/2006/main">
               <a:ext uri="{FF2B5EF4-FFF2-40B4-BE49-F238E27FC236}">
-                <a16:creationId xmlns:a16="http://schemas.microsoft.com/office/drawing/2014/main" id="{7E984343-0836-4CC2-B22E-22B80EEDA091}"/>
+                <a16:creationId xmlns:a16="http://schemas.microsoft.com/office/drawing/2014/main" id="{57750369-B89B-483F-B2EB-8FCA21C9E646}"/>
               </a:ext>
             </a:extLst>
           </p:cNvPr>
@@ -7397,7 +7465,7 @@
           <p:cNvPr id="34" name="">
             <a:extLst xmlns:a="http://schemas.openxmlformats.org/drawingml/2006/main">
               <a:ext uri="{FF2B5EF4-FFF2-40B4-BE49-F238E27FC236}">
-                <a16:creationId xmlns:a16="http://schemas.microsoft.com/office/drawing/2014/main" id="{7F09609A-33BC-4B3A-B73C-E80CD8546943}"/>
+                <a16:creationId xmlns:a16="http://schemas.microsoft.com/office/drawing/2014/main" id="{FE7F64AA-3C93-48BF-934D-5F9F709E1452}"/>
               </a:ext>
             </a:extLst>
           </p:cNvPr>
@@ -7445,7 +7513,7 @@
                   <a:srgbClr val="A9C1D2"/>
                 </a:solidFill>
               </a:rPr>
-              <a:t>Lab defaults: FRR-A 192.168.88.12/24 and FRR-B 192.168.88.13/24.</a:t>
+              <a:t>Deployment addresses: FRR-A 192.168.88.12/24 and FRR-B 192.168.88.13/24.</a:t>
             </a:r>
           </a:p>
         </p:txBody>
@@ -7455,7 +7523,7 @@
           <p:cNvPr id="35" name="">
             <a:extLst xmlns:a="http://schemas.openxmlformats.org/drawingml/2006/main">
               <a:ext uri="{FF2B5EF4-FFF2-40B4-BE49-F238E27FC236}">
-                <a16:creationId xmlns:a16="http://schemas.microsoft.com/office/drawing/2014/main" id="{16D33F81-3523-4B0D-A2F7-39D4BF10331D}"/>
+                <a16:creationId xmlns:a16="http://schemas.microsoft.com/office/drawing/2014/main" id="{96DED55B-7B2D-4FA7-B9DB-7153B7A508F7}"/>
               </a:ext>
             </a:extLst>
           </p:cNvPr>
@@ -7511,7 +7579,7 @@
     </p:spTree>
     <p:extLst>
       <p:ext uri="{BB962C8B-B14F-4D97-AF65-F5344CB8AC3E}">
-        <p14:creationId xmlns:p14="http://schemas.microsoft.com/office/powerpoint/2010/main" val="1180467466"/>
+        <p14:creationId xmlns:p14="http://schemas.microsoft.com/office/powerpoint/2010/main" val="2019975046"/>
       </p:ext>
     </p:extLst>
   </p:cSld>
@@ -7542,7 +7610,7 @@
           <p:cNvPr id="39" name="">
             <a:extLst xmlns:a="http://schemas.openxmlformats.org/drawingml/2006/main">
               <a:ext uri="{FF2B5EF4-FFF2-40B4-BE49-F238E27FC236}">
-                <a16:creationId xmlns:a16="http://schemas.microsoft.com/office/drawing/2014/main" id="{C406E061-3AFD-480C-A67E-24795E6C89CA}"/>
+                <a16:creationId xmlns:a16="http://schemas.microsoft.com/office/drawing/2014/main" id="{3EB0B0FC-7A0A-4856-8907-C9DA2E863847}"/>
               </a:ext>
             </a:extLst>
           </p:cNvPr>
@@ -7600,7 +7668,7 @@
           <p:cNvPr id="2" name="">
             <a:extLst xmlns:a="http://schemas.openxmlformats.org/drawingml/2006/main">
               <a:ext uri="{FF2B5EF4-FFF2-40B4-BE49-F238E27FC236}">
-                <a16:creationId xmlns:a16="http://schemas.microsoft.com/office/drawing/2014/main" id="{17A3983F-05CB-49B0-8457-8AC28CE35216}"/>
+                <a16:creationId xmlns:a16="http://schemas.microsoft.com/office/drawing/2014/main" id="{DD6AAEBC-637B-4F48-8C8B-095E7666C704}"/>
               </a:ext>
             </a:extLst>
           </p:cNvPr>
@@ -7658,7 +7726,7 @@
           <p:cNvPr id="3" name="">
             <a:extLst xmlns:a="http://schemas.openxmlformats.org/drawingml/2006/main">
               <a:ext uri="{FF2B5EF4-FFF2-40B4-BE49-F238E27FC236}">
-                <a16:creationId xmlns:a16="http://schemas.microsoft.com/office/drawing/2014/main" id="{AC5A647D-1B6D-460A-9FA8-21075B6A0954}"/>
+                <a16:creationId xmlns:a16="http://schemas.microsoft.com/office/drawing/2014/main" id="{AFB82F61-10C9-40C5-8DE1-3CACE3BE06A0}"/>
               </a:ext>
             </a:extLst>
           </p:cNvPr>
@@ -7716,7 +7784,7 @@
           <p:cNvPr id="4" name="">
             <a:extLst xmlns:a="http://schemas.openxmlformats.org/drawingml/2006/main">
               <a:ext uri="{FF2B5EF4-FFF2-40B4-BE49-F238E27FC236}">
-                <a16:creationId xmlns:a16="http://schemas.microsoft.com/office/drawing/2014/main" id="{A7D90434-24F2-43D5-8FCF-9F1ADB379147}"/>
+                <a16:creationId xmlns:a16="http://schemas.microsoft.com/office/drawing/2014/main" id="{CB54558F-5EF7-4EDB-8B24-64BCECAA7E37}"/>
               </a:ext>
             </a:extLst>
           </p:cNvPr>
@@ -7751,7 +7819,7 @@
           <p:cNvPr id="5" name="">
             <a:extLst xmlns:a="http://schemas.openxmlformats.org/drawingml/2006/main">
               <a:ext uri="{FF2B5EF4-FFF2-40B4-BE49-F238E27FC236}">
-                <a16:creationId xmlns:a16="http://schemas.microsoft.com/office/drawing/2014/main" id="{2366AC08-41B5-41EF-9473-CFBCC16E8EE8}"/>
+                <a16:creationId xmlns:a16="http://schemas.microsoft.com/office/drawing/2014/main" id="{096F355B-C761-4428-826F-3C0EC7EABEC2}"/>
               </a:ext>
             </a:extLst>
           </p:cNvPr>
@@ -7784,7 +7852,7 @@
           <p:cNvPr id="6" name="">
             <a:extLst xmlns:a="http://schemas.openxmlformats.org/drawingml/2006/main">
               <a:ext uri="{FF2B5EF4-FFF2-40B4-BE49-F238E27FC236}">
-                <a16:creationId xmlns:a16="http://schemas.microsoft.com/office/drawing/2014/main" id="{2D031843-C90B-41F7-8CA4-ABED6CFD193D}"/>
+                <a16:creationId xmlns:a16="http://schemas.microsoft.com/office/drawing/2014/main" id="{809ABBF6-919D-47AB-BB83-5B10B286622A}"/>
               </a:ext>
             </a:extLst>
           </p:cNvPr>
@@ -7842,7 +7910,7 @@
           <p:cNvPr id="7" name="">
             <a:extLst xmlns:a="http://schemas.openxmlformats.org/drawingml/2006/main">
               <a:ext uri="{FF2B5EF4-FFF2-40B4-BE49-F238E27FC236}">
-                <a16:creationId xmlns:a16="http://schemas.microsoft.com/office/drawing/2014/main" id="{F97EB0AB-4614-4DF9-A4CC-6E4CBD707E0E}"/>
+                <a16:creationId xmlns:a16="http://schemas.microsoft.com/office/drawing/2014/main" id="{E88838E8-B463-43EB-8C4F-39A22693BBC8}"/>
               </a:ext>
             </a:extLst>
           </p:cNvPr>
@@ -7900,7 +7968,7 @@
           <p:cNvPr id="8" name="">
             <a:extLst xmlns:a="http://schemas.openxmlformats.org/drawingml/2006/main">
               <a:ext uri="{FF2B5EF4-FFF2-40B4-BE49-F238E27FC236}">
-                <a16:creationId xmlns:a16="http://schemas.microsoft.com/office/drawing/2014/main" id="{4CC00818-506D-4511-AD67-7B37F92174A5}"/>
+                <a16:creationId xmlns:a16="http://schemas.microsoft.com/office/drawing/2014/main" id="{A4E28051-7CBA-47FE-8FBA-9C84E805E002}"/>
               </a:ext>
             </a:extLst>
           </p:cNvPr>
@@ -7975,7 +8043,7 @@
           <p:cNvPr id="9" name="">
             <a:extLst xmlns:a="http://schemas.openxmlformats.org/drawingml/2006/main">
               <a:ext uri="{FF2B5EF4-FFF2-40B4-BE49-F238E27FC236}">
-                <a16:creationId xmlns:a16="http://schemas.microsoft.com/office/drawing/2014/main" id="{5F73567C-E395-4B1E-87E8-C74E97D9E0C0}"/>
+                <a16:creationId xmlns:a16="http://schemas.microsoft.com/office/drawing/2014/main" id="{0FD6731C-C668-4C6E-AE35-D60021B13ADB}"/>
               </a:ext>
             </a:extLst>
           </p:cNvPr>
@@ -8008,7 +8076,7 @@
           <p:cNvPr id="10" name="">
             <a:extLst xmlns:a="http://schemas.openxmlformats.org/drawingml/2006/main">
               <a:ext uri="{FF2B5EF4-FFF2-40B4-BE49-F238E27FC236}">
-                <a16:creationId xmlns:a16="http://schemas.microsoft.com/office/drawing/2014/main" id="{6D8C7DDA-A11E-4086-B25D-CC1966801E4B}"/>
+                <a16:creationId xmlns:a16="http://schemas.microsoft.com/office/drawing/2014/main" id="{23EF415B-107C-49CD-B277-AA0C45EC4BCE}"/>
               </a:ext>
             </a:extLst>
           </p:cNvPr>
@@ -8043,7 +8111,7 @@
           <p:cNvPr id="11" name="">
             <a:extLst xmlns:a="http://schemas.openxmlformats.org/drawingml/2006/main">
               <a:ext uri="{FF2B5EF4-FFF2-40B4-BE49-F238E27FC236}">
-                <a16:creationId xmlns:a16="http://schemas.microsoft.com/office/drawing/2014/main" id="{1EA6782E-1FE8-4655-8D5D-88890463BC6C}"/>
+                <a16:creationId xmlns:a16="http://schemas.microsoft.com/office/drawing/2014/main" id="{CE70A637-7A22-47B6-9D20-15962CC7EC9C}"/>
               </a:ext>
             </a:extLst>
           </p:cNvPr>
@@ -8076,7 +8144,7 @@
           <p:cNvPr id="12" name="">
             <a:extLst xmlns:a="http://schemas.openxmlformats.org/drawingml/2006/main">
               <a:ext uri="{FF2B5EF4-FFF2-40B4-BE49-F238E27FC236}">
-                <a16:creationId xmlns:a16="http://schemas.microsoft.com/office/drawing/2014/main" id="{91A04D5A-F5F7-404E-BAE5-6BDC946F0628}"/>
+                <a16:creationId xmlns:a16="http://schemas.microsoft.com/office/drawing/2014/main" id="{1296B640-4ECE-4CF6-A96F-5FDEC7E50874}"/>
               </a:ext>
             </a:extLst>
           </p:cNvPr>
@@ -8134,7 +8202,7 @@
           <p:cNvPr id="13" name="">
             <a:extLst xmlns:a="http://schemas.openxmlformats.org/drawingml/2006/main">
               <a:ext uri="{FF2B5EF4-FFF2-40B4-BE49-F238E27FC236}">
-                <a16:creationId xmlns:a16="http://schemas.microsoft.com/office/drawing/2014/main" id="{7A91677B-E71A-465A-B2D9-8FB64BC8CB16}"/>
+                <a16:creationId xmlns:a16="http://schemas.microsoft.com/office/drawing/2014/main" id="{C43D644E-1538-48D0-9075-2EB826D724D6}"/>
               </a:ext>
             </a:extLst>
           </p:cNvPr>
@@ -8192,7 +8260,7 @@
           <p:cNvPr id="14" name="">
             <a:extLst xmlns:a="http://schemas.openxmlformats.org/drawingml/2006/main">
               <a:ext uri="{FF2B5EF4-FFF2-40B4-BE49-F238E27FC236}">
-                <a16:creationId xmlns:a16="http://schemas.microsoft.com/office/drawing/2014/main" id="{88E7731E-0327-4CDB-8AB3-434421B6F182}"/>
+                <a16:creationId xmlns:a16="http://schemas.microsoft.com/office/drawing/2014/main" id="{D571663A-E78E-4E8B-B625-9E78CC8C4540}"/>
               </a:ext>
             </a:extLst>
           </p:cNvPr>
@@ -8267,7 +8335,7 @@
           <p:cNvPr id="15" name="">
             <a:extLst xmlns:a="http://schemas.openxmlformats.org/drawingml/2006/main">
               <a:ext uri="{FF2B5EF4-FFF2-40B4-BE49-F238E27FC236}">
-                <a16:creationId xmlns:a16="http://schemas.microsoft.com/office/drawing/2014/main" id="{AE0D575C-2507-417F-8948-D85CCCD97E0D}"/>
+                <a16:creationId xmlns:a16="http://schemas.microsoft.com/office/drawing/2014/main" id="{78FD09AA-CDD3-476A-BD7B-A0017EF131F7}"/>
               </a:ext>
             </a:extLst>
           </p:cNvPr>
@@ -8300,7 +8368,7 @@
           <p:cNvPr id="16" name="">
             <a:extLst xmlns:a="http://schemas.openxmlformats.org/drawingml/2006/main">
               <a:ext uri="{FF2B5EF4-FFF2-40B4-BE49-F238E27FC236}">
-                <a16:creationId xmlns:a16="http://schemas.microsoft.com/office/drawing/2014/main" id="{C65FBE4A-8D02-487A-BE8F-4FDEEB1AA5D4}"/>
+                <a16:creationId xmlns:a16="http://schemas.microsoft.com/office/drawing/2014/main" id="{25D9427F-283E-45D8-9FB9-A17FD4C3E4A2}"/>
               </a:ext>
             </a:extLst>
           </p:cNvPr>
@@ -8335,7 +8403,7 @@
           <p:cNvPr id="17" name="">
             <a:extLst xmlns:a="http://schemas.openxmlformats.org/drawingml/2006/main">
               <a:ext uri="{FF2B5EF4-FFF2-40B4-BE49-F238E27FC236}">
-                <a16:creationId xmlns:a16="http://schemas.microsoft.com/office/drawing/2014/main" id="{08FFAAEE-6FB4-4B7A-9A8C-B29593AEE817}"/>
+                <a16:creationId xmlns:a16="http://schemas.microsoft.com/office/drawing/2014/main" id="{F30334ED-33DE-4827-B11F-3097C92413EE}"/>
               </a:ext>
             </a:extLst>
           </p:cNvPr>
@@ -8368,7 +8436,7 @@
           <p:cNvPr id="18" name="">
             <a:extLst xmlns:a="http://schemas.openxmlformats.org/drawingml/2006/main">
               <a:ext uri="{FF2B5EF4-FFF2-40B4-BE49-F238E27FC236}">
-                <a16:creationId xmlns:a16="http://schemas.microsoft.com/office/drawing/2014/main" id="{9642354F-C63C-427F-BB9A-6552A50C5FA9}"/>
+                <a16:creationId xmlns:a16="http://schemas.microsoft.com/office/drawing/2014/main" id="{09894E45-5B0D-4AD0-B6E8-892B8DE7F33F}"/>
               </a:ext>
             </a:extLst>
           </p:cNvPr>
@@ -8426,7 +8494,7 @@
           <p:cNvPr id="19" name="">
             <a:extLst xmlns:a="http://schemas.openxmlformats.org/drawingml/2006/main">
               <a:ext uri="{FF2B5EF4-FFF2-40B4-BE49-F238E27FC236}">
-                <a16:creationId xmlns:a16="http://schemas.microsoft.com/office/drawing/2014/main" id="{0C104FDA-08DF-4C5A-A238-16442E1DBB5F}"/>
+                <a16:creationId xmlns:a16="http://schemas.microsoft.com/office/drawing/2014/main" id="{7F71B145-9BB3-46F9-B8FB-1B8044D5C4D7}"/>
               </a:ext>
             </a:extLst>
           </p:cNvPr>
@@ -8484,7 +8552,7 @@
           <p:cNvPr id="20" name="">
             <a:extLst xmlns:a="http://schemas.openxmlformats.org/drawingml/2006/main">
               <a:ext uri="{FF2B5EF4-FFF2-40B4-BE49-F238E27FC236}">
-                <a16:creationId xmlns:a16="http://schemas.microsoft.com/office/drawing/2014/main" id="{CB674793-1D02-4855-BA6A-0F9E419E7370}"/>
+                <a16:creationId xmlns:a16="http://schemas.microsoft.com/office/drawing/2014/main" id="{55BDE642-C1C5-4BDB-84CE-7E9D31CD5A1E}"/>
               </a:ext>
             </a:extLst>
           </p:cNvPr>
@@ -8559,7 +8627,7 @@
           <p:cNvPr id="21" name="">
             <a:extLst xmlns:a="http://schemas.openxmlformats.org/drawingml/2006/main">
               <a:ext uri="{FF2B5EF4-FFF2-40B4-BE49-F238E27FC236}">
-                <a16:creationId xmlns:a16="http://schemas.microsoft.com/office/drawing/2014/main" id="{4CF3FC69-CFFF-4701-985F-3BCEAB683615}"/>
+                <a16:creationId xmlns:a16="http://schemas.microsoft.com/office/drawing/2014/main" id="{387D7D52-0B7A-4753-A270-A455BFC2EAB4}"/>
               </a:ext>
             </a:extLst>
           </p:cNvPr>
@@ -8592,7 +8660,7 @@
           <p:cNvPr id="22" name="">
             <a:extLst xmlns:a="http://schemas.openxmlformats.org/drawingml/2006/main">
               <a:ext uri="{FF2B5EF4-FFF2-40B4-BE49-F238E27FC236}">
-                <a16:creationId xmlns:a16="http://schemas.microsoft.com/office/drawing/2014/main" id="{896787F6-7BB8-4274-BC1B-E778645CEA50}"/>
+                <a16:creationId xmlns:a16="http://schemas.microsoft.com/office/drawing/2014/main" id="{230929D0-5CAB-4ACF-9D5C-31D72CE071FA}"/>
               </a:ext>
             </a:extLst>
           </p:cNvPr>
@@ -8627,7 +8695,7 @@
           <p:cNvPr id="23" name="">
             <a:extLst xmlns:a="http://schemas.openxmlformats.org/drawingml/2006/main">
               <a:ext uri="{FF2B5EF4-FFF2-40B4-BE49-F238E27FC236}">
-                <a16:creationId xmlns:a16="http://schemas.microsoft.com/office/drawing/2014/main" id="{49DEA2D7-5C0E-4504-ADC9-F878FEA1D3B9}"/>
+                <a16:creationId xmlns:a16="http://schemas.microsoft.com/office/drawing/2014/main" id="{F31D9BE8-864D-4681-BB2D-B7A77ED2C807}"/>
               </a:ext>
             </a:extLst>
           </p:cNvPr>
@@ -8660,7 +8728,7 @@
           <p:cNvPr id="24" name="">
             <a:extLst xmlns:a="http://schemas.openxmlformats.org/drawingml/2006/main">
               <a:ext uri="{FF2B5EF4-FFF2-40B4-BE49-F238E27FC236}">
-                <a16:creationId xmlns:a16="http://schemas.microsoft.com/office/drawing/2014/main" id="{7C0A6946-CABE-4AB5-A596-EC5292CB6A56}"/>
+                <a16:creationId xmlns:a16="http://schemas.microsoft.com/office/drawing/2014/main" id="{0F81F8CD-C8EB-47EF-9582-0231CA43CE12}"/>
               </a:ext>
             </a:extLst>
           </p:cNvPr>
@@ -8718,7 +8786,7 @@
           <p:cNvPr id="25" name="">
             <a:extLst xmlns:a="http://schemas.openxmlformats.org/drawingml/2006/main">
               <a:ext uri="{FF2B5EF4-FFF2-40B4-BE49-F238E27FC236}">
-                <a16:creationId xmlns:a16="http://schemas.microsoft.com/office/drawing/2014/main" id="{29BF0DC6-C55A-4C48-8624-D64DA89881CE}"/>
+                <a16:creationId xmlns:a16="http://schemas.microsoft.com/office/drawing/2014/main" id="{7A9C0BF3-6F28-4F72-BF14-F01F2D539FEC}"/>
               </a:ext>
             </a:extLst>
           </p:cNvPr>
@@ -8776,7 +8844,7 @@
           <p:cNvPr id="26" name="">
             <a:extLst xmlns:a="http://schemas.openxmlformats.org/drawingml/2006/main">
               <a:ext uri="{FF2B5EF4-FFF2-40B4-BE49-F238E27FC236}">
-                <a16:creationId xmlns:a16="http://schemas.microsoft.com/office/drawing/2014/main" id="{E9BD5AAB-A0CC-4717-B27B-D03F1C26DCB0}"/>
+                <a16:creationId xmlns:a16="http://schemas.microsoft.com/office/drawing/2014/main" id="{978E2C1A-D93C-4E44-81C7-6D6141244480}"/>
               </a:ext>
             </a:extLst>
           </p:cNvPr>
@@ -8851,7 +8919,7 @@
           <p:cNvPr id="27" name="">
             <a:extLst xmlns:a="http://schemas.openxmlformats.org/drawingml/2006/main">
               <a:ext uri="{FF2B5EF4-FFF2-40B4-BE49-F238E27FC236}">
-                <a16:creationId xmlns:a16="http://schemas.microsoft.com/office/drawing/2014/main" id="{2F6188AB-EB25-49C8-9031-1229773FE5A2}"/>
+                <a16:creationId xmlns:a16="http://schemas.microsoft.com/office/drawing/2014/main" id="{4251568F-6F99-49EC-884F-29F471CB0C98}"/>
               </a:ext>
             </a:extLst>
           </p:cNvPr>
@@ -8884,7 +8952,7 @@
           <p:cNvPr id="28" name="">
             <a:extLst xmlns:a="http://schemas.openxmlformats.org/drawingml/2006/main">
               <a:ext uri="{FF2B5EF4-FFF2-40B4-BE49-F238E27FC236}">
-                <a16:creationId xmlns:a16="http://schemas.microsoft.com/office/drawing/2014/main" id="{5676E788-B69F-4ADF-A692-F7BB82980AC7}"/>
+                <a16:creationId xmlns:a16="http://schemas.microsoft.com/office/drawing/2014/main" id="{3CA5CCC3-7DFC-486A-82C3-3C8BEBB60988}"/>
               </a:ext>
             </a:extLst>
           </p:cNvPr>
@@ -8919,7 +8987,7 @@
           <p:cNvPr id="29" name="">
             <a:extLst xmlns:a="http://schemas.openxmlformats.org/drawingml/2006/main">
               <a:ext uri="{FF2B5EF4-FFF2-40B4-BE49-F238E27FC236}">
-                <a16:creationId xmlns:a16="http://schemas.microsoft.com/office/drawing/2014/main" id="{E788AADA-AF11-489E-8171-A4439379655B}"/>
+                <a16:creationId xmlns:a16="http://schemas.microsoft.com/office/drawing/2014/main" id="{B493D558-AADE-4C1C-BA8A-34CA85F32F98}"/>
               </a:ext>
             </a:extLst>
           </p:cNvPr>
@@ -8952,7 +9020,7 @@
           <p:cNvPr id="30" name="">
             <a:extLst xmlns:a="http://schemas.openxmlformats.org/drawingml/2006/main">
               <a:ext uri="{FF2B5EF4-FFF2-40B4-BE49-F238E27FC236}">
-                <a16:creationId xmlns:a16="http://schemas.microsoft.com/office/drawing/2014/main" id="{2716A821-A134-4891-A0D4-1B835777FF21}"/>
+                <a16:creationId xmlns:a16="http://schemas.microsoft.com/office/drawing/2014/main" id="{86284D0F-EBEB-44FA-9C03-C862CF2F293F}"/>
               </a:ext>
             </a:extLst>
           </p:cNvPr>
@@ -9010,7 +9078,7 @@
           <p:cNvPr id="31" name="">
             <a:extLst xmlns:a="http://schemas.openxmlformats.org/drawingml/2006/main">
               <a:ext uri="{FF2B5EF4-FFF2-40B4-BE49-F238E27FC236}">
-                <a16:creationId xmlns:a16="http://schemas.microsoft.com/office/drawing/2014/main" id="{352CA6CE-A1A0-4445-87F9-B6C580C7394A}"/>
+                <a16:creationId xmlns:a16="http://schemas.microsoft.com/office/drawing/2014/main" id="{11B3C3CE-B904-4704-9205-40C0A8591FDE}"/>
               </a:ext>
             </a:extLst>
           </p:cNvPr>
@@ -9068,7 +9136,7 @@
           <p:cNvPr id="32" name="">
             <a:extLst xmlns:a="http://schemas.openxmlformats.org/drawingml/2006/main">
               <a:ext uri="{FF2B5EF4-FFF2-40B4-BE49-F238E27FC236}">
-                <a16:creationId xmlns:a16="http://schemas.microsoft.com/office/drawing/2014/main" id="{794A4C25-5DCF-42C4-AEA2-D872802C66C8}"/>
+                <a16:creationId xmlns:a16="http://schemas.microsoft.com/office/drawing/2014/main" id="{FB0CC195-3358-4449-A04A-4B4730AC0A87}"/>
               </a:ext>
             </a:extLst>
           </p:cNvPr>
@@ -9143,7 +9211,7 @@
           <p:cNvPr id="33" name="">
             <a:extLst xmlns:a="http://schemas.openxmlformats.org/drawingml/2006/main">
               <a:ext uri="{FF2B5EF4-FFF2-40B4-BE49-F238E27FC236}">
-                <a16:creationId xmlns:a16="http://schemas.microsoft.com/office/drawing/2014/main" id="{75A8AA4B-D986-426C-A7FE-F2DC6C48F97F}"/>
+                <a16:creationId xmlns:a16="http://schemas.microsoft.com/office/drawing/2014/main" id="{3E975205-7416-4CD6-AFA0-E4C91626FC7B}"/>
               </a:ext>
             </a:extLst>
           </p:cNvPr>
@@ -9176,7 +9244,7 @@
           <p:cNvPr id="34" name="">
             <a:extLst xmlns:a="http://schemas.openxmlformats.org/drawingml/2006/main">
               <a:ext uri="{FF2B5EF4-FFF2-40B4-BE49-F238E27FC236}">
-                <a16:creationId xmlns:a16="http://schemas.microsoft.com/office/drawing/2014/main" id="{01197200-75DC-419E-9E0B-538A4BAE0C24}"/>
+                <a16:creationId xmlns:a16="http://schemas.microsoft.com/office/drawing/2014/main" id="{7A2B4802-1639-4729-9211-FB6F2FFFBCB2}"/>
               </a:ext>
             </a:extLst>
           </p:cNvPr>
@@ -9234,7 +9302,7 @@
           <p:cNvPr id="35" name="">
             <a:extLst xmlns:a="http://schemas.openxmlformats.org/drawingml/2006/main">
               <a:ext uri="{FF2B5EF4-FFF2-40B4-BE49-F238E27FC236}">
-                <a16:creationId xmlns:a16="http://schemas.microsoft.com/office/drawing/2014/main" id="{F90DE3E0-2247-43A7-BDC6-D22EA2290AB3}"/>
+                <a16:creationId xmlns:a16="http://schemas.microsoft.com/office/drawing/2014/main" id="{5FD53929-3ABA-48F6-873F-07763726AFE7}"/>
               </a:ext>
             </a:extLst>
           </p:cNvPr>
@@ -9292,7 +9360,7 @@
           <p:cNvPr id="36" name="">
             <a:extLst xmlns:a="http://schemas.openxmlformats.org/drawingml/2006/main">
               <a:ext uri="{FF2B5EF4-FFF2-40B4-BE49-F238E27FC236}">
-                <a16:creationId xmlns:a16="http://schemas.microsoft.com/office/drawing/2014/main" id="{20146B03-A9F0-4CA6-8871-0EE0CBF806CA}"/>
+                <a16:creationId xmlns:a16="http://schemas.microsoft.com/office/drawing/2014/main" id="{CB728E84-EE4D-4DB6-8053-51B6FB4B291E}"/>
               </a:ext>
             </a:extLst>
           </p:cNvPr>
@@ -9325,7 +9393,7 @@
           <p:cNvPr id="37" name="">
             <a:extLst xmlns:a="http://schemas.openxmlformats.org/drawingml/2006/main">
               <a:ext uri="{FF2B5EF4-FFF2-40B4-BE49-F238E27FC236}">
-                <a16:creationId xmlns:a16="http://schemas.microsoft.com/office/drawing/2014/main" id="{53325828-E0D3-4218-BB48-ED8DD3B66ACD}"/>
+                <a16:creationId xmlns:a16="http://schemas.microsoft.com/office/drawing/2014/main" id="{ED63C8F9-0633-48B8-992F-0667B19AEBCA}"/>
               </a:ext>
             </a:extLst>
           </p:cNvPr>
@@ -9383,7 +9451,7 @@
           <p:cNvPr id="38" name="">
             <a:extLst xmlns:a="http://schemas.openxmlformats.org/drawingml/2006/main">
               <a:ext uri="{FF2B5EF4-FFF2-40B4-BE49-F238E27FC236}">
-                <a16:creationId xmlns:a16="http://schemas.microsoft.com/office/drawing/2014/main" id="{CF1BD6FD-ECFF-45E2-B0E1-ABEA94A7A027}"/>
+                <a16:creationId xmlns:a16="http://schemas.microsoft.com/office/drawing/2014/main" id="{9049C8EE-5262-4D66-8E9F-65680F1B0470}"/>
               </a:ext>
             </a:extLst>
           </p:cNvPr>
@@ -9439,7 +9507,7 @@
     </p:spTree>
     <p:extLst>
       <p:ext uri="{BB962C8B-B14F-4D97-AF65-F5344CB8AC3E}">
-        <p14:creationId xmlns:p14="http://schemas.microsoft.com/office/powerpoint/2010/main" val="1368876300"/>
+        <p14:creationId xmlns:p14="http://schemas.microsoft.com/office/powerpoint/2010/main" val="887674554"/>
       </p:ext>
     </p:extLst>
   </p:cSld>
@@ -9470,7 +9538,7 @@
           <p:cNvPr id="33" name="">
             <a:extLst xmlns:a="http://schemas.openxmlformats.org/drawingml/2006/main">
               <a:ext uri="{FF2B5EF4-FFF2-40B4-BE49-F238E27FC236}">
-                <a16:creationId xmlns:a16="http://schemas.microsoft.com/office/drawing/2014/main" id="{440A651E-63C6-4E2D-B3EA-34A481BDCA2A}"/>
+                <a16:creationId xmlns:a16="http://schemas.microsoft.com/office/drawing/2014/main" id="{734827D0-89AC-4047-A96C-3CE4615A5D54}"/>
               </a:ext>
             </a:extLst>
           </p:cNvPr>
@@ -9528,7 +9596,7 @@
           <p:cNvPr id="2" name="">
             <a:extLst xmlns:a="http://schemas.openxmlformats.org/drawingml/2006/main">
               <a:ext uri="{FF2B5EF4-FFF2-40B4-BE49-F238E27FC236}">
-                <a16:creationId xmlns:a16="http://schemas.microsoft.com/office/drawing/2014/main" id="{1F4FE75B-2825-4D4D-9719-D0C0BD428E22}"/>
+                <a16:creationId xmlns:a16="http://schemas.microsoft.com/office/drawing/2014/main" id="{F289DE4A-B9CD-4FD1-80C2-BA1F4992FA28}"/>
               </a:ext>
             </a:extLst>
           </p:cNvPr>
@@ -9586,7 +9654,7 @@
           <p:cNvPr id="3" name="">
             <a:extLst xmlns:a="http://schemas.openxmlformats.org/drawingml/2006/main">
               <a:ext uri="{FF2B5EF4-FFF2-40B4-BE49-F238E27FC236}">
-                <a16:creationId xmlns:a16="http://schemas.microsoft.com/office/drawing/2014/main" id="{53B6B362-718F-4CD6-A014-E03221B89D7F}"/>
+                <a16:creationId xmlns:a16="http://schemas.microsoft.com/office/drawing/2014/main" id="{C41283AE-B704-46E4-B331-5251D51DF768}"/>
               </a:ext>
             </a:extLst>
           </p:cNvPr>
@@ -9644,7 +9712,7 @@
           <p:cNvPr id="4" name="">
             <a:extLst xmlns:a="http://schemas.openxmlformats.org/drawingml/2006/main">
               <a:ext uri="{FF2B5EF4-FFF2-40B4-BE49-F238E27FC236}">
-                <a16:creationId xmlns:a16="http://schemas.microsoft.com/office/drawing/2014/main" id="{175E5960-F5F5-4DA4-A708-7AB82DB0349B}"/>
+                <a16:creationId xmlns:a16="http://schemas.microsoft.com/office/drawing/2014/main" id="{028EE183-A806-44F5-95C2-7A1F5AAE02CA}"/>
               </a:ext>
             </a:extLst>
           </p:cNvPr>
@@ -9679,7 +9747,7 @@
           <p:cNvPr id="5" name="">
             <a:extLst xmlns:a="http://schemas.openxmlformats.org/drawingml/2006/main">
               <a:ext uri="{FF2B5EF4-FFF2-40B4-BE49-F238E27FC236}">
-                <a16:creationId xmlns:a16="http://schemas.microsoft.com/office/drawing/2014/main" id="{A7328612-E75D-4C84-92CE-C9564CEAADDF}"/>
+                <a16:creationId xmlns:a16="http://schemas.microsoft.com/office/drawing/2014/main" id="{7A1A2248-006F-4D96-9C9A-5545EE6A46EF}"/>
               </a:ext>
             </a:extLst>
           </p:cNvPr>
@@ -9737,7 +9805,7 @@
           <p:cNvPr id="6" name="">
             <a:extLst xmlns:a="http://schemas.openxmlformats.org/drawingml/2006/main">
               <a:ext uri="{FF2B5EF4-FFF2-40B4-BE49-F238E27FC236}">
-                <a16:creationId xmlns:a16="http://schemas.microsoft.com/office/drawing/2014/main" id="{892647B7-C087-4AAC-9185-CF1BB2CB6BAC}"/>
+                <a16:creationId xmlns:a16="http://schemas.microsoft.com/office/drawing/2014/main" id="{B44AF42A-32FE-4D0D-959C-9C2BCF0DCF6D}"/>
               </a:ext>
             </a:extLst>
           </p:cNvPr>
@@ -9770,7 +9838,7 @@
           <p:cNvPr id="7" name="">
             <a:extLst xmlns:a="http://schemas.openxmlformats.org/drawingml/2006/main">
               <a:ext uri="{FF2B5EF4-FFF2-40B4-BE49-F238E27FC236}">
-                <a16:creationId xmlns:a16="http://schemas.microsoft.com/office/drawing/2014/main" id="{27DBC333-C01B-45F5-8CE3-5AE3CC2CDE99}"/>
+                <a16:creationId xmlns:a16="http://schemas.microsoft.com/office/drawing/2014/main" id="{B30A77BB-A2D3-4743-A9EC-B8427A62DE0F}"/>
               </a:ext>
             </a:extLst>
           </p:cNvPr>
@@ -9828,7 +9896,7 @@
           <p:cNvPr id="8" name="">
             <a:extLst xmlns:a="http://schemas.openxmlformats.org/drawingml/2006/main">
               <a:ext uri="{FF2B5EF4-FFF2-40B4-BE49-F238E27FC236}">
-                <a16:creationId xmlns:a16="http://schemas.microsoft.com/office/drawing/2014/main" id="{C086CBDD-4E35-44A6-B8E6-A29FCA960BF0}"/>
+                <a16:creationId xmlns:a16="http://schemas.microsoft.com/office/drawing/2014/main" id="{34A899FF-C6CA-4D85-9CEA-CCE970D4D70E}"/>
               </a:ext>
             </a:extLst>
           </p:cNvPr>
@@ -9861,7 +9929,7 @@
           <p:cNvPr id="9" name="">
             <a:extLst xmlns:a="http://schemas.openxmlformats.org/drawingml/2006/main">
               <a:ext uri="{FF2B5EF4-FFF2-40B4-BE49-F238E27FC236}">
-                <a16:creationId xmlns:a16="http://schemas.microsoft.com/office/drawing/2014/main" id="{75F29EF0-49E4-4999-81E3-93F00CA1A1F7}"/>
+                <a16:creationId xmlns:a16="http://schemas.microsoft.com/office/drawing/2014/main" id="{39BFF172-0845-4A6B-BA0A-624CF2EB6747}"/>
               </a:ext>
             </a:extLst>
           </p:cNvPr>
@@ -9919,7 +9987,7 @@
           <p:cNvPr id="10" name="">
             <a:extLst xmlns:a="http://schemas.openxmlformats.org/drawingml/2006/main">
               <a:ext uri="{FF2B5EF4-FFF2-40B4-BE49-F238E27FC236}">
-                <a16:creationId xmlns:a16="http://schemas.microsoft.com/office/drawing/2014/main" id="{E79B32EB-7DD3-4B78-85A4-9A56F194697C}"/>
+                <a16:creationId xmlns:a16="http://schemas.microsoft.com/office/drawing/2014/main" id="{592397E8-4BA9-4D29-A7FF-C75997DC2006}"/>
               </a:ext>
             </a:extLst>
           </p:cNvPr>
@@ -9952,7 +10020,7 @@
           <p:cNvPr id="11" name="">
             <a:extLst xmlns:a="http://schemas.openxmlformats.org/drawingml/2006/main">
               <a:ext uri="{FF2B5EF4-FFF2-40B4-BE49-F238E27FC236}">
-                <a16:creationId xmlns:a16="http://schemas.microsoft.com/office/drawing/2014/main" id="{DFF2518E-57A9-4934-A0F1-B292CF946123}"/>
+                <a16:creationId xmlns:a16="http://schemas.microsoft.com/office/drawing/2014/main" id="{E56BE47B-CC8D-49A6-9438-1E9E9E72AF58}"/>
               </a:ext>
             </a:extLst>
           </p:cNvPr>
@@ -10010,7 +10078,7 @@
           <p:cNvPr id="12" name="">
             <a:extLst xmlns:a="http://schemas.openxmlformats.org/drawingml/2006/main">
               <a:ext uri="{FF2B5EF4-FFF2-40B4-BE49-F238E27FC236}">
-                <a16:creationId xmlns:a16="http://schemas.microsoft.com/office/drawing/2014/main" id="{3436B3B2-35A6-47E3-8FC3-D5546D17A193}"/>
+                <a16:creationId xmlns:a16="http://schemas.microsoft.com/office/drawing/2014/main" id="{2630C993-487E-458D-86F6-2BDA13C41EC0}"/>
               </a:ext>
             </a:extLst>
           </p:cNvPr>
@@ -10045,7 +10113,7 @@
           <p:cNvPr id="13" name="">
             <a:extLst xmlns:a="http://schemas.openxmlformats.org/drawingml/2006/main">
               <a:ext uri="{FF2B5EF4-FFF2-40B4-BE49-F238E27FC236}">
-                <a16:creationId xmlns:a16="http://schemas.microsoft.com/office/drawing/2014/main" id="{6F247C6C-0935-4EFA-96AA-A185DAB89A4F}"/>
+                <a16:creationId xmlns:a16="http://schemas.microsoft.com/office/drawing/2014/main" id="{047E950F-C3A6-4C0C-81A7-CD8E53E78332}"/>
               </a:ext>
             </a:extLst>
           </p:cNvPr>
@@ -10103,7 +10171,7 @@
           <p:cNvPr id="14" name="">
             <a:extLst xmlns:a="http://schemas.openxmlformats.org/drawingml/2006/main">
               <a:ext uri="{FF2B5EF4-FFF2-40B4-BE49-F238E27FC236}">
-                <a16:creationId xmlns:a16="http://schemas.microsoft.com/office/drawing/2014/main" id="{AED0333D-C294-43D2-BAFF-F7FB152C413B}"/>
+                <a16:creationId xmlns:a16="http://schemas.microsoft.com/office/drawing/2014/main" id="{C68B00B6-83FD-45BF-A361-13560D369C4F}"/>
               </a:ext>
             </a:extLst>
           </p:cNvPr>
@@ -10138,7 +10206,7 @@
           <p:cNvPr id="15" name="">
             <a:extLst xmlns:a="http://schemas.openxmlformats.org/drawingml/2006/main">
               <a:ext uri="{FF2B5EF4-FFF2-40B4-BE49-F238E27FC236}">
-                <a16:creationId xmlns:a16="http://schemas.microsoft.com/office/drawing/2014/main" id="{81705B50-B775-4465-B41C-74A550F9EC94}"/>
+                <a16:creationId xmlns:a16="http://schemas.microsoft.com/office/drawing/2014/main" id="{57B36EA8-FA22-4600-8E74-0C8EECB15AD6}"/>
               </a:ext>
             </a:extLst>
           </p:cNvPr>
@@ -10171,19 +10239,19 @@
           <p:cNvPr id="16" name="">
             <a:extLst xmlns:a="http://schemas.openxmlformats.org/drawingml/2006/main">
               <a:ext uri="{FF2B5EF4-FFF2-40B4-BE49-F238E27FC236}">
-                <a16:creationId xmlns:a16="http://schemas.microsoft.com/office/drawing/2014/main" id="{8A745BA4-C436-4624-8B64-A55042781E92}"/>
-              </a:ext>
-            </a:extLst>
-          </p:cNvPr>
-          <p:cNvSpPr>
-            <a:spLocks xmlns:a="http://schemas.openxmlformats.org/drawingml/2006/main" noGrp="1"/>
-          </p:cNvSpPr>
-          <p:nvPr/>
-        </p:nvSpPr>
-        <p:spPr>
-          <a:xfrm xmlns:a="http://schemas.openxmlformats.org/drawingml/2006/main">
-            <a:off x="6143625" y="3200400"/>
-            <a:ext cx="1219200" cy="285750"/>
+                <a16:creationId xmlns:a16="http://schemas.microsoft.com/office/drawing/2014/main" id="{83CDBB37-BD43-4E93-ADEF-2C5450843158}"/>
+              </a:ext>
+            </a:extLst>
+          </p:cNvPr>
+          <p:cNvSpPr>
+            <a:spLocks xmlns:a="http://schemas.openxmlformats.org/drawingml/2006/main" noGrp="1"/>
+          </p:cNvSpPr>
+          <p:nvPr/>
+        </p:nvSpPr>
+        <p:spPr>
+          <a:xfrm xmlns:a="http://schemas.openxmlformats.org/drawingml/2006/main">
+            <a:off x="6143625" y="3181350"/>
+            <a:ext cx="1219200" cy="495300"/>
           </a:xfrm>
           <a:prstGeom xmlns:a="http://schemas.openxmlformats.org/drawingml/2006/main" prst="rect">
             <a:avLst/>
@@ -10229,19 +10297,19 @@
           <p:cNvPr id="17" name="">
             <a:extLst xmlns:a="http://schemas.openxmlformats.org/drawingml/2006/main">
               <a:ext uri="{FF2B5EF4-FFF2-40B4-BE49-F238E27FC236}">
-                <a16:creationId xmlns:a16="http://schemas.microsoft.com/office/drawing/2014/main" id="{A29CA053-F210-4B70-9FA0-91A660F47113}"/>
-              </a:ext>
-            </a:extLst>
-          </p:cNvPr>
-          <p:cNvSpPr>
-            <a:spLocks xmlns:a="http://schemas.openxmlformats.org/drawingml/2006/main" noGrp="1"/>
-          </p:cNvSpPr>
-          <p:nvPr/>
-        </p:nvSpPr>
-        <p:spPr>
-          <a:xfrm xmlns:a="http://schemas.openxmlformats.org/drawingml/2006/main">
-            <a:off x="6143625" y="3524250"/>
-            <a:ext cx="1219200" cy="381000"/>
+                <a16:creationId xmlns:a16="http://schemas.microsoft.com/office/drawing/2014/main" id="{9145D737-0A5E-4899-9656-6F19F0912692}"/>
+              </a:ext>
+            </a:extLst>
+          </p:cNvPr>
+          <p:cNvSpPr>
+            <a:spLocks xmlns:a="http://schemas.openxmlformats.org/drawingml/2006/main" noGrp="1"/>
+          </p:cNvSpPr>
+          <p:nvPr/>
+        </p:nvSpPr>
+        <p:spPr>
+          <a:xfrm xmlns:a="http://schemas.openxmlformats.org/drawingml/2006/main">
+            <a:off x="6143625" y="3733800"/>
+            <a:ext cx="1219200" cy="171450"/>
           </a:xfrm>
           <a:prstGeom xmlns:a="http://schemas.openxmlformats.org/drawingml/2006/main" prst="rect">
             <a:avLst/>
@@ -10287,7 +10355,7 @@
           <p:cNvPr id="18" name="">
             <a:extLst xmlns:a="http://schemas.openxmlformats.org/drawingml/2006/main">
               <a:ext uri="{FF2B5EF4-FFF2-40B4-BE49-F238E27FC236}">
-                <a16:creationId xmlns:a16="http://schemas.microsoft.com/office/drawing/2014/main" id="{36643A98-11BE-4B7A-9812-39D5675CD61F}"/>
+                <a16:creationId xmlns:a16="http://schemas.microsoft.com/office/drawing/2014/main" id="{43236D99-4488-46E5-95A8-6A19C7C19480}"/>
               </a:ext>
             </a:extLst>
           </p:cNvPr>
@@ -10322,7 +10390,7 @@
           <p:cNvPr id="19" name="">
             <a:extLst xmlns:a="http://schemas.openxmlformats.org/drawingml/2006/main">
               <a:ext uri="{FF2B5EF4-FFF2-40B4-BE49-F238E27FC236}">
-                <a16:creationId xmlns:a16="http://schemas.microsoft.com/office/drawing/2014/main" id="{AB0935CC-EDD6-4B2A-BD0E-D0549CA44BF1}"/>
+                <a16:creationId xmlns:a16="http://schemas.microsoft.com/office/drawing/2014/main" id="{F4A17E69-93C5-401C-BF8A-4192E486A79E}"/>
               </a:ext>
             </a:extLst>
           </p:cNvPr>
@@ -10355,19 +10423,19 @@
           <p:cNvPr id="20" name="">
             <a:extLst xmlns:a="http://schemas.openxmlformats.org/drawingml/2006/main">
               <a:ext uri="{FF2B5EF4-FFF2-40B4-BE49-F238E27FC236}">
-                <a16:creationId xmlns:a16="http://schemas.microsoft.com/office/drawing/2014/main" id="{D8B7B3C6-BE03-4A89-9FB1-E4A21CFA1F62}"/>
-              </a:ext>
-            </a:extLst>
-          </p:cNvPr>
-          <p:cNvSpPr>
-            <a:spLocks xmlns:a="http://schemas.openxmlformats.org/drawingml/2006/main" noGrp="1"/>
-          </p:cNvSpPr>
-          <p:nvPr/>
-        </p:nvSpPr>
-        <p:spPr>
-          <a:xfrm xmlns:a="http://schemas.openxmlformats.org/drawingml/2006/main">
-            <a:off x="8001000" y="3200400"/>
-            <a:ext cx="1219200" cy="285750"/>
+                <a16:creationId xmlns:a16="http://schemas.microsoft.com/office/drawing/2014/main" id="{DEC0E91C-2E28-468A-8107-E4C35CAC69CE}"/>
+              </a:ext>
+            </a:extLst>
+          </p:cNvPr>
+          <p:cNvSpPr>
+            <a:spLocks xmlns:a="http://schemas.openxmlformats.org/drawingml/2006/main" noGrp="1"/>
+          </p:cNvSpPr>
+          <p:nvPr/>
+        </p:nvSpPr>
+        <p:spPr>
+          <a:xfrm xmlns:a="http://schemas.openxmlformats.org/drawingml/2006/main">
+            <a:off x="8001000" y="3181350"/>
+            <a:ext cx="1219200" cy="495300"/>
           </a:xfrm>
           <a:prstGeom xmlns:a="http://schemas.openxmlformats.org/drawingml/2006/main" prst="rect">
             <a:avLst/>
@@ -10413,19 +10481,19 @@
           <p:cNvPr id="21" name="">
             <a:extLst xmlns:a="http://schemas.openxmlformats.org/drawingml/2006/main">
               <a:ext uri="{FF2B5EF4-FFF2-40B4-BE49-F238E27FC236}">
-                <a16:creationId xmlns:a16="http://schemas.microsoft.com/office/drawing/2014/main" id="{8118960A-AC5C-446D-8944-3DB54D5A21D6}"/>
-              </a:ext>
-            </a:extLst>
-          </p:cNvPr>
-          <p:cNvSpPr>
-            <a:spLocks xmlns:a="http://schemas.openxmlformats.org/drawingml/2006/main" noGrp="1"/>
-          </p:cNvSpPr>
-          <p:nvPr/>
-        </p:nvSpPr>
-        <p:spPr>
-          <a:xfrm xmlns:a="http://schemas.openxmlformats.org/drawingml/2006/main">
-            <a:off x="8001000" y="3524250"/>
-            <a:ext cx="1219200" cy="381000"/>
+                <a16:creationId xmlns:a16="http://schemas.microsoft.com/office/drawing/2014/main" id="{5C053E92-1800-4861-8D02-E6C16719E283}"/>
+              </a:ext>
+            </a:extLst>
+          </p:cNvPr>
+          <p:cNvSpPr>
+            <a:spLocks xmlns:a="http://schemas.openxmlformats.org/drawingml/2006/main" noGrp="1"/>
+          </p:cNvSpPr>
+          <p:nvPr/>
+        </p:nvSpPr>
+        <p:spPr>
+          <a:xfrm xmlns:a="http://schemas.openxmlformats.org/drawingml/2006/main">
+            <a:off x="8001000" y="3733800"/>
+            <a:ext cx="1219200" cy="171450"/>
           </a:xfrm>
           <a:prstGeom xmlns:a="http://schemas.openxmlformats.org/drawingml/2006/main" prst="rect">
             <a:avLst/>
@@ -10471,7 +10539,7 @@
           <p:cNvPr id="22" name="">
             <a:extLst xmlns:a="http://schemas.openxmlformats.org/drawingml/2006/main">
               <a:ext uri="{FF2B5EF4-FFF2-40B4-BE49-F238E27FC236}">
-                <a16:creationId xmlns:a16="http://schemas.microsoft.com/office/drawing/2014/main" id="{38665AE9-60FE-4C7E-90F7-15E35F971416}"/>
+                <a16:creationId xmlns:a16="http://schemas.microsoft.com/office/drawing/2014/main" id="{3DF3C114-1749-44F9-82A7-A4B0B326F3F1}"/>
               </a:ext>
             </a:extLst>
           </p:cNvPr>
@@ -10506,7 +10574,7 @@
           <p:cNvPr id="23" name="">
             <a:extLst xmlns:a="http://schemas.openxmlformats.org/drawingml/2006/main">
               <a:ext uri="{FF2B5EF4-FFF2-40B4-BE49-F238E27FC236}">
-                <a16:creationId xmlns:a16="http://schemas.microsoft.com/office/drawing/2014/main" id="{FFB6221A-16AD-44A4-AEC5-E64FC565C059}"/>
+                <a16:creationId xmlns:a16="http://schemas.microsoft.com/office/drawing/2014/main" id="{60E487D7-0D79-4278-AE36-4F331205A419}"/>
               </a:ext>
             </a:extLst>
           </p:cNvPr>
@@ -10539,19 +10607,19 @@
           <p:cNvPr id="24" name="">
             <a:extLst xmlns:a="http://schemas.openxmlformats.org/drawingml/2006/main">
               <a:ext uri="{FF2B5EF4-FFF2-40B4-BE49-F238E27FC236}">
-                <a16:creationId xmlns:a16="http://schemas.microsoft.com/office/drawing/2014/main" id="{8BE860F2-2067-4CB7-A869-FCB641C4B0D9}"/>
-              </a:ext>
-            </a:extLst>
-          </p:cNvPr>
-          <p:cNvSpPr>
-            <a:spLocks xmlns:a="http://schemas.openxmlformats.org/drawingml/2006/main" noGrp="1"/>
-          </p:cNvSpPr>
-          <p:nvPr/>
-        </p:nvSpPr>
-        <p:spPr>
-          <a:xfrm xmlns:a="http://schemas.openxmlformats.org/drawingml/2006/main">
-            <a:off x="9858375" y="3200400"/>
-            <a:ext cx="1266825" cy="285750"/>
+                <a16:creationId xmlns:a16="http://schemas.microsoft.com/office/drawing/2014/main" id="{390810E0-9B49-4160-9D10-98D589E3DE18}"/>
+              </a:ext>
+            </a:extLst>
+          </p:cNvPr>
+          <p:cNvSpPr>
+            <a:spLocks xmlns:a="http://schemas.openxmlformats.org/drawingml/2006/main" noGrp="1"/>
+          </p:cNvSpPr>
+          <p:nvPr/>
+        </p:nvSpPr>
+        <p:spPr>
+          <a:xfrm xmlns:a="http://schemas.openxmlformats.org/drawingml/2006/main">
+            <a:off x="9858375" y="3181350"/>
+            <a:ext cx="1266825" cy="495300"/>
           </a:xfrm>
           <a:prstGeom xmlns:a="http://schemas.openxmlformats.org/drawingml/2006/main" prst="rect">
             <a:avLst/>
@@ -10597,19 +10665,19 @@
           <p:cNvPr id="25" name="">
             <a:extLst xmlns:a="http://schemas.openxmlformats.org/drawingml/2006/main">
               <a:ext uri="{FF2B5EF4-FFF2-40B4-BE49-F238E27FC236}">
-                <a16:creationId xmlns:a16="http://schemas.microsoft.com/office/drawing/2014/main" id="{C81131D8-358D-4B2A-8F0D-E345A54460DD}"/>
-              </a:ext>
-            </a:extLst>
-          </p:cNvPr>
-          <p:cNvSpPr>
-            <a:spLocks xmlns:a="http://schemas.openxmlformats.org/drawingml/2006/main" noGrp="1"/>
-          </p:cNvSpPr>
-          <p:nvPr/>
-        </p:nvSpPr>
-        <p:spPr>
-          <a:xfrm xmlns:a="http://schemas.openxmlformats.org/drawingml/2006/main">
-            <a:off x="9858375" y="3524250"/>
-            <a:ext cx="1266825" cy="381000"/>
+                <a16:creationId xmlns:a16="http://schemas.microsoft.com/office/drawing/2014/main" id="{60B73818-E18B-42A4-B0B6-F1116BA3FBBF}"/>
+              </a:ext>
+            </a:extLst>
+          </p:cNvPr>
+          <p:cNvSpPr>
+            <a:spLocks xmlns:a="http://schemas.openxmlformats.org/drawingml/2006/main" noGrp="1"/>
+          </p:cNvSpPr>
+          <p:nvPr/>
+        </p:nvSpPr>
+        <p:spPr>
+          <a:xfrm xmlns:a="http://schemas.openxmlformats.org/drawingml/2006/main">
+            <a:off x="9858375" y="3733800"/>
+            <a:ext cx="1266825" cy="171450"/>
           </a:xfrm>
           <a:prstGeom xmlns:a="http://schemas.openxmlformats.org/drawingml/2006/main" prst="rect">
             <a:avLst/>
@@ -10655,7 +10723,7 @@
           <p:cNvPr id="26" name="">
             <a:extLst xmlns:a="http://schemas.openxmlformats.org/drawingml/2006/main">
               <a:ext uri="{FF2B5EF4-FFF2-40B4-BE49-F238E27FC236}">
-                <a16:creationId xmlns:a16="http://schemas.microsoft.com/office/drawing/2014/main" id="{8A8D8D63-09CD-46D2-A754-072015E908DC}"/>
+                <a16:creationId xmlns:a16="http://schemas.microsoft.com/office/drawing/2014/main" id="{2D3C4537-6869-45A9-A121-C53CE264CE41}"/>
               </a:ext>
             </a:extLst>
           </p:cNvPr>
@@ -10713,7 +10781,7 @@
           <p:cNvPr id="27" name="">
             <a:extLst xmlns:a="http://schemas.openxmlformats.org/drawingml/2006/main">
               <a:ext uri="{FF2B5EF4-FFF2-40B4-BE49-F238E27FC236}">
-                <a16:creationId xmlns:a16="http://schemas.microsoft.com/office/drawing/2014/main" id="{143843E3-D315-4A21-B432-8FA969CECD45}"/>
+                <a16:creationId xmlns:a16="http://schemas.microsoft.com/office/drawing/2014/main" id="{70D1837D-14C4-41D2-8E2F-B9D6A637EE39}"/>
               </a:ext>
             </a:extLst>
           </p:cNvPr>
@@ -10746,7 +10814,7 @@
           <p:cNvPr id="28" name="">
             <a:extLst xmlns:a="http://schemas.openxmlformats.org/drawingml/2006/main">
               <a:ext uri="{FF2B5EF4-FFF2-40B4-BE49-F238E27FC236}">
-                <a16:creationId xmlns:a16="http://schemas.microsoft.com/office/drawing/2014/main" id="{47848E65-B962-47DF-A739-DA91B4D476C7}"/>
+                <a16:creationId xmlns:a16="http://schemas.microsoft.com/office/drawing/2014/main" id="{1E1870E4-AD13-4D46-85E5-6971CF2C23B6}"/>
               </a:ext>
             </a:extLst>
           </p:cNvPr>
@@ -10804,7 +10872,7 @@
           <p:cNvPr id="29" name="">
             <a:extLst xmlns:a="http://schemas.openxmlformats.org/drawingml/2006/main">
               <a:ext uri="{FF2B5EF4-FFF2-40B4-BE49-F238E27FC236}">
-                <a16:creationId xmlns:a16="http://schemas.microsoft.com/office/drawing/2014/main" id="{2C510EAE-96AD-402C-B956-48D7745F4728}"/>
+                <a16:creationId xmlns:a16="http://schemas.microsoft.com/office/drawing/2014/main" id="{273F05C1-9C63-4B73-BB62-F04420732944}"/>
               </a:ext>
             </a:extLst>
           </p:cNvPr>
@@ -10862,7 +10930,7 @@
           <p:cNvPr id="30" name="">
             <a:extLst xmlns:a="http://schemas.openxmlformats.org/drawingml/2006/main">
               <a:ext uri="{FF2B5EF4-FFF2-40B4-BE49-F238E27FC236}">
-                <a16:creationId xmlns:a16="http://schemas.microsoft.com/office/drawing/2014/main" id="{8DF612AE-5FCF-4C27-A370-12AD1DAF12E7}"/>
+                <a16:creationId xmlns:a16="http://schemas.microsoft.com/office/drawing/2014/main" id="{3E3F9A3F-9C0E-45D0-BD73-E1F942B41F33}"/>
               </a:ext>
             </a:extLst>
           </p:cNvPr>
@@ -10895,7 +10963,7 @@
           <p:cNvPr id="31" name="">
             <a:extLst xmlns:a="http://schemas.openxmlformats.org/drawingml/2006/main">
               <a:ext uri="{FF2B5EF4-FFF2-40B4-BE49-F238E27FC236}">
-                <a16:creationId xmlns:a16="http://schemas.microsoft.com/office/drawing/2014/main" id="{8412A885-4862-42D7-8220-129B68F56D4D}"/>
+                <a16:creationId xmlns:a16="http://schemas.microsoft.com/office/drawing/2014/main" id="{66D3A1F9-3263-4D24-B1B4-B4BADB215FAD}"/>
               </a:ext>
             </a:extLst>
           </p:cNvPr>
@@ -10953,7 +11021,7 @@
           <p:cNvPr id="32" name="">
             <a:extLst xmlns:a="http://schemas.openxmlformats.org/drawingml/2006/main">
               <a:ext uri="{FF2B5EF4-FFF2-40B4-BE49-F238E27FC236}">
-                <a16:creationId xmlns:a16="http://schemas.microsoft.com/office/drawing/2014/main" id="{D3823960-F7E4-479D-A77D-317423F5FBF8}"/>
+                <a16:creationId xmlns:a16="http://schemas.microsoft.com/office/drawing/2014/main" id="{E8E9B7D9-DDF3-424D-985F-3B94AF63E2EA}"/>
               </a:ext>
             </a:extLst>
           </p:cNvPr>
@@ -11009,7 +11077,7 @@
     </p:spTree>
     <p:extLst>
       <p:ext uri="{BB962C8B-B14F-4D97-AF65-F5344CB8AC3E}">
-        <p14:creationId xmlns:p14="http://schemas.microsoft.com/office/powerpoint/2010/main" val="2097077973"/>
+        <p14:creationId xmlns:p14="http://schemas.microsoft.com/office/powerpoint/2010/main" val="1291659008"/>
       </p:ext>
     </p:extLst>
   </p:cSld>
@@ -11040,7 +11108,7 @@
           <p:cNvPr id="32" name="">
             <a:extLst xmlns:a="http://schemas.openxmlformats.org/drawingml/2006/main">
               <a:ext uri="{FF2B5EF4-FFF2-40B4-BE49-F238E27FC236}">
-                <a16:creationId xmlns:a16="http://schemas.microsoft.com/office/drawing/2014/main" id="{4E5F2EB6-7F8F-4F35-A116-323AF96277F3}"/>
+                <a16:creationId xmlns:a16="http://schemas.microsoft.com/office/drawing/2014/main" id="{C1D7490D-B21F-4827-88F4-708B2F620442}"/>
               </a:ext>
             </a:extLst>
           </p:cNvPr>
@@ -11088,7 +11156,7 @@
                   <a:srgbClr val="23D5D2"/>
                 </a:solidFill>
               </a:rPr>
-              <a:t>5 • WHAT THE LAB PROVED</a:t>
+              <a:t>5 • DEPLOYMENT RESULTS</a:t>
             </a:r>
           </a:p>
         </p:txBody>
@@ -11098,7 +11166,7 @@
           <p:cNvPr id="2" name="">
             <a:extLst xmlns:a="http://schemas.openxmlformats.org/drawingml/2006/main">
               <a:ext uri="{FF2B5EF4-FFF2-40B4-BE49-F238E27FC236}">
-                <a16:creationId xmlns:a16="http://schemas.microsoft.com/office/drawing/2014/main" id="{B6D124CF-53CB-46C9-9686-FCD2A55EDDBD}"/>
+                <a16:creationId xmlns:a16="http://schemas.microsoft.com/office/drawing/2014/main" id="{C3EA849A-DDFF-40B7-8B7C-D65C2FDC8771}"/>
               </a:ext>
             </a:extLst>
           </p:cNvPr>
@@ -11156,7 +11224,7 @@
           <p:cNvPr id="3" name="">
             <a:extLst xmlns:a="http://schemas.openxmlformats.org/drawingml/2006/main">
               <a:ext uri="{FF2B5EF4-FFF2-40B4-BE49-F238E27FC236}">
-                <a16:creationId xmlns:a16="http://schemas.microsoft.com/office/drawing/2014/main" id="{41A3268C-00FA-4302-86D8-E4F3EC7CA38F}"/>
+                <a16:creationId xmlns:a16="http://schemas.microsoft.com/office/drawing/2014/main" id="{202981B6-EF39-4C78-AFF9-6A5919250B7E}"/>
               </a:ext>
             </a:extLst>
           </p:cNvPr>
@@ -11214,7 +11282,7 @@
           <p:cNvPr id="4" name="">
             <a:extLst xmlns:a="http://schemas.openxmlformats.org/drawingml/2006/main">
               <a:ext uri="{FF2B5EF4-FFF2-40B4-BE49-F238E27FC236}">
-                <a16:creationId xmlns:a16="http://schemas.microsoft.com/office/drawing/2014/main" id="{5F2E956C-A6FF-469E-B76D-28E55F79BE9D}"/>
+                <a16:creationId xmlns:a16="http://schemas.microsoft.com/office/drawing/2014/main" id="{154A61EC-94CC-4175-B838-6CB5EB518CE1}"/>
               </a:ext>
             </a:extLst>
           </p:cNvPr>
@@ -11247,7 +11315,7 @@
           <p:cNvPr id="5" name="">
             <a:extLst xmlns:a="http://schemas.openxmlformats.org/drawingml/2006/main">
               <a:ext uri="{FF2B5EF4-FFF2-40B4-BE49-F238E27FC236}">
-                <a16:creationId xmlns:a16="http://schemas.microsoft.com/office/drawing/2014/main" id="{8CAE5FBF-DCFC-43C4-9AD5-B4BEB2AB2715}"/>
+                <a16:creationId xmlns:a16="http://schemas.microsoft.com/office/drawing/2014/main" id="{3C41F502-70EE-4FBB-B37E-4BDEB8513919}"/>
               </a:ext>
             </a:extLst>
           </p:cNvPr>
@@ -11305,7 +11373,7 @@
           <p:cNvPr id="6" name="">
             <a:extLst xmlns:a="http://schemas.openxmlformats.org/drawingml/2006/main">
               <a:ext uri="{FF2B5EF4-FFF2-40B4-BE49-F238E27FC236}">
-                <a16:creationId xmlns:a16="http://schemas.microsoft.com/office/drawing/2014/main" id="{415A1206-DEF0-4CBC-AB27-71471C30689E}"/>
+                <a16:creationId xmlns:a16="http://schemas.microsoft.com/office/drawing/2014/main" id="{E07A534B-CB34-490B-BD84-074719873DFE}"/>
               </a:ext>
             </a:extLst>
           </p:cNvPr>
@@ -11363,7 +11431,7 @@
           <p:cNvPr id="7" name="">
             <a:extLst xmlns:a="http://schemas.openxmlformats.org/drawingml/2006/main">
               <a:ext uri="{FF2B5EF4-FFF2-40B4-BE49-F238E27FC236}">
-                <a16:creationId xmlns:a16="http://schemas.microsoft.com/office/drawing/2014/main" id="{90703E9E-E3CC-4C4C-8CC7-60BEFA5BCFB2}"/>
+                <a16:creationId xmlns:a16="http://schemas.microsoft.com/office/drawing/2014/main" id="{6C85AFA7-2FBE-44A5-94F0-D173E765341A}"/>
               </a:ext>
             </a:extLst>
           </p:cNvPr>
@@ -11421,7 +11489,7 @@
           <p:cNvPr id="8" name="">
             <a:extLst xmlns:a="http://schemas.openxmlformats.org/drawingml/2006/main">
               <a:ext uri="{FF2B5EF4-FFF2-40B4-BE49-F238E27FC236}">
-                <a16:creationId xmlns:a16="http://schemas.microsoft.com/office/drawing/2014/main" id="{2ED92328-037D-409A-8FE5-569929D3C967}"/>
+                <a16:creationId xmlns:a16="http://schemas.microsoft.com/office/drawing/2014/main" id="{91686F65-B453-484E-AB19-06B53E00201C}"/>
               </a:ext>
             </a:extLst>
           </p:cNvPr>
@@ -11454,7 +11522,7 @@
           <p:cNvPr id="9" name="">
             <a:extLst xmlns:a="http://schemas.openxmlformats.org/drawingml/2006/main">
               <a:ext uri="{FF2B5EF4-FFF2-40B4-BE49-F238E27FC236}">
-                <a16:creationId xmlns:a16="http://schemas.microsoft.com/office/drawing/2014/main" id="{D17DDF35-04AF-4038-9021-BF6EC0FE9019}"/>
+                <a16:creationId xmlns:a16="http://schemas.microsoft.com/office/drawing/2014/main" id="{45D70058-5ECA-4CA6-92EE-961BF5254E99}"/>
               </a:ext>
             </a:extLst>
           </p:cNvPr>
@@ -11512,7 +11580,7 @@
           <p:cNvPr id="10" name="">
             <a:extLst xmlns:a="http://schemas.openxmlformats.org/drawingml/2006/main">
               <a:ext uri="{FF2B5EF4-FFF2-40B4-BE49-F238E27FC236}">
-                <a16:creationId xmlns:a16="http://schemas.microsoft.com/office/drawing/2014/main" id="{5C1EB4F8-479E-4AF7-8CD3-A98689DA8B56}"/>
+                <a16:creationId xmlns:a16="http://schemas.microsoft.com/office/drawing/2014/main" id="{1C857B13-D0B8-4F46-A4E0-7FE23C109F40}"/>
               </a:ext>
             </a:extLst>
           </p:cNvPr>
@@ -11570,7 +11638,7 @@
           <p:cNvPr id="11" name="">
             <a:extLst xmlns:a="http://schemas.openxmlformats.org/drawingml/2006/main">
               <a:ext uri="{FF2B5EF4-FFF2-40B4-BE49-F238E27FC236}">
-                <a16:creationId xmlns:a16="http://schemas.microsoft.com/office/drawing/2014/main" id="{596BE982-AB7B-4CB6-8250-D2082AC92917}"/>
+                <a16:creationId xmlns:a16="http://schemas.microsoft.com/office/drawing/2014/main" id="{897EB4A6-7484-493D-BABD-DAF7337A6532}"/>
               </a:ext>
             </a:extLst>
           </p:cNvPr>
@@ -11628,7 +11696,7 @@
           <p:cNvPr id="12" name="">
             <a:extLst xmlns:a="http://schemas.openxmlformats.org/drawingml/2006/main">
               <a:ext uri="{FF2B5EF4-FFF2-40B4-BE49-F238E27FC236}">
-                <a16:creationId xmlns:a16="http://schemas.microsoft.com/office/drawing/2014/main" id="{196BDE1F-E16A-40E9-B918-18AC18C3FF4C}"/>
+                <a16:creationId xmlns:a16="http://schemas.microsoft.com/office/drawing/2014/main" id="{9CAC4D88-6668-4AA2-83E2-2A7B3F062D1F}"/>
               </a:ext>
             </a:extLst>
           </p:cNvPr>
@@ -11661,7 +11729,7 @@
           <p:cNvPr id="13" name="">
             <a:extLst xmlns:a="http://schemas.openxmlformats.org/drawingml/2006/main">
               <a:ext uri="{FF2B5EF4-FFF2-40B4-BE49-F238E27FC236}">
-                <a16:creationId xmlns:a16="http://schemas.microsoft.com/office/drawing/2014/main" id="{3ADE50C8-ADA7-49DB-BB3D-895DA80CD48A}"/>
+                <a16:creationId xmlns:a16="http://schemas.microsoft.com/office/drawing/2014/main" id="{2CAE3439-5B92-48DA-87DA-AE02518B4A4E}"/>
               </a:ext>
             </a:extLst>
           </p:cNvPr>
@@ -11719,7 +11787,7 @@
           <p:cNvPr id="14" name="">
             <a:extLst xmlns:a="http://schemas.openxmlformats.org/drawingml/2006/main">
               <a:ext uri="{FF2B5EF4-FFF2-40B4-BE49-F238E27FC236}">
-                <a16:creationId xmlns:a16="http://schemas.microsoft.com/office/drawing/2014/main" id="{DA277C90-41D2-4275-AB33-F87DE440A105}"/>
+                <a16:creationId xmlns:a16="http://schemas.microsoft.com/office/drawing/2014/main" id="{CEECC3EC-5395-4492-90A8-3DBB3E27BEAC}"/>
               </a:ext>
             </a:extLst>
           </p:cNvPr>
@@ -11777,7 +11845,7 @@
           <p:cNvPr id="15" name="">
             <a:extLst xmlns:a="http://schemas.openxmlformats.org/drawingml/2006/main">
               <a:ext uri="{FF2B5EF4-FFF2-40B4-BE49-F238E27FC236}">
-                <a16:creationId xmlns:a16="http://schemas.microsoft.com/office/drawing/2014/main" id="{9B747F6B-4C93-43B5-B9D8-83B86546A0D1}"/>
+                <a16:creationId xmlns:a16="http://schemas.microsoft.com/office/drawing/2014/main" id="{D12FEECE-4CB3-4DDC-8EF7-F08D11BD7EEC}"/>
               </a:ext>
             </a:extLst>
           </p:cNvPr>
@@ -11835,7 +11903,7 @@
           <p:cNvPr id="16" name="">
             <a:extLst xmlns:a="http://schemas.openxmlformats.org/drawingml/2006/main">
               <a:ext uri="{FF2B5EF4-FFF2-40B4-BE49-F238E27FC236}">
-                <a16:creationId xmlns:a16="http://schemas.microsoft.com/office/drawing/2014/main" id="{36DAF503-29AC-44BE-ACCC-38F56A956EE9}"/>
+                <a16:creationId xmlns:a16="http://schemas.microsoft.com/office/drawing/2014/main" id="{6286EEC0-2D40-477F-B5BF-6DABBD48A37C}"/>
               </a:ext>
             </a:extLst>
           </p:cNvPr>
@@ -11868,7 +11936,7 @@
           <p:cNvPr id="17" name="">
             <a:extLst xmlns:a="http://schemas.openxmlformats.org/drawingml/2006/main">
               <a:ext uri="{FF2B5EF4-FFF2-40B4-BE49-F238E27FC236}">
-                <a16:creationId xmlns:a16="http://schemas.microsoft.com/office/drawing/2014/main" id="{CE29ABAE-45FB-4EC3-B461-A5696A821BF5}"/>
+                <a16:creationId xmlns:a16="http://schemas.microsoft.com/office/drawing/2014/main" id="{4F525EC2-BFD8-43B3-B897-DC466430DD74}"/>
               </a:ext>
             </a:extLst>
           </p:cNvPr>
@@ -11926,7 +11994,7 @@
           <p:cNvPr id="18" name="">
             <a:extLst xmlns:a="http://schemas.openxmlformats.org/drawingml/2006/main">
               <a:ext uri="{FF2B5EF4-FFF2-40B4-BE49-F238E27FC236}">
-                <a16:creationId xmlns:a16="http://schemas.microsoft.com/office/drawing/2014/main" id="{9F998864-E40C-4134-B86E-F8DEADE4F7C2}"/>
+                <a16:creationId xmlns:a16="http://schemas.microsoft.com/office/drawing/2014/main" id="{1E52D3A7-8EFE-46D4-8C2E-195427494279}"/>
               </a:ext>
             </a:extLst>
           </p:cNvPr>
@@ -11984,7 +12052,7 @@
           <p:cNvPr id="19" name="">
             <a:extLst xmlns:a="http://schemas.openxmlformats.org/drawingml/2006/main">
               <a:ext uri="{FF2B5EF4-FFF2-40B4-BE49-F238E27FC236}">
-                <a16:creationId xmlns:a16="http://schemas.microsoft.com/office/drawing/2014/main" id="{0840BF47-5487-4F2A-AA8D-47151CC07468}"/>
+                <a16:creationId xmlns:a16="http://schemas.microsoft.com/office/drawing/2014/main" id="{776DD81E-403A-4107-9A1B-54A7DE416B9A}"/>
               </a:ext>
             </a:extLst>
           </p:cNvPr>
@@ -12042,7 +12110,7 @@
           <p:cNvPr id="20" name="">
             <a:extLst xmlns:a="http://schemas.openxmlformats.org/drawingml/2006/main">
               <a:ext uri="{FF2B5EF4-FFF2-40B4-BE49-F238E27FC236}">
-                <a16:creationId xmlns:a16="http://schemas.microsoft.com/office/drawing/2014/main" id="{474F3012-6801-4888-A0FF-85667F60AEC5}"/>
+                <a16:creationId xmlns:a16="http://schemas.microsoft.com/office/drawing/2014/main" id="{86C721BC-22E1-460A-8DF5-4F592034686D}"/>
               </a:ext>
             </a:extLst>
           </p:cNvPr>
@@ -12075,7 +12143,7 @@
           <p:cNvPr id="21" name="">
             <a:extLst xmlns:a="http://schemas.openxmlformats.org/drawingml/2006/main">
               <a:ext uri="{FF2B5EF4-FFF2-40B4-BE49-F238E27FC236}">
-                <a16:creationId xmlns:a16="http://schemas.microsoft.com/office/drawing/2014/main" id="{D8E288D7-185F-4D29-949F-37AA571E52A0}"/>
+                <a16:creationId xmlns:a16="http://schemas.microsoft.com/office/drawing/2014/main" id="{511AFDBE-64A6-4D45-A99C-BADD1AA8C443}"/>
               </a:ext>
             </a:extLst>
           </p:cNvPr>
@@ -12133,7 +12201,7 @@
           <p:cNvPr id="22" name="">
             <a:extLst xmlns:a="http://schemas.openxmlformats.org/drawingml/2006/main">
               <a:ext uri="{FF2B5EF4-FFF2-40B4-BE49-F238E27FC236}">
-                <a16:creationId xmlns:a16="http://schemas.microsoft.com/office/drawing/2014/main" id="{2104884B-6A09-4360-A04A-857DCBF3D410}"/>
+                <a16:creationId xmlns:a16="http://schemas.microsoft.com/office/drawing/2014/main" id="{DD5C084A-DBEB-4E10-8589-3FDFE9543131}"/>
               </a:ext>
             </a:extLst>
           </p:cNvPr>
@@ -12191,7 +12259,7 @@
           <p:cNvPr id="23" name="">
             <a:extLst xmlns:a="http://schemas.openxmlformats.org/drawingml/2006/main">
               <a:ext uri="{FF2B5EF4-FFF2-40B4-BE49-F238E27FC236}">
-                <a16:creationId xmlns:a16="http://schemas.microsoft.com/office/drawing/2014/main" id="{D6ABF4AC-85A6-4CAB-90DA-CA7371E9DDB9}"/>
+                <a16:creationId xmlns:a16="http://schemas.microsoft.com/office/drawing/2014/main" id="{71381323-596B-4813-89F9-6871B77B1A0D}"/>
               </a:ext>
             </a:extLst>
           </p:cNvPr>
@@ -12249,7 +12317,7 @@
           <p:cNvPr id="24" name="">
             <a:extLst xmlns:a="http://schemas.openxmlformats.org/drawingml/2006/main">
               <a:ext uri="{FF2B5EF4-FFF2-40B4-BE49-F238E27FC236}">
-                <a16:creationId xmlns:a16="http://schemas.microsoft.com/office/drawing/2014/main" id="{16B63382-9B74-4F78-A923-1707C37347A3}"/>
+                <a16:creationId xmlns:a16="http://schemas.microsoft.com/office/drawing/2014/main" id="{D26F1C0F-63A8-478D-A883-2CABB082C153}"/>
               </a:ext>
             </a:extLst>
           </p:cNvPr>
@@ -12284,7 +12352,7 @@
           <p:cNvPr id="25" name="">
             <a:extLst xmlns:a="http://schemas.openxmlformats.org/drawingml/2006/main">
               <a:ext uri="{FF2B5EF4-FFF2-40B4-BE49-F238E27FC236}">
-                <a16:creationId xmlns:a16="http://schemas.microsoft.com/office/drawing/2014/main" id="{CDB385B9-454F-48BA-8F45-924524CC565F}"/>
+                <a16:creationId xmlns:a16="http://schemas.microsoft.com/office/drawing/2014/main" id="{A253BF01-6376-4CBE-8CE9-C21255E6E9E3}"/>
               </a:ext>
             </a:extLst>
           </p:cNvPr>
@@ -12342,7 +12410,7 @@
           <p:cNvPr id="26" name="">
             <a:extLst xmlns:a="http://schemas.openxmlformats.org/drawingml/2006/main">
               <a:ext uri="{FF2B5EF4-FFF2-40B4-BE49-F238E27FC236}">
-                <a16:creationId xmlns:a16="http://schemas.microsoft.com/office/drawing/2014/main" id="{6B86171C-142C-4095-91FB-B7233E430734}"/>
+                <a16:creationId xmlns:a16="http://schemas.microsoft.com/office/drawing/2014/main" id="{EDAC9A32-21FA-4E8B-A212-3735477EB44E}"/>
               </a:ext>
             </a:extLst>
           </p:cNvPr>
@@ -12400,7 +12468,7 @@
           <p:cNvPr id="27" name="">
             <a:extLst xmlns:a="http://schemas.openxmlformats.org/drawingml/2006/main">
               <a:ext uri="{FF2B5EF4-FFF2-40B4-BE49-F238E27FC236}">
-                <a16:creationId xmlns:a16="http://schemas.microsoft.com/office/drawing/2014/main" id="{58DFA9BD-BA9D-4807-8BFA-ABC9005EA052}"/>
+                <a16:creationId xmlns:a16="http://schemas.microsoft.com/office/drawing/2014/main" id="{E8BC7140-7116-4D51-92F6-6E96F47EDC48}"/>
               </a:ext>
             </a:extLst>
           </p:cNvPr>
@@ -12433,7 +12501,7 @@
           <p:cNvPr id="28" name="">
             <a:extLst xmlns:a="http://schemas.openxmlformats.org/drawingml/2006/main">
               <a:ext uri="{FF2B5EF4-FFF2-40B4-BE49-F238E27FC236}">
-                <a16:creationId xmlns:a16="http://schemas.microsoft.com/office/drawing/2014/main" id="{847DEF4F-3707-4E42-8668-BC874673CF86}"/>
+                <a16:creationId xmlns:a16="http://schemas.microsoft.com/office/drawing/2014/main" id="{8FF308B1-5ABF-44AD-BC64-51F5454092E4}"/>
               </a:ext>
             </a:extLst>
           </p:cNvPr>
@@ -12525,7 +12593,7 @@
           <p:cNvPr id="29" name="">
             <a:extLst xmlns:a="http://schemas.openxmlformats.org/drawingml/2006/main">
               <a:ext uri="{FF2B5EF4-FFF2-40B4-BE49-F238E27FC236}">
-                <a16:creationId xmlns:a16="http://schemas.microsoft.com/office/drawing/2014/main" id="{DD10A11D-600C-40CB-901E-1BF661F4414E}"/>
+                <a16:creationId xmlns:a16="http://schemas.microsoft.com/office/drawing/2014/main" id="{CFC5166C-5C2F-4B0C-81D8-CC0DAF1CDBBE}"/>
               </a:ext>
             </a:extLst>
           </p:cNvPr>
@@ -12558,7 +12626,7 @@
           <p:cNvPr id="30" name="">
             <a:extLst xmlns:a="http://schemas.openxmlformats.org/drawingml/2006/main">
               <a:ext uri="{FF2B5EF4-FFF2-40B4-BE49-F238E27FC236}">
-                <a16:creationId xmlns:a16="http://schemas.microsoft.com/office/drawing/2014/main" id="{74395E5B-E854-4733-890A-B1E9D254204F}"/>
+                <a16:creationId xmlns:a16="http://schemas.microsoft.com/office/drawing/2014/main" id="{C061EA2C-DBF5-414B-8616-4258988A8F1C}"/>
               </a:ext>
             </a:extLst>
           </p:cNvPr>
@@ -12616,7 +12684,7 @@
           <p:cNvPr id="31" name="">
             <a:extLst xmlns:a="http://schemas.openxmlformats.org/drawingml/2006/main">
               <a:ext uri="{FF2B5EF4-FFF2-40B4-BE49-F238E27FC236}">
-                <a16:creationId xmlns:a16="http://schemas.microsoft.com/office/drawing/2014/main" id="{91CECA4B-A86B-472E-8A4A-9275B7EE4275}"/>
+                <a16:creationId xmlns:a16="http://schemas.microsoft.com/office/drawing/2014/main" id="{94F0A5FC-687C-40CB-91CF-DA51BFB7068B}"/>
               </a:ext>
             </a:extLst>
           </p:cNvPr>
@@ -12672,7 +12740,7 @@
     </p:spTree>
     <p:extLst>
       <p:ext uri="{BB962C8B-B14F-4D97-AF65-F5344CB8AC3E}">
-        <p14:creationId xmlns:p14="http://schemas.microsoft.com/office/powerpoint/2010/main" val="794308612"/>
+        <p14:creationId xmlns:p14="http://schemas.microsoft.com/office/powerpoint/2010/main" val="480326857"/>
       </p:ext>
     </p:extLst>
   </p:cSld>

</xml_diff>

<commit_message>
Add generated cloud-native edge cover visual
</commit_message>
<xml_diff>
--- a/presentation/cloud-native-vbng-edge.pptx
+++ b/presentation/cloud-native-vbng-edge.pptx
@@ -2,22 +2,22 @@
 <file path=ppt/presentation.xml><?xml version="1.0" encoding="utf-8"?>
 <p:presentation xmlns:p="http://schemas.openxmlformats.org/presentationml/2006/main">
   <p:sldMasterIdLst>
-    <p:sldMasterId xmlns:r="http://schemas.openxmlformats.org/officeDocument/2006/relationships" id="2147483648" r:id="R80367de9d79d4949"/>
+    <p:sldMasterId xmlns:r="http://schemas.openxmlformats.org/officeDocument/2006/relationships" id="2147483648" r:id="R647ccfdf080743fc"/>
   </p:sldMasterIdLst>
   <p:notesMasterIdLst>
-    <p:notesMasterId xmlns:r="http://schemas.openxmlformats.org/officeDocument/2006/relationships" r:id="Rf7a2059ab89b4f8d"/>
+    <p:notesMasterId xmlns:r="http://schemas.openxmlformats.org/officeDocument/2006/relationships" r:id="R78381b3457dc4667"/>
   </p:notesMasterIdLst>
   <p:sldIdLst>
-    <p:sldId xmlns:r="http://schemas.openxmlformats.org/officeDocument/2006/relationships" id="256" r:id="R1e437dd411304746"/>
-    <p:sldId xmlns:r="http://schemas.openxmlformats.org/officeDocument/2006/relationships" id="257" r:id="R8fe0e6ce56a3423c"/>
-    <p:sldId xmlns:r="http://schemas.openxmlformats.org/officeDocument/2006/relationships" id="258" r:id="Rf76dad8479ce4266"/>
-    <p:sldId xmlns:r="http://schemas.openxmlformats.org/officeDocument/2006/relationships" id="259" r:id="Rd7c07b3d4d1548c0"/>
-    <p:sldId xmlns:r="http://schemas.openxmlformats.org/officeDocument/2006/relationships" id="260" r:id="R020a12c897004f41"/>
-    <p:sldId xmlns:r="http://schemas.openxmlformats.org/officeDocument/2006/relationships" id="261" r:id="R29bd9e245eaf4641"/>
-    <p:sldId xmlns:r="http://schemas.openxmlformats.org/officeDocument/2006/relationships" id="262" r:id="R7d429d3a4fa149a5"/>
-    <p:sldId xmlns:r="http://schemas.openxmlformats.org/officeDocument/2006/relationships" id="263" r:id="R963470d21216431d"/>
-    <p:sldId xmlns:r="http://schemas.openxmlformats.org/officeDocument/2006/relationships" id="264" r:id="Rf243aceb47f34566"/>
-    <p:sldId xmlns:r="http://schemas.openxmlformats.org/officeDocument/2006/relationships" id="265" r:id="R2fa712af01284ccd"/>
+    <p:sldId xmlns:r="http://schemas.openxmlformats.org/officeDocument/2006/relationships" id="256" r:id="R1fca78424c254145"/>
+    <p:sldId xmlns:r="http://schemas.openxmlformats.org/officeDocument/2006/relationships" id="257" r:id="R3329f4ca04e649a9"/>
+    <p:sldId xmlns:r="http://schemas.openxmlformats.org/officeDocument/2006/relationships" id="258" r:id="R0622eb74bddf4ece"/>
+    <p:sldId xmlns:r="http://schemas.openxmlformats.org/officeDocument/2006/relationships" id="259" r:id="Racc71fc3655d4b95"/>
+    <p:sldId xmlns:r="http://schemas.openxmlformats.org/officeDocument/2006/relationships" id="260" r:id="R618f4bd0091a4a98"/>
+    <p:sldId xmlns:r="http://schemas.openxmlformats.org/officeDocument/2006/relationships" id="261" r:id="Redab1cb842ab464b"/>
+    <p:sldId xmlns:r="http://schemas.openxmlformats.org/officeDocument/2006/relationships" id="262" r:id="R3b10f21e2ce84fdb"/>
+    <p:sldId xmlns:r="http://schemas.openxmlformats.org/officeDocument/2006/relationships" id="263" r:id="Ra6b57fda239f4655"/>
+    <p:sldId xmlns:r="http://schemas.openxmlformats.org/officeDocument/2006/relationships" id="264" r:id="R5379b9ad4bb94fc3"/>
+    <p:sldId xmlns:r="http://schemas.openxmlformats.org/officeDocument/2006/relationships" id="265" r:id="R5bda1e59be894dcb"/>
   </p:sldIdLst>
   <p:sldSz cx="12192000" cy="6858000"/>
   <p:notesSz cx="6858000" cy="9144000"/>
@@ -1128,7 +1128,7 @@
           <p:cNvPr id="3" name="Title">
             <a:extLst xmlns:a="http://schemas.openxmlformats.org/drawingml/2006/main">
               <a:ext uri="{FF2B5EF4-FFF2-40B4-BE49-F238E27FC236}">
-                <a16:creationId xmlns:a16="http://schemas.microsoft.com/office/drawing/2014/main" id="{29739272-FEC2-413D-A920-7B293B5147EC}"/>
+                <a16:creationId xmlns:a16="http://schemas.microsoft.com/office/drawing/2014/main" id="{2E005597-16C8-48DC-9375-E92B28B27611}"/>
               </a:ext>
             </a:extLst>
           </p:cNvPr>
@@ -1285,7 +1285,7 @@
           <p:cNvPr id="2" name="Subtitle">
             <a:extLst xmlns:a="http://schemas.openxmlformats.org/drawingml/2006/main">
               <a:ext uri="{FF2B5EF4-FFF2-40B4-BE49-F238E27FC236}">
-                <a16:creationId xmlns:a16="http://schemas.microsoft.com/office/drawing/2014/main" id="{31C6F6FD-B6A3-4847-A816-D0E3CF846E6D}"/>
+                <a16:creationId xmlns:a16="http://schemas.microsoft.com/office/drawing/2014/main" id="{646C41CE-BFE2-4CBE-A619-4FBCBE49DA7F}"/>
               </a:ext>
             </a:extLst>
           </p:cNvPr>
@@ -1459,7 +1459,7 @@
           <p:cNvPr id="2" name="Section title">
             <a:extLst xmlns:a="http://schemas.openxmlformats.org/drawingml/2006/main">
               <a:ext uri="{FF2B5EF4-FFF2-40B4-BE49-F238E27FC236}">
-                <a16:creationId xmlns:a16="http://schemas.microsoft.com/office/drawing/2014/main" id="{21D4E613-8D0F-4374-A615-8373F5FA39CA}"/>
+                <a16:creationId xmlns:a16="http://schemas.microsoft.com/office/drawing/2014/main" id="{2C28F149-5150-4B45-A8AD-90659AE2A8FC}"/>
               </a:ext>
             </a:extLst>
           </p:cNvPr>
@@ -1633,7 +1633,7 @@
           <p:cNvPr id="3" name="Title">
             <a:extLst xmlns:a="http://schemas.openxmlformats.org/drawingml/2006/main">
               <a:ext uri="{FF2B5EF4-FFF2-40B4-BE49-F238E27FC236}">
-                <a16:creationId xmlns:a16="http://schemas.microsoft.com/office/drawing/2014/main" id="{0613BBF0-8359-4A4E-BA5D-333562305095}"/>
+                <a16:creationId xmlns:a16="http://schemas.microsoft.com/office/drawing/2014/main" id="{E854A426-F849-486E-9AD9-B87055BD6164}"/>
               </a:ext>
             </a:extLst>
           </p:cNvPr>
@@ -1790,7 +1790,7 @@
           <p:cNvPr id="2" name="Body">
             <a:extLst xmlns:a="http://schemas.openxmlformats.org/drawingml/2006/main">
               <a:ext uri="{FF2B5EF4-FFF2-40B4-BE49-F238E27FC236}">
-                <a16:creationId xmlns:a16="http://schemas.microsoft.com/office/drawing/2014/main" id="{4A33CBAA-DAFE-4F0F-9476-DD773E06F9B0}"/>
+                <a16:creationId xmlns:a16="http://schemas.microsoft.com/office/drawing/2014/main" id="{97AF8B79-D465-4901-83CC-CCA13C61B811}"/>
               </a:ext>
             </a:extLst>
           </p:cNvPr>
@@ -1964,7 +1964,7 @@
           <p:cNvPr id="4" name="Title">
             <a:extLst xmlns:a="http://schemas.openxmlformats.org/drawingml/2006/main">
               <a:ext uri="{FF2B5EF4-FFF2-40B4-BE49-F238E27FC236}">
-                <a16:creationId xmlns:a16="http://schemas.microsoft.com/office/drawing/2014/main" id="{48EFFD98-EC61-405A-9AE8-C98CC31D74DD}"/>
+                <a16:creationId xmlns:a16="http://schemas.microsoft.com/office/drawing/2014/main" id="{6E24D4D9-2895-4F12-9769-A45026F9F627}"/>
               </a:ext>
             </a:extLst>
           </p:cNvPr>
@@ -2121,7 +2121,7 @@
           <p:cNvPr id="2" name="Left column">
             <a:extLst xmlns:a="http://schemas.openxmlformats.org/drawingml/2006/main">
               <a:ext uri="{FF2B5EF4-FFF2-40B4-BE49-F238E27FC236}">
-                <a16:creationId xmlns:a16="http://schemas.microsoft.com/office/drawing/2014/main" id="{151FDC65-1052-4592-958E-91D4B06B70A3}"/>
+                <a16:creationId xmlns:a16="http://schemas.microsoft.com/office/drawing/2014/main" id="{31A68237-F9A8-4EB3-AF4B-2EBA2303DE92}"/>
               </a:ext>
             </a:extLst>
           </p:cNvPr>
@@ -2278,7 +2278,7 @@
           <p:cNvPr id="3" name="Right column">
             <a:extLst xmlns:a="http://schemas.openxmlformats.org/drawingml/2006/main">
               <a:ext uri="{FF2B5EF4-FFF2-40B4-BE49-F238E27FC236}">
-                <a16:creationId xmlns:a16="http://schemas.microsoft.com/office/drawing/2014/main" id="{D3427B66-8064-46C5-BB5D-ABBCD6598F96}"/>
+                <a16:creationId xmlns:a16="http://schemas.microsoft.com/office/drawing/2014/main" id="{E55A34F4-2A1A-403B-BC15-5E7C6B7C7498}"/>
               </a:ext>
             </a:extLst>
           </p:cNvPr>
@@ -2452,7 +2452,7 @@
           <p:cNvPr id="3" name="Title">
             <a:extLst xmlns:a="http://schemas.openxmlformats.org/drawingml/2006/main">
               <a:ext uri="{FF2B5EF4-FFF2-40B4-BE49-F238E27FC236}">
-                <a16:creationId xmlns:a16="http://schemas.microsoft.com/office/drawing/2014/main" id="{6651CF9D-79F8-4158-A575-9B3C637D56B0}"/>
+                <a16:creationId xmlns:a16="http://schemas.microsoft.com/office/drawing/2014/main" id="{144E7A5A-5138-424C-B94C-7336162801A8}"/>
               </a:ext>
             </a:extLst>
           </p:cNvPr>
@@ -2609,7 +2609,7 @@
           <p:cNvPr id="2" name="Left column">
             <a:extLst xmlns:a="http://schemas.openxmlformats.org/drawingml/2006/main">
               <a:ext uri="{FF2B5EF4-FFF2-40B4-BE49-F238E27FC236}">
-                <a16:creationId xmlns:a16="http://schemas.microsoft.com/office/drawing/2014/main" id="{FC904884-8FB3-4D17-B0C0-60378B0849A7}"/>
+                <a16:creationId xmlns:a16="http://schemas.microsoft.com/office/drawing/2014/main" id="{AD22A060-6FAA-4CD2-B12C-F2096A9EA73E}"/>
               </a:ext>
             </a:extLst>
           </p:cNvPr>
@@ -2804,12 +2804,12 @@
   </p:cSld>
   <p:clrMap bg1="lt1" tx1="dk1" bg2="lt2" tx2="dk2" accent1="accent1" accent2="accent2" accent3="accent3" accent4="accent4" accent5="accent5" accent6="accent6" hlink="hlink" folHlink="folHlink"/>
   <p:sldLayoutIdLst>
-    <p:sldLayoutId xmlns:r="http://schemas.openxmlformats.org/officeDocument/2006/relationships" id="2147483649" r:id="R37460f187ae04956"/>
-    <p:sldLayoutId xmlns:r="http://schemas.openxmlformats.org/officeDocument/2006/relationships" id="2147483650" r:id="R453aa2dae442419e"/>
-    <p:sldLayoutId xmlns:r="http://schemas.openxmlformats.org/officeDocument/2006/relationships" id="2147483651" r:id="Rb48125f1379f451a"/>
-    <p:sldLayoutId xmlns:r="http://schemas.openxmlformats.org/officeDocument/2006/relationships" id="2147483652" r:id="Rc5d55a1473c54138"/>
-    <p:sldLayoutId xmlns:r="http://schemas.openxmlformats.org/officeDocument/2006/relationships" id="2147483653" r:id="R1f2af6c3c0224504"/>
-    <p:sldLayoutId xmlns:r="http://schemas.openxmlformats.org/officeDocument/2006/relationships" id="2147483654" r:id="R6cd4a02e97194851"/>
+    <p:sldLayoutId xmlns:r="http://schemas.openxmlformats.org/officeDocument/2006/relationships" id="2147483649" r:id="Ra1f740a773774a60"/>
+    <p:sldLayoutId xmlns:r="http://schemas.openxmlformats.org/officeDocument/2006/relationships" id="2147483650" r:id="R56fee4c32e104c92"/>
+    <p:sldLayoutId xmlns:r="http://schemas.openxmlformats.org/officeDocument/2006/relationships" id="2147483651" r:id="R30bb6edcbf294deb"/>
+    <p:sldLayoutId xmlns:r="http://schemas.openxmlformats.org/officeDocument/2006/relationships" id="2147483652" r:id="Rf46d76e0e9dc424a"/>
+    <p:sldLayoutId xmlns:r="http://schemas.openxmlformats.org/officeDocument/2006/relationships" id="2147483653" r:id="R8aa86ad1890d4a81"/>
+    <p:sldLayoutId xmlns:r="http://schemas.openxmlformats.org/officeDocument/2006/relationships" id="2147483654" r:id="Rd4807a3e80ce4a13"/>
   </p:sldLayoutIdLst>
   <p:txStyles>
     <p:titleStyle>
@@ -3357,10 +3357,10 @@
       </p:grpSpPr>
       <p:sp>
         <p:nvSpPr>
-          <p:cNvPr id="27" name="">
-            <a:extLst xmlns:a="http://schemas.openxmlformats.org/drawingml/2006/main">
-              <a:ext uri="{FF2B5EF4-FFF2-40B4-BE49-F238E27FC236}">
-                <a16:creationId xmlns:a16="http://schemas.microsoft.com/office/drawing/2014/main" id="{7361BAE7-BE84-4F42-9174-B8098DE2A972}"/>
+          <p:cNvPr id="16" name="">
+            <a:extLst xmlns:a="http://schemas.openxmlformats.org/drawingml/2006/main">
+              <a:ext uri="{FF2B5EF4-FFF2-40B4-BE49-F238E27FC236}">
+                <a16:creationId xmlns:a16="http://schemas.microsoft.com/office/drawing/2014/main" id="{E51BB6E5-5AE8-41F9-BC11-54E3D0CF9E2C}"/>
               </a:ext>
             </a:extLst>
           </p:cNvPr>
@@ -3388,20 +3388,27 @@
           </a:ln>
         </p:spPr>
       </p:sp>
-      <p:sp>
-        <p:nvSpPr>
+      <p:pic>
+        <p:nvPicPr>
           <p:cNvPr id="2" name="">
             <a:extLst xmlns:a="http://schemas.openxmlformats.org/drawingml/2006/main">
               <a:ext uri="{FF2B5EF4-FFF2-40B4-BE49-F238E27FC236}">
-                <a16:creationId xmlns:a16="http://schemas.microsoft.com/office/drawing/2014/main" id="{35266819-AA71-4756-BDC6-67D91BFD6DD6}"/>
-              </a:ext>
-            </a:extLst>
-          </p:cNvPr>
-          <p:cNvSpPr>
-            <a:spLocks xmlns:a="http://schemas.openxmlformats.org/drawingml/2006/main" noGrp="1"/>
-          </p:cNvSpPr>
-          <p:nvPr/>
-        </p:nvSpPr>
+                <a16:creationId xmlns:a16="http://schemas.microsoft.com/office/drawing/2014/main" id="{BD2ED3AA-6EAC-4F27-A8FE-E4CF588D31D6}"/>
+              </a:ext>
+            </a:extLst>
+          </p:cNvPr>
+          <p:cNvPicPr>
+            <a:picLocks xmlns:a="http://schemas.openxmlformats.org/drawingml/2006/main" noChangeAspect="1"/>
+          </p:cNvPicPr>
+          <p:nvPr/>
+        </p:nvPicPr>
+        <p:blipFill>
+          <a:blip xmlns:r="http://schemas.openxmlformats.org/officeDocument/2006/relationships" xmlns:a="http://schemas.openxmlformats.org/drawingml/2006/main" r:embed="Redf80c641c094c57"/>
+          <a:srcRect xmlns:a="http://schemas.openxmlformats.org/drawingml/2006/main" l="0" t="5729" r="0" b="5729"/>
+          <a:stretch xmlns:a="http://schemas.openxmlformats.org/drawingml/2006/main">
+            <a:fillRect l="0" t="0" r="0" b="0"/>
+          </a:stretch>
+        </p:blipFill>
         <p:spPr>
           <a:xfrm xmlns:a="http://schemas.openxmlformats.org/drawingml/2006/main">
             <a:off x="7048500" y="685800"/>
@@ -3412,486 +3419,14 @@
               <a:gd name="adj" fmla="val 5106"/>
             </a:avLst>
           </a:prstGeom>
-          <a:solidFill xmlns:a="http://schemas.openxmlformats.org/drawingml/2006/main">
-            <a:srgbClr val="0E2B42"/>
-          </a:solidFill>
-          <a:ln xmlns:a="http://schemas.openxmlformats.org/drawingml/2006/main" w="9525">
-            <a:solidFill>
-              <a:srgbClr val="31536A"/>
-            </a:solidFill>
-            <a:prstDash val="solid"/>
-          </a:ln>
-        </p:spPr>
-      </p:sp>
+        </p:spPr>
+      </p:pic>
       <p:sp>
         <p:nvSpPr>
           <p:cNvPr id="3" name="">
             <a:extLst xmlns:a="http://schemas.openxmlformats.org/drawingml/2006/main">
               <a:ext uri="{FF2B5EF4-FFF2-40B4-BE49-F238E27FC236}">
-                <a16:creationId xmlns:a16="http://schemas.microsoft.com/office/drawing/2014/main" id="{50FDDDB4-275B-41FB-9A93-566E1F246ADF}"/>
-              </a:ext>
-            </a:extLst>
-          </p:cNvPr>
-          <p:cNvSpPr>
-            <a:spLocks xmlns:a="http://schemas.openxmlformats.org/drawingml/2006/main" noGrp="1"/>
-          </p:cNvSpPr>
-          <p:nvPr/>
-        </p:nvSpPr>
-        <p:spPr>
-          <a:xfrm xmlns:a="http://schemas.openxmlformats.org/drawingml/2006/main">
-            <a:off x="7667625" y="1381125"/>
-            <a:ext cx="3190875" cy="647700"/>
-          </a:xfrm>
-          <a:prstGeom xmlns:a="http://schemas.openxmlformats.org/drawingml/2006/main" prst="roundRect">
-            <a:avLst>
-              <a:gd name="adj" fmla="val 17647"/>
-            </a:avLst>
-          </a:prstGeom>
-          <a:solidFill xmlns:a="http://schemas.openxmlformats.org/drawingml/2006/main">
-            <a:srgbClr val="14384F"/>
-          </a:solidFill>
-          <a:ln xmlns:a="http://schemas.openxmlformats.org/drawingml/2006/main" w="0">
-            <a:noFill/>
-            <a:prstDash val="solid"/>
-          </a:ln>
-        </p:spPr>
-      </p:sp>
-      <p:sp>
-        <p:nvSpPr>
-          <p:cNvPr id="4" name="">
-            <a:extLst xmlns:a="http://schemas.openxmlformats.org/drawingml/2006/main">
-              <a:ext uri="{FF2B5EF4-FFF2-40B4-BE49-F238E27FC236}">
-                <a16:creationId xmlns:a16="http://schemas.microsoft.com/office/drawing/2014/main" id="{0AC584D8-D64C-447D-ACFB-CF1313FF880F}"/>
-              </a:ext>
-            </a:extLst>
-          </p:cNvPr>
-          <p:cNvSpPr>
-            <a:spLocks xmlns:a="http://schemas.openxmlformats.org/drawingml/2006/main" noGrp="1"/>
-          </p:cNvSpPr>
-          <p:nvPr/>
-        </p:nvSpPr>
-        <p:spPr>
-          <a:xfrm xmlns:a="http://schemas.openxmlformats.org/drawingml/2006/main">
-            <a:off x="7953375" y="1562100"/>
-            <a:ext cx="2619375" cy="266700"/>
-          </a:xfrm>
-          <a:prstGeom xmlns:a="http://schemas.openxmlformats.org/drawingml/2006/main" prst="rect">
-            <a:avLst/>
-          </a:prstGeom>
-          <a:noFill xmlns:a="http://schemas.openxmlformats.org/drawingml/2006/main"/>
-          <a:ln xmlns:a="http://schemas.openxmlformats.org/drawingml/2006/main" w="0">
-            <a:noFill/>
-            <a:prstDash val="solid"/>
-          </a:ln>
-        </p:spPr>
-        <p:txBody>
-          <a:bodyPr xmlns:a="http://schemas.openxmlformats.org/drawingml/2006/main"/>
-          <a:lstStyle xmlns:a="http://schemas.openxmlformats.org/drawingml/2006/main">
-            <a:defPPr algn="ctr">
-              <a:defRPr sz="1500" b="1">
-                <a:solidFill>
-                  <a:srgbClr val="F7FBFF"/>
-                </a:solidFill>
-              </a:defRPr>
-            </a:defPPr>
-          </a:lstStyle>
-          <a:p xmlns:a="http://schemas.openxmlformats.org/drawingml/2006/main">
-            <a:pPr algn="ctr">
-              <a:defRPr sz="1500" b="1">
-                <a:solidFill>
-                  <a:srgbClr val="F7FBFF"/>
-                </a:solidFill>
-              </a:defRPr>
-            </a:pPr>
-            <a:r>
-              <a:rPr sz="1500" b="1">
-                <a:solidFill>
-                  <a:srgbClr val="F7FBFF"/>
-                </a:solidFill>
-              </a:rPr>
-              <a:t>Subscribers</a:t>
-            </a:r>
-          </a:p>
-        </p:txBody>
-      </p:sp>
-      <p:sp>
-        <p:nvSpPr>
-          <p:cNvPr id="5" name="">
-            <a:extLst xmlns:a="http://schemas.openxmlformats.org/drawingml/2006/main">
-              <a:ext uri="{FF2B5EF4-FFF2-40B4-BE49-F238E27FC236}">
-                <a16:creationId xmlns:a16="http://schemas.microsoft.com/office/drawing/2014/main" id="{C9E5E992-D553-49BE-A185-EE25423C803F}"/>
-              </a:ext>
-            </a:extLst>
-          </p:cNvPr>
-          <p:cNvSpPr>
-            <a:spLocks xmlns:a="http://schemas.openxmlformats.org/drawingml/2006/main" noGrp="1"/>
-          </p:cNvSpPr>
-          <p:nvPr/>
-        </p:nvSpPr>
-        <p:spPr>
-          <a:xfrm xmlns:a="http://schemas.openxmlformats.org/drawingml/2006/main">
-            <a:off x="9191625" y="2028825"/>
-            <a:ext cx="38100" cy="352425"/>
-          </a:xfrm>
-          <a:prstGeom xmlns:a="http://schemas.openxmlformats.org/drawingml/2006/main" prst="rect">
-            <a:avLst/>
-          </a:prstGeom>
-          <a:solidFill xmlns:a="http://schemas.openxmlformats.org/drawingml/2006/main">
-            <a:srgbClr val="23D5D2"/>
-          </a:solidFill>
-          <a:ln xmlns:a="http://schemas.openxmlformats.org/drawingml/2006/main" w="0">
-            <a:solidFill>
-              <a:srgbClr val="23D5D2"/>
-            </a:solidFill>
-            <a:prstDash val="solid"/>
-          </a:ln>
-        </p:spPr>
-      </p:sp>
-      <p:sp>
-        <p:nvSpPr>
-          <p:cNvPr id="6" name="">
-            <a:extLst xmlns:a="http://schemas.openxmlformats.org/drawingml/2006/main">
-              <a:ext uri="{FF2B5EF4-FFF2-40B4-BE49-F238E27FC236}">
-                <a16:creationId xmlns:a16="http://schemas.microsoft.com/office/drawing/2014/main" id="{33B0FB49-BB67-4A34-BCF3-E50DC93BDE3B}"/>
-              </a:ext>
-            </a:extLst>
-          </p:cNvPr>
-          <p:cNvSpPr>
-            <a:spLocks xmlns:a="http://schemas.openxmlformats.org/drawingml/2006/main" noGrp="1"/>
-          </p:cNvSpPr>
-          <p:nvPr/>
-        </p:nvSpPr>
-        <p:spPr>
-          <a:xfrm xmlns:a="http://schemas.openxmlformats.org/drawingml/2006/main">
-            <a:off x="7667625" y="2381250"/>
-            <a:ext cx="3190875" cy="647700"/>
-          </a:xfrm>
-          <a:prstGeom xmlns:a="http://schemas.openxmlformats.org/drawingml/2006/main" prst="roundRect">
-            <a:avLst>
-              <a:gd name="adj" fmla="val 17647"/>
-            </a:avLst>
-          </a:prstGeom>
-          <a:solidFill xmlns:a="http://schemas.openxmlformats.org/drawingml/2006/main">
-            <a:srgbClr val="FF9D42"/>
-          </a:solidFill>
-          <a:ln xmlns:a="http://schemas.openxmlformats.org/drawingml/2006/main" w="0">
-            <a:noFill/>
-            <a:prstDash val="solid"/>
-          </a:ln>
-        </p:spPr>
-      </p:sp>
-      <p:sp>
-        <p:nvSpPr>
-          <p:cNvPr id="7" name="">
-            <a:extLst xmlns:a="http://schemas.openxmlformats.org/drawingml/2006/main">
-              <a:ext uri="{FF2B5EF4-FFF2-40B4-BE49-F238E27FC236}">
-                <a16:creationId xmlns:a16="http://schemas.microsoft.com/office/drawing/2014/main" id="{62AC8781-7EB6-400A-B9B7-A233A6BBD3E2}"/>
-              </a:ext>
-            </a:extLst>
-          </p:cNvPr>
-          <p:cNvSpPr>
-            <a:spLocks xmlns:a="http://schemas.openxmlformats.org/drawingml/2006/main" noGrp="1"/>
-          </p:cNvSpPr>
-          <p:nvPr/>
-        </p:nvSpPr>
-        <p:spPr>
-          <a:xfrm xmlns:a="http://schemas.openxmlformats.org/drawingml/2006/main">
-            <a:off x="7953375" y="2562225"/>
-            <a:ext cx="2619375" cy="266700"/>
-          </a:xfrm>
-          <a:prstGeom xmlns:a="http://schemas.openxmlformats.org/drawingml/2006/main" prst="rect">
-            <a:avLst/>
-          </a:prstGeom>
-          <a:noFill xmlns:a="http://schemas.openxmlformats.org/drawingml/2006/main"/>
-          <a:ln xmlns:a="http://schemas.openxmlformats.org/drawingml/2006/main" w="0">
-            <a:noFill/>
-            <a:prstDash val="solid"/>
-          </a:ln>
-        </p:spPr>
-        <p:txBody>
-          <a:bodyPr xmlns:a="http://schemas.openxmlformats.org/drawingml/2006/main"/>
-          <a:lstStyle xmlns:a="http://schemas.openxmlformats.org/drawingml/2006/main">
-            <a:defPPr algn="ctr">
-              <a:defRPr sz="1500" b="1">
-                <a:solidFill>
-                  <a:srgbClr val="071A2B"/>
-                </a:solidFill>
-              </a:defRPr>
-            </a:defPPr>
-          </a:lstStyle>
-          <a:p xmlns:a="http://schemas.openxmlformats.org/drawingml/2006/main">
-            <a:pPr algn="ctr">
-              <a:defRPr sz="1500" b="1">
-                <a:solidFill>
-                  <a:srgbClr val="071A2B"/>
-                </a:solidFill>
-              </a:defRPr>
-            </a:pPr>
-            <a:r>
-              <a:rPr sz="1500" b="1">
-                <a:solidFill>
-                  <a:srgbClr val="071A2B"/>
-                </a:solidFill>
-              </a:rPr>
-              <a:t>Kubernetes edge</a:t>
-            </a:r>
-          </a:p>
-        </p:txBody>
-      </p:sp>
-      <p:sp>
-        <p:nvSpPr>
-          <p:cNvPr id="8" name="">
-            <a:extLst xmlns:a="http://schemas.openxmlformats.org/drawingml/2006/main">
-              <a:ext uri="{FF2B5EF4-FFF2-40B4-BE49-F238E27FC236}">
-                <a16:creationId xmlns:a16="http://schemas.microsoft.com/office/drawing/2014/main" id="{FA9E06D1-EA2E-48F9-98CA-BCEC11E73A92}"/>
-              </a:ext>
-            </a:extLst>
-          </p:cNvPr>
-          <p:cNvSpPr>
-            <a:spLocks xmlns:a="http://schemas.openxmlformats.org/drawingml/2006/main" noGrp="1"/>
-          </p:cNvSpPr>
-          <p:nvPr/>
-        </p:nvSpPr>
-        <p:spPr>
-          <a:xfrm xmlns:a="http://schemas.openxmlformats.org/drawingml/2006/main">
-            <a:off x="9191625" y="3028950"/>
-            <a:ext cx="38100" cy="352425"/>
-          </a:xfrm>
-          <a:prstGeom xmlns:a="http://schemas.openxmlformats.org/drawingml/2006/main" prst="rect">
-            <a:avLst/>
-          </a:prstGeom>
-          <a:solidFill xmlns:a="http://schemas.openxmlformats.org/drawingml/2006/main">
-            <a:srgbClr val="23D5D2"/>
-          </a:solidFill>
-          <a:ln xmlns:a="http://schemas.openxmlformats.org/drawingml/2006/main" w="0">
-            <a:solidFill>
-              <a:srgbClr val="23D5D2"/>
-            </a:solidFill>
-            <a:prstDash val="solid"/>
-          </a:ln>
-        </p:spPr>
-      </p:sp>
-      <p:sp>
-        <p:nvSpPr>
-          <p:cNvPr id="9" name="">
-            <a:extLst xmlns:a="http://schemas.openxmlformats.org/drawingml/2006/main">
-              <a:ext uri="{FF2B5EF4-FFF2-40B4-BE49-F238E27FC236}">
-                <a16:creationId xmlns:a16="http://schemas.microsoft.com/office/drawing/2014/main" id="{C74C14AD-AAE1-454D-8447-100AC0E5F68E}"/>
-              </a:ext>
-            </a:extLst>
-          </p:cNvPr>
-          <p:cNvSpPr>
-            <a:spLocks xmlns:a="http://schemas.openxmlformats.org/drawingml/2006/main" noGrp="1"/>
-          </p:cNvSpPr>
-          <p:nvPr/>
-        </p:nvSpPr>
-        <p:spPr>
-          <a:xfrm xmlns:a="http://schemas.openxmlformats.org/drawingml/2006/main">
-            <a:off x="7667625" y="3381375"/>
-            <a:ext cx="3190875" cy="647700"/>
-          </a:xfrm>
-          <a:prstGeom xmlns:a="http://schemas.openxmlformats.org/drawingml/2006/main" prst="roundRect">
-            <a:avLst>
-              <a:gd name="adj" fmla="val 17647"/>
-            </a:avLst>
-          </a:prstGeom>
-          <a:solidFill xmlns:a="http://schemas.openxmlformats.org/drawingml/2006/main">
-            <a:srgbClr val="14384F"/>
-          </a:solidFill>
-          <a:ln xmlns:a="http://schemas.openxmlformats.org/drawingml/2006/main" w="0">
-            <a:noFill/>
-            <a:prstDash val="solid"/>
-          </a:ln>
-        </p:spPr>
-      </p:sp>
-      <p:sp>
-        <p:nvSpPr>
-          <p:cNvPr id="10" name="">
-            <a:extLst xmlns:a="http://schemas.openxmlformats.org/drawingml/2006/main">
-              <a:ext uri="{FF2B5EF4-FFF2-40B4-BE49-F238E27FC236}">
-                <a16:creationId xmlns:a16="http://schemas.microsoft.com/office/drawing/2014/main" id="{23F61E4B-FB8D-48CB-91C1-02C650CF6916}"/>
-              </a:ext>
-            </a:extLst>
-          </p:cNvPr>
-          <p:cNvSpPr>
-            <a:spLocks xmlns:a="http://schemas.openxmlformats.org/drawingml/2006/main" noGrp="1"/>
-          </p:cNvSpPr>
-          <p:nvPr/>
-        </p:nvSpPr>
-        <p:spPr>
-          <a:xfrm xmlns:a="http://schemas.openxmlformats.org/drawingml/2006/main">
-            <a:off x="7953375" y="3562350"/>
-            <a:ext cx="2619375" cy="266700"/>
-          </a:xfrm>
-          <a:prstGeom xmlns:a="http://schemas.openxmlformats.org/drawingml/2006/main" prst="rect">
-            <a:avLst/>
-          </a:prstGeom>
-          <a:noFill xmlns:a="http://schemas.openxmlformats.org/drawingml/2006/main"/>
-          <a:ln xmlns:a="http://schemas.openxmlformats.org/drawingml/2006/main" w="0">
-            <a:noFill/>
-            <a:prstDash val="solid"/>
-          </a:ln>
-        </p:spPr>
-        <p:txBody>
-          <a:bodyPr xmlns:a="http://schemas.openxmlformats.org/drawingml/2006/main"/>
-          <a:lstStyle xmlns:a="http://schemas.openxmlformats.org/drawingml/2006/main">
-            <a:defPPr algn="ctr">
-              <a:defRPr sz="1500" b="1">
-                <a:solidFill>
-                  <a:srgbClr val="F7FBFF"/>
-                </a:solidFill>
-              </a:defRPr>
-            </a:defPPr>
-          </a:lstStyle>
-          <a:p xmlns:a="http://schemas.openxmlformats.org/drawingml/2006/main">
-            <a:pPr algn="ctr">
-              <a:defRPr sz="1500" b="1">
-                <a:solidFill>
-                  <a:srgbClr val="F7FBFF"/>
-                </a:solidFill>
-              </a:defRPr>
-            </a:pPr>
-            <a:r>
-              <a:rPr sz="1500" b="1">
-                <a:solidFill>
-                  <a:srgbClr val="F7FBFF"/>
-                </a:solidFill>
-              </a:rPr>
-              <a:t>vBNG + routing</a:t>
-            </a:r>
-          </a:p>
-        </p:txBody>
-      </p:sp>
-      <p:sp>
-        <p:nvSpPr>
-          <p:cNvPr id="11" name="">
-            <a:extLst xmlns:a="http://schemas.openxmlformats.org/drawingml/2006/main">
-              <a:ext uri="{FF2B5EF4-FFF2-40B4-BE49-F238E27FC236}">
-                <a16:creationId xmlns:a16="http://schemas.microsoft.com/office/drawing/2014/main" id="{F3A3E236-8D60-4762-BECC-242487B78803}"/>
-              </a:ext>
-            </a:extLst>
-          </p:cNvPr>
-          <p:cNvSpPr>
-            <a:spLocks xmlns:a="http://schemas.openxmlformats.org/drawingml/2006/main" noGrp="1"/>
-          </p:cNvSpPr>
-          <p:nvPr/>
-        </p:nvSpPr>
-        <p:spPr>
-          <a:xfrm xmlns:a="http://schemas.openxmlformats.org/drawingml/2006/main">
-            <a:off x="9191625" y="4029075"/>
-            <a:ext cx="38100" cy="352425"/>
-          </a:xfrm>
-          <a:prstGeom xmlns:a="http://schemas.openxmlformats.org/drawingml/2006/main" prst="rect">
-            <a:avLst/>
-          </a:prstGeom>
-          <a:solidFill xmlns:a="http://schemas.openxmlformats.org/drawingml/2006/main">
-            <a:srgbClr val="23D5D2"/>
-          </a:solidFill>
-          <a:ln xmlns:a="http://schemas.openxmlformats.org/drawingml/2006/main" w="0">
-            <a:solidFill>
-              <a:srgbClr val="23D5D2"/>
-            </a:solidFill>
-            <a:prstDash val="solid"/>
-          </a:ln>
-        </p:spPr>
-      </p:sp>
-      <p:sp>
-        <p:nvSpPr>
-          <p:cNvPr id="12" name="">
-            <a:extLst xmlns:a="http://schemas.openxmlformats.org/drawingml/2006/main">
-              <a:ext uri="{FF2B5EF4-FFF2-40B4-BE49-F238E27FC236}">
-                <a16:creationId xmlns:a16="http://schemas.microsoft.com/office/drawing/2014/main" id="{E2873E9E-6F32-4A7E-B531-15071B4CB834}"/>
-              </a:ext>
-            </a:extLst>
-          </p:cNvPr>
-          <p:cNvSpPr>
-            <a:spLocks xmlns:a="http://schemas.openxmlformats.org/drawingml/2006/main" noGrp="1"/>
-          </p:cNvSpPr>
-          <p:nvPr/>
-        </p:nvSpPr>
-        <p:spPr>
-          <a:xfrm xmlns:a="http://schemas.openxmlformats.org/drawingml/2006/main">
-            <a:off x="7667625" y="4381500"/>
-            <a:ext cx="3190875" cy="647700"/>
-          </a:xfrm>
-          <a:prstGeom xmlns:a="http://schemas.openxmlformats.org/drawingml/2006/main" prst="roundRect">
-            <a:avLst>
-              <a:gd name="adj" fmla="val 17647"/>
-            </a:avLst>
-          </a:prstGeom>
-          <a:solidFill xmlns:a="http://schemas.openxmlformats.org/drawingml/2006/main">
-            <a:srgbClr val="14384F"/>
-          </a:solidFill>
-          <a:ln xmlns:a="http://schemas.openxmlformats.org/drawingml/2006/main" w="0">
-            <a:noFill/>
-            <a:prstDash val="solid"/>
-          </a:ln>
-        </p:spPr>
-      </p:sp>
-      <p:sp>
-        <p:nvSpPr>
-          <p:cNvPr id="13" name="">
-            <a:extLst xmlns:a="http://schemas.openxmlformats.org/drawingml/2006/main">
-              <a:ext uri="{FF2B5EF4-FFF2-40B4-BE49-F238E27FC236}">
-                <a16:creationId xmlns:a16="http://schemas.microsoft.com/office/drawing/2014/main" id="{0D10BB61-A8AB-428F-A6B7-7E1237B6E27E}"/>
-              </a:ext>
-            </a:extLst>
-          </p:cNvPr>
-          <p:cNvSpPr>
-            <a:spLocks xmlns:a="http://schemas.openxmlformats.org/drawingml/2006/main" noGrp="1"/>
-          </p:cNvSpPr>
-          <p:nvPr/>
-        </p:nvSpPr>
-        <p:spPr>
-          <a:xfrm xmlns:a="http://schemas.openxmlformats.org/drawingml/2006/main">
-            <a:off x="7953375" y="4562475"/>
-            <a:ext cx="2619375" cy="266700"/>
-          </a:xfrm>
-          <a:prstGeom xmlns:a="http://schemas.openxmlformats.org/drawingml/2006/main" prst="rect">
-            <a:avLst/>
-          </a:prstGeom>
-          <a:noFill xmlns:a="http://schemas.openxmlformats.org/drawingml/2006/main"/>
-          <a:ln xmlns:a="http://schemas.openxmlformats.org/drawingml/2006/main" w="0">
-            <a:noFill/>
-            <a:prstDash val="solid"/>
-          </a:ln>
-        </p:spPr>
-        <p:txBody>
-          <a:bodyPr xmlns:a="http://schemas.openxmlformats.org/drawingml/2006/main"/>
-          <a:lstStyle xmlns:a="http://schemas.openxmlformats.org/drawingml/2006/main">
-            <a:defPPr algn="ctr">
-              <a:defRPr sz="1500" b="1">
-                <a:solidFill>
-                  <a:srgbClr val="F7FBFF"/>
-                </a:solidFill>
-              </a:defRPr>
-            </a:defPPr>
-          </a:lstStyle>
-          <a:p xmlns:a="http://schemas.openxmlformats.org/drawingml/2006/main">
-            <a:pPr algn="ctr">
-              <a:defRPr sz="1500" b="1">
-                <a:solidFill>
-                  <a:srgbClr val="F7FBFF"/>
-                </a:solidFill>
-              </a:defRPr>
-            </a:pPr>
-            <a:r>
-              <a:rPr sz="1500" b="1">
-                <a:solidFill>
-                  <a:srgbClr val="F7FBFF"/>
-                </a:solidFill>
-              </a:rPr>
-              <a:t>Internet services</a:t>
-            </a:r>
-          </a:p>
-        </p:txBody>
-      </p:sp>
-      <p:sp>
-        <p:nvSpPr>
-          <p:cNvPr id="14" name="">
-            <a:extLst xmlns:a="http://schemas.openxmlformats.org/drawingml/2006/main">
-              <a:ext uri="{FF2B5EF4-FFF2-40B4-BE49-F238E27FC236}">
-                <a16:creationId xmlns:a16="http://schemas.microsoft.com/office/drawing/2014/main" id="{037B1450-8EA4-4146-88B7-30E680C0436E}"/>
+                <a16:creationId xmlns:a16="http://schemas.microsoft.com/office/drawing/2014/main" id="{5A4FF4F2-F3CA-4AAB-A3A5-0DBC9A532FF5}"/>
               </a:ext>
             </a:extLst>
           </p:cNvPr>
@@ -3963,10 +3498,10 @@
       </p:sp>
       <p:sp>
         <p:nvSpPr>
-          <p:cNvPr id="15" name="">
-            <a:extLst xmlns:a="http://schemas.openxmlformats.org/drawingml/2006/main">
-              <a:ext uri="{FF2B5EF4-FFF2-40B4-BE49-F238E27FC236}">
-                <a16:creationId xmlns:a16="http://schemas.microsoft.com/office/drawing/2014/main" id="{170257DE-0F12-49B4-A31B-084B293C40CE}"/>
+          <p:cNvPr id="4" name="">
+            <a:extLst xmlns:a="http://schemas.openxmlformats.org/drawingml/2006/main">
+              <a:ext uri="{FF2B5EF4-FFF2-40B4-BE49-F238E27FC236}">
+                <a16:creationId xmlns:a16="http://schemas.microsoft.com/office/drawing/2014/main" id="{94221983-BB00-410D-85E1-1164608253BF}"/>
               </a:ext>
             </a:extLst>
           </p:cNvPr>
@@ -4021,10 +3556,10 @@
       </p:sp>
       <p:sp>
         <p:nvSpPr>
-          <p:cNvPr id="16" name="">
-            <a:extLst xmlns:a="http://schemas.openxmlformats.org/drawingml/2006/main">
-              <a:ext uri="{FF2B5EF4-FFF2-40B4-BE49-F238E27FC236}">
-                <a16:creationId xmlns:a16="http://schemas.microsoft.com/office/drawing/2014/main" id="{71CBBA18-1690-4BF3-8021-14314F6F4CF8}"/>
+          <p:cNvPr id="5" name="">
+            <a:extLst xmlns:a="http://schemas.openxmlformats.org/drawingml/2006/main">
+              <a:ext uri="{FF2B5EF4-FFF2-40B4-BE49-F238E27FC236}">
+                <a16:creationId xmlns:a16="http://schemas.microsoft.com/office/drawing/2014/main" id="{7CC88497-F0C3-48DD-AAB6-124FC977EA21}"/>
               </a:ext>
             </a:extLst>
           </p:cNvPr>
@@ -4079,10 +3614,10 @@
       </p:sp>
       <p:sp>
         <p:nvSpPr>
-          <p:cNvPr id="17" name="">
-            <a:extLst xmlns:a="http://schemas.openxmlformats.org/drawingml/2006/main">
-              <a:ext uri="{FF2B5EF4-FFF2-40B4-BE49-F238E27FC236}">
-                <a16:creationId xmlns:a16="http://schemas.microsoft.com/office/drawing/2014/main" id="{0CEB5280-D8E7-4BD1-883B-EF9BF60B3434}"/>
+          <p:cNvPr id="6" name="">
+            <a:extLst xmlns:a="http://schemas.openxmlformats.org/drawingml/2006/main">
+              <a:ext uri="{FF2B5EF4-FFF2-40B4-BE49-F238E27FC236}">
+                <a16:creationId xmlns:a16="http://schemas.microsoft.com/office/drawing/2014/main" id="{7E75754E-D72F-410C-8A6A-475036464EEE}"/>
               </a:ext>
             </a:extLst>
           </p:cNvPr>
@@ -4112,10 +3647,10 @@
       </p:sp>
       <p:sp>
         <p:nvSpPr>
-          <p:cNvPr id="18" name="">
-            <a:extLst xmlns:a="http://schemas.openxmlformats.org/drawingml/2006/main">
-              <a:ext uri="{FF2B5EF4-FFF2-40B4-BE49-F238E27FC236}">
-                <a16:creationId xmlns:a16="http://schemas.microsoft.com/office/drawing/2014/main" id="{325FF002-C944-49A9-8F8C-7B81490FA61D}"/>
+          <p:cNvPr id="7" name="">
+            <a:extLst xmlns:a="http://schemas.openxmlformats.org/drawingml/2006/main">
+              <a:ext uri="{FF2B5EF4-FFF2-40B4-BE49-F238E27FC236}">
+                <a16:creationId xmlns:a16="http://schemas.microsoft.com/office/drawing/2014/main" id="{31B7B940-3098-4A28-93AC-6D00D4B205CA}"/>
               </a:ext>
             </a:extLst>
           </p:cNvPr>
@@ -4170,10 +3705,10 @@
       </p:sp>
       <p:sp>
         <p:nvSpPr>
-          <p:cNvPr id="19" name="">
-            <a:extLst xmlns:a="http://schemas.openxmlformats.org/drawingml/2006/main">
-              <a:ext uri="{FF2B5EF4-FFF2-40B4-BE49-F238E27FC236}">
-                <a16:creationId xmlns:a16="http://schemas.microsoft.com/office/drawing/2014/main" id="{549F195A-6E15-4893-B182-A9AE09C46EC4}"/>
+          <p:cNvPr id="8" name="">
+            <a:extLst xmlns:a="http://schemas.openxmlformats.org/drawingml/2006/main">
+              <a:ext uri="{FF2B5EF4-FFF2-40B4-BE49-F238E27FC236}">
+                <a16:creationId xmlns:a16="http://schemas.microsoft.com/office/drawing/2014/main" id="{A20F21C9-666B-469A-B6C7-120013C85789}"/>
               </a:ext>
             </a:extLst>
           </p:cNvPr>
@@ -4203,10 +3738,10 @@
       </p:sp>
       <p:sp>
         <p:nvSpPr>
-          <p:cNvPr id="20" name="">
-            <a:extLst xmlns:a="http://schemas.openxmlformats.org/drawingml/2006/main">
-              <a:ext uri="{FF2B5EF4-FFF2-40B4-BE49-F238E27FC236}">
-                <a16:creationId xmlns:a16="http://schemas.microsoft.com/office/drawing/2014/main" id="{0D9D2EC9-F8ED-4F4C-B43C-E33FAD5659A7}"/>
+          <p:cNvPr id="9" name="">
+            <a:extLst xmlns:a="http://schemas.openxmlformats.org/drawingml/2006/main">
+              <a:ext uri="{FF2B5EF4-FFF2-40B4-BE49-F238E27FC236}">
+                <a16:creationId xmlns:a16="http://schemas.microsoft.com/office/drawing/2014/main" id="{CFA1D67F-193D-4A01-9450-7936DA4337E6}"/>
               </a:ext>
             </a:extLst>
           </p:cNvPr>
@@ -4261,10 +3796,10 @@
       </p:sp>
       <p:sp>
         <p:nvSpPr>
-          <p:cNvPr id="21" name="">
-            <a:extLst xmlns:a="http://schemas.openxmlformats.org/drawingml/2006/main">
-              <a:ext uri="{FF2B5EF4-FFF2-40B4-BE49-F238E27FC236}">
-                <a16:creationId xmlns:a16="http://schemas.microsoft.com/office/drawing/2014/main" id="{FDE6018E-F27B-4473-89FE-5FF19DFA4046}"/>
+          <p:cNvPr id="10" name="">
+            <a:extLst xmlns:a="http://schemas.openxmlformats.org/drawingml/2006/main">
+              <a:ext uri="{FF2B5EF4-FFF2-40B4-BE49-F238E27FC236}">
+                <a16:creationId xmlns:a16="http://schemas.microsoft.com/office/drawing/2014/main" id="{F4543883-C79B-4BFF-8291-CC5E341247FC}"/>
               </a:ext>
             </a:extLst>
           </p:cNvPr>
@@ -4294,10 +3829,10 @@
       </p:sp>
       <p:sp>
         <p:nvSpPr>
-          <p:cNvPr id="22" name="">
-            <a:extLst xmlns:a="http://schemas.openxmlformats.org/drawingml/2006/main">
-              <a:ext uri="{FF2B5EF4-FFF2-40B4-BE49-F238E27FC236}">
-                <a16:creationId xmlns:a16="http://schemas.microsoft.com/office/drawing/2014/main" id="{B922A6DB-B194-43F6-9474-DDD3AACD4021}"/>
+          <p:cNvPr id="11" name="">
+            <a:extLst xmlns:a="http://schemas.openxmlformats.org/drawingml/2006/main">
+              <a:ext uri="{FF2B5EF4-FFF2-40B4-BE49-F238E27FC236}">
+                <a16:creationId xmlns:a16="http://schemas.microsoft.com/office/drawing/2014/main" id="{B3627D10-1CF6-4BE2-A18E-9D30CD494993}"/>
               </a:ext>
             </a:extLst>
           </p:cNvPr>
@@ -4352,10 +3887,10 @@
       </p:sp>
       <p:sp>
         <p:nvSpPr>
-          <p:cNvPr id="23" name="">
-            <a:extLst xmlns:a="http://schemas.openxmlformats.org/drawingml/2006/main">
-              <a:ext uri="{FF2B5EF4-FFF2-40B4-BE49-F238E27FC236}">
-                <a16:creationId xmlns:a16="http://schemas.microsoft.com/office/drawing/2014/main" id="{F39D0BA7-31EC-4583-9D36-FC800D580C43}"/>
+          <p:cNvPr id="12" name="">
+            <a:extLst xmlns:a="http://schemas.openxmlformats.org/drawingml/2006/main">
+              <a:ext uri="{FF2B5EF4-FFF2-40B4-BE49-F238E27FC236}">
+                <a16:creationId xmlns:a16="http://schemas.microsoft.com/office/drawing/2014/main" id="{59DF02B6-A454-45F2-8B3E-56D806A94088}"/>
               </a:ext>
             </a:extLst>
           </p:cNvPr>
@@ -4410,10 +3945,10 @@
       </p:sp>
       <p:sp>
         <p:nvSpPr>
-          <p:cNvPr id="24" name="">
-            <a:extLst xmlns:a="http://schemas.openxmlformats.org/drawingml/2006/main">
-              <a:ext uri="{FF2B5EF4-FFF2-40B4-BE49-F238E27FC236}">
-                <a16:creationId xmlns:a16="http://schemas.microsoft.com/office/drawing/2014/main" id="{9CB5D36B-29CD-4223-B0F8-8EAE2CBD71DA}"/>
+          <p:cNvPr id="13" name="">
+            <a:extLst xmlns:a="http://schemas.openxmlformats.org/drawingml/2006/main">
+              <a:ext uri="{FF2B5EF4-FFF2-40B4-BE49-F238E27FC236}">
+                <a16:creationId xmlns:a16="http://schemas.microsoft.com/office/drawing/2014/main" id="{A0FAB163-FE59-428D-AD76-182B3F92287F}"/>
               </a:ext>
             </a:extLst>
           </p:cNvPr>
@@ -4443,10 +3978,10 @@
       </p:sp>
       <p:sp>
         <p:nvSpPr>
-          <p:cNvPr id="25" name="">
-            <a:extLst xmlns:a="http://schemas.openxmlformats.org/drawingml/2006/main">
-              <a:ext uri="{FF2B5EF4-FFF2-40B4-BE49-F238E27FC236}">
-                <a16:creationId xmlns:a16="http://schemas.microsoft.com/office/drawing/2014/main" id="{B18427EA-AEA2-4193-AC74-BF6387ABD55D}"/>
+          <p:cNvPr id="14" name="">
+            <a:extLst xmlns:a="http://schemas.openxmlformats.org/drawingml/2006/main">
+              <a:ext uri="{FF2B5EF4-FFF2-40B4-BE49-F238E27FC236}">
+                <a16:creationId xmlns:a16="http://schemas.microsoft.com/office/drawing/2014/main" id="{F050E6B3-A68B-4797-9792-6D748058A5B7}"/>
               </a:ext>
             </a:extLst>
           </p:cNvPr>
@@ -4489,10 +4024,10 @@
       </p:sp>
       <p:sp>
         <p:nvSpPr>
-          <p:cNvPr id="26" name="">
-            <a:extLst xmlns:a="http://schemas.openxmlformats.org/drawingml/2006/main">
-              <a:ext uri="{FF2B5EF4-FFF2-40B4-BE49-F238E27FC236}">
-                <a16:creationId xmlns:a16="http://schemas.microsoft.com/office/drawing/2014/main" id="{F12BFDF9-CC98-4987-8CE7-7EFB83B00BBD}"/>
+          <p:cNvPr id="15" name="">
+            <a:extLst xmlns:a="http://schemas.openxmlformats.org/drawingml/2006/main">
+              <a:ext uri="{FF2B5EF4-FFF2-40B4-BE49-F238E27FC236}">
+                <a16:creationId xmlns:a16="http://schemas.microsoft.com/office/drawing/2014/main" id="{0A6F584A-DA4B-4C6D-9244-4F920309C302}"/>
               </a:ext>
             </a:extLst>
           </p:cNvPr>
@@ -4548,7 +4083,7 @@
     </p:spTree>
     <p:extLst>
       <p:ext uri="{BB962C8B-B14F-4D97-AF65-F5344CB8AC3E}">
-        <p14:creationId xmlns:p14="http://schemas.microsoft.com/office/powerpoint/2010/main" val="1456867660"/>
+        <p14:creationId xmlns:p14="http://schemas.microsoft.com/office/powerpoint/2010/main" val="430512511"/>
       </p:ext>
     </p:extLst>
   </p:cSld>
@@ -4579,7 +4114,7 @@
           <p:cNvPr id="32" name="">
             <a:extLst xmlns:a="http://schemas.openxmlformats.org/drawingml/2006/main">
               <a:ext uri="{FF2B5EF4-FFF2-40B4-BE49-F238E27FC236}">
-                <a16:creationId xmlns:a16="http://schemas.microsoft.com/office/drawing/2014/main" id="{DDE13096-BB71-430F-AD9D-7C1A57CD8BB7}"/>
+                <a16:creationId xmlns:a16="http://schemas.microsoft.com/office/drawing/2014/main" id="{16067255-D23D-4203-92B8-103008423CF5}"/>
               </a:ext>
             </a:extLst>
           </p:cNvPr>
@@ -4637,7 +4172,7 @@
           <p:cNvPr id="2" name="">
             <a:extLst xmlns:a="http://schemas.openxmlformats.org/drawingml/2006/main">
               <a:ext uri="{FF2B5EF4-FFF2-40B4-BE49-F238E27FC236}">
-                <a16:creationId xmlns:a16="http://schemas.microsoft.com/office/drawing/2014/main" id="{4ACAC89D-B074-44C0-A313-21761695A069}"/>
+                <a16:creationId xmlns:a16="http://schemas.microsoft.com/office/drawing/2014/main" id="{57B66BD6-0D87-4F6E-A460-A6831BBC268C}"/>
               </a:ext>
             </a:extLst>
           </p:cNvPr>
@@ -4695,7 +4230,7 @@
           <p:cNvPr id="3" name="">
             <a:extLst xmlns:a="http://schemas.openxmlformats.org/drawingml/2006/main">
               <a:ext uri="{FF2B5EF4-FFF2-40B4-BE49-F238E27FC236}">
-                <a16:creationId xmlns:a16="http://schemas.microsoft.com/office/drawing/2014/main" id="{8D0FD17B-53D8-4D81-B979-2605E7FA98DE}"/>
+                <a16:creationId xmlns:a16="http://schemas.microsoft.com/office/drawing/2014/main" id="{85CC7EA3-373B-4560-A19A-D0A1B41AECBC}"/>
               </a:ext>
             </a:extLst>
           </p:cNvPr>
@@ -4753,7 +4288,7 @@
           <p:cNvPr id="4" name="">
             <a:extLst xmlns:a="http://schemas.openxmlformats.org/drawingml/2006/main">
               <a:ext uri="{FF2B5EF4-FFF2-40B4-BE49-F238E27FC236}">
-                <a16:creationId xmlns:a16="http://schemas.microsoft.com/office/drawing/2014/main" id="{F2F5273D-40C7-40EF-BF50-B996776C84CB}"/>
+                <a16:creationId xmlns:a16="http://schemas.microsoft.com/office/drawing/2014/main" id="{1649165A-18E2-4608-9CAE-465983D1563D}"/>
               </a:ext>
             </a:extLst>
           </p:cNvPr>
@@ -4788,7 +4323,7 @@
           <p:cNvPr id="5" name="">
             <a:extLst xmlns:a="http://schemas.openxmlformats.org/drawingml/2006/main">
               <a:ext uri="{FF2B5EF4-FFF2-40B4-BE49-F238E27FC236}">
-                <a16:creationId xmlns:a16="http://schemas.microsoft.com/office/drawing/2014/main" id="{C11993E2-0258-4CF1-BDB7-D57022A15694}"/>
+                <a16:creationId xmlns:a16="http://schemas.microsoft.com/office/drawing/2014/main" id="{6E657310-CEE2-4DB2-B3DA-B7820AB30878}"/>
               </a:ext>
             </a:extLst>
           </p:cNvPr>
@@ -4821,7 +4356,7 @@
           <p:cNvPr id="6" name="">
             <a:extLst xmlns:a="http://schemas.openxmlformats.org/drawingml/2006/main">
               <a:ext uri="{FF2B5EF4-FFF2-40B4-BE49-F238E27FC236}">
-                <a16:creationId xmlns:a16="http://schemas.microsoft.com/office/drawing/2014/main" id="{1D5DDC3B-9F90-4750-8C83-744B3B800E53}"/>
+                <a16:creationId xmlns:a16="http://schemas.microsoft.com/office/drawing/2014/main" id="{09D756F4-D251-4CAF-8CFB-B839EE112580}"/>
               </a:ext>
             </a:extLst>
           </p:cNvPr>
@@ -4879,7 +4414,7 @@
           <p:cNvPr id="7" name="">
             <a:extLst xmlns:a="http://schemas.openxmlformats.org/drawingml/2006/main">
               <a:ext uri="{FF2B5EF4-FFF2-40B4-BE49-F238E27FC236}">
-                <a16:creationId xmlns:a16="http://schemas.microsoft.com/office/drawing/2014/main" id="{5FB23E46-A74E-4014-9A33-BE4749FF6F88}"/>
+                <a16:creationId xmlns:a16="http://schemas.microsoft.com/office/drawing/2014/main" id="{EB8D7ED2-D5C3-4E79-87E0-36A8F179B728}"/>
               </a:ext>
             </a:extLst>
           </p:cNvPr>
@@ -4954,7 +4489,7 @@
           <p:cNvPr id="8" name="">
             <a:extLst xmlns:a="http://schemas.openxmlformats.org/drawingml/2006/main">
               <a:ext uri="{FF2B5EF4-FFF2-40B4-BE49-F238E27FC236}">
-                <a16:creationId xmlns:a16="http://schemas.microsoft.com/office/drawing/2014/main" id="{F81B4E8D-16F1-4CB5-AAAF-5FE0928C95B5}"/>
+                <a16:creationId xmlns:a16="http://schemas.microsoft.com/office/drawing/2014/main" id="{B47D32C4-D216-4010-9722-D145B874A565}"/>
               </a:ext>
             </a:extLst>
           </p:cNvPr>
@@ -4989,7 +4524,7 @@
           <p:cNvPr id="9" name="">
             <a:extLst xmlns:a="http://schemas.openxmlformats.org/drawingml/2006/main">
               <a:ext uri="{FF2B5EF4-FFF2-40B4-BE49-F238E27FC236}">
-                <a16:creationId xmlns:a16="http://schemas.microsoft.com/office/drawing/2014/main" id="{48CCE799-84E4-44F8-BA0F-9578CFC2E0B9}"/>
+                <a16:creationId xmlns:a16="http://schemas.microsoft.com/office/drawing/2014/main" id="{8492DD0B-B5FE-4E29-AA75-AF6F619B96B8}"/>
               </a:ext>
             </a:extLst>
           </p:cNvPr>
@@ -5022,7 +4557,7 @@
           <p:cNvPr id="10" name="">
             <a:extLst xmlns:a="http://schemas.openxmlformats.org/drawingml/2006/main">
               <a:ext uri="{FF2B5EF4-FFF2-40B4-BE49-F238E27FC236}">
-                <a16:creationId xmlns:a16="http://schemas.microsoft.com/office/drawing/2014/main" id="{2AB4F394-5C5A-4740-9FAA-535219EF2971}"/>
+                <a16:creationId xmlns:a16="http://schemas.microsoft.com/office/drawing/2014/main" id="{11E108B6-3662-4E4D-A7B7-807D4BB54656}"/>
               </a:ext>
             </a:extLst>
           </p:cNvPr>
@@ -5080,7 +4615,7 @@
           <p:cNvPr id="11" name="">
             <a:extLst xmlns:a="http://schemas.openxmlformats.org/drawingml/2006/main">
               <a:ext uri="{FF2B5EF4-FFF2-40B4-BE49-F238E27FC236}">
-                <a16:creationId xmlns:a16="http://schemas.microsoft.com/office/drawing/2014/main" id="{EDD37A36-D111-44F8-8DC4-0993696B38B4}"/>
+                <a16:creationId xmlns:a16="http://schemas.microsoft.com/office/drawing/2014/main" id="{B8818125-625B-48BB-ACB1-BA5FC7673B68}"/>
               </a:ext>
             </a:extLst>
           </p:cNvPr>
@@ -5155,7 +4690,7 @@
           <p:cNvPr id="12" name="">
             <a:extLst xmlns:a="http://schemas.openxmlformats.org/drawingml/2006/main">
               <a:ext uri="{FF2B5EF4-FFF2-40B4-BE49-F238E27FC236}">
-                <a16:creationId xmlns:a16="http://schemas.microsoft.com/office/drawing/2014/main" id="{7B4A700D-D4A6-4A3D-AB92-FB94623F8DA1}"/>
+                <a16:creationId xmlns:a16="http://schemas.microsoft.com/office/drawing/2014/main" id="{66F575EB-CB53-4073-BB17-C944EF5D8506}"/>
               </a:ext>
             </a:extLst>
           </p:cNvPr>
@@ -5190,7 +4725,7 @@
           <p:cNvPr id="13" name="">
             <a:extLst xmlns:a="http://schemas.openxmlformats.org/drawingml/2006/main">
               <a:ext uri="{FF2B5EF4-FFF2-40B4-BE49-F238E27FC236}">
-                <a16:creationId xmlns:a16="http://schemas.microsoft.com/office/drawing/2014/main" id="{20AF8C0A-CFA0-41AE-89AA-1216595FD9F5}"/>
+                <a16:creationId xmlns:a16="http://schemas.microsoft.com/office/drawing/2014/main" id="{A058A59B-4251-4584-B07B-565B51D6AC8C}"/>
               </a:ext>
             </a:extLst>
           </p:cNvPr>
@@ -5223,7 +4758,7 @@
           <p:cNvPr id="14" name="">
             <a:extLst xmlns:a="http://schemas.openxmlformats.org/drawingml/2006/main">
               <a:ext uri="{FF2B5EF4-FFF2-40B4-BE49-F238E27FC236}">
-                <a16:creationId xmlns:a16="http://schemas.microsoft.com/office/drawing/2014/main" id="{D0FA6055-F40B-463C-9583-D1CA5ACB5868}"/>
+                <a16:creationId xmlns:a16="http://schemas.microsoft.com/office/drawing/2014/main" id="{1B16078E-E23D-4A0B-80F5-D4C2EC64ECDF}"/>
               </a:ext>
             </a:extLst>
           </p:cNvPr>
@@ -5281,7 +4816,7 @@
           <p:cNvPr id="15" name="">
             <a:extLst xmlns:a="http://schemas.openxmlformats.org/drawingml/2006/main">
               <a:ext uri="{FF2B5EF4-FFF2-40B4-BE49-F238E27FC236}">
-                <a16:creationId xmlns:a16="http://schemas.microsoft.com/office/drawing/2014/main" id="{A6F7C4A8-7595-475B-AAB7-A66E102F1EE5}"/>
+                <a16:creationId xmlns:a16="http://schemas.microsoft.com/office/drawing/2014/main" id="{8EFD2CCF-80C7-4E48-B754-B136BA8F7287}"/>
               </a:ext>
             </a:extLst>
           </p:cNvPr>
@@ -5356,7 +4891,7 @@
           <p:cNvPr id="16" name="">
             <a:extLst xmlns:a="http://schemas.openxmlformats.org/drawingml/2006/main">
               <a:ext uri="{FF2B5EF4-FFF2-40B4-BE49-F238E27FC236}">
-                <a16:creationId xmlns:a16="http://schemas.microsoft.com/office/drawing/2014/main" id="{A5E32635-9303-4986-86C2-2B5DAECF86D2}"/>
+                <a16:creationId xmlns:a16="http://schemas.microsoft.com/office/drawing/2014/main" id="{04029EB4-0DA1-482A-BD4D-B30E39531B79}"/>
               </a:ext>
             </a:extLst>
           </p:cNvPr>
@@ -5391,7 +4926,7 @@
           <p:cNvPr id="17" name="">
             <a:extLst xmlns:a="http://schemas.openxmlformats.org/drawingml/2006/main">
               <a:ext uri="{FF2B5EF4-FFF2-40B4-BE49-F238E27FC236}">
-                <a16:creationId xmlns:a16="http://schemas.microsoft.com/office/drawing/2014/main" id="{51716239-5F09-4BC9-A5F0-A523B01B3262}"/>
+                <a16:creationId xmlns:a16="http://schemas.microsoft.com/office/drawing/2014/main" id="{E57633CC-9223-4010-8C56-1F184713CF3D}"/>
               </a:ext>
             </a:extLst>
           </p:cNvPr>
@@ -5424,7 +4959,7 @@
           <p:cNvPr id="18" name="">
             <a:extLst xmlns:a="http://schemas.openxmlformats.org/drawingml/2006/main">
               <a:ext uri="{FF2B5EF4-FFF2-40B4-BE49-F238E27FC236}">
-                <a16:creationId xmlns:a16="http://schemas.microsoft.com/office/drawing/2014/main" id="{324DD317-283F-4938-9B2E-0723B30D31FC}"/>
+                <a16:creationId xmlns:a16="http://schemas.microsoft.com/office/drawing/2014/main" id="{948EFF44-DE38-4660-B817-048D474D04D3}"/>
               </a:ext>
             </a:extLst>
           </p:cNvPr>
@@ -5482,7 +5017,7 @@
           <p:cNvPr id="19" name="">
             <a:extLst xmlns:a="http://schemas.openxmlformats.org/drawingml/2006/main">
               <a:ext uri="{FF2B5EF4-FFF2-40B4-BE49-F238E27FC236}">
-                <a16:creationId xmlns:a16="http://schemas.microsoft.com/office/drawing/2014/main" id="{A282BE7A-A421-418A-A9B5-820A54D8035F}"/>
+                <a16:creationId xmlns:a16="http://schemas.microsoft.com/office/drawing/2014/main" id="{D454F1B8-D7C8-4B0A-9CB5-AEC9B3C1A869}"/>
               </a:ext>
             </a:extLst>
           </p:cNvPr>
@@ -5557,7 +5092,7 @@
           <p:cNvPr id="20" name="">
             <a:extLst xmlns:a="http://schemas.openxmlformats.org/drawingml/2006/main">
               <a:ext uri="{FF2B5EF4-FFF2-40B4-BE49-F238E27FC236}">
-                <a16:creationId xmlns:a16="http://schemas.microsoft.com/office/drawing/2014/main" id="{A37378D5-D3E7-4EBC-BFD0-BBB985148D68}"/>
+                <a16:creationId xmlns:a16="http://schemas.microsoft.com/office/drawing/2014/main" id="{24051140-F03F-487F-BC86-85DDC2A0FA0C}"/>
               </a:ext>
             </a:extLst>
           </p:cNvPr>
@@ -5590,7 +5125,7 @@
           <p:cNvPr id="21" name="">
             <a:extLst xmlns:a="http://schemas.openxmlformats.org/drawingml/2006/main">
               <a:ext uri="{FF2B5EF4-FFF2-40B4-BE49-F238E27FC236}">
-                <a16:creationId xmlns:a16="http://schemas.microsoft.com/office/drawing/2014/main" id="{22B3AFA4-AA4F-4A6D-B210-19E851734C9F}"/>
+                <a16:creationId xmlns:a16="http://schemas.microsoft.com/office/drawing/2014/main" id="{152003F6-9C53-48FF-ACBD-64F01FACB40C}"/>
               </a:ext>
             </a:extLst>
           </p:cNvPr>
@@ -5623,7 +5158,7 @@
           <p:cNvPr id="22" name="">
             <a:extLst xmlns:a="http://schemas.openxmlformats.org/drawingml/2006/main">
               <a:ext uri="{FF2B5EF4-FFF2-40B4-BE49-F238E27FC236}">
-                <a16:creationId xmlns:a16="http://schemas.microsoft.com/office/drawing/2014/main" id="{F4990836-51E9-4162-9F51-C71383D2B31A}"/>
+                <a16:creationId xmlns:a16="http://schemas.microsoft.com/office/drawing/2014/main" id="{876AA3E1-B74A-41D0-A190-C635BCA7E8DA}"/>
               </a:ext>
             </a:extLst>
           </p:cNvPr>
@@ -5656,7 +5191,7 @@
           <p:cNvPr id="23" name="">
             <a:extLst xmlns:a="http://schemas.openxmlformats.org/drawingml/2006/main">
               <a:ext uri="{FF2B5EF4-FFF2-40B4-BE49-F238E27FC236}">
-                <a16:creationId xmlns:a16="http://schemas.microsoft.com/office/drawing/2014/main" id="{8F480D15-A70C-482B-8A8D-8AD6BB45EBC5}"/>
+                <a16:creationId xmlns:a16="http://schemas.microsoft.com/office/drawing/2014/main" id="{1035DBDB-1E3E-418B-A156-2FF21D7EE68C}"/>
               </a:ext>
             </a:extLst>
           </p:cNvPr>
@@ -5689,7 +5224,7 @@
           <p:cNvPr id="24" name="">
             <a:extLst xmlns:a="http://schemas.openxmlformats.org/drawingml/2006/main">
               <a:ext uri="{FF2B5EF4-FFF2-40B4-BE49-F238E27FC236}">
-                <a16:creationId xmlns:a16="http://schemas.microsoft.com/office/drawing/2014/main" id="{45131D52-F744-472D-97B9-5C6B033D5BEE}"/>
+                <a16:creationId xmlns:a16="http://schemas.microsoft.com/office/drawing/2014/main" id="{6F9911DF-FC9F-483C-AA34-69494E5B1E3B}"/>
               </a:ext>
             </a:extLst>
           </p:cNvPr>
@@ -5747,7 +5282,7 @@
           <p:cNvPr id="25" name="">
             <a:extLst xmlns:a="http://schemas.openxmlformats.org/drawingml/2006/main">
               <a:ext uri="{FF2B5EF4-FFF2-40B4-BE49-F238E27FC236}">
-                <a16:creationId xmlns:a16="http://schemas.microsoft.com/office/drawing/2014/main" id="{35C8B35E-3373-4861-8EF5-DC67790BA42C}"/>
+                <a16:creationId xmlns:a16="http://schemas.microsoft.com/office/drawing/2014/main" id="{C3F3503F-3B8D-409B-B211-9C20C9C5A7FD}"/>
               </a:ext>
             </a:extLst>
           </p:cNvPr>
@@ -5805,7 +5340,7 @@
           <p:cNvPr id="26" name="">
             <a:extLst xmlns:a="http://schemas.openxmlformats.org/drawingml/2006/main">
               <a:ext uri="{FF2B5EF4-FFF2-40B4-BE49-F238E27FC236}">
-                <a16:creationId xmlns:a16="http://schemas.microsoft.com/office/drawing/2014/main" id="{AA9ACF56-0C0B-41F7-8659-C4578E004CD0}"/>
+                <a16:creationId xmlns:a16="http://schemas.microsoft.com/office/drawing/2014/main" id="{25ACB655-A3D0-43B9-A602-E81A2E78359D}"/>
               </a:ext>
             </a:extLst>
           </p:cNvPr>
@@ -5838,7 +5373,7 @@
           <p:cNvPr id="27" name="">
             <a:extLst xmlns:a="http://schemas.openxmlformats.org/drawingml/2006/main">
               <a:ext uri="{FF2B5EF4-FFF2-40B4-BE49-F238E27FC236}">
-                <a16:creationId xmlns:a16="http://schemas.microsoft.com/office/drawing/2014/main" id="{6E7AFEDA-B236-4FCD-9753-5947DDE6F813}"/>
+                <a16:creationId xmlns:a16="http://schemas.microsoft.com/office/drawing/2014/main" id="{9C04E4AC-EB94-4542-9264-7F9DE32D0CAA}"/>
               </a:ext>
             </a:extLst>
           </p:cNvPr>
@@ -5896,7 +5431,7 @@
           <p:cNvPr id="28" name="">
             <a:extLst xmlns:a="http://schemas.openxmlformats.org/drawingml/2006/main">
               <a:ext uri="{FF2B5EF4-FFF2-40B4-BE49-F238E27FC236}">
-                <a16:creationId xmlns:a16="http://schemas.microsoft.com/office/drawing/2014/main" id="{C327ECF8-8B86-4025-801C-343FA2A548B0}"/>
+                <a16:creationId xmlns:a16="http://schemas.microsoft.com/office/drawing/2014/main" id="{4748CEB2-D70E-4E88-9101-05622D1C3438}"/>
               </a:ext>
             </a:extLst>
           </p:cNvPr>
@@ -5954,7 +5489,7 @@
           <p:cNvPr id="29" name="">
             <a:extLst xmlns:a="http://schemas.openxmlformats.org/drawingml/2006/main">
               <a:ext uri="{FF2B5EF4-FFF2-40B4-BE49-F238E27FC236}">
-                <a16:creationId xmlns:a16="http://schemas.microsoft.com/office/drawing/2014/main" id="{785F1CEB-2B31-47B0-B887-848D97DCE2F9}"/>
+                <a16:creationId xmlns:a16="http://schemas.microsoft.com/office/drawing/2014/main" id="{F9F7079D-6465-42E0-B420-82E4A802FFFF}"/>
               </a:ext>
             </a:extLst>
           </p:cNvPr>
@@ -5987,7 +5522,7 @@
           <p:cNvPr id="30" name="">
             <a:extLst xmlns:a="http://schemas.openxmlformats.org/drawingml/2006/main">
               <a:ext uri="{FF2B5EF4-FFF2-40B4-BE49-F238E27FC236}">
-                <a16:creationId xmlns:a16="http://schemas.microsoft.com/office/drawing/2014/main" id="{70022228-0210-49E6-ACE3-025E5702E3BE}"/>
+                <a16:creationId xmlns:a16="http://schemas.microsoft.com/office/drawing/2014/main" id="{BC7D8DA9-0FBA-4EC5-9DCA-403315D7D75D}"/>
               </a:ext>
             </a:extLst>
           </p:cNvPr>
@@ -6045,7 +5580,7 @@
           <p:cNvPr id="31" name="">
             <a:extLst xmlns:a="http://schemas.openxmlformats.org/drawingml/2006/main">
               <a:ext uri="{FF2B5EF4-FFF2-40B4-BE49-F238E27FC236}">
-                <a16:creationId xmlns:a16="http://schemas.microsoft.com/office/drawing/2014/main" id="{E21AA12A-3A77-44B0-9D72-44AB3DD30C35}"/>
+                <a16:creationId xmlns:a16="http://schemas.microsoft.com/office/drawing/2014/main" id="{7CF9AA41-344C-4BDA-B9F8-52CFB512639E}"/>
               </a:ext>
             </a:extLst>
           </p:cNvPr>
@@ -6101,7 +5636,7 @@
     </p:spTree>
     <p:extLst>
       <p:ext uri="{BB962C8B-B14F-4D97-AF65-F5344CB8AC3E}">
-        <p14:creationId xmlns:p14="http://schemas.microsoft.com/office/powerpoint/2010/main" val="1693334619"/>
+        <p14:creationId xmlns:p14="http://schemas.microsoft.com/office/powerpoint/2010/main" val="1432726483"/>
       </p:ext>
     </p:extLst>
   </p:cSld>
@@ -6132,7 +5667,7 @@
           <p:cNvPr id="18" name="">
             <a:extLst xmlns:a="http://schemas.openxmlformats.org/drawingml/2006/main">
               <a:ext uri="{FF2B5EF4-FFF2-40B4-BE49-F238E27FC236}">
-                <a16:creationId xmlns:a16="http://schemas.microsoft.com/office/drawing/2014/main" id="{43413504-5A6D-4CEF-BFF0-143C3709BC71}"/>
+                <a16:creationId xmlns:a16="http://schemas.microsoft.com/office/drawing/2014/main" id="{896B3332-B17B-49FC-AC9A-9F776E767B40}"/>
               </a:ext>
             </a:extLst>
           </p:cNvPr>
@@ -6190,7 +5725,7 @@
           <p:cNvPr id="2" name="">
             <a:extLst xmlns:a="http://schemas.openxmlformats.org/drawingml/2006/main">
               <a:ext uri="{FF2B5EF4-FFF2-40B4-BE49-F238E27FC236}">
-                <a16:creationId xmlns:a16="http://schemas.microsoft.com/office/drawing/2014/main" id="{3CA7CEEB-390F-4E9E-A907-AAC732E24263}"/>
+                <a16:creationId xmlns:a16="http://schemas.microsoft.com/office/drawing/2014/main" id="{F31270B8-8287-4A1A-AEA5-E1EB9E29544C}"/>
               </a:ext>
             </a:extLst>
           </p:cNvPr>
@@ -6248,7 +5783,7 @@
           <p:cNvPr id="3" name="">
             <a:extLst xmlns:a="http://schemas.openxmlformats.org/drawingml/2006/main">
               <a:ext uri="{FF2B5EF4-FFF2-40B4-BE49-F238E27FC236}">
-                <a16:creationId xmlns:a16="http://schemas.microsoft.com/office/drawing/2014/main" id="{6379CD82-CFED-493B-A267-82D449BE2BF4}"/>
+                <a16:creationId xmlns:a16="http://schemas.microsoft.com/office/drawing/2014/main" id="{91D42638-56DE-4448-B085-2EA525168492}"/>
               </a:ext>
             </a:extLst>
           </p:cNvPr>
@@ -6306,7 +5841,7 @@
           <p:cNvPr id="4" name="">
             <a:extLst xmlns:a="http://schemas.openxmlformats.org/drawingml/2006/main">
               <a:ext uri="{FF2B5EF4-FFF2-40B4-BE49-F238E27FC236}">
-                <a16:creationId xmlns:a16="http://schemas.microsoft.com/office/drawing/2014/main" id="{A252AA58-A848-4F33-9C62-99B1EA28D96F}"/>
+                <a16:creationId xmlns:a16="http://schemas.microsoft.com/office/drawing/2014/main" id="{D5A8ED01-99D0-4E41-B814-2D1E6CE1B927}"/>
               </a:ext>
             </a:extLst>
           </p:cNvPr>
@@ -6341,7 +5876,7 @@
           <p:cNvPr id="5" name="">
             <a:extLst xmlns:a="http://schemas.openxmlformats.org/drawingml/2006/main">
               <a:ext uri="{FF2B5EF4-FFF2-40B4-BE49-F238E27FC236}">
-                <a16:creationId xmlns:a16="http://schemas.microsoft.com/office/drawing/2014/main" id="{8BD3A480-4845-4F53-918A-9FE16E6C5B22}"/>
+                <a16:creationId xmlns:a16="http://schemas.microsoft.com/office/drawing/2014/main" id="{9EA16A64-D74F-4B1F-A16F-6C76166AFAAC}"/>
               </a:ext>
             </a:extLst>
           </p:cNvPr>
@@ -6399,7 +5934,7 @@
           <p:cNvPr id="6" name="">
             <a:extLst xmlns:a="http://schemas.openxmlformats.org/drawingml/2006/main">
               <a:ext uri="{FF2B5EF4-FFF2-40B4-BE49-F238E27FC236}">
-                <a16:creationId xmlns:a16="http://schemas.microsoft.com/office/drawing/2014/main" id="{05833FF9-7443-4AB2-A06D-B5DD63217331}"/>
+                <a16:creationId xmlns:a16="http://schemas.microsoft.com/office/drawing/2014/main" id="{FA1D4AD2-78F6-4B41-BB5E-340226CB16C7}"/>
               </a:ext>
             </a:extLst>
           </p:cNvPr>
@@ -6457,7 +5992,7 @@
           <p:cNvPr id="7" name="">
             <a:extLst xmlns:a="http://schemas.openxmlformats.org/drawingml/2006/main">
               <a:ext uri="{FF2B5EF4-FFF2-40B4-BE49-F238E27FC236}">
-                <a16:creationId xmlns:a16="http://schemas.microsoft.com/office/drawing/2014/main" id="{5C263545-9B60-4FC7-8439-6EC193AB9E49}"/>
+                <a16:creationId xmlns:a16="http://schemas.microsoft.com/office/drawing/2014/main" id="{2D368EA7-A1C3-41F9-9C22-7DEB7175E3FB}"/>
               </a:ext>
             </a:extLst>
           </p:cNvPr>
@@ -6515,7 +6050,7 @@
           <p:cNvPr id="8" name="">
             <a:extLst xmlns:a="http://schemas.openxmlformats.org/drawingml/2006/main">
               <a:ext uri="{FF2B5EF4-FFF2-40B4-BE49-F238E27FC236}">
-                <a16:creationId xmlns:a16="http://schemas.microsoft.com/office/drawing/2014/main" id="{0F3AAFE2-6265-49A3-B6E5-89D3C1993093}"/>
+                <a16:creationId xmlns:a16="http://schemas.microsoft.com/office/drawing/2014/main" id="{8C5BB91E-0343-4322-8085-AE8C549EB142}"/>
               </a:ext>
             </a:extLst>
           </p:cNvPr>
@@ -6573,7 +6108,7 @@
           <p:cNvPr id="9" name="">
             <a:extLst xmlns:a="http://schemas.openxmlformats.org/drawingml/2006/main">
               <a:ext uri="{FF2B5EF4-FFF2-40B4-BE49-F238E27FC236}">
-                <a16:creationId xmlns:a16="http://schemas.microsoft.com/office/drawing/2014/main" id="{02601C50-4D94-48C8-95B6-191A2DB23A69}"/>
+                <a16:creationId xmlns:a16="http://schemas.microsoft.com/office/drawing/2014/main" id="{AC9FC84A-DD18-4F67-92C5-456FEC6C5793}"/>
               </a:ext>
             </a:extLst>
           </p:cNvPr>
@@ -6608,7 +6143,7 @@
           <p:cNvPr id="10" name="">
             <a:extLst xmlns:a="http://schemas.openxmlformats.org/drawingml/2006/main">
               <a:ext uri="{FF2B5EF4-FFF2-40B4-BE49-F238E27FC236}">
-                <a16:creationId xmlns:a16="http://schemas.microsoft.com/office/drawing/2014/main" id="{CC3CE0B5-A26E-4647-A9EB-172D714D289F}"/>
+                <a16:creationId xmlns:a16="http://schemas.microsoft.com/office/drawing/2014/main" id="{DDBDA038-1324-4E43-93BD-9E075532603F}"/>
               </a:ext>
             </a:extLst>
           </p:cNvPr>
@@ -6666,7 +6201,7 @@
           <p:cNvPr id="11" name="">
             <a:extLst xmlns:a="http://schemas.openxmlformats.org/drawingml/2006/main">
               <a:ext uri="{FF2B5EF4-FFF2-40B4-BE49-F238E27FC236}">
-                <a16:creationId xmlns:a16="http://schemas.microsoft.com/office/drawing/2014/main" id="{DB92147C-ECC6-46C0-A5A9-DC0E2130C8C6}"/>
+                <a16:creationId xmlns:a16="http://schemas.microsoft.com/office/drawing/2014/main" id="{E10A4134-4C30-40E2-B3C6-220B1279F96F}"/>
               </a:ext>
             </a:extLst>
           </p:cNvPr>
@@ -6724,7 +6259,7 @@
           <p:cNvPr id="12" name="">
             <a:extLst xmlns:a="http://schemas.openxmlformats.org/drawingml/2006/main">
               <a:ext uri="{FF2B5EF4-FFF2-40B4-BE49-F238E27FC236}">
-                <a16:creationId xmlns:a16="http://schemas.microsoft.com/office/drawing/2014/main" id="{83762A31-5F34-49CD-BA68-29ADCA91D160}"/>
+                <a16:creationId xmlns:a16="http://schemas.microsoft.com/office/drawing/2014/main" id="{C92B4DD3-559D-4B61-905E-172AD6350DA6}"/>
               </a:ext>
             </a:extLst>
           </p:cNvPr>
@@ -6759,7 +6294,7 @@
           <p:cNvPr id="13" name="">
             <a:extLst xmlns:a="http://schemas.openxmlformats.org/drawingml/2006/main">
               <a:ext uri="{FF2B5EF4-FFF2-40B4-BE49-F238E27FC236}">
-                <a16:creationId xmlns:a16="http://schemas.microsoft.com/office/drawing/2014/main" id="{0D5CAF0D-8E58-42DB-80E3-35810B8A0DC7}"/>
+                <a16:creationId xmlns:a16="http://schemas.microsoft.com/office/drawing/2014/main" id="{12734032-65B4-41F6-9262-FB627C6C5ADC}"/>
               </a:ext>
             </a:extLst>
           </p:cNvPr>
@@ -6817,7 +6352,7 @@
           <p:cNvPr id="14" name="">
             <a:extLst xmlns:a="http://schemas.openxmlformats.org/drawingml/2006/main">
               <a:ext uri="{FF2B5EF4-FFF2-40B4-BE49-F238E27FC236}">
-                <a16:creationId xmlns:a16="http://schemas.microsoft.com/office/drawing/2014/main" id="{C4771786-25C6-4B7D-9728-D8687667B7A1}"/>
+                <a16:creationId xmlns:a16="http://schemas.microsoft.com/office/drawing/2014/main" id="{8635BDBC-E6AA-415F-889D-49140FA53BCE}"/>
               </a:ext>
             </a:extLst>
           </p:cNvPr>
@@ -6875,7 +6410,7 @@
           <p:cNvPr id="15" name="">
             <a:extLst xmlns:a="http://schemas.openxmlformats.org/drawingml/2006/main">
               <a:ext uri="{FF2B5EF4-FFF2-40B4-BE49-F238E27FC236}">
-                <a16:creationId xmlns:a16="http://schemas.microsoft.com/office/drawing/2014/main" id="{46711E56-97FE-4189-A8C1-F06CB5F50209}"/>
+                <a16:creationId xmlns:a16="http://schemas.microsoft.com/office/drawing/2014/main" id="{87FF37D1-E4BD-467F-B292-F7B9813C51E3}"/>
               </a:ext>
             </a:extLst>
           </p:cNvPr>
@@ -6908,7 +6443,7 @@
           <p:cNvPr id="16" name="">
             <a:extLst xmlns:a="http://schemas.openxmlformats.org/drawingml/2006/main">
               <a:ext uri="{FF2B5EF4-FFF2-40B4-BE49-F238E27FC236}">
-                <a16:creationId xmlns:a16="http://schemas.microsoft.com/office/drawing/2014/main" id="{6E0F2FE5-2A6B-444F-AD64-ED5FF197A172}"/>
+                <a16:creationId xmlns:a16="http://schemas.microsoft.com/office/drawing/2014/main" id="{ABB5E52E-89A0-43BE-916A-E70B4952CBBE}"/>
               </a:ext>
             </a:extLst>
           </p:cNvPr>
@@ -6954,7 +6489,7 @@
           <p:cNvPr id="17" name="">
             <a:extLst xmlns:a="http://schemas.openxmlformats.org/drawingml/2006/main">
               <a:ext uri="{FF2B5EF4-FFF2-40B4-BE49-F238E27FC236}">
-                <a16:creationId xmlns:a16="http://schemas.microsoft.com/office/drawing/2014/main" id="{245DC8BE-1644-41DE-B670-1D0FCA4524D5}"/>
+                <a16:creationId xmlns:a16="http://schemas.microsoft.com/office/drawing/2014/main" id="{20F2650C-B946-4B10-9D64-D0E624C8D2CB}"/>
               </a:ext>
             </a:extLst>
           </p:cNvPr>
@@ -7010,7 +6545,7 @@
     </p:spTree>
     <p:extLst>
       <p:ext uri="{BB962C8B-B14F-4D97-AF65-F5344CB8AC3E}">
-        <p14:creationId xmlns:p14="http://schemas.microsoft.com/office/powerpoint/2010/main" val="1837489316"/>
+        <p14:creationId xmlns:p14="http://schemas.microsoft.com/office/powerpoint/2010/main" val="430394888"/>
       </p:ext>
     </p:extLst>
   </p:cSld>
@@ -7041,7 +6576,7 @@
           <p:cNvPr id="28" name="">
             <a:extLst xmlns:a="http://schemas.openxmlformats.org/drawingml/2006/main">
               <a:ext uri="{FF2B5EF4-FFF2-40B4-BE49-F238E27FC236}">
-                <a16:creationId xmlns:a16="http://schemas.microsoft.com/office/drawing/2014/main" id="{93E75988-D409-4111-A166-6D1E78B1B423}"/>
+                <a16:creationId xmlns:a16="http://schemas.microsoft.com/office/drawing/2014/main" id="{1A448946-BCC8-4666-B9D9-7D8315E38F90}"/>
               </a:ext>
             </a:extLst>
           </p:cNvPr>
@@ -7099,7 +6634,7 @@
           <p:cNvPr id="2" name="">
             <a:extLst xmlns:a="http://schemas.openxmlformats.org/drawingml/2006/main">
               <a:ext uri="{FF2B5EF4-FFF2-40B4-BE49-F238E27FC236}">
-                <a16:creationId xmlns:a16="http://schemas.microsoft.com/office/drawing/2014/main" id="{318E1827-124A-4907-8EA8-812A6B980644}"/>
+                <a16:creationId xmlns:a16="http://schemas.microsoft.com/office/drawing/2014/main" id="{98CE6736-BD74-4283-832A-B9FACA49D910}"/>
               </a:ext>
             </a:extLst>
           </p:cNvPr>
@@ -7157,7 +6692,7 @@
           <p:cNvPr id="3" name="">
             <a:extLst xmlns:a="http://schemas.openxmlformats.org/drawingml/2006/main">
               <a:ext uri="{FF2B5EF4-FFF2-40B4-BE49-F238E27FC236}">
-                <a16:creationId xmlns:a16="http://schemas.microsoft.com/office/drawing/2014/main" id="{BD80F2D1-CEE6-4476-828A-0C9ECE7F6D9D}"/>
+                <a16:creationId xmlns:a16="http://schemas.microsoft.com/office/drawing/2014/main" id="{5321CD73-64C2-465F-9743-36929A9CC5F0}"/>
               </a:ext>
             </a:extLst>
           </p:cNvPr>
@@ -7215,7 +6750,7 @@
           <p:cNvPr id="4" name="">
             <a:extLst xmlns:a="http://schemas.openxmlformats.org/drawingml/2006/main">
               <a:ext uri="{FF2B5EF4-FFF2-40B4-BE49-F238E27FC236}">
-                <a16:creationId xmlns:a16="http://schemas.microsoft.com/office/drawing/2014/main" id="{A0E0F056-E979-48D7-A667-7FAF84CBB925}"/>
+                <a16:creationId xmlns:a16="http://schemas.microsoft.com/office/drawing/2014/main" id="{0B045977-B64F-4ABF-9727-37628458BE1C}"/>
               </a:ext>
             </a:extLst>
           </p:cNvPr>
@@ -7250,7 +6785,7 @@
           <p:cNvPr id="5" name="">
             <a:extLst xmlns:a="http://schemas.openxmlformats.org/drawingml/2006/main">
               <a:ext uri="{FF2B5EF4-FFF2-40B4-BE49-F238E27FC236}">
-                <a16:creationId xmlns:a16="http://schemas.microsoft.com/office/drawing/2014/main" id="{3593309A-9260-43C5-85D0-75779BD7E337}"/>
+                <a16:creationId xmlns:a16="http://schemas.microsoft.com/office/drawing/2014/main" id="{9376CD2A-28CE-4902-9920-C1CD3E39F619}"/>
               </a:ext>
             </a:extLst>
           </p:cNvPr>
@@ -7308,7 +6843,7 @@
           <p:cNvPr id="6" name="">
             <a:extLst xmlns:a="http://schemas.openxmlformats.org/drawingml/2006/main">
               <a:ext uri="{FF2B5EF4-FFF2-40B4-BE49-F238E27FC236}">
-                <a16:creationId xmlns:a16="http://schemas.microsoft.com/office/drawing/2014/main" id="{1628EACD-EF23-4E4C-A695-4A9A9952AB6A}"/>
+                <a16:creationId xmlns:a16="http://schemas.microsoft.com/office/drawing/2014/main" id="{2E212B84-15E5-4F23-B1D2-BE80E23FB1E7}"/>
               </a:ext>
             </a:extLst>
           </p:cNvPr>
@@ -7366,7 +6901,7 @@
           <p:cNvPr id="7" name="">
             <a:extLst xmlns:a="http://schemas.openxmlformats.org/drawingml/2006/main">
               <a:ext uri="{FF2B5EF4-FFF2-40B4-BE49-F238E27FC236}">
-                <a16:creationId xmlns:a16="http://schemas.microsoft.com/office/drawing/2014/main" id="{EB324590-5C99-467A-9561-4FF777F66730}"/>
+                <a16:creationId xmlns:a16="http://schemas.microsoft.com/office/drawing/2014/main" id="{43356B81-048C-4F0A-BFDC-186FA107DE23}"/>
               </a:ext>
             </a:extLst>
           </p:cNvPr>
@@ -7424,7 +6959,7 @@
           <p:cNvPr id="8" name="">
             <a:extLst xmlns:a="http://schemas.openxmlformats.org/drawingml/2006/main">
               <a:ext uri="{FF2B5EF4-FFF2-40B4-BE49-F238E27FC236}">
-                <a16:creationId xmlns:a16="http://schemas.microsoft.com/office/drawing/2014/main" id="{3EBA38FB-1C08-45D5-9CDE-B39C81DD620A}"/>
+                <a16:creationId xmlns:a16="http://schemas.microsoft.com/office/drawing/2014/main" id="{10BA27C5-3121-441A-B181-01BD811092DA}"/>
               </a:ext>
             </a:extLst>
           </p:cNvPr>
@@ -7482,7 +7017,7 @@
           <p:cNvPr id="9" name="">
             <a:extLst xmlns:a="http://schemas.openxmlformats.org/drawingml/2006/main">
               <a:ext uri="{FF2B5EF4-FFF2-40B4-BE49-F238E27FC236}">
-                <a16:creationId xmlns:a16="http://schemas.microsoft.com/office/drawing/2014/main" id="{6803498E-993C-4B31-B0FD-75D00DF14B98}"/>
+                <a16:creationId xmlns:a16="http://schemas.microsoft.com/office/drawing/2014/main" id="{F56E15B3-FA4A-4325-8EA9-F95EA792D892}"/>
               </a:ext>
             </a:extLst>
           </p:cNvPr>
@@ -7540,7 +7075,7 @@
           <p:cNvPr id="10" name="">
             <a:extLst xmlns:a="http://schemas.openxmlformats.org/drawingml/2006/main">
               <a:ext uri="{FF2B5EF4-FFF2-40B4-BE49-F238E27FC236}">
-                <a16:creationId xmlns:a16="http://schemas.microsoft.com/office/drawing/2014/main" id="{45A474E9-F0F9-49FE-BBDD-FCEDEA27E1AE}"/>
+                <a16:creationId xmlns:a16="http://schemas.microsoft.com/office/drawing/2014/main" id="{EAF5D9AA-9F12-4945-9A8F-543806D2D0A1}"/>
               </a:ext>
             </a:extLst>
           </p:cNvPr>
@@ -7575,7 +7110,7 @@
           <p:cNvPr id="11" name="">
             <a:extLst xmlns:a="http://schemas.openxmlformats.org/drawingml/2006/main">
               <a:ext uri="{FF2B5EF4-FFF2-40B4-BE49-F238E27FC236}">
-                <a16:creationId xmlns:a16="http://schemas.microsoft.com/office/drawing/2014/main" id="{568EC064-9649-4323-9D7D-5498651FDD2A}"/>
+                <a16:creationId xmlns:a16="http://schemas.microsoft.com/office/drawing/2014/main" id="{E2C875C8-7909-40A9-8DEB-5D2FE89A1093}"/>
               </a:ext>
             </a:extLst>
           </p:cNvPr>
@@ -7633,7 +7168,7 @@
           <p:cNvPr id="12" name="">
             <a:extLst xmlns:a="http://schemas.openxmlformats.org/drawingml/2006/main">
               <a:ext uri="{FF2B5EF4-FFF2-40B4-BE49-F238E27FC236}">
-                <a16:creationId xmlns:a16="http://schemas.microsoft.com/office/drawing/2014/main" id="{F5D4912D-56FA-4718-8D8C-DAC4C684BC77}"/>
+                <a16:creationId xmlns:a16="http://schemas.microsoft.com/office/drawing/2014/main" id="{FB445629-C9A1-4D27-B518-B3A1D94CC15B}"/>
               </a:ext>
             </a:extLst>
           </p:cNvPr>
@@ -7668,7 +7203,7 @@
           <p:cNvPr id="13" name="">
             <a:extLst xmlns:a="http://schemas.openxmlformats.org/drawingml/2006/main">
               <a:ext uri="{FF2B5EF4-FFF2-40B4-BE49-F238E27FC236}">
-                <a16:creationId xmlns:a16="http://schemas.microsoft.com/office/drawing/2014/main" id="{B390C76F-B2EB-4DA3-95C1-0866D7E28798}"/>
+                <a16:creationId xmlns:a16="http://schemas.microsoft.com/office/drawing/2014/main" id="{DD464B2D-9D05-47B2-8B64-D4B1ADADB3B6}"/>
               </a:ext>
             </a:extLst>
           </p:cNvPr>
@@ -7701,7 +7236,7 @@
           <p:cNvPr id="14" name="">
             <a:extLst xmlns:a="http://schemas.openxmlformats.org/drawingml/2006/main">
               <a:ext uri="{FF2B5EF4-FFF2-40B4-BE49-F238E27FC236}">
-                <a16:creationId xmlns:a16="http://schemas.microsoft.com/office/drawing/2014/main" id="{77812BD2-2A3E-4582-94BF-B0EE55A931CC}"/>
+                <a16:creationId xmlns:a16="http://schemas.microsoft.com/office/drawing/2014/main" id="{A3F5F20E-5EA9-407B-8638-349BE57B3D83}"/>
               </a:ext>
             </a:extLst>
           </p:cNvPr>
@@ -7759,7 +7294,7 @@
           <p:cNvPr id="15" name="">
             <a:extLst xmlns:a="http://schemas.openxmlformats.org/drawingml/2006/main">
               <a:ext uri="{FF2B5EF4-FFF2-40B4-BE49-F238E27FC236}">
-                <a16:creationId xmlns:a16="http://schemas.microsoft.com/office/drawing/2014/main" id="{64580EDD-0A4B-41C6-ABBE-39BE6C6798AB}"/>
+                <a16:creationId xmlns:a16="http://schemas.microsoft.com/office/drawing/2014/main" id="{44F8F318-EAEE-4FA3-8B98-9730C4A1DF74}"/>
               </a:ext>
             </a:extLst>
           </p:cNvPr>
@@ -7834,7 +7369,7 @@
           <p:cNvPr id="16" name="">
             <a:extLst xmlns:a="http://schemas.openxmlformats.org/drawingml/2006/main">
               <a:ext uri="{FF2B5EF4-FFF2-40B4-BE49-F238E27FC236}">
-                <a16:creationId xmlns:a16="http://schemas.microsoft.com/office/drawing/2014/main" id="{AD25E7F5-10D0-4161-80F4-466AA4F77B09}"/>
+                <a16:creationId xmlns:a16="http://schemas.microsoft.com/office/drawing/2014/main" id="{84509294-AE41-4591-8FD5-BF592DA4A102}"/>
               </a:ext>
             </a:extLst>
           </p:cNvPr>
@@ -7869,7 +7404,7 @@
           <p:cNvPr id="17" name="">
             <a:extLst xmlns:a="http://schemas.openxmlformats.org/drawingml/2006/main">
               <a:ext uri="{FF2B5EF4-FFF2-40B4-BE49-F238E27FC236}">
-                <a16:creationId xmlns:a16="http://schemas.microsoft.com/office/drawing/2014/main" id="{632E7988-D19D-45F2-A63D-33B3A6CB6F23}"/>
+                <a16:creationId xmlns:a16="http://schemas.microsoft.com/office/drawing/2014/main" id="{1D1AB443-AC42-4484-8E33-DC53C142E9FB}"/>
               </a:ext>
             </a:extLst>
           </p:cNvPr>
@@ -7902,7 +7437,7 @@
           <p:cNvPr id="18" name="">
             <a:extLst xmlns:a="http://schemas.openxmlformats.org/drawingml/2006/main">
               <a:ext uri="{FF2B5EF4-FFF2-40B4-BE49-F238E27FC236}">
-                <a16:creationId xmlns:a16="http://schemas.microsoft.com/office/drawing/2014/main" id="{997C9F0B-7CED-40AA-8861-A6F533C83C9A}"/>
+                <a16:creationId xmlns:a16="http://schemas.microsoft.com/office/drawing/2014/main" id="{A0C13585-00E7-4EB1-90E6-29D8BAEE99AC}"/>
               </a:ext>
             </a:extLst>
           </p:cNvPr>
@@ -7960,7 +7495,7 @@
           <p:cNvPr id="19" name="">
             <a:extLst xmlns:a="http://schemas.openxmlformats.org/drawingml/2006/main">
               <a:ext uri="{FF2B5EF4-FFF2-40B4-BE49-F238E27FC236}">
-                <a16:creationId xmlns:a16="http://schemas.microsoft.com/office/drawing/2014/main" id="{C1BA99A2-E31A-4218-A563-CC0741E54CE3}"/>
+                <a16:creationId xmlns:a16="http://schemas.microsoft.com/office/drawing/2014/main" id="{14EB870D-ED27-4A16-AC9F-E7857736CC55}"/>
               </a:ext>
             </a:extLst>
           </p:cNvPr>
@@ -8035,7 +7570,7 @@
           <p:cNvPr id="20" name="">
             <a:extLst xmlns:a="http://schemas.openxmlformats.org/drawingml/2006/main">
               <a:ext uri="{FF2B5EF4-FFF2-40B4-BE49-F238E27FC236}">
-                <a16:creationId xmlns:a16="http://schemas.microsoft.com/office/drawing/2014/main" id="{3D341A9C-C691-4133-AD21-C62ADAF8EE82}"/>
+                <a16:creationId xmlns:a16="http://schemas.microsoft.com/office/drawing/2014/main" id="{718C8C2C-0E02-4E0E-AC03-907AC2CCC297}"/>
               </a:ext>
             </a:extLst>
           </p:cNvPr>
@@ -8068,7 +7603,7 @@
           <p:cNvPr id="21" name="">
             <a:extLst xmlns:a="http://schemas.openxmlformats.org/drawingml/2006/main">
               <a:ext uri="{FF2B5EF4-FFF2-40B4-BE49-F238E27FC236}">
-                <a16:creationId xmlns:a16="http://schemas.microsoft.com/office/drawing/2014/main" id="{C88177A5-BBF7-4FFB-AD58-6AB05BC13790}"/>
+                <a16:creationId xmlns:a16="http://schemas.microsoft.com/office/drawing/2014/main" id="{F4DBF89A-9D68-4FDA-8C99-033F980D2C69}"/>
               </a:ext>
             </a:extLst>
           </p:cNvPr>
@@ -8101,7 +7636,7 @@
           <p:cNvPr id="22" name="">
             <a:extLst xmlns:a="http://schemas.openxmlformats.org/drawingml/2006/main">
               <a:ext uri="{FF2B5EF4-FFF2-40B4-BE49-F238E27FC236}">
-                <a16:creationId xmlns:a16="http://schemas.microsoft.com/office/drawing/2014/main" id="{30B77732-4390-4740-9B3B-5823A7254452}"/>
+                <a16:creationId xmlns:a16="http://schemas.microsoft.com/office/drawing/2014/main" id="{D20D5732-4848-4BBD-9EBA-DAC6738BE7BE}"/>
               </a:ext>
             </a:extLst>
           </p:cNvPr>
@@ -8159,7 +7694,7 @@
           <p:cNvPr id="23" name="">
             <a:extLst xmlns:a="http://schemas.openxmlformats.org/drawingml/2006/main">
               <a:ext uri="{FF2B5EF4-FFF2-40B4-BE49-F238E27FC236}">
-                <a16:creationId xmlns:a16="http://schemas.microsoft.com/office/drawing/2014/main" id="{32D5A7F0-F6D9-4164-9C2D-14663419A68D}"/>
+                <a16:creationId xmlns:a16="http://schemas.microsoft.com/office/drawing/2014/main" id="{A2F4D5F7-1D29-4890-9E2E-EB9C443143DA}"/>
               </a:ext>
             </a:extLst>
           </p:cNvPr>
@@ -8192,7 +7727,7 @@
           <p:cNvPr id="24" name="">
             <a:extLst xmlns:a="http://schemas.openxmlformats.org/drawingml/2006/main">
               <a:ext uri="{FF2B5EF4-FFF2-40B4-BE49-F238E27FC236}">
-                <a16:creationId xmlns:a16="http://schemas.microsoft.com/office/drawing/2014/main" id="{262D0CAC-9653-4593-BDD4-F680D310FAE1}"/>
+                <a16:creationId xmlns:a16="http://schemas.microsoft.com/office/drawing/2014/main" id="{BA3FFDB8-EA67-4BDF-AAE7-F3F9CE296305}"/>
               </a:ext>
             </a:extLst>
           </p:cNvPr>
@@ -8250,7 +7785,7 @@
           <p:cNvPr id="25" name="">
             <a:extLst xmlns:a="http://schemas.openxmlformats.org/drawingml/2006/main">
               <a:ext uri="{FF2B5EF4-FFF2-40B4-BE49-F238E27FC236}">
-                <a16:creationId xmlns:a16="http://schemas.microsoft.com/office/drawing/2014/main" id="{0F7A5B4C-686B-47A6-A28E-F9B51AF04A85}"/>
+                <a16:creationId xmlns:a16="http://schemas.microsoft.com/office/drawing/2014/main" id="{3C535692-872B-4050-9C06-97AD35377720}"/>
               </a:ext>
             </a:extLst>
           </p:cNvPr>
@@ -8283,7 +7818,7 @@
           <p:cNvPr id="26" name="">
             <a:extLst xmlns:a="http://schemas.openxmlformats.org/drawingml/2006/main">
               <a:ext uri="{FF2B5EF4-FFF2-40B4-BE49-F238E27FC236}">
-                <a16:creationId xmlns:a16="http://schemas.microsoft.com/office/drawing/2014/main" id="{E22E5EB3-8C99-483A-810D-D1D6F45B6BA2}"/>
+                <a16:creationId xmlns:a16="http://schemas.microsoft.com/office/drawing/2014/main" id="{15E9CF97-0D7D-4CFE-9B2A-1C5EFDD1A907}"/>
               </a:ext>
             </a:extLst>
           </p:cNvPr>
@@ -8341,7 +7876,7 @@
           <p:cNvPr id="27" name="">
             <a:extLst xmlns:a="http://schemas.openxmlformats.org/drawingml/2006/main">
               <a:ext uri="{FF2B5EF4-FFF2-40B4-BE49-F238E27FC236}">
-                <a16:creationId xmlns:a16="http://schemas.microsoft.com/office/drawing/2014/main" id="{96BA1115-EA1D-4B81-BFDC-7408B07DFE02}"/>
+                <a16:creationId xmlns:a16="http://schemas.microsoft.com/office/drawing/2014/main" id="{87DA47CC-BF39-407A-BF65-9F615EF7BB5C}"/>
               </a:ext>
             </a:extLst>
           </p:cNvPr>
@@ -8397,7 +7932,7 @@
     </p:spTree>
     <p:extLst>
       <p:ext uri="{BB962C8B-B14F-4D97-AF65-F5344CB8AC3E}">
-        <p14:creationId xmlns:p14="http://schemas.microsoft.com/office/powerpoint/2010/main" val="59926897"/>
+        <p14:creationId xmlns:p14="http://schemas.microsoft.com/office/powerpoint/2010/main" val="895042410"/>
       </p:ext>
     </p:extLst>
   </p:cSld>
@@ -8428,7 +7963,7 @@
           <p:cNvPr id="30" name="">
             <a:extLst xmlns:a="http://schemas.openxmlformats.org/drawingml/2006/main">
               <a:ext uri="{FF2B5EF4-FFF2-40B4-BE49-F238E27FC236}">
-                <a16:creationId xmlns:a16="http://schemas.microsoft.com/office/drawing/2014/main" id="{1F3F4361-A4FB-4D5F-833A-1C1C2494A700}"/>
+                <a16:creationId xmlns:a16="http://schemas.microsoft.com/office/drawing/2014/main" id="{B361C4D4-FFD2-4739-8A7D-538D1B4523B0}"/>
               </a:ext>
             </a:extLst>
           </p:cNvPr>
@@ -8486,7 +8021,7 @@
           <p:cNvPr id="2" name="">
             <a:extLst xmlns:a="http://schemas.openxmlformats.org/drawingml/2006/main">
               <a:ext uri="{FF2B5EF4-FFF2-40B4-BE49-F238E27FC236}">
-                <a16:creationId xmlns:a16="http://schemas.microsoft.com/office/drawing/2014/main" id="{ADAC4CCB-B3B3-4D1B-8426-70C7A7C2A7A2}"/>
+                <a16:creationId xmlns:a16="http://schemas.microsoft.com/office/drawing/2014/main" id="{48BD2D03-B397-480E-866E-DC12E4E60B57}"/>
               </a:ext>
             </a:extLst>
           </p:cNvPr>
@@ -8544,7 +8079,7 @@
           <p:cNvPr id="3" name="">
             <a:extLst xmlns:a="http://schemas.openxmlformats.org/drawingml/2006/main">
               <a:ext uri="{FF2B5EF4-FFF2-40B4-BE49-F238E27FC236}">
-                <a16:creationId xmlns:a16="http://schemas.microsoft.com/office/drawing/2014/main" id="{080C66B7-454B-4058-A080-057F5B987419}"/>
+                <a16:creationId xmlns:a16="http://schemas.microsoft.com/office/drawing/2014/main" id="{7BA34C5E-501B-4870-87E1-573602FB359B}"/>
               </a:ext>
             </a:extLst>
           </p:cNvPr>
@@ -8602,7 +8137,7 @@
           <p:cNvPr id="4" name="">
             <a:extLst xmlns:a="http://schemas.openxmlformats.org/drawingml/2006/main">
               <a:ext uri="{FF2B5EF4-FFF2-40B4-BE49-F238E27FC236}">
-                <a16:creationId xmlns:a16="http://schemas.microsoft.com/office/drawing/2014/main" id="{DD5FE839-8387-4E54-8733-200671EC4DCA}"/>
+                <a16:creationId xmlns:a16="http://schemas.microsoft.com/office/drawing/2014/main" id="{167378D5-C092-4960-BE39-DB3022798B1B}"/>
               </a:ext>
             </a:extLst>
           </p:cNvPr>
@@ -8637,7 +8172,7 @@
           <p:cNvPr id="5" name="">
             <a:extLst xmlns:a="http://schemas.openxmlformats.org/drawingml/2006/main">
               <a:ext uri="{FF2B5EF4-FFF2-40B4-BE49-F238E27FC236}">
-                <a16:creationId xmlns:a16="http://schemas.microsoft.com/office/drawing/2014/main" id="{EFE9CF08-9D1B-4F07-9C72-F4AD939B1637}"/>
+                <a16:creationId xmlns:a16="http://schemas.microsoft.com/office/drawing/2014/main" id="{09D1BE7D-9C35-4EF2-8684-96ECCAA7B424}"/>
               </a:ext>
             </a:extLst>
           </p:cNvPr>
@@ -8670,7 +8205,7 @@
           <p:cNvPr id="6" name="">
             <a:extLst xmlns:a="http://schemas.openxmlformats.org/drawingml/2006/main">
               <a:ext uri="{FF2B5EF4-FFF2-40B4-BE49-F238E27FC236}">
-                <a16:creationId xmlns:a16="http://schemas.microsoft.com/office/drawing/2014/main" id="{D57BA434-0F0C-42A6-91A8-98385CBAB42F}"/>
+                <a16:creationId xmlns:a16="http://schemas.microsoft.com/office/drawing/2014/main" id="{61B27D34-4CB1-4D73-9F5F-E5F1A4E3DBE2}"/>
               </a:ext>
             </a:extLst>
           </p:cNvPr>
@@ -8728,7 +8263,7 @@
           <p:cNvPr id="7" name="">
             <a:extLst xmlns:a="http://schemas.openxmlformats.org/drawingml/2006/main">
               <a:ext uri="{FF2B5EF4-FFF2-40B4-BE49-F238E27FC236}">
-                <a16:creationId xmlns:a16="http://schemas.microsoft.com/office/drawing/2014/main" id="{AF2D811A-D6BC-409C-8D01-81C73CF6E10A}"/>
+                <a16:creationId xmlns:a16="http://schemas.microsoft.com/office/drawing/2014/main" id="{AB09B2C6-6250-452D-B97C-1605ECB6E9EB}"/>
               </a:ext>
             </a:extLst>
           </p:cNvPr>
@@ -8786,7 +8321,7 @@
           <p:cNvPr id="8" name="">
             <a:extLst xmlns:a="http://schemas.openxmlformats.org/drawingml/2006/main">
               <a:ext uri="{FF2B5EF4-FFF2-40B4-BE49-F238E27FC236}">
-                <a16:creationId xmlns:a16="http://schemas.microsoft.com/office/drawing/2014/main" id="{0B23932B-7021-4E6F-999C-ABEBB6950115}"/>
+                <a16:creationId xmlns:a16="http://schemas.microsoft.com/office/drawing/2014/main" id="{3E3EC278-4504-4D17-9EA0-623967FC6786}"/>
               </a:ext>
             </a:extLst>
           </p:cNvPr>
@@ -8861,7 +8396,7 @@
           <p:cNvPr id="9" name="">
             <a:extLst xmlns:a="http://schemas.openxmlformats.org/drawingml/2006/main">
               <a:ext uri="{FF2B5EF4-FFF2-40B4-BE49-F238E27FC236}">
-                <a16:creationId xmlns:a16="http://schemas.microsoft.com/office/drawing/2014/main" id="{C45B006E-8A3F-42F0-BE1A-B069471B6D33}"/>
+                <a16:creationId xmlns:a16="http://schemas.microsoft.com/office/drawing/2014/main" id="{0BE8705F-1E28-40B1-A2A3-0C1AAB97F7B3}"/>
               </a:ext>
             </a:extLst>
           </p:cNvPr>
@@ -8896,7 +8431,7 @@
           <p:cNvPr id="10" name="">
             <a:extLst xmlns:a="http://schemas.openxmlformats.org/drawingml/2006/main">
               <a:ext uri="{FF2B5EF4-FFF2-40B4-BE49-F238E27FC236}">
-                <a16:creationId xmlns:a16="http://schemas.microsoft.com/office/drawing/2014/main" id="{61F22C64-F729-4D15-8E4C-AFA4F401A00D}"/>
+                <a16:creationId xmlns:a16="http://schemas.microsoft.com/office/drawing/2014/main" id="{FF188EF4-DF8C-4ACC-8A61-70E75AA7824B}"/>
               </a:ext>
             </a:extLst>
           </p:cNvPr>
@@ -8929,7 +8464,7 @@
           <p:cNvPr id="11" name="">
             <a:extLst xmlns:a="http://schemas.openxmlformats.org/drawingml/2006/main">
               <a:ext uri="{FF2B5EF4-FFF2-40B4-BE49-F238E27FC236}">
-                <a16:creationId xmlns:a16="http://schemas.microsoft.com/office/drawing/2014/main" id="{9B82218D-2B59-45F2-AEF7-3B5CCCC6F69D}"/>
+                <a16:creationId xmlns:a16="http://schemas.microsoft.com/office/drawing/2014/main" id="{F247EC0B-2B1F-4B74-A2C4-B91CC9B904FD}"/>
               </a:ext>
             </a:extLst>
           </p:cNvPr>
@@ -8987,7 +8522,7 @@
           <p:cNvPr id="12" name="">
             <a:extLst xmlns:a="http://schemas.openxmlformats.org/drawingml/2006/main">
               <a:ext uri="{FF2B5EF4-FFF2-40B4-BE49-F238E27FC236}">
-                <a16:creationId xmlns:a16="http://schemas.microsoft.com/office/drawing/2014/main" id="{017CA745-670E-4EC0-A845-412BEA8643F3}"/>
+                <a16:creationId xmlns:a16="http://schemas.microsoft.com/office/drawing/2014/main" id="{D44A58E1-341D-403B-BADA-30B27A83792F}"/>
               </a:ext>
             </a:extLst>
           </p:cNvPr>
@@ -9045,7 +8580,7 @@
           <p:cNvPr id="13" name="">
             <a:extLst xmlns:a="http://schemas.openxmlformats.org/drawingml/2006/main">
               <a:ext uri="{FF2B5EF4-FFF2-40B4-BE49-F238E27FC236}">
-                <a16:creationId xmlns:a16="http://schemas.microsoft.com/office/drawing/2014/main" id="{16AF2179-19A0-4418-8DBC-6A994D96FBE2}"/>
+                <a16:creationId xmlns:a16="http://schemas.microsoft.com/office/drawing/2014/main" id="{0BA16D3C-8692-4184-A474-E7ED98B71C76}"/>
               </a:ext>
             </a:extLst>
           </p:cNvPr>
@@ -9120,7 +8655,7 @@
           <p:cNvPr id="14" name="">
             <a:extLst xmlns:a="http://schemas.openxmlformats.org/drawingml/2006/main">
               <a:ext uri="{FF2B5EF4-FFF2-40B4-BE49-F238E27FC236}">
-                <a16:creationId xmlns:a16="http://schemas.microsoft.com/office/drawing/2014/main" id="{4FE5E970-69F4-4768-B02E-EF9213003947}"/>
+                <a16:creationId xmlns:a16="http://schemas.microsoft.com/office/drawing/2014/main" id="{71100541-1893-40D0-BD33-AD9559FA225A}"/>
               </a:ext>
             </a:extLst>
           </p:cNvPr>
@@ -9155,7 +8690,7 @@
           <p:cNvPr id="15" name="">
             <a:extLst xmlns:a="http://schemas.openxmlformats.org/drawingml/2006/main">
               <a:ext uri="{FF2B5EF4-FFF2-40B4-BE49-F238E27FC236}">
-                <a16:creationId xmlns:a16="http://schemas.microsoft.com/office/drawing/2014/main" id="{B2CBCE93-5EDD-48EF-8662-2F551D0AA2CD}"/>
+                <a16:creationId xmlns:a16="http://schemas.microsoft.com/office/drawing/2014/main" id="{321E0719-17AA-417F-A342-6D1D461A1DC4}"/>
               </a:ext>
             </a:extLst>
           </p:cNvPr>
@@ -9188,7 +8723,7 @@
           <p:cNvPr id="16" name="">
             <a:extLst xmlns:a="http://schemas.openxmlformats.org/drawingml/2006/main">
               <a:ext uri="{FF2B5EF4-FFF2-40B4-BE49-F238E27FC236}">
-                <a16:creationId xmlns:a16="http://schemas.microsoft.com/office/drawing/2014/main" id="{9E07D868-708A-4C21-9832-F87A29F93B29}"/>
+                <a16:creationId xmlns:a16="http://schemas.microsoft.com/office/drawing/2014/main" id="{2BFA282E-295F-4D53-A193-78CE5829D8F6}"/>
               </a:ext>
             </a:extLst>
           </p:cNvPr>
@@ -9246,7 +8781,7 @@
           <p:cNvPr id="17" name="">
             <a:extLst xmlns:a="http://schemas.openxmlformats.org/drawingml/2006/main">
               <a:ext uri="{FF2B5EF4-FFF2-40B4-BE49-F238E27FC236}">
-                <a16:creationId xmlns:a16="http://schemas.microsoft.com/office/drawing/2014/main" id="{423C32C9-A4E7-46E5-B174-51254DC9E188}"/>
+                <a16:creationId xmlns:a16="http://schemas.microsoft.com/office/drawing/2014/main" id="{7F0E3DF8-403D-4F17-A796-AAA42FE7C5FD}"/>
               </a:ext>
             </a:extLst>
           </p:cNvPr>
@@ -9304,7 +8839,7 @@
           <p:cNvPr id="18" name="">
             <a:extLst xmlns:a="http://schemas.openxmlformats.org/drawingml/2006/main">
               <a:ext uri="{FF2B5EF4-FFF2-40B4-BE49-F238E27FC236}">
-                <a16:creationId xmlns:a16="http://schemas.microsoft.com/office/drawing/2014/main" id="{438D0506-F3B6-4BF5-B6C5-F733F2F06C19}"/>
+                <a16:creationId xmlns:a16="http://schemas.microsoft.com/office/drawing/2014/main" id="{01EEDC15-5755-42C5-86A3-3696710B64B2}"/>
               </a:ext>
             </a:extLst>
           </p:cNvPr>
@@ -9379,7 +8914,7 @@
           <p:cNvPr id="19" name="">
             <a:extLst xmlns:a="http://schemas.openxmlformats.org/drawingml/2006/main">
               <a:ext uri="{FF2B5EF4-FFF2-40B4-BE49-F238E27FC236}">
-                <a16:creationId xmlns:a16="http://schemas.microsoft.com/office/drawing/2014/main" id="{D23FD6CD-8CF1-4704-BAF9-BC83D7A3EDAA}"/>
+                <a16:creationId xmlns:a16="http://schemas.microsoft.com/office/drawing/2014/main" id="{65ECA8D9-A090-41B4-AA20-A244839D9128}"/>
               </a:ext>
             </a:extLst>
           </p:cNvPr>
@@ -9414,7 +8949,7 @@
           <p:cNvPr id="20" name="">
             <a:extLst xmlns:a="http://schemas.openxmlformats.org/drawingml/2006/main">
               <a:ext uri="{FF2B5EF4-FFF2-40B4-BE49-F238E27FC236}">
-                <a16:creationId xmlns:a16="http://schemas.microsoft.com/office/drawing/2014/main" id="{EA54A2EC-DE60-4833-BAD1-7023A75B6245}"/>
+                <a16:creationId xmlns:a16="http://schemas.microsoft.com/office/drawing/2014/main" id="{03DC599C-49FC-4BC9-BD08-30E4C9F7BFB0}"/>
               </a:ext>
             </a:extLst>
           </p:cNvPr>
@@ -9447,7 +8982,7 @@
           <p:cNvPr id="21" name="">
             <a:extLst xmlns:a="http://schemas.openxmlformats.org/drawingml/2006/main">
               <a:ext uri="{FF2B5EF4-FFF2-40B4-BE49-F238E27FC236}">
-                <a16:creationId xmlns:a16="http://schemas.microsoft.com/office/drawing/2014/main" id="{8D152C1B-F317-4203-BABF-F98E89F3E789}"/>
+                <a16:creationId xmlns:a16="http://schemas.microsoft.com/office/drawing/2014/main" id="{D6A6C32F-57DC-4C06-9E71-47F99E90AB28}"/>
               </a:ext>
             </a:extLst>
           </p:cNvPr>
@@ -9505,7 +9040,7 @@
           <p:cNvPr id="22" name="">
             <a:extLst xmlns:a="http://schemas.openxmlformats.org/drawingml/2006/main">
               <a:ext uri="{FF2B5EF4-FFF2-40B4-BE49-F238E27FC236}">
-                <a16:creationId xmlns:a16="http://schemas.microsoft.com/office/drawing/2014/main" id="{38D3B669-0B39-4446-8FEC-4C56DAB59B9F}"/>
+                <a16:creationId xmlns:a16="http://schemas.microsoft.com/office/drawing/2014/main" id="{9C75D6CC-142C-44ED-93F6-B61116C5C50C}"/>
               </a:ext>
             </a:extLst>
           </p:cNvPr>
@@ -9563,7 +9098,7 @@
           <p:cNvPr id="23" name="">
             <a:extLst xmlns:a="http://schemas.openxmlformats.org/drawingml/2006/main">
               <a:ext uri="{FF2B5EF4-FFF2-40B4-BE49-F238E27FC236}">
-                <a16:creationId xmlns:a16="http://schemas.microsoft.com/office/drawing/2014/main" id="{1B599A7F-4FA5-47E8-80FD-F4796CCD26C0}"/>
+                <a16:creationId xmlns:a16="http://schemas.microsoft.com/office/drawing/2014/main" id="{B55107AE-2704-4444-B843-2BE9C1BF752F}"/>
               </a:ext>
             </a:extLst>
           </p:cNvPr>
@@ -9638,7 +9173,7 @@
           <p:cNvPr id="24" name="">
             <a:extLst xmlns:a="http://schemas.openxmlformats.org/drawingml/2006/main">
               <a:ext uri="{FF2B5EF4-FFF2-40B4-BE49-F238E27FC236}">
-                <a16:creationId xmlns:a16="http://schemas.microsoft.com/office/drawing/2014/main" id="{FE2B688D-5370-4397-9221-CA53D34C2F95}"/>
+                <a16:creationId xmlns:a16="http://schemas.microsoft.com/office/drawing/2014/main" id="{F99CD031-E115-4195-943E-22F444A55B3C}"/>
               </a:ext>
             </a:extLst>
           </p:cNvPr>
@@ -9671,7 +9206,7 @@
           <p:cNvPr id="25" name="">
             <a:extLst xmlns:a="http://schemas.openxmlformats.org/drawingml/2006/main">
               <a:ext uri="{FF2B5EF4-FFF2-40B4-BE49-F238E27FC236}">
-                <a16:creationId xmlns:a16="http://schemas.microsoft.com/office/drawing/2014/main" id="{BA8C2DDD-A8FF-4B6E-96A9-2892A037E093}"/>
+                <a16:creationId xmlns:a16="http://schemas.microsoft.com/office/drawing/2014/main" id="{FAE65A4E-6000-4A1A-88EB-8CD260FA1B28}"/>
               </a:ext>
             </a:extLst>
           </p:cNvPr>
@@ -9729,7 +9264,7 @@
           <p:cNvPr id="26" name="">
             <a:extLst xmlns:a="http://schemas.openxmlformats.org/drawingml/2006/main">
               <a:ext uri="{FF2B5EF4-FFF2-40B4-BE49-F238E27FC236}">
-                <a16:creationId xmlns:a16="http://schemas.microsoft.com/office/drawing/2014/main" id="{DE31C5D1-0F51-4E1D-9BEC-E193DFF05DE3}"/>
+                <a16:creationId xmlns:a16="http://schemas.microsoft.com/office/drawing/2014/main" id="{B8A7E5A3-3E95-4BCE-B386-066876FB67C9}"/>
               </a:ext>
             </a:extLst>
           </p:cNvPr>
@@ -9787,7 +9322,7 @@
           <p:cNvPr id="27" name="">
             <a:extLst xmlns:a="http://schemas.openxmlformats.org/drawingml/2006/main">
               <a:ext uri="{FF2B5EF4-FFF2-40B4-BE49-F238E27FC236}">
-                <a16:creationId xmlns:a16="http://schemas.microsoft.com/office/drawing/2014/main" id="{BD3B1B63-A4FA-457E-B5DB-4399CD62C2FA}"/>
+                <a16:creationId xmlns:a16="http://schemas.microsoft.com/office/drawing/2014/main" id="{2B87344E-330B-40CC-8468-57E8FB63C667}"/>
               </a:ext>
             </a:extLst>
           </p:cNvPr>
@@ -9820,7 +9355,7 @@
           <p:cNvPr id="28" name="">
             <a:extLst xmlns:a="http://schemas.openxmlformats.org/drawingml/2006/main">
               <a:ext uri="{FF2B5EF4-FFF2-40B4-BE49-F238E27FC236}">
-                <a16:creationId xmlns:a16="http://schemas.microsoft.com/office/drawing/2014/main" id="{8AE85F6B-289C-4C1D-858C-1F8DCB60A26A}"/>
+                <a16:creationId xmlns:a16="http://schemas.microsoft.com/office/drawing/2014/main" id="{31D129F7-A615-45BD-B9EB-F6C1CAE75F6E}"/>
               </a:ext>
             </a:extLst>
           </p:cNvPr>
@@ -9878,7 +9413,7 @@
           <p:cNvPr id="29" name="">
             <a:extLst xmlns:a="http://schemas.openxmlformats.org/drawingml/2006/main">
               <a:ext uri="{FF2B5EF4-FFF2-40B4-BE49-F238E27FC236}">
-                <a16:creationId xmlns:a16="http://schemas.microsoft.com/office/drawing/2014/main" id="{4AA50DF2-756C-495A-B3CE-4C0CD5B6B3A6}"/>
+                <a16:creationId xmlns:a16="http://schemas.microsoft.com/office/drawing/2014/main" id="{CDBE02E2-4B36-4DF4-A6E4-CC7DD4BAA6D0}"/>
               </a:ext>
             </a:extLst>
           </p:cNvPr>
@@ -9934,7 +9469,7 @@
     </p:spTree>
     <p:extLst>
       <p:ext uri="{BB962C8B-B14F-4D97-AF65-F5344CB8AC3E}">
-        <p14:creationId xmlns:p14="http://schemas.microsoft.com/office/powerpoint/2010/main" val="1506372719"/>
+        <p14:creationId xmlns:p14="http://schemas.microsoft.com/office/powerpoint/2010/main" val="653302803"/>
       </p:ext>
     </p:extLst>
   </p:cSld>
@@ -9965,7 +9500,7 @@
           <p:cNvPr id="36" name="">
             <a:extLst xmlns:a="http://schemas.openxmlformats.org/drawingml/2006/main">
               <a:ext uri="{FF2B5EF4-FFF2-40B4-BE49-F238E27FC236}">
-                <a16:creationId xmlns:a16="http://schemas.microsoft.com/office/drawing/2014/main" id="{F5255278-F5E7-407A-BB3A-4AA49A5F0896}"/>
+                <a16:creationId xmlns:a16="http://schemas.microsoft.com/office/drawing/2014/main" id="{841848DC-1AA4-489A-9C20-9E761E3A0901}"/>
               </a:ext>
             </a:extLst>
           </p:cNvPr>
@@ -10023,7 +9558,7 @@
           <p:cNvPr id="2" name="">
             <a:extLst xmlns:a="http://schemas.openxmlformats.org/drawingml/2006/main">
               <a:ext uri="{FF2B5EF4-FFF2-40B4-BE49-F238E27FC236}">
-                <a16:creationId xmlns:a16="http://schemas.microsoft.com/office/drawing/2014/main" id="{BA241BEF-75DB-4D01-9992-B4EE33A6BD1B}"/>
+                <a16:creationId xmlns:a16="http://schemas.microsoft.com/office/drawing/2014/main" id="{2E54578F-57D8-4103-8740-05A77335FCB6}"/>
               </a:ext>
             </a:extLst>
           </p:cNvPr>
@@ -10081,7 +9616,7 @@
           <p:cNvPr id="3" name="">
             <a:extLst xmlns:a="http://schemas.openxmlformats.org/drawingml/2006/main">
               <a:ext uri="{FF2B5EF4-FFF2-40B4-BE49-F238E27FC236}">
-                <a16:creationId xmlns:a16="http://schemas.microsoft.com/office/drawing/2014/main" id="{283404A1-3FBA-48DC-B085-45E7026777C7}"/>
+                <a16:creationId xmlns:a16="http://schemas.microsoft.com/office/drawing/2014/main" id="{65575F6A-F494-405E-AD82-E456C18D58F9}"/>
               </a:ext>
             </a:extLst>
           </p:cNvPr>
@@ -10139,7 +9674,7 @@
           <p:cNvPr id="4" name="">
             <a:extLst xmlns:a="http://schemas.openxmlformats.org/drawingml/2006/main">
               <a:ext uri="{FF2B5EF4-FFF2-40B4-BE49-F238E27FC236}">
-                <a16:creationId xmlns:a16="http://schemas.microsoft.com/office/drawing/2014/main" id="{9D189ABB-5E1C-4A90-8494-76E4DBF8492F}"/>
+                <a16:creationId xmlns:a16="http://schemas.microsoft.com/office/drawing/2014/main" id="{9F217011-BE17-456E-9407-E876F4B15182}"/>
               </a:ext>
             </a:extLst>
           </p:cNvPr>
@@ -10174,7 +9709,7 @@
           <p:cNvPr id="5" name="">
             <a:extLst xmlns:a="http://schemas.openxmlformats.org/drawingml/2006/main">
               <a:ext uri="{FF2B5EF4-FFF2-40B4-BE49-F238E27FC236}">
-                <a16:creationId xmlns:a16="http://schemas.microsoft.com/office/drawing/2014/main" id="{D63F015A-97A7-44C6-A7FF-108B17AC62DB}"/>
+                <a16:creationId xmlns:a16="http://schemas.microsoft.com/office/drawing/2014/main" id="{3BEBCBEB-0FE0-4332-8590-5317BA59346E}"/>
               </a:ext>
             </a:extLst>
           </p:cNvPr>
@@ -10207,7 +9742,7 @@
           <p:cNvPr id="6" name="">
             <a:extLst xmlns:a="http://schemas.openxmlformats.org/drawingml/2006/main">
               <a:ext uri="{FF2B5EF4-FFF2-40B4-BE49-F238E27FC236}">
-                <a16:creationId xmlns:a16="http://schemas.microsoft.com/office/drawing/2014/main" id="{F7C1BEE4-0A73-4B29-928F-AB3CB66B7900}"/>
+                <a16:creationId xmlns:a16="http://schemas.microsoft.com/office/drawing/2014/main" id="{4F5A166E-B3FC-4B30-8F94-F051C0AABA5A}"/>
               </a:ext>
             </a:extLst>
           </p:cNvPr>
@@ -10265,7 +9800,7 @@
           <p:cNvPr id="7" name="">
             <a:extLst xmlns:a="http://schemas.openxmlformats.org/drawingml/2006/main">
               <a:ext uri="{FF2B5EF4-FFF2-40B4-BE49-F238E27FC236}">
-                <a16:creationId xmlns:a16="http://schemas.microsoft.com/office/drawing/2014/main" id="{B7E1E3EE-FB11-4E8F-AED6-7D3F9FF5FD51}"/>
+                <a16:creationId xmlns:a16="http://schemas.microsoft.com/office/drawing/2014/main" id="{840BA16E-1487-420D-B1E9-6CEBC0ADD697}"/>
               </a:ext>
             </a:extLst>
           </p:cNvPr>
@@ -10340,7 +9875,7 @@
           <p:cNvPr id="8" name="">
             <a:extLst xmlns:a="http://schemas.openxmlformats.org/drawingml/2006/main">
               <a:ext uri="{FF2B5EF4-FFF2-40B4-BE49-F238E27FC236}">
-                <a16:creationId xmlns:a16="http://schemas.microsoft.com/office/drawing/2014/main" id="{340390E0-30D9-41BE-9875-45C8AFB422BE}"/>
+                <a16:creationId xmlns:a16="http://schemas.microsoft.com/office/drawing/2014/main" id="{FE8754DE-25A7-4F43-8E8F-5E3EDA438EB6}"/>
               </a:ext>
             </a:extLst>
           </p:cNvPr>
@@ -10375,7 +9910,7 @@
           <p:cNvPr id="9" name="">
             <a:extLst xmlns:a="http://schemas.openxmlformats.org/drawingml/2006/main">
               <a:ext uri="{FF2B5EF4-FFF2-40B4-BE49-F238E27FC236}">
-                <a16:creationId xmlns:a16="http://schemas.microsoft.com/office/drawing/2014/main" id="{F9D1C0E0-7CB9-48F5-9FF8-CE2E845A27BF}"/>
+                <a16:creationId xmlns:a16="http://schemas.microsoft.com/office/drawing/2014/main" id="{40DA8C84-3C1D-4FF5-B667-FDACEFD4DF1E}"/>
               </a:ext>
             </a:extLst>
           </p:cNvPr>
@@ -10408,7 +9943,7 @@
           <p:cNvPr id="10" name="">
             <a:extLst xmlns:a="http://schemas.openxmlformats.org/drawingml/2006/main">
               <a:ext uri="{FF2B5EF4-FFF2-40B4-BE49-F238E27FC236}">
-                <a16:creationId xmlns:a16="http://schemas.microsoft.com/office/drawing/2014/main" id="{A9D0784A-EE14-44B0-B4CD-B288035028F0}"/>
+                <a16:creationId xmlns:a16="http://schemas.microsoft.com/office/drawing/2014/main" id="{CC6009DE-330A-4C50-832D-3A499D887855}"/>
               </a:ext>
             </a:extLst>
           </p:cNvPr>
@@ -10466,7 +10001,7 @@
           <p:cNvPr id="11" name="">
             <a:extLst xmlns:a="http://schemas.openxmlformats.org/drawingml/2006/main">
               <a:ext uri="{FF2B5EF4-FFF2-40B4-BE49-F238E27FC236}">
-                <a16:creationId xmlns:a16="http://schemas.microsoft.com/office/drawing/2014/main" id="{BA47F68C-FE7B-4197-9092-D6635E03652A}"/>
+                <a16:creationId xmlns:a16="http://schemas.microsoft.com/office/drawing/2014/main" id="{D13AD3EE-3F1C-4999-85F9-6AD946F72F68}"/>
               </a:ext>
             </a:extLst>
           </p:cNvPr>
@@ -10541,7 +10076,7 @@
           <p:cNvPr id="12" name="">
             <a:extLst xmlns:a="http://schemas.openxmlformats.org/drawingml/2006/main">
               <a:ext uri="{FF2B5EF4-FFF2-40B4-BE49-F238E27FC236}">
-                <a16:creationId xmlns:a16="http://schemas.microsoft.com/office/drawing/2014/main" id="{CC6D1667-EAED-4896-BAEF-16361329A4F9}"/>
+                <a16:creationId xmlns:a16="http://schemas.microsoft.com/office/drawing/2014/main" id="{F85003F8-9D09-4CFD-BD88-2FA44C083897}"/>
               </a:ext>
             </a:extLst>
           </p:cNvPr>
@@ -10576,7 +10111,7 @@
           <p:cNvPr id="13" name="">
             <a:extLst xmlns:a="http://schemas.openxmlformats.org/drawingml/2006/main">
               <a:ext uri="{FF2B5EF4-FFF2-40B4-BE49-F238E27FC236}">
-                <a16:creationId xmlns:a16="http://schemas.microsoft.com/office/drawing/2014/main" id="{4420FB9E-08A2-4154-A6A2-8ED0C5C97D46}"/>
+                <a16:creationId xmlns:a16="http://schemas.microsoft.com/office/drawing/2014/main" id="{26A2BCA3-F60F-4945-B45B-67EBCF4DD78E}"/>
               </a:ext>
             </a:extLst>
           </p:cNvPr>
@@ -10609,7 +10144,7 @@
           <p:cNvPr id="14" name="">
             <a:extLst xmlns:a="http://schemas.openxmlformats.org/drawingml/2006/main">
               <a:ext uri="{FF2B5EF4-FFF2-40B4-BE49-F238E27FC236}">
-                <a16:creationId xmlns:a16="http://schemas.microsoft.com/office/drawing/2014/main" id="{9FD78607-2743-4358-9B6C-4B6A7CB9202F}"/>
+                <a16:creationId xmlns:a16="http://schemas.microsoft.com/office/drawing/2014/main" id="{6939842B-0499-491E-945C-BAAAB29D22F6}"/>
               </a:ext>
             </a:extLst>
           </p:cNvPr>
@@ -10667,7 +10202,7 @@
           <p:cNvPr id="15" name="">
             <a:extLst xmlns:a="http://schemas.openxmlformats.org/drawingml/2006/main">
               <a:ext uri="{FF2B5EF4-FFF2-40B4-BE49-F238E27FC236}">
-                <a16:creationId xmlns:a16="http://schemas.microsoft.com/office/drawing/2014/main" id="{17B09FB1-60ED-4971-B6EB-38FD48F48CF1}"/>
+                <a16:creationId xmlns:a16="http://schemas.microsoft.com/office/drawing/2014/main" id="{756AD1AE-BB65-428A-AC10-43017CDB9ACE}"/>
               </a:ext>
             </a:extLst>
           </p:cNvPr>
@@ -10742,7 +10277,7 @@
           <p:cNvPr id="16" name="">
             <a:extLst xmlns:a="http://schemas.openxmlformats.org/drawingml/2006/main">
               <a:ext uri="{FF2B5EF4-FFF2-40B4-BE49-F238E27FC236}">
-                <a16:creationId xmlns:a16="http://schemas.microsoft.com/office/drawing/2014/main" id="{CC9E46BA-90B2-4270-87A3-4B742A25953D}"/>
+                <a16:creationId xmlns:a16="http://schemas.microsoft.com/office/drawing/2014/main" id="{943827F7-9599-460F-AB43-172E729DCD3C}"/>
               </a:ext>
             </a:extLst>
           </p:cNvPr>
@@ -10777,7 +10312,7 @@
           <p:cNvPr id="17" name="">
             <a:extLst xmlns:a="http://schemas.openxmlformats.org/drawingml/2006/main">
               <a:ext uri="{FF2B5EF4-FFF2-40B4-BE49-F238E27FC236}">
-                <a16:creationId xmlns:a16="http://schemas.microsoft.com/office/drawing/2014/main" id="{CA7E0906-CA8C-45E5-B699-9A398E940B36}"/>
+                <a16:creationId xmlns:a16="http://schemas.microsoft.com/office/drawing/2014/main" id="{5A558421-CE36-4CBD-8605-314A6ACE5D2C}"/>
               </a:ext>
             </a:extLst>
           </p:cNvPr>
@@ -10810,7 +10345,7 @@
           <p:cNvPr id="18" name="">
             <a:extLst xmlns:a="http://schemas.openxmlformats.org/drawingml/2006/main">
               <a:ext uri="{FF2B5EF4-FFF2-40B4-BE49-F238E27FC236}">
-                <a16:creationId xmlns:a16="http://schemas.microsoft.com/office/drawing/2014/main" id="{7E25C773-B2AA-4F35-91D2-7456EB80C06A}"/>
+                <a16:creationId xmlns:a16="http://schemas.microsoft.com/office/drawing/2014/main" id="{344A93ED-8C81-48DA-AB59-D7725BE06535}"/>
               </a:ext>
             </a:extLst>
           </p:cNvPr>
@@ -10868,7 +10403,7 @@
           <p:cNvPr id="19" name="">
             <a:extLst xmlns:a="http://schemas.openxmlformats.org/drawingml/2006/main">
               <a:ext uri="{FF2B5EF4-FFF2-40B4-BE49-F238E27FC236}">
-                <a16:creationId xmlns:a16="http://schemas.microsoft.com/office/drawing/2014/main" id="{74A199EA-6A4B-40C2-B7D1-2C1838BC51B2}"/>
+                <a16:creationId xmlns:a16="http://schemas.microsoft.com/office/drawing/2014/main" id="{CB661F71-9257-462F-86FA-20F2359F221D}"/>
               </a:ext>
             </a:extLst>
           </p:cNvPr>
@@ -10943,7 +10478,7 @@
           <p:cNvPr id="20" name="">
             <a:extLst xmlns:a="http://schemas.openxmlformats.org/drawingml/2006/main">
               <a:ext uri="{FF2B5EF4-FFF2-40B4-BE49-F238E27FC236}">
-                <a16:creationId xmlns:a16="http://schemas.microsoft.com/office/drawing/2014/main" id="{022F0C20-1384-491B-83C1-320940B1C343}"/>
+                <a16:creationId xmlns:a16="http://schemas.microsoft.com/office/drawing/2014/main" id="{A8A4C11D-98AD-4C40-BEDA-24595E9BBD23}"/>
               </a:ext>
             </a:extLst>
           </p:cNvPr>
@@ -10976,7 +10511,7 @@
           <p:cNvPr id="21" name="">
             <a:extLst xmlns:a="http://schemas.openxmlformats.org/drawingml/2006/main">
               <a:ext uri="{FF2B5EF4-FFF2-40B4-BE49-F238E27FC236}">
-                <a16:creationId xmlns:a16="http://schemas.microsoft.com/office/drawing/2014/main" id="{F6A4F725-0366-41F0-89F5-5787A96433BE}"/>
+                <a16:creationId xmlns:a16="http://schemas.microsoft.com/office/drawing/2014/main" id="{1388D399-EFCD-4980-9C48-39D3217D4E3D}"/>
               </a:ext>
             </a:extLst>
           </p:cNvPr>
@@ -11009,7 +10544,7 @@
           <p:cNvPr id="22" name="">
             <a:extLst xmlns:a="http://schemas.openxmlformats.org/drawingml/2006/main">
               <a:ext uri="{FF2B5EF4-FFF2-40B4-BE49-F238E27FC236}">
-                <a16:creationId xmlns:a16="http://schemas.microsoft.com/office/drawing/2014/main" id="{C178F398-A365-4C0D-94F4-5BF93F43FBFF}"/>
+                <a16:creationId xmlns:a16="http://schemas.microsoft.com/office/drawing/2014/main" id="{627C3EC2-22C1-4BC1-99A2-75F7D3C64CDC}"/>
               </a:ext>
             </a:extLst>
           </p:cNvPr>
@@ -11042,7 +10577,7 @@
           <p:cNvPr id="23" name="">
             <a:extLst xmlns:a="http://schemas.openxmlformats.org/drawingml/2006/main">
               <a:ext uri="{FF2B5EF4-FFF2-40B4-BE49-F238E27FC236}">
-                <a16:creationId xmlns:a16="http://schemas.microsoft.com/office/drawing/2014/main" id="{227D4C2B-0B17-4053-86DD-692957E82125}"/>
+                <a16:creationId xmlns:a16="http://schemas.microsoft.com/office/drawing/2014/main" id="{66FC319A-F503-45EB-BE24-F75E2346E883}"/>
               </a:ext>
             </a:extLst>
           </p:cNvPr>
@@ -11075,7 +10610,7 @@
           <p:cNvPr id="24" name="">
             <a:extLst xmlns:a="http://schemas.openxmlformats.org/drawingml/2006/main">
               <a:ext uri="{FF2B5EF4-FFF2-40B4-BE49-F238E27FC236}">
-                <a16:creationId xmlns:a16="http://schemas.microsoft.com/office/drawing/2014/main" id="{3F7698FC-AAC5-44F8-B8B4-7D5BDD4DE64C}"/>
+                <a16:creationId xmlns:a16="http://schemas.microsoft.com/office/drawing/2014/main" id="{07567FF6-04EF-4447-9157-4A89B875B899}"/>
               </a:ext>
             </a:extLst>
           </p:cNvPr>
@@ -11150,7 +10685,7 @@
           <p:cNvPr id="25" name="">
             <a:extLst xmlns:a="http://schemas.openxmlformats.org/drawingml/2006/main">
               <a:ext uri="{FF2B5EF4-FFF2-40B4-BE49-F238E27FC236}">
-                <a16:creationId xmlns:a16="http://schemas.microsoft.com/office/drawing/2014/main" id="{EA8DBBA6-7DA7-43E3-B4C7-6DAEBBDD8211}"/>
+                <a16:creationId xmlns:a16="http://schemas.microsoft.com/office/drawing/2014/main" id="{332A69E2-8E29-4ED3-A3CE-B74987620930}"/>
               </a:ext>
             </a:extLst>
           </p:cNvPr>
@@ -11183,7 +10718,7 @@
           <p:cNvPr id="26" name="">
             <a:extLst xmlns:a="http://schemas.openxmlformats.org/drawingml/2006/main">
               <a:ext uri="{FF2B5EF4-FFF2-40B4-BE49-F238E27FC236}">
-                <a16:creationId xmlns:a16="http://schemas.microsoft.com/office/drawing/2014/main" id="{C3FC7ED6-F41F-45AF-808B-01561B9CF9C4}"/>
+                <a16:creationId xmlns:a16="http://schemas.microsoft.com/office/drawing/2014/main" id="{75B78B6F-0503-4A75-B2EF-C04D100B714D}"/>
               </a:ext>
             </a:extLst>
           </p:cNvPr>
@@ -11258,7 +10793,7 @@
           <p:cNvPr id="27" name="">
             <a:extLst xmlns:a="http://schemas.openxmlformats.org/drawingml/2006/main">
               <a:ext uri="{FF2B5EF4-FFF2-40B4-BE49-F238E27FC236}">
-                <a16:creationId xmlns:a16="http://schemas.microsoft.com/office/drawing/2014/main" id="{FA3E2C6A-DDBA-49FE-B685-6420D709E406}"/>
+                <a16:creationId xmlns:a16="http://schemas.microsoft.com/office/drawing/2014/main" id="{0FE5B158-CAAD-4D16-BC8F-2AC0AC1AF1E4}"/>
               </a:ext>
             </a:extLst>
           </p:cNvPr>
@@ -11291,7 +10826,7 @@
           <p:cNvPr id="28" name="">
             <a:extLst xmlns:a="http://schemas.openxmlformats.org/drawingml/2006/main">
               <a:ext uri="{FF2B5EF4-FFF2-40B4-BE49-F238E27FC236}">
-                <a16:creationId xmlns:a16="http://schemas.microsoft.com/office/drawing/2014/main" id="{77D2345E-1726-4F51-B3E8-54C386F2414D}"/>
+                <a16:creationId xmlns:a16="http://schemas.microsoft.com/office/drawing/2014/main" id="{195B2D0A-6B9D-4C41-9AC2-9B45A7FF794F}"/>
               </a:ext>
             </a:extLst>
           </p:cNvPr>
@@ -11366,7 +10901,7 @@
           <p:cNvPr id="29" name="">
             <a:extLst xmlns:a="http://schemas.openxmlformats.org/drawingml/2006/main">
               <a:ext uri="{FF2B5EF4-FFF2-40B4-BE49-F238E27FC236}">
-                <a16:creationId xmlns:a16="http://schemas.microsoft.com/office/drawing/2014/main" id="{0C451033-AB63-49EF-80D6-CE10E38F9417}"/>
+                <a16:creationId xmlns:a16="http://schemas.microsoft.com/office/drawing/2014/main" id="{66E3DB54-2044-4E54-A2D5-3E266583283C}"/>
               </a:ext>
             </a:extLst>
           </p:cNvPr>
@@ -11399,7 +10934,7 @@
           <p:cNvPr id="30" name="">
             <a:extLst xmlns:a="http://schemas.openxmlformats.org/drawingml/2006/main">
               <a:ext uri="{FF2B5EF4-FFF2-40B4-BE49-F238E27FC236}">
-                <a16:creationId xmlns:a16="http://schemas.microsoft.com/office/drawing/2014/main" id="{BB1578AA-A9DE-4B95-862B-DD26CB9D6C34}"/>
+                <a16:creationId xmlns:a16="http://schemas.microsoft.com/office/drawing/2014/main" id="{28489EC3-A070-4A4B-B909-AFAD78F5BD42}"/>
               </a:ext>
             </a:extLst>
           </p:cNvPr>
@@ -11474,7 +11009,7 @@
           <p:cNvPr id="31" name="">
             <a:extLst xmlns:a="http://schemas.openxmlformats.org/drawingml/2006/main">
               <a:ext uri="{FF2B5EF4-FFF2-40B4-BE49-F238E27FC236}">
-                <a16:creationId xmlns:a16="http://schemas.microsoft.com/office/drawing/2014/main" id="{0DF6249D-D8B6-40EA-803D-05978A96B811}"/>
+                <a16:creationId xmlns:a16="http://schemas.microsoft.com/office/drawing/2014/main" id="{EFE37213-D316-4ED0-996D-064606EC181A}"/>
               </a:ext>
             </a:extLst>
           </p:cNvPr>
@@ -11507,7 +11042,7 @@
           <p:cNvPr id="32" name="">
             <a:extLst xmlns:a="http://schemas.openxmlformats.org/drawingml/2006/main">
               <a:ext uri="{FF2B5EF4-FFF2-40B4-BE49-F238E27FC236}">
-                <a16:creationId xmlns:a16="http://schemas.microsoft.com/office/drawing/2014/main" id="{3A4E4870-C030-40E2-ABF3-92E951E38C62}"/>
+                <a16:creationId xmlns:a16="http://schemas.microsoft.com/office/drawing/2014/main" id="{764C323B-BC7C-45D4-9E8C-7899F88808C9}"/>
               </a:ext>
             </a:extLst>
           </p:cNvPr>
@@ -11565,7 +11100,7 @@
           <p:cNvPr id="33" name="">
             <a:extLst xmlns:a="http://schemas.openxmlformats.org/drawingml/2006/main">
               <a:ext uri="{FF2B5EF4-FFF2-40B4-BE49-F238E27FC236}">
-                <a16:creationId xmlns:a16="http://schemas.microsoft.com/office/drawing/2014/main" id="{5D6279CF-47FC-4B10-BFFA-3D3E005E7326}"/>
+                <a16:creationId xmlns:a16="http://schemas.microsoft.com/office/drawing/2014/main" id="{2A9BB033-1FBB-4756-BB76-CDD7D3B0FF04}"/>
               </a:ext>
             </a:extLst>
           </p:cNvPr>
@@ -11598,7 +11133,7 @@
           <p:cNvPr id="34" name="">
             <a:extLst xmlns:a="http://schemas.openxmlformats.org/drawingml/2006/main">
               <a:ext uri="{FF2B5EF4-FFF2-40B4-BE49-F238E27FC236}">
-                <a16:creationId xmlns:a16="http://schemas.microsoft.com/office/drawing/2014/main" id="{5F1997D2-999F-43ED-B7F3-437049999C82}"/>
+                <a16:creationId xmlns:a16="http://schemas.microsoft.com/office/drawing/2014/main" id="{05890DBF-133C-4563-92FD-DB6E76D60E79}"/>
               </a:ext>
             </a:extLst>
           </p:cNvPr>
@@ -11656,7 +11191,7 @@
           <p:cNvPr id="35" name="">
             <a:extLst xmlns:a="http://schemas.openxmlformats.org/drawingml/2006/main">
               <a:ext uri="{FF2B5EF4-FFF2-40B4-BE49-F238E27FC236}">
-                <a16:creationId xmlns:a16="http://schemas.microsoft.com/office/drawing/2014/main" id="{277073F5-59D2-4283-913D-137C62DE93D3}"/>
+                <a16:creationId xmlns:a16="http://schemas.microsoft.com/office/drawing/2014/main" id="{988F4AD7-B524-432E-8B1B-532C4BE10853}"/>
               </a:ext>
             </a:extLst>
           </p:cNvPr>
@@ -11712,7 +11247,7 @@
     </p:spTree>
     <p:extLst>
       <p:ext uri="{BB962C8B-B14F-4D97-AF65-F5344CB8AC3E}">
-        <p14:creationId xmlns:p14="http://schemas.microsoft.com/office/powerpoint/2010/main" val="2016133955"/>
+        <p14:creationId xmlns:p14="http://schemas.microsoft.com/office/powerpoint/2010/main" val="1944018624"/>
       </p:ext>
     </p:extLst>
   </p:cSld>
@@ -11743,7 +11278,7 @@
           <p:cNvPr id="23" name="">
             <a:extLst xmlns:a="http://schemas.openxmlformats.org/drawingml/2006/main">
               <a:ext uri="{FF2B5EF4-FFF2-40B4-BE49-F238E27FC236}">
-                <a16:creationId xmlns:a16="http://schemas.microsoft.com/office/drawing/2014/main" id="{523A448A-AEFA-4C4C-9DBD-0FE3A69DE975}"/>
+                <a16:creationId xmlns:a16="http://schemas.microsoft.com/office/drawing/2014/main" id="{CDCBED45-1747-4073-B5C2-A65DF9A0170C}"/>
               </a:ext>
             </a:extLst>
           </p:cNvPr>
@@ -11801,7 +11336,7 @@
           <p:cNvPr id="2" name="">
             <a:extLst xmlns:a="http://schemas.openxmlformats.org/drawingml/2006/main">
               <a:ext uri="{FF2B5EF4-FFF2-40B4-BE49-F238E27FC236}">
-                <a16:creationId xmlns:a16="http://schemas.microsoft.com/office/drawing/2014/main" id="{3611C3E6-FC91-4C22-AA32-CB4E4C16F539}"/>
+                <a16:creationId xmlns:a16="http://schemas.microsoft.com/office/drawing/2014/main" id="{C15854EA-D9EB-462E-8C2A-0369C761F48D}"/>
               </a:ext>
             </a:extLst>
           </p:cNvPr>
@@ -11859,7 +11394,7 @@
           <p:cNvPr id="3" name="">
             <a:extLst xmlns:a="http://schemas.openxmlformats.org/drawingml/2006/main">
               <a:ext uri="{FF2B5EF4-FFF2-40B4-BE49-F238E27FC236}">
-                <a16:creationId xmlns:a16="http://schemas.microsoft.com/office/drawing/2014/main" id="{B2134DE0-5E4C-4A4D-9829-E26E812CEBAB}"/>
+                <a16:creationId xmlns:a16="http://schemas.microsoft.com/office/drawing/2014/main" id="{F2F639EC-106B-48A8-AC6D-C6CF8EDE06B2}"/>
               </a:ext>
             </a:extLst>
           </p:cNvPr>
@@ -11917,7 +11452,7 @@
           <p:cNvPr id="4" name="">
             <a:extLst xmlns:a="http://schemas.openxmlformats.org/drawingml/2006/main">
               <a:ext uri="{FF2B5EF4-FFF2-40B4-BE49-F238E27FC236}">
-                <a16:creationId xmlns:a16="http://schemas.microsoft.com/office/drawing/2014/main" id="{F14FF6E9-1199-4693-BF13-8748C2CEC8EC}"/>
+                <a16:creationId xmlns:a16="http://schemas.microsoft.com/office/drawing/2014/main" id="{129C3EBD-4452-482A-89A1-90C95DB91E7D}"/>
               </a:ext>
             </a:extLst>
           </p:cNvPr>
@@ -11952,7 +11487,7 @@
           <p:cNvPr id="5" name="">
             <a:extLst xmlns:a="http://schemas.openxmlformats.org/drawingml/2006/main">
               <a:ext uri="{FF2B5EF4-FFF2-40B4-BE49-F238E27FC236}">
-                <a16:creationId xmlns:a16="http://schemas.microsoft.com/office/drawing/2014/main" id="{D6DD1B48-9F4E-4E38-9F86-4C4922045021}"/>
+                <a16:creationId xmlns:a16="http://schemas.microsoft.com/office/drawing/2014/main" id="{F4D8C257-C365-4637-BECA-A0459F0D2EB0}"/>
               </a:ext>
             </a:extLst>
           </p:cNvPr>
@@ -12010,7 +11545,7 @@
           <p:cNvPr id="6" name="">
             <a:extLst xmlns:a="http://schemas.openxmlformats.org/drawingml/2006/main">
               <a:ext uri="{FF2B5EF4-FFF2-40B4-BE49-F238E27FC236}">
-                <a16:creationId xmlns:a16="http://schemas.microsoft.com/office/drawing/2014/main" id="{B0486234-8DEF-479C-957D-271A755DAEB5}"/>
+                <a16:creationId xmlns:a16="http://schemas.microsoft.com/office/drawing/2014/main" id="{63FB7895-900B-414F-BB44-7E8CC5C042E5}"/>
               </a:ext>
             </a:extLst>
           </p:cNvPr>
@@ -12068,7 +11603,7 @@
           <p:cNvPr id="7" name="">
             <a:extLst xmlns:a="http://schemas.openxmlformats.org/drawingml/2006/main">
               <a:ext uri="{FF2B5EF4-FFF2-40B4-BE49-F238E27FC236}">
-                <a16:creationId xmlns:a16="http://schemas.microsoft.com/office/drawing/2014/main" id="{59F2666A-D375-4B00-A3FC-6E9369CBE6F7}"/>
+                <a16:creationId xmlns:a16="http://schemas.microsoft.com/office/drawing/2014/main" id="{89065D63-FFA9-4ECE-BE12-C431EB66A22A}"/>
               </a:ext>
             </a:extLst>
           </p:cNvPr>
@@ -12126,7 +11661,7 @@
           <p:cNvPr id="8" name="">
             <a:extLst xmlns:a="http://schemas.openxmlformats.org/drawingml/2006/main">
               <a:ext uri="{FF2B5EF4-FFF2-40B4-BE49-F238E27FC236}">
-                <a16:creationId xmlns:a16="http://schemas.microsoft.com/office/drawing/2014/main" id="{A0A7712D-628E-4886-8431-B0314E097E4A}"/>
+                <a16:creationId xmlns:a16="http://schemas.microsoft.com/office/drawing/2014/main" id="{7EB36F30-39E7-4F24-BD72-A1979874488C}"/>
               </a:ext>
             </a:extLst>
           </p:cNvPr>
@@ -12184,7 +11719,7 @@
           <p:cNvPr id="9" name="">
             <a:extLst xmlns:a="http://schemas.openxmlformats.org/drawingml/2006/main">
               <a:ext uri="{FF2B5EF4-FFF2-40B4-BE49-F238E27FC236}">
-                <a16:creationId xmlns:a16="http://schemas.microsoft.com/office/drawing/2014/main" id="{E80B7D68-8219-4609-BADB-E762DB1B85FA}"/>
+                <a16:creationId xmlns:a16="http://schemas.microsoft.com/office/drawing/2014/main" id="{90DD6A72-DEDE-4500-B0E1-35F554C2F613}"/>
               </a:ext>
             </a:extLst>
           </p:cNvPr>
@@ -12242,7 +11777,7 @@
           <p:cNvPr id="10" name="">
             <a:extLst xmlns:a="http://schemas.openxmlformats.org/drawingml/2006/main">
               <a:ext uri="{FF2B5EF4-FFF2-40B4-BE49-F238E27FC236}">
-                <a16:creationId xmlns:a16="http://schemas.microsoft.com/office/drawing/2014/main" id="{7334B067-7EC7-4913-83C9-F8AC260D52A4}"/>
+                <a16:creationId xmlns:a16="http://schemas.microsoft.com/office/drawing/2014/main" id="{29ECEDD2-EBDC-4FE8-9CB3-27361C965150}"/>
               </a:ext>
             </a:extLst>
           </p:cNvPr>
@@ -12300,7 +11835,7 @@
           <p:cNvPr id="11" name="">
             <a:extLst xmlns:a="http://schemas.openxmlformats.org/drawingml/2006/main">
               <a:ext uri="{FF2B5EF4-FFF2-40B4-BE49-F238E27FC236}">
-                <a16:creationId xmlns:a16="http://schemas.microsoft.com/office/drawing/2014/main" id="{E49D2BAA-54CF-4B15-811D-063B1B33E398}"/>
+                <a16:creationId xmlns:a16="http://schemas.microsoft.com/office/drawing/2014/main" id="{51815260-5892-4E52-8564-DE7EDE07F991}"/>
               </a:ext>
             </a:extLst>
           </p:cNvPr>
@@ -12358,7 +11893,7 @@
           <p:cNvPr id="12" name="">
             <a:extLst xmlns:a="http://schemas.openxmlformats.org/drawingml/2006/main">
               <a:ext uri="{FF2B5EF4-FFF2-40B4-BE49-F238E27FC236}">
-                <a16:creationId xmlns:a16="http://schemas.microsoft.com/office/drawing/2014/main" id="{E19CA0A4-F1B8-4CCF-898A-B50410DD2E95}"/>
+                <a16:creationId xmlns:a16="http://schemas.microsoft.com/office/drawing/2014/main" id="{C0C23D18-C0B4-4722-B0DB-8E863232CDAE}"/>
               </a:ext>
             </a:extLst>
           </p:cNvPr>
@@ -12416,7 +11951,7 @@
           <p:cNvPr id="13" name="">
             <a:extLst xmlns:a="http://schemas.openxmlformats.org/drawingml/2006/main">
               <a:ext uri="{FF2B5EF4-FFF2-40B4-BE49-F238E27FC236}">
-                <a16:creationId xmlns:a16="http://schemas.microsoft.com/office/drawing/2014/main" id="{56E4A41E-C05C-4F58-94B9-07CB350DD4E7}"/>
+                <a16:creationId xmlns:a16="http://schemas.microsoft.com/office/drawing/2014/main" id="{16B8D7B0-22B3-4BE8-987F-16E0BEAC52D8}"/>
               </a:ext>
             </a:extLst>
           </p:cNvPr>
@@ -12474,7 +12009,7 @@
           <p:cNvPr id="14" name="">
             <a:extLst xmlns:a="http://schemas.openxmlformats.org/drawingml/2006/main">
               <a:ext uri="{FF2B5EF4-FFF2-40B4-BE49-F238E27FC236}">
-                <a16:creationId xmlns:a16="http://schemas.microsoft.com/office/drawing/2014/main" id="{49C5B386-ED7C-4ADE-9ECE-2FCEB77D3764}"/>
+                <a16:creationId xmlns:a16="http://schemas.microsoft.com/office/drawing/2014/main" id="{3712C097-3103-44B8-B840-093FECCD7147}"/>
               </a:ext>
             </a:extLst>
           </p:cNvPr>
@@ -12509,7 +12044,7 @@
           <p:cNvPr id="15" name="">
             <a:extLst xmlns:a="http://schemas.openxmlformats.org/drawingml/2006/main">
               <a:ext uri="{FF2B5EF4-FFF2-40B4-BE49-F238E27FC236}">
-                <a16:creationId xmlns:a16="http://schemas.microsoft.com/office/drawing/2014/main" id="{E6B2B9E6-A41E-43CB-8BEE-4724FA0C3D7E}"/>
+                <a16:creationId xmlns:a16="http://schemas.microsoft.com/office/drawing/2014/main" id="{28770BA6-B056-4495-9A64-E694126C80CE}"/>
               </a:ext>
             </a:extLst>
           </p:cNvPr>
@@ -12567,7 +12102,7 @@
           <p:cNvPr id="16" name="">
             <a:extLst xmlns:a="http://schemas.openxmlformats.org/drawingml/2006/main">
               <a:ext uri="{FF2B5EF4-FFF2-40B4-BE49-F238E27FC236}">
-                <a16:creationId xmlns:a16="http://schemas.microsoft.com/office/drawing/2014/main" id="{6819ED23-3349-486B-83EA-9046E59E6BB2}"/>
+                <a16:creationId xmlns:a16="http://schemas.microsoft.com/office/drawing/2014/main" id="{4D62F6BF-1441-47CA-88E0-18674968DCF2}"/>
               </a:ext>
             </a:extLst>
           </p:cNvPr>
@@ -12727,7 +12262,7 @@
           <p:cNvPr id="17" name="">
             <a:extLst xmlns:a="http://schemas.openxmlformats.org/drawingml/2006/main">
               <a:ext uri="{FF2B5EF4-FFF2-40B4-BE49-F238E27FC236}">
-                <a16:creationId xmlns:a16="http://schemas.microsoft.com/office/drawing/2014/main" id="{CEF9BD48-5709-46E8-925C-E819F4695DBB}"/>
+                <a16:creationId xmlns:a16="http://schemas.microsoft.com/office/drawing/2014/main" id="{548BB611-179C-4E2D-A485-1929F4917FEE}"/>
               </a:ext>
             </a:extLst>
           </p:cNvPr>
@@ -12760,7 +12295,7 @@
           <p:cNvPr id="18" name="">
             <a:extLst xmlns:a="http://schemas.openxmlformats.org/drawingml/2006/main">
               <a:ext uri="{FF2B5EF4-FFF2-40B4-BE49-F238E27FC236}">
-                <a16:creationId xmlns:a16="http://schemas.microsoft.com/office/drawing/2014/main" id="{EC01E7FE-B1FE-468F-A96F-3F8487D0F9CD}"/>
+                <a16:creationId xmlns:a16="http://schemas.microsoft.com/office/drawing/2014/main" id="{5B1D7D24-5447-4C66-A0F1-3925CA60C852}"/>
               </a:ext>
             </a:extLst>
           </p:cNvPr>
@@ -12818,7 +12353,7 @@
           <p:cNvPr id="19" name="">
             <a:extLst xmlns:a="http://schemas.openxmlformats.org/drawingml/2006/main">
               <a:ext uri="{FF2B5EF4-FFF2-40B4-BE49-F238E27FC236}">
-                <a16:creationId xmlns:a16="http://schemas.microsoft.com/office/drawing/2014/main" id="{4712B32D-FB12-4B43-860B-E1AE87D50825}"/>
+                <a16:creationId xmlns:a16="http://schemas.microsoft.com/office/drawing/2014/main" id="{90458426-7E44-467E-B6DB-2930BC0096E8}"/>
               </a:ext>
             </a:extLst>
           </p:cNvPr>
@@ -12893,7 +12428,7 @@
           <p:cNvPr id="20" name="">
             <a:extLst xmlns:a="http://schemas.openxmlformats.org/drawingml/2006/main">
               <a:ext uri="{FF2B5EF4-FFF2-40B4-BE49-F238E27FC236}">
-                <a16:creationId xmlns:a16="http://schemas.microsoft.com/office/drawing/2014/main" id="{7E3B7096-2E51-49E8-BEBE-CACC807E0D40}"/>
+                <a16:creationId xmlns:a16="http://schemas.microsoft.com/office/drawing/2014/main" id="{E1DB263E-9CAA-44D5-847C-2A53A6AF0578}"/>
               </a:ext>
             </a:extLst>
           </p:cNvPr>
@@ -12926,7 +12461,7 @@
           <p:cNvPr id="21" name="">
             <a:extLst xmlns:a="http://schemas.openxmlformats.org/drawingml/2006/main">
               <a:ext uri="{FF2B5EF4-FFF2-40B4-BE49-F238E27FC236}">
-                <a16:creationId xmlns:a16="http://schemas.microsoft.com/office/drawing/2014/main" id="{4C4D5C31-9C67-4048-A692-A3DD9F1CED98}"/>
+                <a16:creationId xmlns:a16="http://schemas.microsoft.com/office/drawing/2014/main" id="{7F377B88-70BB-40BC-AA72-D86D1F52E9B0}"/>
               </a:ext>
             </a:extLst>
           </p:cNvPr>
@@ -12984,7 +12519,7 @@
           <p:cNvPr id="22" name="">
             <a:extLst xmlns:a="http://schemas.openxmlformats.org/drawingml/2006/main">
               <a:ext uri="{FF2B5EF4-FFF2-40B4-BE49-F238E27FC236}">
-                <a16:creationId xmlns:a16="http://schemas.microsoft.com/office/drawing/2014/main" id="{07C8F2D0-6DFA-4585-A378-9BFC4EA928E4}"/>
+                <a16:creationId xmlns:a16="http://schemas.microsoft.com/office/drawing/2014/main" id="{85125CB7-0864-4C42-A56D-13F7F68F8F99}"/>
               </a:ext>
             </a:extLst>
           </p:cNvPr>
@@ -13040,7 +12575,7 @@
     </p:spTree>
     <p:extLst>
       <p:ext uri="{BB962C8B-B14F-4D97-AF65-F5344CB8AC3E}">
-        <p14:creationId xmlns:p14="http://schemas.microsoft.com/office/powerpoint/2010/main" val="506860415"/>
+        <p14:creationId xmlns:p14="http://schemas.microsoft.com/office/powerpoint/2010/main" val="1530829595"/>
       </p:ext>
     </p:extLst>
   </p:cSld>
@@ -13071,7 +12606,7 @@
           <p:cNvPr id="39" name="">
             <a:extLst xmlns:a="http://schemas.openxmlformats.org/drawingml/2006/main">
               <a:ext uri="{FF2B5EF4-FFF2-40B4-BE49-F238E27FC236}">
-                <a16:creationId xmlns:a16="http://schemas.microsoft.com/office/drawing/2014/main" id="{77841CF3-EBCA-490F-AB50-DF8252A66845}"/>
+                <a16:creationId xmlns:a16="http://schemas.microsoft.com/office/drawing/2014/main" id="{A8F34694-F267-49E0-9AA6-3DE8980D0BD7}"/>
               </a:ext>
             </a:extLst>
           </p:cNvPr>
@@ -13129,7 +12664,7 @@
           <p:cNvPr id="2" name="">
             <a:extLst xmlns:a="http://schemas.openxmlformats.org/drawingml/2006/main">
               <a:ext uri="{FF2B5EF4-FFF2-40B4-BE49-F238E27FC236}">
-                <a16:creationId xmlns:a16="http://schemas.microsoft.com/office/drawing/2014/main" id="{7FDB009D-D402-49B4-8635-294282087A3F}"/>
+                <a16:creationId xmlns:a16="http://schemas.microsoft.com/office/drawing/2014/main" id="{43B16428-871B-4D1A-9240-A976FB5ABA83}"/>
               </a:ext>
             </a:extLst>
           </p:cNvPr>
@@ -13187,7 +12722,7 @@
           <p:cNvPr id="3" name="">
             <a:extLst xmlns:a="http://schemas.openxmlformats.org/drawingml/2006/main">
               <a:ext uri="{FF2B5EF4-FFF2-40B4-BE49-F238E27FC236}">
-                <a16:creationId xmlns:a16="http://schemas.microsoft.com/office/drawing/2014/main" id="{C4A56AB6-80ED-4BFE-B599-7A5DE2C254FD}"/>
+                <a16:creationId xmlns:a16="http://schemas.microsoft.com/office/drawing/2014/main" id="{85BF327F-69EF-4527-879B-14317463BF2F}"/>
               </a:ext>
             </a:extLst>
           </p:cNvPr>
@@ -13245,7 +12780,7 @@
           <p:cNvPr id="4" name="">
             <a:extLst xmlns:a="http://schemas.openxmlformats.org/drawingml/2006/main">
               <a:ext uri="{FF2B5EF4-FFF2-40B4-BE49-F238E27FC236}">
-                <a16:creationId xmlns:a16="http://schemas.microsoft.com/office/drawing/2014/main" id="{6E32240B-033A-4574-ADF0-92807F032DC5}"/>
+                <a16:creationId xmlns:a16="http://schemas.microsoft.com/office/drawing/2014/main" id="{44CC43A2-440F-455D-BC0B-D1D4BFE319F1}"/>
               </a:ext>
             </a:extLst>
           </p:cNvPr>
@@ -13280,7 +12815,7 @@
           <p:cNvPr id="5" name="">
             <a:extLst xmlns:a="http://schemas.openxmlformats.org/drawingml/2006/main">
               <a:ext uri="{FF2B5EF4-FFF2-40B4-BE49-F238E27FC236}">
-                <a16:creationId xmlns:a16="http://schemas.microsoft.com/office/drawing/2014/main" id="{3660EA82-DC1D-4220-BF5E-AEF3083F5132}"/>
+                <a16:creationId xmlns:a16="http://schemas.microsoft.com/office/drawing/2014/main" id="{D43A7649-0BAF-4B59-BA01-78C7F5C57819}"/>
               </a:ext>
             </a:extLst>
           </p:cNvPr>
@@ -13313,7 +12848,7 @@
           <p:cNvPr id="6" name="">
             <a:extLst xmlns:a="http://schemas.openxmlformats.org/drawingml/2006/main">
               <a:ext uri="{FF2B5EF4-FFF2-40B4-BE49-F238E27FC236}">
-                <a16:creationId xmlns:a16="http://schemas.microsoft.com/office/drawing/2014/main" id="{EC6F8332-55E8-4945-899F-4786EB945918}"/>
+                <a16:creationId xmlns:a16="http://schemas.microsoft.com/office/drawing/2014/main" id="{C8E7BF9C-28DD-4D5E-AB21-9133F5C58E4B}"/>
               </a:ext>
             </a:extLst>
           </p:cNvPr>
@@ -13371,7 +12906,7 @@
           <p:cNvPr id="7" name="">
             <a:extLst xmlns:a="http://schemas.openxmlformats.org/drawingml/2006/main">
               <a:ext uri="{FF2B5EF4-FFF2-40B4-BE49-F238E27FC236}">
-                <a16:creationId xmlns:a16="http://schemas.microsoft.com/office/drawing/2014/main" id="{DBE0582D-B9CC-49B3-8DB0-499EB0816B9B}"/>
+                <a16:creationId xmlns:a16="http://schemas.microsoft.com/office/drawing/2014/main" id="{7111F9CF-DA15-4F3A-9916-7A3CF8CDAFF3}"/>
               </a:ext>
             </a:extLst>
           </p:cNvPr>
@@ -13429,7 +12964,7 @@
           <p:cNvPr id="8" name="">
             <a:extLst xmlns:a="http://schemas.openxmlformats.org/drawingml/2006/main">
               <a:ext uri="{FF2B5EF4-FFF2-40B4-BE49-F238E27FC236}">
-                <a16:creationId xmlns:a16="http://schemas.microsoft.com/office/drawing/2014/main" id="{6579C5D5-604F-4173-A370-C43A0B744F64}"/>
+                <a16:creationId xmlns:a16="http://schemas.microsoft.com/office/drawing/2014/main" id="{4EF6A0AB-750F-42DF-9449-B1FDAA25E9F3}"/>
               </a:ext>
             </a:extLst>
           </p:cNvPr>
@@ -13504,7 +13039,7 @@
           <p:cNvPr id="9" name="">
             <a:extLst xmlns:a="http://schemas.openxmlformats.org/drawingml/2006/main">
               <a:ext uri="{FF2B5EF4-FFF2-40B4-BE49-F238E27FC236}">
-                <a16:creationId xmlns:a16="http://schemas.microsoft.com/office/drawing/2014/main" id="{597AFCA0-5F7A-4DDA-B378-304A9AFA34A0}"/>
+                <a16:creationId xmlns:a16="http://schemas.microsoft.com/office/drawing/2014/main" id="{8B873C49-831A-4F75-85E3-B1CA40CDFBE5}"/>
               </a:ext>
             </a:extLst>
           </p:cNvPr>
@@ -13537,7 +13072,7 @@
           <p:cNvPr id="10" name="">
             <a:extLst xmlns:a="http://schemas.openxmlformats.org/drawingml/2006/main">
               <a:ext uri="{FF2B5EF4-FFF2-40B4-BE49-F238E27FC236}">
-                <a16:creationId xmlns:a16="http://schemas.microsoft.com/office/drawing/2014/main" id="{D679F659-1E54-4A70-8157-204BE123909D}"/>
+                <a16:creationId xmlns:a16="http://schemas.microsoft.com/office/drawing/2014/main" id="{90EC484F-F594-4B3E-9A8C-A222CF475941}"/>
               </a:ext>
             </a:extLst>
           </p:cNvPr>
@@ -13572,7 +13107,7 @@
           <p:cNvPr id="11" name="">
             <a:extLst xmlns:a="http://schemas.openxmlformats.org/drawingml/2006/main">
               <a:ext uri="{FF2B5EF4-FFF2-40B4-BE49-F238E27FC236}">
-                <a16:creationId xmlns:a16="http://schemas.microsoft.com/office/drawing/2014/main" id="{FB284153-FEFC-42C7-9026-FE9C9CF2B1C6}"/>
+                <a16:creationId xmlns:a16="http://schemas.microsoft.com/office/drawing/2014/main" id="{31F505E1-9387-4455-841C-D2E203727EE4}"/>
               </a:ext>
             </a:extLst>
           </p:cNvPr>
@@ -13605,7 +13140,7 @@
           <p:cNvPr id="12" name="">
             <a:extLst xmlns:a="http://schemas.openxmlformats.org/drawingml/2006/main">
               <a:ext uri="{FF2B5EF4-FFF2-40B4-BE49-F238E27FC236}">
-                <a16:creationId xmlns:a16="http://schemas.microsoft.com/office/drawing/2014/main" id="{FDBB63A1-2463-4313-8ABA-A21384CDDA7D}"/>
+                <a16:creationId xmlns:a16="http://schemas.microsoft.com/office/drawing/2014/main" id="{EE5873C7-717A-4063-8A3F-9CCE74F55062}"/>
               </a:ext>
             </a:extLst>
           </p:cNvPr>
@@ -13663,7 +13198,7 @@
           <p:cNvPr id="13" name="">
             <a:extLst xmlns:a="http://schemas.openxmlformats.org/drawingml/2006/main">
               <a:ext uri="{FF2B5EF4-FFF2-40B4-BE49-F238E27FC236}">
-                <a16:creationId xmlns:a16="http://schemas.microsoft.com/office/drawing/2014/main" id="{9112D9E5-2087-4D30-ACF1-F6C67AE0BDC0}"/>
+                <a16:creationId xmlns:a16="http://schemas.microsoft.com/office/drawing/2014/main" id="{73770016-BB75-4965-A386-BF297D0E56A5}"/>
               </a:ext>
             </a:extLst>
           </p:cNvPr>
@@ -13721,7 +13256,7 @@
           <p:cNvPr id="14" name="">
             <a:extLst xmlns:a="http://schemas.openxmlformats.org/drawingml/2006/main">
               <a:ext uri="{FF2B5EF4-FFF2-40B4-BE49-F238E27FC236}">
-                <a16:creationId xmlns:a16="http://schemas.microsoft.com/office/drawing/2014/main" id="{6F19C03D-9E64-4F3C-A100-FAB760EB500B}"/>
+                <a16:creationId xmlns:a16="http://schemas.microsoft.com/office/drawing/2014/main" id="{BB66BDEB-3824-45D6-AE9E-A002EA17C38F}"/>
               </a:ext>
             </a:extLst>
           </p:cNvPr>
@@ -13796,7 +13331,7 @@
           <p:cNvPr id="15" name="">
             <a:extLst xmlns:a="http://schemas.openxmlformats.org/drawingml/2006/main">
               <a:ext uri="{FF2B5EF4-FFF2-40B4-BE49-F238E27FC236}">
-                <a16:creationId xmlns:a16="http://schemas.microsoft.com/office/drawing/2014/main" id="{A5B35921-5890-4CDB-869C-5FF670E5796E}"/>
+                <a16:creationId xmlns:a16="http://schemas.microsoft.com/office/drawing/2014/main" id="{97F73705-48CD-4A50-AF37-58137A1D566C}"/>
               </a:ext>
             </a:extLst>
           </p:cNvPr>
@@ -13829,7 +13364,7 @@
           <p:cNvPr id="16" name="">
             <a:extLst xmlns:a="http://schemas.openxmlformats.org/drawingml/2006/main">
               <a:ext uri="{FF2B5EF4-FFF2-40B4-BE49-F238E27FC236}">
-                <a16:creationId xmlns:a16="http://schemas.microsoft.com/office/drawing/2014/main" id="{0820E020-7F22-4F67-AEDB-D51B74D9B74A}"/>
+                <a16:creationId xmlns:a16="http://schemas.microsoft.com/office/drawing/2014/main" id="{EF105335-33B2-4077-A79F-526098C8E31A}"/>
               </a:ext>
             </a:extLst>
           </p:cNvPr>
@@ -13864,7 +13399,7 @@
           <p:cNvPr id="17" name="">
             <a:extLst xmlns:a="http://schemas.openxmlformats.org/drawingml/2006/main">
               <a:ext uri="{FF2B5EF4-FFF2-40B4-BE49-F238E27FC236}">
-                <a16:creationId xmlns:a16="http://schemas.microsoft.com/office/drawing/2014/main" id="{61FE36B4-8C91-45BE-9685-A6C5E23BAB2D}"/>
+                <a16:creationId xmlns:a16="http://schemas.microsoft.com/office/drawing/2014/main" id="{0F68677D-8559-4674-9888-35E5435B55A3}"/>
               </a:ext>
             </a:extLst>
           </p:cNvPr>
@@ -13897,7 +13432,7 @@
           <p:cNvPr id="18" name="">
             <a:extLst xmlns:a="http://schemas.openxmlformats.org/drawingml/2006/main">
               <a:ext uri="{FF2B5EF4-FFF2-40B4-BE49-F238E27FC236}">
-                <a16:creationId xmlns:a16="http://schemas.microsoft.com/office/drawing/2014/main" id="{A7232D52-9013-4DA4-8FF4-4B6F39636518}"/>
+                <a16:creationId xmlns:a16="http://schemas.microsoft.com/office/drawing/2014/main" id="{4026AD69-7BB5-4AA4-8F5F-00910999FB36}"/>
               </a:ext>
             </a:extLst>
           </p:cNvPr>
@@ -13955,7 +13490,7 @@
           <p:cNvPr id="19" name="">
             <a:extLst xmlns:a="http://schemas.openxmlformats.org/drawingml/2006/main">
               <a:ext uri="{FF2B5EF4-FFF2-40B4-BE49-F238E27FC236}">
-                <a16:creationId xmlns:a16="http://schemas.microsoft.com/office/drawing/2014/main" id="{F171B32B-FA55-455E-AC6F-43459315024F}"/>
+                <a16:creationId xmlns:a16="http://schemas.microsoft.com/office/drawing/2014/main" id="{CE54A6B4-E143-4380-A27A-D96AFDA0E6A0}"/>
               </a:ext>
             </a:extLst>
           </p:cNvPr>
@@ -14013,7 +13548,7 @@
           <p:cNvPr id="20" name="">
             <a:extLst xmlns:a="http://schemas.openxmlformats.org/drawingml/2006/main">
               <a:ext uri="{FF2B5EF4-FFF2-40B4-BE49-F238E27FC236}">
-                <a16:creationId xmlns:a16="http://schemas.microsoft.com/office/drawing/2014/main" id="{A435B6AF-BA57-4717-A746-61825E631756}"/>
+                <a16:creationId xmlns:a16="http://schemas.microsoft.com/office/drawing/2014/main" id="{3DFC2747-8483-42E7-A4C3-A9F1C7E83B60}"/>
               </a:ext>
             </a:extLst>
           </p:cNvPr>
@@ -14088,7 +13623,7 @@
           <p:cNvPr id="21" name="">
             <a:extLst xmlns:a="http://schemas.openxmlformats.org/drawingml/2006/main">
               <a:ext uri="{FF2B5EF4-FFF2-40B4-BE49-F238E27FC236}">
-                <a16:creationId xmlns:a16="http://schemas.microsoft.com/office/drawing/2014/main" id="{06E3BF07-EF3E-40B2-8C99-1FCFFC29289F}"/>
+                <a16:creationId xmlns:a16="http://schemas.microsoft.com/office/drawing/2014/main" id="{2B73B001-A1C3-4E38-8D0E-13C447176E16}"/>
               </a:ext>
             </a:extLst>
           </p:cNvPr>
@@ -14121,7 +13656,7 @@
           <p:cNvPr id="22" name="">
             <a:extLst xmlns:a="http://schemas.openxmlformats.org/drawingml/2006/main">
               <a:ext uri="{FF2B5EF4-FFF2-40B4-BE49-F238E27FC236}">
-                <a16:creationId xmlns:a16="http://schemas.microsoft.com/office/drawing/2014/main" id="{EC204EFA-C46E-4AF6-B37C-B1EC011CC450}"/>
+                <a16:creationId xmlns:a16="http://schemas.microsoft.com/office/drawing/2014/main" id="{0B6FEEAB-EBE7-4CB2-9C0D-DDF4508AF316}"/>
               </a:ext>
             </a:extLst>
           </p:cNvPr>
@@ -14156,7 +13691,7 @@
           <p:cNvPr id="23" name="">
             <a:extLst xmlns:a="http://schemas.openxmlformats.org/drawingml/2006/main">
               <a:ext uri="{FF2B5EF4-FFF2-40B4-BE49-F238E27FC236}">
-                <a16:creationId xmlns:a16="http://schemas.microsoft.com/office/drawing/2014/main" id="{A21FAA5C-C757-498B-BE43-8DCD3240A2BA}"/>
+                <a16:creationId xmlns:a16="http://schemas.microsoft.com/office/drawing/2014/main" id="{EADCA215-3E53-4C80-AE7C-E2D700BE3132}"/>
               </a:ext>
             </a:extLst>
           </p:cNvPr>
@@ -14189,7 +13724,7 @@
           <p:cNvPr id="24" name="">
             <a:extLst xmlns:a="http://schemas.openxmlformats.org/drawingml/2006/main">
               <a:ext uri="{FF2B5EF4-FFF2-40B4-BE49-F238E27FC236}">
-                <a16:creationId xmlns:a16="http://schemas.microsoft.com/office/drawing/2014/main" id="{059A037F-8158-441D-9FDA-B4568D12E6A1}"/>
+                <a16:creationId xmlns:a16="http://schemas.microsoft.com/office/drawing/2014/main" id="{C4772133-8B75-49EB-96C8-69F5A0C00ADF}"/>
               </a:ext>
             </a:extLst>
           </p:cNvPr>
@@ -14247,7 +13782,7 @@
           <p:cNvPr id="25" name="">
             <a:extLst xmlns:a="http://schemas.openxmlformats.org/drawingml/2006/main">
               <a:ext uri="{FF2B5EF4-FFF2-40B4-BE49-F238E27FC236}">
-                <a16:creationId xmlns:a16="http://schemas.microsoft.com/office/drawing/2014/main" id="{F9912C2C-CFFF-48FE-979E-EAC815C43B46}"/>
+                <a16:creationId xmlns:a16="http://schemas.microsoft.com/office/drawing/2014/main" id="{8963E169-2F4D-4991-9338-0648FA18457A}"/>
               </a:ext>
             </a:extLst>
           </p:cNvPr>
@@ -14305,7 +13840,7 @@
           <p:cNvPr id="26" name="">
             <a:extLst xmlns:a="http://schemas.openxmlformats.org/drawingml/2006/main">
               <a:ext uri="{FF2B5EF4-FFF2-40B4-BE49-F238E27FC236}">
-                <a16:creationId xmlns:a16="http://schemas.microsoft.com/office/drawing/2014/main" id="{83CB0D6B-D9AC-47D5-A97D-1586A56F46B1}"/>
+                <a16:creationId xmlns:a16="http://schemas.microsoft.com/office/drawing/2014/main" id="{E1C9E45C-C043-44A4-B3F4-61D49F1C41EE}"/>
               </a:ext>
             </a:extLst>
           </p:cNvPr>
@@ -14380,7 +13915,7 @@
           <p:cNvPr id="27" name="">
             <a:extLst xmlns:a="http://schemas.openxmlformats.org/drawingml/2006/main">
               <a:ext uri="{FF2B5EF4-FFF2-40B4-BE49-F238E27FC236}">
-                <a16:creationId xmlns:a16="http://schemas.microsoft.com/office/drawing/2014/main" id="{8682BD62-66C0-4965-9541-0FACAF5A281A}"/>
+                <a16:creationId xmlns:a16="http://schemas.microsoft.com/office/drawing/2014/main" id="{DED6F906-90BE-4BD7-A332-70AD2152CBE7}"/>
               </a:ext>
             </a:extLst>
           </p:cNvPr>
@@ -14413,7 +13948,7 @@
           <p:cNvPr id="28" name="">
             <a:extLst xmlns:a="http://schemas.openxmlformats.org/drawingml/2006/main">
               <a:ext uri="{FF2B5EF4-FFF2-40B4-BE49-F238E27FC236}">
-                <a16:creationId xmlns:a16="http://schemas.microsoft.com/office/drawing/2014/main" id="{6155C2A3-DDC9-4C8C-8FFD-E568206FAD1B}"/>
+                <a16:creationId xmlns:a16="http://schemas.microsoft.com/office/drawing/2014/main" id="{AF84FE14-DD30-42A2-924B-DBA3D0DDB493}"/>
               </a:ext>
             </a:extLst>
           </p:cNvPr>
@@ -14448,7 +13983,7 @@
           <p:cNvPr id="29" name="">
             <a:extLst xmlns:a="http://schemas.openxmlformats.org/drawingml/2006/main">
               <a:ext uri="{FF2B5EF4-FFF2-40B4-BE49-F238E27FC236}">
-                <a16:creationId xmlns:a16="http://schemas.microsoft.com/office/drawing/2014/main" id="{C41D7F10-7497-4CBE-8588-0735CC3A056B}"/>
+                <a16:creationId xmlns:a16="http://schemas.microsoft.com/office/drawing/2014/main" id="{44DF5A5D-1EC5-4E1B-B67E-87FCC19BC4BE}"/>
               </a:ext>
             </a:extLst>
           </p:cNvPr>
@@ -14481,7 +14016,7 @@
           <p:cNvPr id="30" name="">
             <a:extLst xmlns:a="http://schemas.openxmlformats.org/drawingml/2006/main">
               <a:ext uri="{FF2B5EF4-FFF2-40B4-BE49-F238E27FC236}">
-                <a16:creationId xmlns:a16="http://schemas.microsoft.com/office/drawing/2014/main" id="{7BF509AA-F715-43A1-BBFA-C1B7C4F8E4F0}"/>
+                <a16:creationId xmlns:a16="http://schemas.microsoft.com/office/drawing/2014/main" id="{9317BA63-D6DB-4581-BAD6-B0274FA8DB70}"/>
               </a:ext>
             </a:extLst>
           </p:cNvPr>
@@ -14539,7 +14074,7 @@
           <p:cNvPr id="31" name="">
             <a:extLst xmlns:a="http://schemas.openxmlformats.org/drawingml/2006/main">
               <a:ext uri="{FF2B5EF4-FFF2-40B4-BE49-F238E27FC236}">
-                <a16:creationId xmlns:a16="http://schemas.microsoft.com/office/drawing/2014/main" id="{239330A8-0696-4838-9FC2-3713233A6FCC}"/>
+                <a16:creationId xmlns:a16="http://schemas.microsoft.com/office/drawing/2014/main" id="{FE5A2E83-18DB-4EDF-8683-EF474EDEF84B}"/>
               </a:ext>
             </a:extLst>
           </p:cNvPr>
@@ -14597,7 +14132,7 @@
           <p:cNvPr id="32" name="">
             <a:extLst xmlns:a="http://schemas.openxmlformats.org/drawingml/2006/main">
               <a:ext uri="{FF2B5EF4-FFF2-40B4-BE49-F238E27FC236}">
-                <a16:creationId xmlns:a16="http://schemas.microsoft.com/office/drawing/2014/main" id="{C162D16E-DDB0-405E-9750-A5D0AACEB104}"/>
+                <a16:creationId xmlns:a16="http://schemas.microsoft.com/office/drawing/2014/main" id="{DC2F7C0C-6019-4D0F-9219-7FAD25FFA26A}"/>
               </a:ext>
             </a:extLst>
           </p:cNvPr>
@@ -14672,7 +14207,7 @@
           <p:cNvPr id="33" name="">
             <a:extLst xmlns:a="http://schemas.openxmlformats.org/drawingml/2006/main">
               <a:ext uri="{FF2B5EF4-FFF2-40B4-BE49-F238E27FC236}">
-                <a16:creationId xmlns:a16="http://schemas.microsoft.com/office/drawing/2014/main" id="{38ABE7FA-1DC9-4227-9322-86A1703A583B}"/>
+                <a16:creationId xmlns:a16="http://schemas.microsoft.com/office/drawing/2014/main" id="{11A67BBA-1CA4-463D-B917-D41C41A01900}"/>
               </a:ext>
             </a:extLst>
           </p:cNvPr>
@@ -14705,7 +14240,7 @@
           <p:cNvPr id="34" name="">
             <a:extLst xmlns:a="http://schemas.openxmlformats.org/drawingml/2006/main">
               <a:ext uri="{FF2B5EF4-FFF2-40B4-BE49-F238E27FC236}">
-                <a16:creationId xmlns:a16="http://schemas.microsoft.com/office/drawing/2014/main" id="{BA21CF44-4F4B-4990-AB81-15D5940FA3FA}"/>
+                <a16:creationId xmlns:a16="http://schemas.microsoft.com/office/drawing/2014/main" id="{D5CC5C59-AABF-4DE0-BC5B-31B8CB5987A3}"/>
               </a:ext>
             </a:extLst>
           </p:cNvPr>
@@ -14763,7 +14298,7 @@
           <p:cNvPr id="35" name="">
             <a:extLst xmlns:a="http://schemas.openxmlformats.org/drawingml/2006/main">
               <a:ext uri="{FF2B5EF4-FFF2-40B4-BE49-F238E27FC236}">
-                <a16:creationId xmlns:a16="http://schemas.microsoft.com/office/drawing/2014/main" id="{7E980AFF-2974-4C2C-BE67-BAA8451D681B}"/>
+                <a16:creationId xmlns:a16="http://schemas.microsoft.com/office/drawing/2014/main" id="{E4D203A5-BD8B-47A7-9FD1-33E0517EB836}"/>
               </a:ext>
             </a:extLst>
           </p:cNvPr>
@@ -14821,7 +14356,7 @@
           <p:cNvPr id="36" name="">
             <a:extLst xmlns:a="http://schemas.openxmlformats.org/drawingml/2006/main">
               <a:ext uri="{FF2B5EF4-FFF2-40B4-BE49-F238E27FC236}">
-                <a16:creationId xmlns:a16="http://schemas.microsoft.com/office/drawing/2014/main" id="{FB60180F-2A5F-4B91-97FB-37982FFAE021}"/>
+                <a16:creationId xmlns:a16="http://schemas.microsoft.com/office/drawing/2014/main" id="{DFD6F59D-6F55-494D-A944-301A2CAF44AB}"/>
               </a:ext>
             </a:extLst>
           </p:cNvPr>
@@ -14854,7 +14389,7 @@
           <p:cNvPr id="37" name="">
             <a:extLst xmlns:a="http://schemas.openxmlformats.org/drawingml/2006/main">
               <a:ext uri="{FF2B5EF4-FFF2-40B4-BE49-F238E27FC236}">
-                <a16:creationId xmlns:a16="http://schemas.microsoft.com/office/drawing/2014/main" id="{F07EE2D7-C226-4111-B1A9-8F85F9B5FE80}"/>
+                <a16:creationId xmlns:a16="http://schemas.microsoft.com/office/drawing/2014/main" id="{686D5BBF-7F16-4F66-B8A8-EC9E6056747B}"/>
               </a:ext>
             </a:extLst>
           </p:cNvPr>
@@ -14912,7 +14447,7 @@
           <p:cNvPr id="38" name="">
             <a:extLst xmlns:a="http://schemas.openxmlformats.org/drawingml/2006/main">
               <a:ext uri="{FF2B5EF4-FFF2-40B4-BE49-F238E27FC236}">
-                <a16:creationId xmlns:a16="http://schemas.microsoft.com/office/drawing/2014/main" id="{E2494538-C6D0-4118-94F4-7C4397FF5444}"/>
+                <a16:creationId xmlns:a16="http://schemas.microsoft.com/office/drawing/2014/main" id="{A6011247-33CD-4068-8475-26CFBAE9DD06}"/>
               </a:ext>
             </a:extLst>
           </p:cNvPr>
@@ -14968,7 +14503,7 @@
     </p:spTree>
     <p:extLst>
       <p:ext uri="{BB962C8B-B14F-4D97-AF65-F5344CB8AC3E}">
-        <p14:creationId xmlns:p14="http://schemas.microsoft.com/office/powerpoint/2010/main" val="1663289865"/>
+        <p14:creationId xmlns:p14="http://schemas.microsoft.com/office/powerpoint/2010/main" val="153761603"/>
       </p:ext>
     </p:extLst>
   </p:cSld>
@@ -14999,7 +14534,7 @@
           <p:cNvPr id="33" name="">
             <a:extLst xmlns:a="http://schemas.openxmlformats.org/drawingml/2006/main">
               <a:ext uri="{FF2B5EF4-FFF2-40B4-BE49-F238E27FC236}">
-                <a16:creationId xmlns:a16="http://schemas.microsoft.com/office/drawing/2014/main" id="{8C677D16-D9E1-4D67-85DD-FD7733649DFC}"/>
+                <a16:creationId xmlns:a16="http://schemas.microsoft.com/office/drawing/2014/main" id="{DDAAF8D5-82C2-4DC0-BD2A-94DDE51F9D27}"/>
               </a:ext>
             </a:extLst>
           </p:cNvPr>
@@ -15057,7 +14592,7 @@
           <p:cNvPr id="2" name="">
             <a:extLst xmlns:a="http://schemas.openxmlformats.org/drawingml/2006/main">
               <a:ext uri="{FF2B5EF4-FFF2-40B4-BE49-F238E27FC236}">
-                <a16:creationId xmlns:a16="http://schemas.microsoft.com/office/drawing/2014/main" id="{65301B05-2A21-4479-89A1-4A45461065E0}"/>
+                <a16:creationId xmlns:a16="http://schemas.microsoft.com/office/drawing/2014/main" id="{B6988AAF-B0F8-4F70-89DA-EA67F144D929}"/>
               </a:ext>
             </a:extLst>
           </p:cNvPr>
@@ -15115,7 +14650,7 @@
           <p:cNvPr id="3" name="">
             <a:extLst xmlns:a="http://schemas.openxmlformats.org/drawingml/2006/main">
               <a:ext uri="{FF2B5EF4-FFF2-40B4-BE49-F238E27FC236}">
-                <a16:creationId xmlns:a16="http://schemas.microsoft.com/office/drawing/2014/main" id="{690C99CD-DF2C-4ABE-AEB3-EF622F497147}"/>
+                <a16:creationId xmlns:a16="http://schemas.microsoft.com/office/drawing/2014/main" id="{AEA1A10E-19AC-4035-B68E-BE41634F28F7}"/>
               </a:ext>
             </a:extLst>
           </p:cNvPr>
@@ -15173,7 +14708,7 @@
           <p:cNvPr id="4" name="">
             <a:extLst xmlns:a="http://schemas.openxmlformats.org/drawingml/2006/main">
               <a:ext uri="{FF2B5EF4-FFF2-40B4-BE49-F238E27FC236}">
-                <a16:creationId xmlns:a16="http://schemas.microsoft.com/office/drawing/2014/main" id="{488DCC29-E172-463B-9349-E12DE8FCE4E4}"/>
+                <a16:creationId xmlns:a16="http://schemas.microsoft.com/office/drawing/2014/main" id="{DF969CB8-CA97-4F95-9BD1-3B39C3A152FD}"/>
               </a:ext>
             </a:extLst>
           </p:cNvPr>
@@ -15208,7 +14743,7 @@
           <p:cNvPr id="5" name="">
             <a:extLst xmlns:a="http://schemas.openxmlformats.org/drawingml/2006/main">
               <a:ext uri="{FF2B5EF4-FFF2-40B4-BE49-F238E27FC236}">
-                <a16:creationId xmlns:a16="http://schemas.microsoft.com/office/drawing/2014/main" id="{E7C85C1A-5B77-41FF-9C9F-ACEC8871EB2B}"/>
+                <a16:creationId xmlns:a16="http://schemas.microsoft.com/office/drawing/2014/main" id="{63204186-5891-4845-9C19-5561CCEDF69C}"/>
               </a:ext>
             </a:extLst>
           </p:cNvPr>
@@ -15266,7 +14801,7 @@
           <p:cNvPr id="6" name="">
             <a:extLst xmlns:a="http://schemas.openxmlformats.org/drawingml/2006/main">
               <a:ext uri="{FF2B5EF4-FFF2-40B4-BE49-F238E27FC236}">
-                <a16:creationId xmlns:a16="http://schemas.microsoft.com/office/drawing/2014/main" id="{B984CB73-92BE-42FB-84C3-D507DDB07279}"/>
+                <a16:creationId xmlns:a16="http://schemas.microsoft.com/office/drawing/2014/main" id="{3DB688B4-3E91-4C14-8B7E-C42E72AA156A}"/>
               </a:ext>
             </a:extLst>
           </p:cNvPr>
@@ -15299,7 +14834,7 @@
           <p:cNvPr id="7" name="">
             <a:extLst xmlns:a="http://schemas.openxmlformats.org/drawingml/2006/main">
               <a:ext uri="{FF2B5EF4-FFF2-40B4-BE49-F238E27FC236}">
-                <a16:creationId xmlns:a16="http://schemas.microsoft.com/office/drawing/2014/main" id="{8DFFA8AE-453C-4C21-9428-2D4F797DAF77}"/>
+                <a16:creationId xmlns:a16="http://schemas.microsoft.com/office/drawing/2014/main" id="{08C68AFB-4B2C-484D-8F33-C13FB5FCD7EA}"/>
               </a:ext>
             </a:extLst>
           </p:cNvPr>
@@ -15357,7 +14892,7 @@
           <p:cNvPr id="8" name="">
             <a:extLst xmlns:a="http://schemas.openxmlformats.org/drawingml/2006/main">
               <a:ext uri="{FF2B5EF4-FFF2-40B4-BE49-F238E27FC236}">
-                <a16:creationId xmlns:a16="http://schemas.microsoft.com/office/drawing/2014/main" id="{08E75336-52D9-4B6B-BF5F-4AF93F15A200}"/>
+                <a16:creationId xmlns:a16="http://schemas.microsoft.com/office/drawing/2014/main" id="{2C9C59A9-ABFE-4D72-9DF5-60FAACA2FEFF}"/>
               </a:ext>
             </a:extLst>
           </p:cNvPr>
@@ -15390,7 +14925,7 @@
           <p:cNvPr id="9" name="">
             <a:extLst xmlns:a="http://schemas.openxmlformats.org/drawingml/2006/main">
               <a:ext uri="{FF2B5EF4-FFF2-40B4-BE49-F238E27FC236}">
-                <a16:creationId xmlns:a16="http://schemas.microsoft.com/office/drawing/2014/main" id="{6CCE157A-5046-439C-8EE4-FCC7F7B33B80}"/>
+                <a16:creationId xmlns:a16="http://schemas.microsoft.com/office/drawing/2014/main" id="{B6CB383E-B51C-4A9F-A6E6-DD635813FB98}"/>
               </a:ext>
             </a:extLst>
           </p:cNvPr>
@@ -15448,7 +14983,7 @@
           <p:cNvPr id="10" name="">
             <a:extLst xmlns:a="http://schemas.openxmlformats.org/drawingml/2006/main">
               <a:ext uri="{FF2B5EF4-FFF2-40B4-BE49-F238E27FC236}">
-                <a16:creationId xmlns:a16="http://schemas.microsoft.com/office/drawing/2014/main" id="{241E1CCD-D8CB-492A-A55C-40D866916F88}"/>
+                <a16:creationId xmlns:a16="http://schemas.microsoft.com/office/drawing/2014/main" id="{509542F0-7B34-4EC6-AF2C-B5C51B7A30D4}"/>
               </a:ext>
             </a:extLst>
           </p:cNvPr>
@@ -15481,7 +15016,7 @@
           <p:cNvPr id="11" name="">
             <a:extLst xmlns:a="http://schemas.openxmlformats.org/drawingml/2006/main">
               <a:ext uri="{FF2B5EF4-FFF2-40B4-BE49-F238E27FC236}">
-                <a16:creationId xmlns:a16="http://schemas.microsoft.com/office/drawing/2014/main" id="{C8E3E927-A992-49B7-AC1A-5EE5E6A896E2}"/>
+                <a16:creationId xmlns:a16="http://schemas.microsoft.com/office/drawing/2014/main" id="{7094D106-615B-495E-A7E6-95FDC7A8E0E6}"/>
               </a:ext>
             </a:extLst>
           </p:cNvPr>
@@ -15539,7 +15074,7 @@
           <p:cNvPr id="12" name="">
             <a:extLst xmlns:a="http://schemas.openxmlformats.org/drawingml/2006/main">
               <a:ext uri="{FF2B5EF4-FFF2-40B4-BE49-F238E27FC236}">
-                <a16:creationId xmlns:a16="http://schemas.microsoft.com/office/drawing/2014/main" id="{A8CD82EB-A923-42AF-BE90-2C54EBD6C425}"/>
+                <a16:creationId xmlns:a16="http://schemas.microsoft.com/office/drawing/2014/main" id="{711D5A02-B96B-4F1C-B7E5-6D29FE2E142F}"/>
               </a:ext>
             </a:extLst>
           </p:cNvPr>
@@ -15574,7 +15109,7 @@
           <p:cNvPr id="13" name="">
             <a:extLst xmlns:a="http://schemas.openxmlformats.org/drawingml/2006/main">
               <a:ext uri="{FF2B5EF4-FFF2-40B4-BE49-F238E27FC236}">
-                <a16:creationId xmlns:a16="http://schemas.microsoft.com/office/drawing/2014/main" id="{8C1EE8DC-DCD2-4084-9542-FE8B686D3A8D}"/>
+                <a16:creationId xmlns:a16="http://schemas.microsoft.com/office/drawing/2014/main" id="{50B45C3C-3BC7-498B-86F4-17DF59A5A06E}"/>
               </a:ext>
             </a:extLst>
           </p:cNvPr>
@@ -15632,7 +15167,7 @@
           <p:cNvPr id="14" name="">
             <a:extLst xmlns:a="http://schemas.openxmlformats.org/drawingml/2006/main">
               <a:ext uri="{FF2B5EF4-FFF2-40B4-BE49-F238E27FC236}">
-                <a16:creationId xmlns:a16="http://schemas.microsoft.com/office/drawing/2014/main" id="{996BA455-BF60-49FE-A00C-FDE07572A8AC}"/>
+                <a16:creationId xmlns:a16="http://schemas.microsoft.com/office/drawing/2014/main" id="{4D0CA5C8-A76C-4ABE-A4A1-234D036BC799}"/>
               </a:ext>
             </a:extLst>
           </p:cNvPr>
@@ -15667,7 +15202,7 @@
           <p:cNvPr id="15" name="">
             <a:extLst xmlns:a="http://schemas.openxmlformats.org/drawingml/2006/main">
               <a:ext uri="{FF2B5EF4-FFF2-40B4-BE49-F238E27FC236}">
-                <a16:creationId xmlns:a16="http://schemas.microsoft.com/office/drawing/2014/main" id="{6FFE6A08-ED6E-42E0-9DB1-0238D5F5AB64}"/>
+                <a16:creationId xmlns:a16="http://schemas.microsoft.com/office/drawing/2014/main" id="{D042A471-41A5-4524-9D8F-EA6209A24985}"/>
               </a:ext>
             </a:extLst>
           </p:cNvPr>
@@ -15700,7 +15235,7 @@
           <p:cNvPr id="16" name="">
             <a:extLst xmlns:a="http://schemas.openxmlformats.org/drawingml/2006/main">
               <a:ext uri="{FF2B5EF4-FFF2-40B4-BE49-F238E27FC236}">
-                <a16:creationId xmlns:a16="http://schemas.microsoft.com/office/drawing/2014/main" id="{0A9475F0-6D8B-444A-99A0-C00493A4806C}"/>
+                <a16:creationId xmlns:a16="http://schemas.microsoft.com/office/drawing/2014/main" id="{F8B4DDE7-CF4D-4B1E-BBDA-FC80669B78DD}"/>
               </a:ext>
             </a:extLst>
           </p:cNvPr>
@@ -15758,7 +15293,7 @@
           <p:cNvPr id="17" name="">
             <a:extLst xmlns:a="http://schemas.openxmlformats.org/drawingml/2006/main">
               <a:ext uri="{FF2B5EF4-FFF2-40B4-BE49-F238E27FC236}">
-                <a16:creationId xmlns:a16="http://schemas.microsoft.com/office/drawing/2014/main" id="{23326F50-663C-4347-BB73-74F9ED59D1D5}"/>
+                <a16:creationId xmlns:a16="http://schemas.microsoft.com/office/drawing/2014/main" id="{203C5797-FDD4-4A85-91B9-FBA39808D39D}"/>
               </a:ext>
             </a:extLst>
           </p:cNvPr>
@@ -15816,7 +15351,7 @@
           <p:cNvPr id="18" name="">
             <a:extLst xmlns:a="http://schemas.openxmlformats.org/drawingml/2006/main">
               <a:ext uri="{FF2B5EF4-FFF2-40B4-BE49-F238E27FC236}">
-                <a16:creationId xmlns:a16="http://schemas.microsoft.com/office/drawing/2014/main" id="{5A05371D-E9E8-4F90-A2D7-97B635074395}"/>
+                <a16:creationId xmlns:a16="http://schemas.microsoft.com/office/drawing/2014/main" id="{A12F67AF-180A-44A4-A8CE-DFD7E9C7D061}"/>
               </a:ext>
             </a:extLst>
           </p:cNvPr>
@@ -15851,7 +15386,7 @@
           <p:cNvPr id="19" name="">
             <a:extLst xmlns:a="http://schemas.openxmlformats.org/drawingml/2006/main">
               <a:ext uri="{FF2B5EF4-FFF2-40B4-BE49-F238E27FC236}">
-                <a16:creationId xmlns:a16="http://schemas.microsoft.com/office/drawing/2014/main" id="{C8D6EDEB-D6B8-4A1F-9069-50F39EB1EECE}"/>
+                <a16:creationId xmlns:a16="http://schemas.microsoft.com/office/drawing/2014/main" id="{E3876074-08F5-4FC1-B647-3E26A0CBEF11}"/>
               </a:ext>
             </a:extLst>
           </p:cNvPr>
@@ -15884,7 +15419,7 @@
           <p:cNvPr id="20" name="">
             <a:extLst xmlns:a="http://schemas.openxmlformats.org/drawingml/2006/main">
               <a:ext uri="{FF2B5EF4-FFF2-40B4-BE49-F238E27FC236}">
-                <a16:creationId xmlns:a16="http://schemas.microsoft.com/office/drawing/2014/main" id="{96B5A3DC-22AD-40FC-BEAA-8F3960770820}"/>
+                <a16:creationId xmlns:a16="http://schemas.microsoft.com/office/drawing/2014/main" id="{510862B2-EFF9-493F-A020-0A5815435BE4}"/>
               </a:ext>
             </a:extLst>
           </p:cNvPr>
@@ -15942,7 +15477,7 @@
           <p:cNvPr id="21" name="">
             <a:extLst xmlns:a="http://schemas.openxmlformats.org/drawingml/2006/main">
               <a:ext uri="{FF2B5EF4-FFF2-40B4-BE49-F238E27FC236}">
-                <a16:creationId xmlns:a16="http://schemas.microsoft.com/office/drawing/2014/main" id="{501660FB-E817-427D-9C26-DECA826A54DB}"/>
+                <a16:creationId xmlns:a16="http://schemas.microsoft.com/office/drawing/2014/main" id="{97D585F3-81B6-4045-A5A4-93A18D710579}"/>
               </a:ext>
             </a:extLst>
           </p:cNvPr>
@@ -16000,7 +15535,7 @@
           <p:cNvPr id="22" name="">
             <a:extLst xmlns:a="http://schemas.openxmlformats.org/drawingml/2006/main">
               <a:ext uri="{FF2B5EF4-FFF2-40B4-BE49-F238E27FC236}">
-                <a16:creationId xmlns:a16="http://schemas.microsoft.com/office/drawing/2014/main" id="{AE079F8C-FEB8-4BF7-8C44-85D6E6212EC8}"/>
+                <a16:creationId xmlns:a16="http://schemas.microsoft.com/office/drawing/2014/main" id="{494C3E5D-C12B-416F-B8CE-8AA3C9EDF319}"/>
               </a:ext>
             </a:extLst>
           </p:cNvPr>
@@ -16035,7 +15570,7 @@
           <p:cNvPr id="23" name="">
             <a:extLst xmlns:a="http://schemas.openxmlformats.org/drawingml/2006/main">
               <a:ext uri="{FF2B5EF4-FFF2-40B4-BE49-F238E27FC236}">
-                <a16:creationId xmlns:a16="http://schemas.microsoft.com/office/drawing/2014/main" id="{DB5F0082-77F6-4E12-8496-A300BDC6F317}"/>
+                <a16:creationId xmlns:a16="http://schemas.microsoft.com/office/drawing/2014/main" id="{2D9463A6-69EB-4185-A938-D9ADBE1088A8}"/>
               </a:ext>
             </a:extLst>
           </p:cNvPr>
@@ -16068,7 +15603,7 @@
           <p:cNvPr id="24" name="">
             <a:extLst xmlns:a="http://schemas.openxmlformats.org/drawingml/2006/main">
               <a:ext uri="{FF2B5EF4-FFF2-40B4-BE49-F238E27FC236}">
-                <a16:creationId xmlns:a16="http://schemas.microsoft.com/office/drawing/2014/main" id="{FB2BEF09-6E14-4DF2-A8D9-5F0679FB3293}"/>
+                <a16:creationId xmlns:a16="http://schemas.microsoft.com/office/drawing/2014/main" id="{42362C6A-2376-4897-BE19-4B21FF8F9064}"/>
               </a:ext>
             </a:extLst>
           </p:cNvPr>
@@ -16126,7 +15661,7 @@
           <p:cNvPr id="25" name="">
             <a:extLst xmlns:a="http://schemas.openxmlformats.org/drawingml/2006/main">
               <a:ext uri="{FF2B5EF4-FFF2-40B4-BE49-F238E27FC236}">
-                <a16:creationId xmlns:a16="http://schemas.microsoft.com/office/drawing/2014/main" id="{28550441-4F11-45DF-A4B4-B8242133203C}"/>
+                <a16:creationId xmlns:a16="http://schemas.microsoft.com/office/drawing/2014/main" id="{C5523788-A77B-46CF-B912-C2EE79543527}"/>
               </a:ext>
             </a:extLst>
           </p:cNvPr>
@@ -16184,7 +15719,7 @@
           <p:cNvPr id="26" name="">
             <a:extLst xmlns:a="http://schemas.openxmlformats.org/drawingml/2006/main">
               <a:ext uri="{FF2B5EF4-FFF2-40B4-BE49-F238E27FC236}">
-                <a16:creationId xmlns:a16="http://schemas.microsoft.com/office/drawing/2014/main" id="{D6C0146B-7F82-4212-85B8-C3754C45BB3C}"/>
+                <a16:creationId xmlns:a16="http://schemas.microsoft.com/office/drawing/2014/main" id="{76FAE7B8-DF70-4096-9720-7736640AE954}"/>
               </a:ext>
             </a:extLst>
           </p:cNvPr>
@@ -16242,7 +15777,7 @@
           <p:cNvPr id="27" name="">
             <a:extLst xmlns:a="http://schemas.openxmlformats.org/drawingml/2006/main">
               <a:ext uri="{FF2B5EF4-FFF2-40B4-BE49-F238E27FC236}">
-                <a16:creationId xmlns:a16="http://schemas.microsoft.com/office/drawing/2014/main" id="{E0015F86-5ACB-45FA-821F-61AE02E7065A}"/>
+                <a16:creationId xmlns:a16="http://schemas.microsoft.com/office/drawing/2014/main" id="{7BD4084E-ECF0-490A-92BE-AE5C0E098DD1}"/>
               </a:ext>
             </a:extLst>
           </p:cNvPr>
@@ -16275,7 +15810,7 @@
           <p:cNvPr id="28" name="">
             <a:extLst xmlns:a="http://schemas.openxmlformats.org/drawingml/2006/main">
               <a:ext uri="{FF2B5EF4-FFF2-40B4-BE49-F238E27FC236}">
-                <a16:creationId xmlns:a16="http://schemas.microsoft.com/office/drawing/2014/main" id="{28523700-0E54-458B-93ED-D371CFC3C360}"/>
+                <a16:creationId xmlns:a16="http://schemas.microsoft.com/office/drawing/2014/main" id="{26E2C3A0-8296-42AA-86DA-E28E526B55F0}"/>
               </a:ext>
             </a:extLst>
           </p:cNvPr>
@@ -16333,7 +15868,7 @@
           <p:cNvPr id="29" name="">
             <a:extLst xmlns:a="http://schemas.openxmlformats.org/drawingml/2006/main">
               <a:ext uri="{FF2B5EF4-FFF2-40B4-BE49-F238E27FC236}">
-                <a16:creationId xmlns:a16="http://schemas.microsoft.com/office/drawing/2014/main" id="{EEAD5FA1-8E3E-4954-B3EE-18E5B38194F8}"/>
+                <a16:creationId xmlns:a16="http://schemas.microsoft.com/office/drawing/2014/main" id="{2E78EA7E-C92D-4FF2-B1AA-B2164A204DD8}"/>
               </a:ext>
             </a:extLst>
           </p:cNvPr>
@@ -16391,7 +15926,7 @@
           <p:cNvPr id="30" name="">
             <a:extLst xmlns:a="http://schemas.openxmlformats.org/drawingml/2006/main">
               <a:ext uri="{FF2B5EF4-FFF2-40B4-BE49-F238E27FC236}">
-                <a16:creationId xmlns:a16="http://schemas.microsoft.com/office/drawing/2014/main" id="{2B5B5F14-DBE1-4538-904B-8348416B454B}"/>
+                <a16:creationId xmlns:a16="http://schemas.microsoft.com/office/drawing/2014/main" id="{B21F51D8-89AB-4BFE-985E-8605B39B2C42}"/>
               </a:ext>
             </a:extLst>
           </p:cNvPr>
@@ -16424,7 +15959,7 @@
           <p:cNvPr id="31" name="">
             <a:extLst xmlns:a="http://schemas.openxmlformats.org/drawingml/2006/main">
               <a:ext uri="{FF2B5EF4-FFF2-40B4-BE49-F238E27FC236}">
-                <a16:creationId xmlns:a16="http://schemas.microsoft.com/office/drawing/2014/main" id="{7B18B0BE-EEC7-41A6-A1EF-6CDA38330F18}"/>
+                <a16:creationId xmlns:a16="http://schemas.microsoft.com/office/drawing/2014/main" id="{EBEA9D64-A52F-4996-B914-245063A915FB}"/>
               </a:ext>
             </a:extLst>
           </p:cNvPr>
@@ -16482,7 +16017,7 @@
           <p:cNvPr id="32" name="">
             <a:extLst xmlns:a="http://schemas.openxmlformats.org/drawingml/2006/main">
               <a:ext uri="{FF2B5EF4-FFF2-40B4-BE49-F238E27FC236}">
-                <a16:creationId xmlns:a16="http://schemas.microsoft.com/office/drawing/2014/main" id="{4015C50D-0E35-4440-B24D-554B7D927995}"/>
+                <a16:creationId xmlns:a16="http://schemas.microsoft.com/office/drawing/2014/main" id="{168CD0F4-AC23-469E-9306-91DB2A421417}"/>
               </a:ext>
             </a:extLst>
           </p:cNvPr>
@@ -16538,7 +16073,7 @@
     </p:spTree>
     <p:extLst>
       <p:ext uri="{BB962C8B-B14F-4D97-AF65-F5344CB8AC3E}">
-        <p14:creationId xmlns:p14="http://schemas.microsoft.com/office/powerpoint/2010/main" val="309338846"/>
+        <p14:creationId xmlns:p14="http://schemas.microsoft.com/office/powerpoint/2010/main" val="654697449"/>
       </p:ext>
     </p:extLst>
   </p:cSld>
@@ -16569,7 +16104,7 @@
           <p:cNvPr id="32" name="">
             <a:extLst xmlns:a="http://schemas.openxmlformats.org/drawingml/2006/main">
               <a:ext uri="{FF2B5EF4-FFF2-40B4-BE49-F238E27FC236}">
-                <a16:creationId xmlns:a16="http://schemas.microsoft.com/office/drawing/2014/main" id="{B64BF4EB-5E6A-419B-9C44-AF731FB9BB45}"/>
+                <a16:creationId xmlns:a16="http://schemas.microsoft.com/office/drawing/2014/main" id="{A92C8B5D-BA3B-4FE8-A803-8EE12DB06ADB}"/>
               </a:ext>
             </a:extLst>
           </p:cNvPr>
@@ -16627,7 +16162,7 @@
           <p:cNvPr id="2" name="">
             <a:extLst xmlns:a="http://schemas.openxmlformats.org/drawingml/2006/main">
               <a:ext uri="{FF2B5EF4-FFF2-40B4-BE49-F238E27FC236}">
-                <a16:creationId xmlns:a16="http://schemas.microsoft.com/office/drawing/2014/main" id="{C381A109-4A85-4D45-AB48-12C86B234E37}"/>
+                <a16:creationId xmlns:a16="http://schemas.microsoft.com/office/drawing/2014/main" id="{5A4BCC52-9161-4EA5-965A-624C98E80DAB}"/>
               </a:ext>
             </a:extLst>
           </p:cNvPr>
@@ -16685,7 +16220,7 @@
           <p:cNvPr id="3" name="">
             <a:extLst xmlns:a="http://schemas.openxmlformats.org/drawingml/2006/main">
               <a:ext uri="{FF2B5EF4-FFF2-40B4-BE49-F238E27FC236}">
-                <a16:creationId xmlns:a16="http://schemas.microsoft.com/office/drawing/2014/main" id="{AA830DE1-8D2C-48F1-8309-01C1CAA7BCDB}"/>
+                <a16:creationId xmlns:a16="http://schemas.microsoft.com/office/drawing/2014/main" id="{BE04F21B-C1E4-45C6-BD20-40C1F36D2CEE}"/>
               </a:ext>
             </a:extLst>
           </p:cNvPr>
@@ -16743,7 +16278,7 @@
           <p:cNvPr id="4" name="">
             <a:extLst xmlns:a="http://schemas.openxmlformats.org/drawingml/2006/main">
               <a:ext uri="{FF2B5EF4-FFF2-40B4-BE49-F238E27FC236}">
-                <a16:creationId xmlns:a16="http://schemas.microsoft.com/office/drawing/2014/main" id="{8807F6FF-6DA4-4D25-BA5C-F0FEF9DA9C90}"/>
+                <a16:creationId xmlns:a16="http://schemas.microsoft.com/office/drawing/2014/main" id="{202171EC-EF72-4AE5-BB66-71DE0F75748B}"/>
               </a:ext>
             </a:extLst>
           </p:cNvPr>
@@ -16776,7 +16311,7 @@
           <p:cNvPr id="5" name="">
             <a:extLst xmlns:a="http://schemas.openxmlformats.org/drawingml/2006/main">
               <a:ext uri="{FF2B5EF4-FFF2-40B4-BE49-F238E27FC236}">
-                <a16:creationId xmlns:a16="http://schemas.microsoft.com/office/drawing/2014/main" id="{E0D001CC-3B8D-4563-9987-E96129260A74}"/>
+                <a16:creationId xmlns:a16="http://schemas.microsoft.com/office/drawing/2014/main" id="{BCC77917-EB82-4033-BEEC-C386F7CAFD00}"/>
               </a:ext>
             </a:extLst>
           </p:cNvPr>
@@ -16834,7 +16369,7 @@
           <p:cNvPr id="6" name="">
             <a:extLst xmlns:a="http://schemas.openxmlformats.org/drawingml/2006/main">
               <a:ext uri="{FF2B5EF4-FFF2-40B4-BE49-F238E27FC236}">
-                <a16:creationId xmlns:a16="http://schemas.microsoft.com/office/drawing/2014/main" id="{7147C6DF-A1E0-41B5-8C74-755E0EA7997C}"/>
+                <a16:creationId xmlns:a16="http://schemas.microsoft.com/office/drawing/2014/main" id="{E830F6EF-2F99-4834-B94A-4BBB4D04D2DC}"/>
               </a:ext>
             </a:extLst>
           </p:cNvPr>
@@ -16892,7 +16427,7 @@
           <p:cNvPr id="7" name="">
             <a:extLst xmlns:a="http://schemas.openxmlformats.org/drawingml/2006/main">
               <a:ext uri="{FF2B5EF4-FFF2-40B4-BE49-F238E27FC236}">
-                <a16:creationId xmlns:a16="http://schemas.microsoft.com/office/drawing/2014/main" id="{1B7704ED-E26F-4968-9AF1-52CEBBBA44AD}"/>
+                <a16:creationId xmlns:a16="http://schemas.microsoft.com/office/drawing/2014/main" id="{74C26426-C5C8-4021-AB04-66F9F1E0E539}"/>
               </a:ext>
             </a:extLst>
           </p:cNvPr>
@@ -16950,7 +16485,7 @@
           <p:cNvPr id="8" name="">
             <a:extLst xmlns:a="http://schemas.openxmlformats.org/drawingml/2006/main">
               <a:ext uri="{FF2B5EF4-FFF2-40B4-BE49-F238E27FC236}">
-                <a16:creationId xmlns:a16="http://schemas.microsoft.com/office/drawing/2014/main" id="{EEB9A746-B22E-4D94-9D7A-16995E9FE0ED}"/>
+                <a16:creationId xmlns:a16="http://schemas.microsoft.com/office/drawing/2014/main" id="{B00919EE-C24C-4EE3-BA14-280888F6D070}"/>
               </a:ext>
             </a:extLst>
           </p:cNvPr>
@@ -16983,7 +16518,7 @@
           <p:cNvPr id="9" name="">
             <a:extLst xmlns:a="http://schemas.openxmlformats.org/drawingml/2006/main">
               <a:ext uri="{FF2B5EF4-FFF2-40B4-BE49-F238E27FC236}">
-                <a16:creationId xmlns:a16="http://schemas.microsoft.com/office/drawing/2014/main" id="{F733A41B-4749-4FDC-B7AE-F152C0BC2D1A}"/>
+                <a16:creationId xmlns:a16="http://schemas.microsoft.com/office/drawing/2014/main" id="{7F8129F2-3CF8-438B-BC54-24140B56C64A}"/>
               </a:ext>
             </a:extLst>
           </p:cNvPr>
@@ -17041,7 +16576,7 @@
           <p:cNvPr id="10" name="">
             <a:extLst xmlns:a="http://schemas.openxmlformats.org/drawingml/2006/main">
               <a:ext uri="{FF2B5EF4-FFF2-40B4-BE49-F238E27FC236}">
-                <a16:creationId xmlns:a16="http://schemas.microsoft.com/office/drawing/2014/main" id="{CBB57A84-9DB4-4F8C-87B1-8F7FC7D3CCEB}"/>
+                <a16:creationId xmlns:a16="http://schemas.microsoft.com/office/drawing/2014/main" id="{4792AD28-CCF8-4353-BB39-7E6757749DBB}"/>
               </a:ext>
             </a:extLst>
           </p:cNvPr>
@@ -17099,7 +16634,7 @@
           <p:cNvPr id="11" name="">
             <a:extLst xmlns:a="http://schemas.openxmlformats.org/drawingml/2006/main">
               <a:ext uri="{FF2B5EF4-FFF2-40B4-BE49-F238E27FC236}">
-                <a16:creationId xmlns:a16="http://schemas.microsoft.com/office/drawing/2014/main" id="{0420386F-A883-4ACB-92F1-66F7F9C12594}"/>
+                <a16:creationId xmlns:a16="http://schemas.microsoft.com/office/drawing/2014/main" id="{56DDCCB8-DED8-450A-BBAD-64B1DA18A3A0}"/>
               </a:ext>
             </a:extLst>
           </p:cNvPr>
@@ -17157,7 +16692,7 @@
           <p:cNvPr id="12" name="">
             <a:extLst xmlns:a="http://schemas.openxmlformats.org/drawingml/2006/main">
               <a:ext uri="{FF2B5EF4-FFF2-40B4-BE49-F238E27FC236}">
-                <a16:creationId xmlns:a16="http://schemas.microsoft.com/office/drawing/2014/main" id="{44749040-6D08-481E-9A92-D0B6FD43AB42}"/>
+                <a16:creationId xmlns:a16="http://schemas.microsoft.com/office/drawing/2014/main" id="{8BDDD8C1-9A73-4426-8A08-0B75BBDA0D88}"/>
               </a:ext>
             </a:extLst>
           </p:cNvPr>
@@ -17190,7 +16725,7 @@
           <p:cNvPr id="13" name="">
             <a:extLst xmlns:a="http://schemas.openxmlformats.org/drawingml/2006/main">
               <a:ext uri="{FF2B5EF4-FFF2-40B4-BE49-F238E27FC236}">
-                <a16:creationId xmlns:a16="http://schemas.microsoft.com/office/drawing/2014/main" id="{AB80FE97-6119-4DF6-A529-21E70B3EC16D}"/>
+                <a16:creationId xmlns:a16="http://schemas.microsoft.com/office/drawing/2014/main" id="{759DF1CB-D677-4E85-B93E-17C3F1522FF5}"/>
               </a:ext>
             </a:extLst>
           </p:cNvPr>
@@ -17248,7 +16783,7 @@
           <p:cNvPr id="14" name="">
             <a:extLst xmlns:a="http://schemas.openxmlformats.org/drawingml/2006/main">
               <a:ext uri="{FF2B5EF4-FFF2-40B4-BE49-F238E27FC236}">
-                <a16:creationId xmlns:a16="http://schemas.microsoft.com/office/drawing/2014/main" id="{A9222B03-AD28-4676-B4A1-4342C7CA4E49}"/>
+                <a16:creationId xmlns:a16="http://schemas.microsoft.com/office/drawing/2014/main" id="{691CC888-7B12-431E-AC4C-1962A8257E84}"/>
               </a:ext>
             </a:extLst>
           </p:cNvPr>
@@ -17306,7 +16841,7 @@
           <p:cNvPr id="15" name="">
             <a:extLst xmlns:a="http://schemas.openxmlformats.org/drawingml/2006/main">
               <a:ext uri="{FF2B5EF4-FFF2-40B4-BE49-F238E27FC236}">
-                <a16:creationId xmlns:a16="http://schemas.microsoft.com/office/drawing/2014/main" id="{CB36064C-853B-427B-A549-1854C7B1414C}"/>
+                <a16:creationId xmlns:a16="http://schemas.microsoft.com/office/drawing/2014/main" id="{F08BB9F0-0363-4C05-AE2E-3B1BFD19AFA8}"/>
               </a:ext>
             </a:extLst>
           </p:cNvPr>
@@ -17364,7 +16899,7 @@
           <p:cNvPr id="16" name="">
             <a:extLst xmlns:a="http://schemas.openxmlformats.org/drawingml/2006/main">
               <a:ext uri="{FF2B5EF4-FFF2-40B4-BE49-F238E27FC236}">
-                <a16:creationId xmlns:a16="http://schemas.microsoft.com/office/drawing/2014/main" id="{BA3B7FD1-166B-4535-8939-694F6411F5F6}"/>
+                <a16:creationId xmlns:a16="http://schemas.microsoft.com/office/drawing/2014/main" id="{2B5D7436-9074-4DC6-958A-E0AB559D6697}"/>
               </a:ext>
             </a:extLst>
           </p:cNvPr>
@@ -17397,7 +16932,7 @@
           <p:cNvPr id="17" name="">
             <a:extLst xmlns:a="http://schemas.openxmlformats.org/drawingml/2006/main">
               <a:ext uri="{FF2B5EF4-FFF2-40B4-BE49-F238E27FC236}">
-                <a16:creationId xmlns:a16="http://schemas.microsoft.com/office/drawing/2014/main" id="{26A0E050-3B42-47F2-A194-60A1A578172F}"/>
+                <a16:creationId xmlns:a16="http://schemas.microsoft.com/office/drawing/2014/main" id="{37A2D0B9-72FE-4696-BCF3-028172286D9E}"/>
               </a:ext>
             </a:extLst>
           </p:cNvPr>
@@ -17455,7 +16990,7 @@
           <p:cNvPr id="18" name="">
             <a:extLst xmlns:a="http://schemas.openxmlformats.org/drawingml/2006/main">
               <a:ext uri="{FF2B5EF4-FFF2-40B4-BE49-F238E27FC236}">
-                <a16:creationId xmlns:a16="http://schemas.microsoft.com/office/drawing/2014/main" id="{65CA98FE-D9BD-4BB3-BA96-8B6928354DE7}"/>
+                <a16:creationId xmlns:a16="http://schemas.microsoft.com/office/drawing/2014/main" id="{D2894E57-0AE7-4689-AD70-4A7591D18C80}"/>
               </a:ext>
             </a:extLst>
           </p:cNvPr>
@@ -17513,7 +17048,7 @@
           <p:cNvPr id="19" name="">
             <a:extLst xmlns:a="http://schemas.openxmlformats.org/drawingml/2006/main">
               <a:ext uri="{FF2B5EF4-FFF2-40B4-BE49-F238E27FC236}">
-                <a16:creationId xmlns:a16="http://schemas.microsoft.com/office/drawing/2014/main" id="{F5E10B34-5C91-48D2-AA1B-7291064BE282}"/>
+                <a16:creationId xmlns:a16="http://schemas.microsoft.com/office/drawing/2014/main" id="{663CE7DA-51FD-442F-B1B9-096710ABAF26}"/>
               </a:ext>
             </a:extLst>
           </p:cNvPr>
@@ -17571,7 +17106,7 @@
           <p:cNvPr id="20" name="">
             <a:extLst xmlns:a="http://schemas.openxmlformats.org/drawingml/2006/main">
               <a:ext uri="{FF2B5EF4-FFF2-40B4-BE49-F238E27FC236}">
-                <a16:creationId xmlns:a16="http://schemas.microsoft.com/office/drawing/2014/main" id="{EE50A276-5556-45DA-BC37-265EF6569A56}"/>
+                <a16:creationId xmlns:a16="http://schemas.microsoft.com/office/drawing/2014/main" id="{D06ACE08-3C88-49B7-A06E-5249786A7BAB}"/>
               </a:ext>
             </a:extLst>
           </p:cNvPr>
@@ -17604,7 +17139,7 @@
           <p:cNvPr id="21" name="">
             <a:extLst xmlns:a="http://schemas.openxmlformats.org/drawingml/2006/main">
               <a:ext uri="{FF2B5EF4-FFF2-40B4-BE49-F238E27FC236}">
-                <a16:creationId xmlns:a16="http://schemas.microsoft.com/office/drawing/2014/main" id="{98931F99-7AAA-4062-A00D-1F816828543A}"/>
+                <a16:creationId xmlns:a16="http://schemas.microsoft.com/office/drawing/2014/main" id="{30C0C725-8A47-4F44-ABA1-27C853CA1EFF}"/>
               </a:ext>
             </a:extLst>
           </p:cNvPr>
@@ -17662,7 +17197,7 @@
           <p:cNvPr id="22" name="">
             <a:extLst xmlns:a="http://schemas.openxmlformats.org/drawingml/2006/main">
               <a:ext uri="{FF2B5EF4-FFF2-40B4-BE49-F238E27FC236}">
-                <a16:creationId xmlns:a16="http://schemas.microsoft.com/office/drawing/2014/main" id="{FA3E93A4-9AE8-48B2-8322-8052F0D5D955}"/>
+                <a16:creationId xmlns:a16="http://schemas.microsoft.com/office/drawing/2014/main" id="{59A95390-D6F3-47F8-997F-C14C6A62C020}"/>
               </a:ext>
             </a:extLst>
           </p:cNvPr>
@@ -17720,7 +17255,7 @@
           <p:cNvPr id="23" name="">
             <a:extLst xmlns:a="http://schemas.openxmlformats.org/drawingml/2006/main">
               <a:ext uri="{FF2B5EF4-FFF2-40B4-BE49-F238E27FC236}">
-                <a16:creationId xmlns:a16="http://schemas.microsoft.com/office/drawing/2014/main" id="{5574A390-E988-4283-826F-212B37257649}"/>
+                <a16:creationId xmlns:a16="http://schemas.microsoft.com/office/drawing/2014/main" id="{5C3E7440-0449-4739-A2E7-2A3F4785719F}"/>
               </a:ext>
             </a:extLst>
           </p:cNvPr>
@@ -17778,7 +17313,7 @@
           <p:cNvPr id="24" name="">
             <a:extLst xmlns:a="http://schemas.openxmlformats.org/drawingml/2006/main">
               <a:ext uri="{FF2B5EF4-FFF2-40B4-BE49-F238E27FC236}">
-                <a16:creationId xmlns:a16="http://schemas.microsoft.com/office/drawing/2014/main" id="{A6E5FE91-E1D9-4AFE-8D87-731E437E4E20}"/>
+                <a16:creationId xmlns:a16="http://schemas.microsoft.com/office/drawing/2014/main" id="{1598D4B4-2BC6-4EA7-9230-08BE91DD9CA0}"/>
               </a:ext>
             </a:extLst>
           </p:cNvPr>
@@ -17813,7 +17348,7 @@
           <p:cNvPr id="25" name="">
             <a:extLst xmlns:a="http://schemas.openxmlformats.org/drawingml/2006/main">
               <a:ext uri="{FF2B5EF4-FFF2-40B4-BE49-F238E27FC236}">
-                <a16:creationId xmlns:a16="http://schemas.microsoft.com/office/drawing/2014/main" id="{769E9C39-60BF-41E7-8DAB-B2693B020756}"/>
+                <a16:creationId xmlns:a16="http://schemas.microsoft.com/office/drawing/2014/main" id="{92300044-8FF4-4C65-BBDC-348C5F140E11}"/>
               </a:ext>
             </a:extLst>
           </p:cNvPr>
@@ -17871,7 +17406,7 @@
           <p:cNvPr id="26" name="">
             <a:extLst xmlns:a="http://schemas.openxmlformats.org/drawingml/2006/main">
               <a:ext uri="{FF2B5EF4-FFF2-40B4-BE49-F238E27FC236}">
-                <a16:creationId xmlns:a16="http://schemas.microsoft.com/office/drawing/2014/main" id="{DF95F287-B848-4ED6-824F-4FBAE23ACEE3}"/>
+                <a16:creationId xmlns:a16="http://schemas.microsoft.com/office/drawing/2014/main" id="{A9B149CE-2BBE-4A0E-8457-757221889D02}"/>
               </a:ext>
             </a:extLst>
           </p:cNvPr>
@@ -17929,7 +17464,7 @@
           <p:cNvPr id="27" name="">
             <a:extLst xmlns:a="http://schemas.openxmlformats.org/drawingml/2006/main">
               <a:ext uri="{FF2B5EF4-FFF2-40B4-BE49-F238E27FC236}">
-                <a16:creationId xmlns:a16="http://schemas.microsoft.com/office/drawing/2014/main" id="{42815065-AC0A-4695-B237-B529D620F43F}"/>
+                <a16:creationId xmlns:a16="http://schemas.microsoft.com/office/drawing/2014/main" id="{2DECF9F8-7BE1-4A0E-A0FD-94C24A3F4A47}"/>
               </a:ext>
             </a:extLst>
           </p:cNvPr>
@@ -17962,7 +17497,7 @@
           <p:cNvPr id="28" name="">
             <a:extLst xmlns:a="http://schemas.openxmlformats.org/drawingml/2006/main">
               <a:ext uri="{FF2B5EF4-FFF2-40B4-BE49-F238E27FC236}">
-                <a16:creationId xmlns:a16="http://schemas.microsoft.com/office/drawing/2014/main" id="{8BB4A50C-B247-40AF-BBE7-913831A6DEE4}"/>
+                <a16:creationId xmlns:a16="http://schemas.microsoft.com/office/drawing/2014/main" id="{7487D03D-D4F7-41C6-B71B-40D61F7A5FC3}"/>
               </a:ext>
             </a:extLst>
           </p:cNvPr>
@@ -18054,7 +17589,7 @@
           <p:cNvPr id="29" name="">
             <a:extLst xmlns:a="http://schemas.openxmlformats.org/drawingml/2006/main">
               <a:ext uri="{FF2B5EF4-FFF2-40B4-BE49-F238E27FC236}">
-                <a16:creationId xmlns:a16="http://schemas.microsoft.com/office/drawing/2014/main" id="{0A61505C-FBDF-49A8-A999-5CF5274D648D}"/>
+                <a16:creationId xmlns:a16="http://schemas.microsoft.com/office/drawing/2014/main" id="{92178AD5-93FE-4F8E-ACC5-8195BEA5662B}"/>
               </a:ext>
             </a:extLst>
           </p:cNvPr>
@@ -18087,7 +17622,7 @@
           <p:cNvPr id="30" name="">
             <a:extLst xmlns:a="http://schemas.openxmlformats.org/drawingml/2006/main">
               <a:ext uri="{FF2B5EF4-FFF2-40B4-BE49-F238E27FC236}">
-                <a16:creationId xmlns:a16="http://schemas.microsoft.com/office/drawing/2014/main" id="{994F4F34-3595-4AB5-8AE8-2C3E8998ED11}"/>
+                <a16:creationId xmlns:a16="http://schemas.microsoft.com/office/drawing/2014/main" id="{DE02061D-225E-4DED-B8BA-5D66D349A6AD}"/>
               </a:ext>
             </a:extLst>
           </p:cNvPr>
@@ -18145,7 +17680,7 @@
           <p:cNvPr id="31" name="">
             <a:extLst xmlns:a="http://schemas.openxmlformats.org/drawingml/2006/main">
               <a:ext uri="{FF2B5EF4-FFF2-40B4-BE49-F238E27FC236}">
-                <a16:creationId xmlns:a16="http://schemas.microsoft.com/office/drawing/2014/main" id="{5579F8F8-8B79-4429-A3FB-0CB42E6496BE}"/>
+                <a16:creationId xmlns:a16="http://schemas.microsoft.com/office/drawing/2014/main" id="{FA6D7DE6-B304-46F4-9BF6-3EB2F553685D}"/>
               </a:ext>
             </a:extLst>
           </p:cNvPr>
@@ -18201,7 +17736,7 @@
     </p:spTree>
     <p:extLst>
       <p:ext uri="{BB962C8B-B14F-4D97-AF65-F5344CB8AC3E}">
-        <p14:creationId xmlns:p14="http://schemas.microsoft.com/office/powerpoint/2010/main" val="1486202450"/>
+        <p14:creationId xmlns:p14="http://schemas.microsoft.com/office/powerpoint/2010/main" val="461574763"/>
       </p:ext>
     </p:extLst>
   </p:cSld>

</xml_diff>